<commit_message>
Give the evidence figure a cartographic palette
</commit_message>
<xml_diff>
--- a/docs/figures/evidence-trace/editable/intellicrawl-evidence-trace.pptx
+++ b/docs/figures/evidence-trace/editable/intellicrawl-evidence-trace.pptx
@@ -2,13 +2,13 @@
 <file path=ppt/presentation.xml><?xml version="1.0" encoding="utf-8"?>
 <p:presentation xmlns:p="http://schemas.openxmlformats.org/presentationml/2006/main">
   <p:sldMasterIdLst>
-    <p:sldMasterId xmlns:r="http://schemas.openxmlformats.org/officeDocument/2006/relationships" id="2147483648" r:id="R0b0adfbfb50b4331"/>
+    <p:sldMasterId xmlns:r="http://schemas.openxmlformats.org/officeDocument/2006/relationships" id="2147483648" r:id="R5e6e566ba32d4828"/>
   </p:sldMasterIdLst>
   <p:notesMasterIdLst>
-    <p:notesMasterId xmlns:r="http://schemas.openxmlformats.org/officeDocument/2006/relationships" r:id="R33f30813e1ec4c5d"/>
+    <p:notesMasterId xmlns:r="http://schemas.openxmlformats.org/officeDocument/2006/relationships" r:id="Rbd0a7bc4784c483e"/>
   </p:notesMasterIdLst>
   <p:sldIdLst>
-    <p:sldId xmlns:r="http://schemas.openxmlformats.org/officeDocument/2006/relationships" id="256" r:id="Rcd587aa0b8324e1d"/>
+    <p:sldId xmlns:r="http://schemas.openxmlformats.org/officeDocument/2006/relationships" id="256" r:id="Rbc5625743a8b40ed"/>
   </p:sldIdLst>
   <p:sldSz cx="12192000" cy="6858000"/>
   <p:notesSz cx="6858000" cy="9144000"/>
@@ -601,7 +601,7 @@
   </p:cSld>
   <p:clrMap bg1="lt1" tx1="dk1" bg2="lt2" tx2="dk2" accent1="accent1" accent2="accent2" accent3="accent3" accent4="accent4" accent5="accent5" accent6="accent6" hlink="hlink" folHlink="folHlink"/>
   <p:sldLayoutIdLst>
-    <p:sldLayoutId xmlns:r="http://schemas.openxmlformats.org/officeDocument/2006/relationships" id="2147483649" r:id="R9edb96dee95e4bda"/>
+    <p:sldLayoutId xmlns:r="http://schemas.openxmlformats.org/officeDocument/2006/relationships" id="2147483649" r:id="Rd9a520d8574d4f2e"/>
   </p:sldLayoutIdLst>
   <p:txStyles>
     <p:titleStyle>
@@ -1134,7 +1134,7 @@
     <p:bg>
       <p:bgPr>
         <a:solidFill xmlns:a="http://schemas.openxmlformats.org/drawingml/2006/main">
-          <a:srgbClr val="F7F4ED"/>
+          <a:srgbClr val="F3EFE6"/>
         </a:solidFill>
       </p:bgPr>
     </p:bg>
@@ -1152,7 +1152,7 @@
           <p:cNvPr id="122" name="title">
             <a:extLst xmlns:a="http://schemas.openxmlformats.org/drawingml/2006/main">
               <a:ext uri="{FF2B5EF4-FFF2-40B4-BE49-F238E27FC236}">
-                <a16:creationId xmlns:a16="http://schemas.microsoft.com/office/drawing/2014/main" id="{1E0FACC0-FCAB-45C1-9506-BC855968AB55}"/>
+                <a16:creationId xmlns:a16="http://schemas.microsoft.com/office/drawing/2014/main" id="{85A491DB-7A16-47B7-AE05-B128E4D64DA0}"/>
               </a:ext>
             </a:extLst>
           </p:cNvPr>
@@ -1182,14 +1182,14 @@
             <a:pPr algn="l">
               <a:defRPr sz="2550" b="1">
                 <a:solidFill>
-                  <a:srgbClr val="191B1A"/>
+                  <a:srgbClr val="24211D"/>
                 </a:solidFill>
               </a:defRPr>
             </a:pPr>
             <a:r>
               <a:rPr sz="2550" b="1">
                 <a:solidFill>
-                  <a:srgbClr val="191B1A"/>
+                  <a:srgbClr val="24211D"/>
                 </a:solidFill>
               </a:rPr>
               <a:t>IntelliCrawl exposes the source behind every normalized field</a:t>
@@ -1202,7 +1202,7 @@
           <p:cNvPr id="2" name="subtitle">
             <a:extLst xmlns:a="http://schemas.openxmlformats.org/drawingml/2006/main">
               <a:ext uri="{FF2B5EF4-FFF2-40B4-BE49-F238E27FC236}">
-                <a16:creationId xmlns:a16="http://schemas.microsoft.com/office/drawing/2014/main" id="{193676A9-AF46-4194-8DEE-F20983CD3459}"/>
+                <a16:creationId xmlns:a16="http://schemas.microsoft.com/office/drawing/2014/main" id="{5C8D5E13-C8D2-4934-9862-E75B0A6E3F61}"/>
               </a:ext>
             </a:extLst>
           </p:cNvPr>
@@ -1232,14 +1232,14 @@
             <a:pPr algn="l">
               <a:defRPr sz="1200" b="0">
                 <a:solidFill>
-                  <a:srgbClr val="656A67"/>
+                  <a:srgbClr val="6B655E"/>
                 </a:solidFill>
               </a:defRPr>
             </a:pPr>
             <a:r>
               <a:rPr sz="1200" b="0">
                 <a:solidFill>
-                  <a:srgbClr val="656A67"/>
+                  <a:srgbClr val="6B655E"/>
                 </a:solidFill>
               </a:rPr>
               <a:t>The dated fixture fans one research question into three parallel profiles, then validates each field-level source tag before export.</a:t>
@@ -1252,7 +1252,7 @@
           <p:cNvPr id="3" name="header-rule">
             <a:extLst xmlns:a="http://schemas.openxmlformats.org/drawingml/2006/main">
               <a:ext uri="{FF2B5EF4-FFF2-40B4-BE49-F238E27FC236}">
-                <a16:creationId xmlns:a16="http://schemas.microsoft.com/office/drawing/2014/main" id="{FC26C0A3-4EDB-4DBF-B529-EC7E065FA1A8}"/>
+                <a16:creationId xmlns:a16="http://schemas.microsoft.com/office/drawing/2014/main" id="{8B98FB42-97D9-4C6E-954C-9C8D5EA6F9ED}"/>
               </a:ext>
             </a:extLst>
           </p:cNvPr>
@@ -1272,7 +1272,7 @@
           <a:noFill xmlns:a="http://schemas.openxmlformats.org/drawingml/2006/main"/>
           <a:ln xmlns:a="http://schemas.openxmlformats.org/drawingml/2006/main" w="14288">
             <a:solidFill>
-              <a:srgbClr val="191B1A"/>
+              <a:srgbClr val="24211D"/>
             </a:solidFill>
             <a:prstDash val="solid"/>
           </a:ln>
@@ -1283,7 +1283,7 @@
           <p:cNvPr id="4" name="question-to-spine">
             <a:extLst xmlns:a="http://schemas.openxmlformats.org/drawingml/2006/main">
               <a:ext uri="{FF2B5EF4-FFF2-40B4-BE49-F238E27FC236}">
-                <a16:creationId xmlns:a16="http://schemas.microsoft.com/office/drawing/2014/main" id="{0016F4BE-8C83-4A12-89DC-AA6CAB54FE95}"/>
+                <a16:creationId xmlns:a16="http://schemas.microsoft.com/office/drawing/2014/main" id="{F28C4657-00BF-45C0-AEE1-91F17F6D8846}"/>
               </a:ext>
             </a:extLst>
           </p:cNvPr>
@@ -1301,11 +1301,11 @@
             <a:avLst/>
           </a:prstGeom>
           <a:solidFill xmlns:a="http://schemas.openxmlformats.org/drawingml/2006/main">
-            <a:srgbClr val="183B5C"/>
+            <a:srgbClr val="36453B"/>
           </a:solidFill>
           <a:ln xmlns:a="http://schemas.openxmlformats.org/drawingml/2006/main" w="0">
             <a:solidFill>
-              <a:srgbClr val="183B5C"/>
+              <a:srgbClr val="36453B"/>
             </a:solidFill>
             <a:prstDash val="solid"/>
           </a:ln>
@@ -1316,7 +1316,7 @@
           <p:cNvPr id="5" name="fanout-spine">
             <a:extLst xmlns:a="http://schemas.openxmlformats.org/drawingml/2006/main">
               <a:ext uri="{FF2B5EF4-FFF2-40B4-BE49-F238E27FC236}">
-                <a16:creationId xmlns:a16="http://schemas.microsoft.com/office/drawing/2014/main" id="{D50E1C2D-C2DC-4BDE-BAF7-B6289279A498}"/>
+                <a16:creationId xmlns:a16="http://schemas.microsoft.com/office/drawing/2014/main" id="{5C846AE7-2E1C-4687-8B38-02BFFCD6C658}"/>
               </a:ext>
             </a:extLst>
           </p:cNvPr>
@@ -1336,7 +1336,7 @@
           <a:noFill xmlns:a="http://schemas.openxmlformats.org/drawingml/2006/main"/>
           <a:ln xmlns:a="http://schemas.openxmlformats.org/drawingml/2006/main" w="15240">
             <a:solidFill>
-              <a:srgbClr val="183B5C"/>
+              <a:srgbClr val="36453B"/>
             </a:solidFill>
             <a:prstDash val="solid"/>
           </a:ln>
@@ -1347,7 +1347,7 @@
           <p:cNvPr id="6" name="spine-to-lane-0">
             <a:extLst xmlns:a="http://schemas.openxmlformats.org/drawingml/2006/main">
               <a:ext uri="{FF2B5EF4-FFF2-40B4-BE49-F238E27FC236}">
-                <a16:creationId xmlns:a16="http://schemas.microsoft.com/office/drawing/2014/main" id="{3D2A0B8C-F638-4E61-B9C7-DA50B9D744AD}"/>
+                <a16:creationId xmlns:a16="http://schemas.microsoft.com/office/drawing/2014/main" id="{1CBC9286-AD21-4A3D-8DF4-93C0F68FEBED}"/>
               </a:ext>
             </a:extLst>
           </p:cNvPr>
@@ -1365,11 +1365,11 @@
             <a:avLst/>
           </a:prstGeom>
           <a:solidFill xmlns:a="http://schemas.openxmlformats.org/drawingml/2006/main">
-            <a:srgbClr val="183B5C"/>
+            <a:srgbClr val="36453B"/>
           </a:solidFill>
           <a:ln xmlns:a="http://schemas.openxmlformats.org/drawingml/2006/main" w="0">
             <a:solidFill>
-              <a:srgbClr val="183B5C"/>
+              <a:srgbClr val="36453B"/>
             </a:solidFill>
             <a:prstDash val="solid"/>
           </a:ln>
@@ -1380,7 +1380,7 @@
           <p:cNvPr id="7" name="spine-to-lane-1">
             <a:extLst xmlns:a="http://schemas.openxmlformats.org/drawingml/2006/main">
               <a:ext uri="{FF2B5EF4-FFF2-40B4-BE49-F238E27FC236}">
-                <a16:creationId xmlns:a16="http://schemas.microsoft.com/office/drawing/2014/main" id="{9DE3EB53-2E15-44EF-BD90-287BC3CB700C}"/>
+                <a16:creationId xmlns:a16="http://schemas.microsoft.com/office/drawing/2014/main" id="{B159F6AA-193E-41B2-A1C7-D95173B76DE4}"/>
               </a:ext>
             </a:extLst>
           </p:cNvPr>
@@ -1398,11 +1398,11 @@
             <a:avLst/>
           </a:prstGeom>
           <a:solidFill xmlns:a="http://schemas.openxmlformats.org/drawingml/2006/main">
-            <a:srgbClr val="183B5C"/>
+            <a:srgbClr val="36453B"/>
           </a:solidFill>
           <a:ln xmlns:a="http://schemas.openxmlformats.org/drawingml/2006/main" w="0">
             <a:solidFill>
-              <a:srgbClr val="183B5C"/>
+              <a:srgbClr val="36453B"/>
             </a:solidFill>
             <a:prstDash val="solid"/>
           </a:ln>
@@ -1413,7 +1413,7 @@
           <p:cNvPr id="8" name="spine-to-lane-2">
             <a:extLst xmlns:a="http://schemas.openxmlformats.org/drawingml/2006/main">
               <a:ext uri="{FF2B5EF4-FFF2-40B4-BE49-F238E27FC236}">
-                <a16:creationId xmlns:a16="http://schemas.microsoft.com/office/drawing/2014/main" id="{0DE84638-C8A0-49A6-AC91-B8400EAA7C03}"/>
+                <a16:creationId xmlns:a16="http://schemas.microsoft.com/office/drawing/2014/main" id="{AC7D9B9B-939D-4976-AEEE-1E8D678BF745}"/>
               </a:ext>
             </a:extLst>
           </p:cNvPr>
@@ -1431,11 +1431,11 @@
             <a:avLst/>
           </a:prstGeom>
           <a:solidFill xmlns:a="http://schemas.openxmlformats.org/drawingml/2006/main">
-            <a:srgbClr val="183B5C"/>
+            <a:srgbClr val="36453B"/>
           </a:solidFill>
           <a:ln xmlns:a="http://schemas.openxmlformats.org/drawingml/2006/main" w="0">
             <a:solidFill>
-              <a:srgbClr val="183B5C"/>
+              <a:srgbClr val="36453B"/>
             </a:solidFill>
             <a:prstDash val="solid"/>
           </a:ln>
@@ -1446,7 +1446,7 @@
           <p:cNvPr id="9" name="lane-to-report-0">
             <a:extLst xmlns:a="http://schemas.openxmlformats.org/drawingml/2006/main">
               <a:ext uri="{FF2B5EF4-FFF2-40B4-BE49-F238E27FC236}">
-                <a16:creationId xmlns:a16="http://schemas.microsoft.com/office/drawing/2014/main" id="{B76C4EB1-0E7B-4C9D-8E50-E887F38470A7}"/>
+                <a16:creationId xmlns:a16="http://schemas.microsoft.com/office/drawing/2014/main" id="{E3D10DDD-84B4-4663-A91D-997A080814E4}"/>
               </a:ext>
             </a:extLst>
           </p:cNvPr>
@@ -1464,11 +1464,11 @@
             <a:avLst/>
           </a:prstGeom>
           <a:solidFill xmlns:a="http://schemas.openxmlformats.org/drawingml/2006/main">
-            <a:srgbClr val="183B5C"/>
+            <a:srgbClr val="36453B"/>
           </a:solidFill>
           <a:ln xmlns:a="http://schemas.openxmlformats.org/drawingml/2006/main" w="0">
             <a:solidFill>
-              <a:srgbClr val="183B5C"/>
+              <a:srgbClr val="36453B"/>
             </a:solidFill>
             <a:prstDash val="solid"/>
           </a:ln>
@@ -1479,7 +1479,7 @@
           <p:cNvPr id="10" name="lane-to-report-1">
             <a:extLst xmlns:a="http://schemas.openxmlformats.org/drawingml/2006/main">
               <a:ext uri="{FF2B5EF4-FFF2-40B4-BE49-F238E27FC236}">
-                <a16:creationId xmlns:a16="http://schemas.microsoft.com/office/drawing/2014/main" id="{22E6AEFF-F4B5-4275-96B2-F4C3AA3172D0}"/>
+                <a16:creationId xmlns:a16="http://schemas.microsoft.com/office/drawing/2014/main" id="{2681069E-3564-47A5-B434-9973A9FE2B86}"/>
               </a:ext>
             </a:extLst>
           </p:cNvPr>
@@ -1497,11 +1497,11 @@
             <a:avLst/>
           </a:prstGeom>
           <a:solidFill xmlns:a="http://schemas.openxmlformats.org/drawingml/2006/main">
-            <a:srgbClr val="183B5C"/>
+            <a:srgbClr val="36453B"/>
           </a:solidFill>
           <a:ln xmlns:a="http://schemas.openxmlformats.org/drawingml/2006/main" w="0">
             <a:solidFill>
-              <a:srgbClr val="183B5C"/>
+              <a:srgbClr val="36453B"/>
             </a:solidFill>
             <a:prstDash val="solid"/>
           </a:ln>
@@ -1512,7 +1512,7 @@
           <p:cNvPr id="11" name="lane-to-report-2">
             <a:extLst xmlns:a="http://schemas.openxmlformats.org/drawingml/2006/main">
               <a:ext uri="{FF2B5EF4-FFF2-40B4-BE49-F238E27FC236}">
-                <a16:creationId xmlns:a16="http://schemas.microsoft.com/office/drawing/2014/main" id="{2435375C-94A4-461F-95B8-36FAFE13DD3D}"/>
+                <a16:creationId xmlns:a16="http://schemas.microsoft.com/office/drawing/2014/main" id="{0F1F8FC4-12ED-435F-8714-DDDDF1DB9E1E}"/>
               </a:ext>
             </a:extLst>
           </p:cNvPr>
@@ -1530,11 +1530,11 @@
             <a:avLst/>
           </a:prstGeom>
           <a:solidFill xmlns:a="http://schemas.openxmlformats.org/drawingml/2006/main">
-            <a:srgbClr val="183B5C"/>
+            <a:srgbClr val="36453B"/>
           </a:solidFill>
           <a:ln xmlns:a="http://schemas.openxmlformats.org/drawingml/2006/main" w="0">
             <a:solidFill>
-              <a:srgbClr val="183B5C"/>
+              <a:srgbClr val="36453B"/>
             </a:solidFill>
             <a:prstDash val="solid"/>
           </a:ln>
@@ -1545,7 +1545,7 @@
           <p:cNvPr id="12" name="report-to-exports">
             <a:extLst xmlns:a="http://schemas.openxmlformats.org/drawingml/2006/main">
               <a:ext uri="{FF2B5EF4-FFF2-40B4-BE49-F238E27FC236}">
-                <a16:creationId xmlns:a16="http://schemas.microsoft.com/office/drawing/2014/main" id="{048CC96A-1355-4593-87AD-101F9B2D791C}"/>
+                <a16:creationId xmlns:a16="http://schemas.microsoft.com/office/drawing/2014/main" id="{EE5C67B0-F9A2-4994-925A-51227FA00571}"/>
               </a:ext>
             </a:extLst>
           </p:cNvPr>
@@ -1563,11 +1563,11 @@
             <a:avLst/>
           </a:prstGeom>
           <a:solidFill xmlns:a="http://schemas.openxmlformats.org/drawingml/2006/main">
-            <a:srgbClr val="9C3451"/>
+            <a:srgbClr val="9B3A2B"/>
           </a:solidFill>
           <a:ln xmlns:a="http://schemas.openxmlformats.org/drawingml/2006/main" w="0">
             <a:solidFill>
-              <a:srgbClr val="9C3451"/>
+              <a:srgbClr val="9B3A2B"/>
             </a:solidFill>
             <a:prstDash val="solid"/>
           </a:ln>
@@ -1578,7 +1578,7 @@
           <p:cNvPr id="13" name="input-label">
             <a:extLst xmlns:a="http://schemas.openxmlformats.org/drawingml/2006/main">
               <a:ext uri="{FF2B5EF4-FFF2-40B4-BE49-F238E27FC236}">
-                <a16:creationId xmlns:a16="http://schemas.microsoft.com/office/drawing/2014/main" id="{88214B90-E15C-4297-AA86-B76B67BB3D5D}"/>
+                <a16:creationId xmlns:a16="http://schemas.microsoft.com/office/drawing/2014/main" id="{000EDABD-9AE0-4514-AA86-392E9D2BF8B7}"/>
               </a:ext>
             </a:extLst>
           </p:cNvPr>
@@ -1608,14 +1608,14 @@
             <a:pPr algn="l">
               <a:defRPr sz="900" b="1">
                 <a:solidFill>
-                  <a:srgbClr val="9C3451"/>
+                  <a:srgbClr val="9B3A2B"/>
                 </a:solidFill>
               </a:defRPr>
             </a:pPr>
             <a:r>
               <a:rPr sz="900" b="1">
                 <a:solidFill>
-                  <a:srgbClr val="9C3451"/>
+                  <a:srgbClr val="9B3A2B"/>
                 </a:solidFill>
               </a:rPr>
               <a:t>ONE RESEARCH QUESTION</a:t>
@@ -1628,7 +1628,7 @@
           <p:cNvPr id="14" name="query">
             <a:extLst xmlns:a="http://schemas.openxmlformats.org/drawingml/2006/main">
               <a:ext uri="{FF2B5EF4-FFF2-40B4-BE49-F238E27FC236}">
-                <a16:creationId xmlns:a16="http://schemas.microsoft.com/office/drawing/2014/main" id="{9EB46CBA-FAEA-4D9A-9AB1-742E1034D2F5}"/>
+                <a16:creationId xmlns:a16="http://schemas.microsoft.com/office/drawing/2014/main" id="{BEFCBF34-DE8C-4B42-9775-1AB60EF16F59}"/>
               </a:ext>
             </a:extLst>
           </p:cNvPr>
@@ -1648,11 +1648,11 @@
             </a:avLst>
           </a:prstGeom>
           <a:solidFill xmlns:a="http://schemas.openxmlformats.org/drawingml/2006/main">
-            <a:srgbClr val="E7EDF2"/>
+            <a:srgbClr val="E7E4D7"/>
           </a:solidFill>
           <a:ln xmlns:a="http://schemas.openxmlformats.org/drawingml/2006/main" w="11430">
             <a:solidFill>
-              <a:srgbClr val="183B5C"/>
+              <a:srgbClr val="36453B"/>
             </a:solidFill>
             <a:prstDash val="solid"/>
           </a:ln>
@@ -1663,7 +1663,7 @@
           <p:cNvPr id="15" name="query-text">
             <a:extLst xmlns:a="http://schemas.openxmlformats.org/drawingml/2006/main">
               <a:ext uri="{FF2B5EF4-FFF2-40B4-BE49-F238E27FC236}">
-                <a16:creationId xmlns:a16="http://schemas.microsoft.com/office/drawing/2014/main" id="{8DAADE54-A78F-4D64-953A-F759648E146D}"/>
+                <a16:creationId xmlns:a16="http://schemas.microsoft.com/office/drawing/2014/main" id="{5EAD1D8F-9A28-43D6-B0A3-141EA373508F}"/>
               </a:ext>
             </a:extLst>
           </p:cNvPr>
@@ -1693,14 +1693,14 @@
             <a:pPr algn="l">
               <a:defRPr sz="1275" b="1">
                 <a:solidFill>
-                  <a:srgbClr val="183B5C"/>
+                  <a:srgbClr val="36453B"/>
                 </a:solidFill>
               </a:defRPr>
             </a:pPr>
             <a:r>
               <a:rPr sz="1275" b="1">
                 <a:solidFill>
-                  <a:srgbClr val="183B5C"/>
+                  <a:srgbClr val="36453B"/>
                 </a:solidFill>
               </a:rPr>
               <a:t>vector databases for production RAG</a:t>
@@ -1713,7 +1713,7 @@
           <p:cNvPr id="16" name="query-date">
             <a:extLst xmlns:a="http://schemas.openxmlformats.org/drawingml/2006/main">
               <a:ext uri="{FF2B5EF4-FFF2-40B4-BE49-F238E27FC236}">
-                <a16:creationId xmlns:a16="http://schemas.microsoft.com/office/drawing/2014/main" id="{E1CF7D9E-C95D-493C-980A-A47E9220604E}"/>
+                <a16:creationId xmlns:a16="http://schemas.microsoft.com/office/drawing/2014/main" id="{F5CCCF3B-1DEE-4E68-B23B-ABC2E9C3E473}"/>
               </a:ext>
             </a:extLst>
           </p:cNvPr>
@@ -1743,14 +1743,14 @@
             <a:pPr algn="l">
               <a:defRPr sz="825" b="0">
                 <a:solidFill>
-                  <a:srgbClr val="656A67"/>
+                  <a:srgbClr val="6B655E"/>
                 </a:solidFill>
               </a:defRPr>
             </a:pPr>
             <a:r>
               <a:rPr sz="825" b="0">
                 <a:solidFill>
-                  <a:srgbClr val="656A67"/>
+                  <a:srgbClr val="6B655E"/>
                 </a:solidFill>
               </a:rPr>
               <a:t>dated fixture · 2026-07-11</a:t>
@@ -1763,7 +1763,7 @@
           <p:cNvPr id="17" name="parallel-label">
             <a:extLst xmlns:a="http://schemas.openxmlformats.org/drawingml/2006/main">
               <a:ext uri="{FF2B5EF4-FFF2-40B4-BE49-F238E27FC236}">
-                <a16:creationId xmlns:a16="http://schemas.microsoft.com/office/drawing/2014/main" id="{3B2CAED1-45BD-40C4-95D9-FC7CEDF66116}"/>
+                <a16:creationId xmlns:a16="http://schemas.microsoft.com/office/drawing/2014/main" id="{AE1F63CF-FE0C-441A-B5A3-2674E43BD297}"/>
               </a:ext>
             </a:extLst>
           </p:cNvPr>
@@ -1793,14 +1793,14 @@
             <a:pPr algn="l">
               <a:defRPr sz="900" b="1">
                 <a:solidFill>
-                  <a:srgbClr val="9C3451"/>
+                  <a:srgbClr val="9B3A2B"/>
                 </a:solidFill>
               </a:defRPr>
             </a:pPr>
             <a:r>
               <a:rPr sz="900" b="1">
                 <a:solidFill>
-                  <a:srgbClr val="9C3451"/>
+                  <a:srgbClr val="9B3A2B"/>
                 </a:solidFill>
               </a:rPr>
               <a:t>PARALLEL PROFILES WITH LOCAL SOURCE TAGS</a:t>
@@ -1813,7 +1813,7 @@
           <p:cNvPr id="18" name="tool-0">
             <a:extLst xmlns:a="http://schemas.openxmlformats.org/drawingml/2006/main">
               <a:ext uri="{FF2B5EF4-FFF2-40B4-BE49-F238E27FC236}">
-                <a16:creationId xmlns:a16="http://schemas.microsoft.com/office/drawing/2014/main" id="{7CA322E5-20A5-426D-A0D0-0CDA4B8056DA}"/>
+                <a16:creationId xmlns:a16="http://schemas.microsoft.com/office/drawing/2014/main" id="{FCB4B0D9-3AE2-43D7-A056-B9F5A89015F9}"/>
               </a:ext>
             </a:extLst>
           </p:cNvPr>
@@ -1843,14 +1843,14 @@
             <a:pPr algn="l">
               <a:defRPr sz="1350" b="1">
                 <a:solidFill>
-                  <a:srgbClr val="2E7752"/>
+                  <a:srgbClr val="466B4A"/>
                 </a:solidFill>
               </a:defRPr>
             </a:pPr>
             <a:r>
               <a:rPr sz="1350" b="1">
                 <a:solidFill>
-                  <a:srgbClr val="2E7752"/>
+                  <a:srgbClr val="466B4A"/>
                 </a:solidFill>
               </a:rPr>
               <a:t>Weaviate</a:t>
@@ -1863,7 +1863,7 @@
           <p:cNvPr id="19" name="status-0">
             <a:extLst xmlns:a="http://schemas.openxmlformats.org/drawingml/2006/main">
               <a:ext uri="{FF2B5EF4-FFF2-40B4-BE49-F238E27FC236}">
-                <a16:creationId xmlns:a16="http://schemas.microsoft.com/office/drawing/2014/main" id="{47C0BAE7-2883-492A-B078-D5713C131FF6}"/>
+                <a16:creationId xmlns:a16="http://schemas.microsoft.com/office/drawing/2014/main" id="{2D8A37C4-18AA-4652-80A9-A923D6C1CCF8}"/>
               </a:ext>
             </a:extLst>
           </p:cNvPr>
@@ -1893,14 +1893,14 @@
             <a:pPr algn="l">
               <a:defRPr sz="825" b="0">
                 <a:solidFill>
-                  <a:srgbClr val="656A67"/>
+                  <a:srgbClr val="6B655E"/>
                 </a:solidFill>
               </a:defRPr>
             </a:pPr>
             <a:r>
               <a:rPr sz="825" b="0">
                 <a:solidFill>
-                  <a:srgbClr val="656A67"/>
+                  <a:srgbClr val="6B655E"/>
                 </a:solidFill>
               </a:rPr>
               <a:t>complete</a:t>
@@ -1913,7 +1913,7 @@
           <p:cNvPr id="20" name="source-doc-0">
             <a:extLst xmlns:a="http://schemas.openxmlformats.org/drawingml/2006/main">
               <a:ext uri="{FF2B5EF4-FFF2-40B4-BE49-F238E27FC236}">
-                <a16:creationId xmlns:a16="http://schemas.microsoft.com/office/drawing/2014/main" id="{0E680222-B6FF-43B0-B2F0-6308AAE7DC89}"/>
+                <a16:creationId xmlns:a16="http://schemas.microsoft.com/office/drawing/2014/main" id="{FE044190-0394-48E5-B727-6D503B2A232D}"/>
               </a:ext>
             </a:extLst>
           </p:cNvPr>
@@ -1933,11 +1933,11 @@
             </a:avLst>
           </a:prstGeom>
           <a:solidFill xmlns:a="http://schemas.openxmlformats.org/drawingml/2006/main">
-            <a:srgbClr val="FFFFFF"/>
+            <a:srgbClr val="FFFDF7"/>
           </a:solidFill>
           <a:ln xmlns:a="http://schemas.openxmlformats.org/drawingml/2006/main" w="9525">
             <a:solidFill>
-              <a:srgbClr val="2E7752"/>
+              <a:srgbClr val="466B4A"/>
             </a:solidFill>
             <a:prstDash val="solid"/>
           </a:ln>
@@ -1948,7 +1948,7 @@
           <p:cNvPr id="21" name="source-doc-text-0">
             <a:extLst xmlns:a="http://schemas.openxmlformats.org/drawingml/2006/main">
               <a:ext uri="{FF2B5EF4-FFF2-40B4-BE49-F238E27FC236}">
-                <a16:creationId xmlns:a16="http://schemas.microsoft.com/office/drawing/2014/main" id="{E4335EAC-318A-443D-8C56-8F53F8D740AB}"/>
+                <a16:creationId xmlns:a16="http://schemas.microsoft.com/office/drawing/2014/main" id="{6DD876BE-D9AE-4B85-A50A-B013D005BAE4}"/>
               </a:ext>
             </a:extLst>
           </p:cNvPr>
@@ -1978,14 +1978,14 @@
             <a:pPr algn="l">
               <a:defRPr sz="900" b="1">
                 <a:solidFill>
-                  <a:srgbClr val="2E7752"/>
+                  <a:srgbClr val="466B4A"/>
                 </a:solidFill>
               </a:defRPr>
             </a:pPr>
             <a:r>
               <a:rPr sz="900" b="1">
                 <a:solidFill>
-                  <a:srgbClr val="2E7752"/>
+                  <a:srgbClr val="466B4A"/>
                 </a:solidFill>
               </a:rPr>
               <a:t>S1  docs</a:t>
@@ -1998,7 +1998,7 @@
           <p:cNvPr id="22" name="source-price-0">
             <a:extLst xmlns:a="http://schemas.openxmlformats.org/drawingml/2006/main">
               <a:ext uri="{FF2B5EF4-FFF2-40B4-BE49-F238E27FC236}">
-                <a16:creationId xmlns:a16="http://schemas.microsoft.com/office/drawing/2014/main" id="{B01A9A34-8DD1-4FB8-96F0-5A56C68A68B6}"/>
+                <a16:creationId xmlns:a16="http://schemas.microsoft.com/office/drawing/2014/main" id="{B58520B7-125A-4ECA-B2AD-E1B17E8E944F}"/>
               </a:ext>
             </a:extLst>
           </p:cNvPr>
@@ -2018,11 +2018,11 @@
             </a:avLst>
           </a:prstGeom>
           <a:solidFill xmlns:a="http://schemas.openxmlformats.org/drawingml/2006/main">
-            <a:srgbClr val="FFFFFF"/>
+            <a:srgbClr val="FFFDF7"/>
           </a:solidFill>
           <a:ln xmlns:a="http://schemas.openxmlformats.org/drawingml/2006/main" w="9525">
             <a:solidFill>
-              <a:srgbClr val="2E7752"/>
+              <a:srgbClr val="466B4A"/>
             </a:solidFill>
             <a:prstDash val="solid"/>
           </a:ln>
@@ -2033,7 +2033,7 @@
           <p:cNvPr id="23" name="source-price-text-0">
             <a:extLst xmlns:a="http://schemas.openxmlformats.org/drawingml/2006/main">
               <a:ext uri="{FF2B5EF4-FFF2-40B4-BE49-F238E27FC236}">
-                <a16:creationId xmlns:a16="http://schemas.microsoft.com/office/drawing/2014/main" id="{D1EEF16C-1FC8-4ACA-838C-803B31F12D51}"/>
+                <a16:creationId xmlns:a16="http://schemas.microsoft.com/office/drawing/2014/main" id="{DD51B30A-F71C-4EAE-AC55-8B276ECD9BB8}"/>
               </a:ext>
             </a:extLst>
           </p:cNvPr>
@@ -2063,14 +2063,14 @@
             <a:pPr algn="l">
               <a:defRPr sz="900" b="1">
                 <a:solidFill>
-                  <a:srgbClr val="2E7752"/>
+                  <a:srgbClr val="466B4A"/>
                 </a:solidFill>
               </a:defRPr>
             </a:pPr>
             <a:r>
               <a:rPr sz="900" b="1">
                 <a:solidFill>
-                  <a:srgbClr val="2E7752"/>
+                  <a:srgbClr val="466B4A"/>
                 </a:solidFill>
               </a:rPr>
               <a:t>S2  pricing</a:t>
@@ -2083,7 +2083,7 @@
           <p:cNvPr id="24" name="lane-rule-0">
             <a:extLst xmlns:a="http://schemas.openxmlformats.org/drawingml/2006/main">
               <a:ext uri="{FF2B5EF4-FFF2-40B4-BE49-F238E27FC236}">
-                <a16:creationId xmlns:a16="http://schemas.microsoft.com/office/drawing/2014/main" id="{9905CAEE-9117-4E98-B20F-67F8433D381F}"/>
+                <a16:creationId xmlns:a16="http://schemas.microsoft.com/office/drawing/2014/main" id="{C404C95A-09A1-400D-8697-CEC5BE48F8C4}"/>
               </a:ext>
             </a:extLst>
           </p:cNvPr>
@@ -2103,7 +2103,7 @@
           <a:noFill xmlns:a="http://schemas.openxmlformats.org/drawingml/2006/main"/>
           <a:ln xmlns:a="http://schemas.openxmlformats.org/drawingml/2006/main" w="11430">
             <a:solidFill>
-              <a:srgbClr val="2E7752"/>
+              <a:srgbClr val="466B4A"/>
             </a:solidFill>
             <a:prstDash val="solid"/>
           </a:ln>
@@ -2114,7 +2114,7 @@
           <p:cNvPr id="25" name="field-0-0">
             <a:extLst xmlns:a="http://schemas.openxmlformats.org/drawingml/2006/main">
               <a:ext uri="{FF2B5EF4-FFF2-40B4-BE49-F238E27FC236}">
-                <a16:creationId xmlns:a16="http://schemas.microsoft.com/office/drawing/2014/main" id="{1C147F74-B64B-4631-A661-090C8F5F2B13}"/>
+                <a16:creationId xmlns:a16="http://schemas.microsoft.com/office/drawing/2014/main" id="{3A3B2D84-F910-484C-A335-214E7F5D1627}"/>
               </a:ext>
             </a:extLst>
           </p:cNvPr>
@@ -2134,11 +2134,11 @@
             </a:avLst>
           </a:prstGeom>
           <a:solidFill xmlns:a="http://schemas.openxmlformats.org/drawingml/2006/main">
-            <a:srgbClr val="E7F0EA"/>
+            <a:srgbClr val="E8EFE4"/>
           </a:solidFill>
           <a:ln xmlns:a="http://schemas.openxmlformats.org/drawingml/2006/main" w="9525">
             <a:solidFill>
-              <a:srgbClr val="2E7752"/>
+              <a:srgbClr val="466B4A"/>
             </a:solidFill>
             <a:prstDash val="solid"/>
           </a:ln>
@@ -2149,7 +2149,7 @@
           <p:cNvPr id="26" name="field-name-0-0">
             <a:extLst xmlns:a="http://schemas.openxmlformats.org/drawingml/2006/main">
               <a:ext uri="{FF2B5EF4-FFF2-40B4-BE49-F238E27FC236}">
-                <a16:creationId xmlns:a16="http://schemas.microsoft.com/office/drawing/2014/main" id="{FCEB5378-BF3E-4222-828C-77D63323A3E3}"/>
+                <a16:creationId xmlns:a16="http://schemas.microsoft.com/office/drawing/2014/main" id="{7D00552F-34D7-49FF-9AF2-F42B46DDE29D}"/>
               </a:ext>
             </a:extLst>
           </p:cNvPr>
@@ -2179,14 +2179,14 @@
             <a:pPr algn="ctr">
               <a:defRPr sz="825" b="1">
                 <a:solidFill>
-                  <a:srgbClr val="191B1A"/>
+                  <a:srgbClr val="24211D"/>
                 </a:solidFill>
               </a:defRPr>
             </a:pPr>
             <a:r>
               <a:rPr sz="825" b="1">
                 <a:solidFill>
-                  <a:srgbClr val="191B1A"/>
+                  <a:srgbClr val="24211D"/>
                 </a:solidFill>
               </a:rPr>
               <a:t>profile</a:t>
@@ -2199,7 +2199,7 @@
           <p:cNvPr id="27" name="field-source-0-0">
             <a:extLst xmlns:a="http://schemas.openxmlformats.org/drawingml/2006/main">
               <a:ext uri="{FF2B5EF4-FFF2-40B4-BE49-F238E27FC236}">
-                <a16:creationId xmlns:a16="http://schemas.microsoft.com/office/drawing/2014/main" id="{714708BF-3146-433C-928D-8D03F9051EFF}"/>
+                <a16:creationId xmlns:a16="http://schemas.microsoft.com/office/drawing/2014/main" id="{E3423096-E8C3-429D-A462-E569A1C1E76E}"/>
               </a:ext>
             </a:extLst>
           </p:cNvPr>
@@ -2229,14 +2229,14 @@
             <a:pPr algn="ctr">
               <a:defRPr sz="900" b="1">
                 <a:solidFill>
-                  <a:srgbClr val="2E7752"/>
+                  <a:srgbClr val="466B4A"/>
                 </a:solidFill>
               </a:defRPr>
             </a:pPr>
             <a:r>
               <a:rPr sz="900" b="1">
                 <a:solidFill>
-                  <a:srgbClr val="2E7752"/>
+                  <a:srgbClr val="466B4A"/>
                 </a:solidFill>
               </a:rPr>
               <a:t>S1</a:t>
@@ -2249,7 +2249,7 @@
           <p:cNvPr id="28" name="field-0-1">
             <a:extLst xmlns:a="http://schemas.openxmlformats.org/drawingml/2006/main">
               <a:ext uri="{FF2B5EF4-FFF2-40B4-BE49-F238E27FC236}">
-                <a16:creationId xmlns:a16="http://schemas.microsoft.com/office/drawing/2014/main" id="{A92E7ABA-DBFC-4C59-A663-7211DFB77714}"/>
+                <a16:creationId xmlns:a16="http://schemas.microsoft.com/office/drawing/2014/main" id="{40A02BA5-473C-42D2-B506-151B2795ADF2}"/>
               </a:ext>
             </a:extLst>
           </p:cNvPr>
@@ -2269,11 +2269,11 @@
             </a:avLst>
           </a:prstGeom>
           <a:solidFill xmlns:a="http://schemas.openxmlformats.org/drawingml/2006/main">
-            <a:srgbClr val="E7F0EA"/>
+            <a:srgbClr val="E8EFE4"/>
           </a:solidFill>
           <a:ln xmlns:a="http://schemas.openxmlformats.org/drawingml/2006/main" w="9525">
             <a:solidFill>
-              <a:srgbClr val="2E7752"/>
+              <a:srgbClr val="466B4A"/>
             </a:solidFill>
             <a:prstDash val="solid"/>
           </a:ln>
@@ -2284,7 +2284,7 @@
           <p:cNvPr id="29" name="field-name-0-1">
             <a:extLst xmlns:a="http://schemas.openxmlformats.org/drawingml/2006/main">
               <a:ext uri="{FF2B5EF4-FFF2-40B4-BE49-F238E27FC236}">
-                <a16:creationId xmlns:a16="http://schemas.microsoft.com/office/drawing/2014/main" id="{E9FAC96E-9E6F-4FF1-B1E0-0646330B2C6E}"/>
+                <a16:creationId xmlns:a16="http://schemas.microsoft.com/office/drawing/2014/main" id="{AD2AF719-7C95-453F-97DC-EEF090A12AE0}"/>
               </a:ext>
             </a:extLst>
           </p:cNvPr>
@@ -2314,14 +2314,14 @@
             <a:pPr algn="ctr">
               <a:defRPr sz="825" b="1">
                 <a:solidFill>
-                  <a:srgbClr val="191B1A"/>
+                  <a:srgbClr val="24211D"/>
                 </a:solidFill>
               </a:defRPr>
             </a:pPr>
             <a:r>
               <a:rPr sz="825" b="1">
                 <a:solidFill>
-                  <a:srgbClr val="191B1A"/>
+                  <a:srgbClr val="24211D"/>
                 </a:solidFill>
               </a:rPr>
               <a:t>price</a:t>
@@ -2334,7 +2334,7 @@
           <p:cNvPr id="30" name="field-source-0-1">
             <a:extLst xmlns:a="http://schemas.openxmlformats.org/drawingml/2006/main">
               <a:ext uri="{FF2B5EF4-FFF2-40B4-BE49-F238E27FC236}">
-                <a16:creationId xmlns:a16="http://schemas.microsoft.com/office/drawing/2014/main" id="{9CE97D37-CBD0-4D7A-9AE2-F991AEEC26D0}"/>
+                <a16:creationId xmlns:a16="http://schemas.microsoft.com/office/drawing/2014/main" id="{1A850C04-23FD-49E0-87C8-781DDE5C831B}"/>
               </a:ext>
             </a:extLst>
           </p:cNvPr>
@@ -2364,14 +2364,14 @@
             <a:pPr algn="ctr">
               <a:defRPr sz="900" b="1">
                 <a:solidFill>
-                  <a:srgbClr val="2E7752"/>
+                  <a:srgbClr val="466B4A"/>
                 </a:solidFill>
               </a:defRPr>
             </a:pPr>
             <a:r>
               <a:rPr sz="900" b="1">
                 <a:solidFill>
-                  <a:srgbClr val="2E7752"/>
+                  <a:srgbClr val="466B4A"/>
                 </a:solidFill>
               </a:rPr>
               <a:t>S2</a:t>
@@ -2384,7 +2384,7 @@
           <p:cNvPr id="31" name="field-0-2">
             <a:extLst xmlns:a="http://schemas.openxmlformats.org/drawingml/2006/main">
               <a:ext uri="{FF2B5EF4-FFF2-40B4-BE49-F238E27FC236}">
-                <a16:creationId xmlns:a16="http://schemas.microsoft.com/office/drawing/2014/main" id="{39F3502B-2308-41C7-A129-B39497CCF60E}"/>
+                <a16:creationId xmlns:a16="http://schemas.microsoft.com/office/drawing/2014/main" id="{E4B2D5A9-F348-4290-8877-1C1FF3CF868E}"/>
               </a:ext>
             </a:extLst>
           </p:cNvPr>
@@ -2404,11 +2404,11 @@
             </a:avLst>
           </a:prstGeom>
           <a:solidFill xmlns:a="http://schemas.openxmlformats.org/drawingml/2006/main">
-            <a:srgbClr val="E7F0EA"/>
+            <a:srgbClr val="E8EFE4"/>
           </a:solidFill>
           <a:ln xmlns:a="http://schemas.openxmlformats.org/drawingml/2006/main" w="9525">
             <a:solidFill>
-              <a:srgbClr val="2E7752"/>
+              <a:srgbClr val="466B4A"/>
             </a:solidFill>
             <a:prstDash val="solid"/>
           </a:ln>
@@ -2419,7 +2419,7 @@
           <p:cNvPr id="32" name="field-name-0-2">
             <a:extLst xmlns:a="http://schemas.openxmlformats.org/drawingml/2006/main">
               <a:ext uri="{FF2B5EF4-FFF2-40B4-BE49-F238E27FC236}">
-                <a16:creationId xmlns:a16="http://schemas.microsoft.com/office/drawing/2014/main" id="{BC7DFBCE-1FA2-4C90-9DCA-3096F436576B}"/>
+                <a16:creationId xmlns:a16="http://schemas.microsoft.com/office/drawing/2014/main" id="{EADCABBE-7E19-4834-AB52-CBFEF850D14A}"/>
               </a:ext>
             </a:extLst>
           </p:cNvPr>
@@ -2449,14 +2449,14 @@
             <a:pPr algn="ctr">
               <a:defRPr sz="825" b="1">
                 <a:solidFill>
-                  <a:srgbClr val="191B1A"/>
+                  <a:srgbClr val="24211D"/>
                 </a:solidFill>
               </a:defRPr>
             </a:pPr>
             <a:r>
               <a:rPr sz="825" b="1">
                 <a:solidFill>
-                  <a:srgbClr val="191B1A"/>
+                  <a:srgbClr val="24211D"/>
                 </a:solidFill>
               </a:rPr>
               <a:t>OSS</a:t>
@@ -2469,7 +2469,7 @@
           <p:cNvPr id="33" name="field-source-0-2">
             <a:extLst xmlns:a="http://schemas.openxmlformats.org/drawingml/2006/main">
               <a:ext uri="{FF2B5EF4-FFF2-40B4-BE49-F238E27FC236}">
-                <a16:creationId xmlns:a16="http://schemas.microsoft.com/office/drawing/2014/main" id="{CDCBA724-7CF1-4290-BD5C-CD48CF180800}"/>
+                <a16:creationId xmlns:a16="http://schemas.microsoft.com/office/drawing/2014/main" id="{08873A0E-A22E-4469-98D3-6C1613EAB214}"/>
               </a:ext>
             </a:extLst>
           </p:cNvPr>
@@ -2499,14 +2499,14 @@
             <a:pPr algn="ctr">
               <a:defRPr sz="900" b="1">
                 <a:solidFill>
-                  <a:srgbClr val="2E7752"/>
+                  <a:srgbClr val="466B4A"/>
                 </a:solidFill>
               </a:defRPr>
             </a:pPr>
             <a:r>
               <a:rPr sz="900" b="1">
                 <a:solidFill>
-                  <a:srgbClr val="2E7752"/>
+                  <a:srgbClr val="466B4A"/>
                 </a:solidFill>
               </a:rPr>
               <a:t>S1</a:t>
@@ -2519,7 +2519,7 @@
           <p:cNvPr id="34" name="field-0-3">
             <a:extLst xmlns:a="http://schemas.openxmlformats.org/drawingml/2006/main">
               <a:ext uri="{FF2B5EF4-FFF2-40B4-BE49-F238E27FC236}">
-                <a16:creationId xmlns:a16="http://schemas.microsoft.com/office/drawing/2014/main" id="{D0AC3028-F153-4EC3-B08B-BFEA8E11EE5D}"/>
+                <a16:creationId xmlns:a16="http://schemas.microsoft.com/office/drawing/2014/main" id="{54D6870A-EBC4-4364-A61D-B868AD9A91D5}"/>
               </a:ext>
             </a:extLst>
           </p:cNvPr>
@@ -2539,11 +2539,11 @@
             </a:avLst>
           </a:prstGeom>
           <a:solidFill xmlns:a="http://schemas.openxmlformats.org/drawingml/2006/main">
-            <a:srgbClr val="E7F0EA"/>
+            <a:srgbClr val="E8EFE4"/>
           </a:solidFill>
           <a:ln xmlns:a="http://schemas.openxmlformats.org/drawingml/2006/main" w="9525">
             <a:solidFill>
-              <a:srgbClr val="2E7752"/>
+              <a:srgbClr val="466B4A"/>
             </a:solidFill>
             <a:prstDash val="solid"/>
           </a:ln>
@@ -2554,7 +2554,7 @@
           <p:cNvPr id="35" name="field-name-0-3">
             <a:extLst xmlns:a="http://schemas.openxmlformats.org/drawingml/2006/main">
               <a:ext uri="{FF2B5EF4-FFF2-40B4-BE49-F238E27FC236}">
-                <a16:creationId xmlns:a16="http://schemas.microsoft.com/office/drawing/2014/main" id="{558A9B4A-84DA-40A0-AE30-505361539CD4}"/>
+                <a16:creationId xmlns:a16="http://schemas.microsoft.com/office/drawing/2014/main" id="{F3F707C0-1858-4E86-B542-186CB031CE19}"/>
               </a:ext>
             </a:extLst>
           </p:cNvPr>
@@ -2584,14 +2584,14 @@
             <a:pPr algn="ctr">
               <a:defRPr sz="825" b="1">
                 <a:solidFill>
-                  <a:srgbClr val="191B1A"/>
+                  <a:srgbClr val="24211D"/>
                 </a:solidFill>
               </a:defRPr>
             </a:pPr>
             <a:r>
               <a:rPr sz="825" b="1">
                 <a:solidFill>
-                  <a:srgbClr val="191B1A"/>
+                  <a:srgbClr val="24211D"/>
                 </a:solidFill>
               </a:rPr>
               <a:t>API</a:t>
@@ -2604,7 +2604,7 @@
           <p:cNvPr id="36" name="field-source-0-3">
             <a:extLst xmlns:a="http://schemas.openxmlformats.org/drawingml/2006/main">
               <a:ext uri="{FF2B5EF4-FFF2-40B4-BE49-F238E27FC236}">
-                <a16:creationId xmlns:a16="http://schemas.microsoft.com/office/drawing/2014/main" id="{E695A77C-D2B5-4B08-8FD5-873AD21D8FB6}"/>
+                <a16:creationId xmlns:a16="http://schemas.microsoft.com/office/drawing/2014/main" id="{2FDD91C2-97C7-4834-A65B-03248682562E}"/>
               </a:ext>
             </a:extLst>
           </p:cNvPr>
@@ -2634,14 +2634,14 @@
             <a:pPr algn="ctr">
               <a:defRPr sz="900" b="1">
                 <a:solidFill>
-                  <a:srgbClr val="2E7752"/>
+                  <a:srgbClr val="466B4A"/>
                 </a:solidFill>
               </a:defRPr>
             </a:pPr>
             <a:r>
               <a:rPr sz="900" b="1">
                 <a:solidFill>
-                  <a:srgbClr val="2E7752"/>
+                  <a:srgbClr val="466B4A"/>
                 </a:solidFill>
               </a:rPr>
               <a:t>S1</a:t>
@@ -2654,7 +2654,7 @@
           <p:cNvPr id="37" name="field-0-4">
             <a:extLst xmlns:a="http://schemas.openxmlformats.org/drawingml/2006/main">
               <a:ext uri="{FF2B5EF4-FFF2-40B4-BE49-F238E27FC236}">
-                <a16:creationId xmlns:a16="http://schemas.microsoft.com/office/drawing/2014/main" id="{036AEF1F-A565-4CA8-ACC5-CC7154AF062D}"/>
+                <a16:creationId xmlns:a16="http://schemas.microsoft.com/office/drawing/2014/main" id="{2F3B2731-18A5-423D-9736-EAE2107607DE}"/>
               </a:ext>
             </a:extLst>
           </p:cNvPr>
@@ -2674,11 +2674,11 @@
             </a:avLst>
           </a:prstGeom>
           <a:solidFill xmlns:a="http://schemas.openxmlformats.org/drawingml/2006/main">
-            <a:srgbClr val="E7F0EA"/>
+            <a:srgbClr val="E8EFE4"/>
           </a:solidFill>
           <a:ln xmlns:a="http://schemas.openxmlformats.org/drawingml/2006/main" w="9525">
             <a:solidFill>
-              <a:srgbClr val="2E7752"/>
+              <a:srgbClr val="466B4A"/>
             </a:solidFill>
             <a:prstDash val="solid"/>
           </a:ln>
@@ -2689,7 +2689,7 @@
           <p:cNvPr id="38" name="field-name-0-4">
             <a:extLst xmlns:a="http://schemas.openxmlformats.org/drawingml/2006/main">
               <a:ext uri="{FF2B5EF4-FFF2-40B4-BE49-F238E27FC236}">
-                <a16:creationId xmlns:a16="http://schemas.microsoft.com/office/drawing/2014/main" id="{A5B60F9E-1901-462A-A1C1-4C31852A1F6E}"/>
+                <a16:creationId xmlns:a16="http://schemas.microsoft.com/office/drawing/2014/main" id="{182C9F33-5423-4BAC-A885-7C444B0DC306}"/>
               </a:ext>
             </a:extLst>
           </p:cNvPr>
@@ -2719,14 +2719,14 @@
             <a:pPr algn="ctr">
               <a:defRPr sz="825" b="1">
                 <a:solidFill>
-                  <a:srgbClr val="191B1A"/>
+                  <a:srgbClr val="24211D"/>
                 </a:solidFill>
               </a:defRPr>
             </a:pPr>
             <a:r>
               <a:rPr sz="825" b="1">
                 <a:solidFill>
-                  <a:srgbClr val="191B1A"/>
+                  <a:srgbClr val="24211D"/>
                 </a:solidFill>
               </a:rPr>
               <a:t>SDKs</a:t>
@@ -2739,7 +2739,7 @@
           <p:cNvPr id="39" name="field-source-0-4">
             <a:extLst xmlns:a="http://schemas.openxmlformats.org/drawingml/2006/main">
               <a:ext uri="{FF2B5EF4-FFF2-40B4-BE49-F238E27FC236}">
-                <a16:creationId xmlns:a16="http://schemas.microsoft.com/office/drawing/2014/main" id="{D4652FAB-75F3-4F9E-BC69-3DC8B8D845CA}"/>
+                <a16:creationId xmlns:a16="http://schemas.microsoft.com/office/drawing/2014/main" id="{1AB9BBE8-F6DC-45FB-B498-59A98DF7D070}"/>
               </a:ext>
             </a:extLst>
           </p:cNvPr>
@@ -2769,14 +2769,14 @@
             <a:pPr algn="ctr">
               <a:defRPr sz="900" b="1">
                 <a:solidFill>
-                  <a:srgbClr val="2E7752"/>
+                  <a:srgbClr val="466B4A"/>
                 </a:solidFill>
               </a:defRPr>
             </a:pPr>
             <a:r>
               <a:rPr sz="900" b="1">
                 <a:solidFill>
-                  <a:srgbClr val="2E7752"/>
+                  <a:srgbClr val="466B4A"/>
                 </a:solidFill>
               </a:rPr>
               <a:t>S1</a:t>
@@ -2789,7 +2789,7 @@
           <p:cNvPr id="40" name="field-0-5">
             <a:extLst xmlns:a="http://schemas.openxmlformats.org/drawingml/2006/main">
               <a:ext uri="{FF2B5EF4-FFF2-40B4-BE49-F238E27FC236}">
-                <a16:creationId xmlns:a16="http://schemas.microsoft.com/office/drawing/2014/main" id="{CF7AB387-CC09-420C-8CA0-45C21F79A136}"/>
+                <a16:creationId xmlns:a16="http://schemas.microsoft.com/office/drawing/2014/main" id="{071DE66D-8566-40F8-A7B4-A0CF64C99579}"/>
               </a:ext>
             </a:extLst>
           </p:cNvPr>
@@ -2809,11 +2809,11 @@
             </a:avLst>
           </a:prstGeom>
           <a:solidFill xmlns:a="http://schemas.openxmlformats.org/drawingml/2006/main">
-            <a:srgbClr val="E7F0EA"/>
+            <a:srgbClr val="E8EFE4"/>
           </a:solidFill>
           <a:ln xmlns:a="http://schemas.openxmlformats.org/drawingml/2006/main" w="9525">
             <a:solidFill>
-              <a:srgbClr val="2E7752"/>
+              <a:srgbClr val="466B4A"/>
             </a:solidFill>
             <a:prstDash val="solid"/>
           </a:ln>
@@ -2824,7 +2824,7 @@
           <p:cNvPr id="41" name="field-name-0-5">
             <a:extLst xmlns:a="http://schemas.openxmlformats.org/drawingml/2006/main">
               <a:ext uri="{FF2B5EF4-FFF2-40B4-BE49-F238E27FC236}">
-                <a16:creationId xmlns:a16="http://schemas.microsoft.com/office/drawing/2014/main" id="{BFEFA6D7-EA39-41F1-8D91-E63FF42E3F34}"/>
+                <a16:creationId xmlns:a16="http://schemas.microsoft.com/office/drawing/2014/main" id="{F6068AB6-6ACC-40C2-BD07-75868FCC66D8}"/>
               </a:ext>
             </a:extLst>
           </p:cNvPr>
@@ -2854,14 +2854,14 @@
             <a:pPr algn="ctr">
               <a:defRPr sz="825" b="1">
                 <a:solidFill>
-                  <a:srgbClr val="191B1A"/>
+                  <a:srgbClr val="24211D"/>
                 </a:solidFill>
               </a:defRPr>
             </a:pPr>
             <a:r>
               <a:rPr sz="825" b="1">
                 <a:solidFill>
-                  <a:srgbClr val="191B1A"/>
+                  <a:srgbClr val="24211D"/>
                 </a:solidFill>
               </a:rPr>
               <a:t>integr.</a:t>
@@ -2874,7 +2874,7 @@
           <p:cNvPr id="42" name="field-source-0-5">
             <a:extLst xmlns:a="http://schemas.openxmlformats.org/drawingml/2006/main">
               <a:ext uri="{FF2B5EF4-FFF2-40B4-BE49-F238E27FC236}">
-                <a16:creationId xmlns:a16="http://schemas.microsoft.com/office/drawing/2014/main" id="{D5CD281A-17D7-4472-8FBF-D374A02C9C62}"/>
+                <a16:creationId xmlns:a16="http://schemas.microsoft.com/office/drawing/2014/main" id="{B1E402F7-50A5-4FE7-B219-9A69CFCE0A4A}"/>
               </a:ext>
             </a:extLst>
           </p:cNvPr>
@@ -2904,14 +2904,14 @@
             <a:pPr algn="ctr">
               <a:defRPr sz="900" b="1">
                 <a:solidFill>
-                  <a:srgbClr val="2E7752"/>
+                  <a:srgbClr val="466B4A"/>
                 </a:solidFill>
               </a:defRPr>
             </a:pPr>
             <a:r>
               <a:rPr sz="900" b="1">
                 <a:solidFill>
-                  <a:srgbClr val="2E7752"/>
+                  <a:srgbClr val="466B4A"/>
                 </a:solidFill>
               </a:rPr>
               <a:t>S1</a:t>
@@ -2924,7 +2924,7 @@
           <p:cNvPr id="43" name="validation-0">
             <a:extLst xmlns:a="http://schemas.openxmlformats.org/drawingml/2006/main">
               <a:ext uri="{FF2B5EF4-FFF2-40B4-BE49-F238E27FC236}">
-                <a16:creationId xmlns:a16="http://schemas.microsoft.com/office/drawing/2014/main" id="{E6939EDD-7971-4303-A528-51CD520DE4C1}"/>
+                <a16:creationId xmlns:a16="http://schemas.microsoft.com/office/drawing/2014/main" id="{D150C33F-908C-403E-ABFE-F6EBB7EF53BE}"/>
               </a:ext>
             </a:extLst>
           </p:cNvPr>
@@ -2954,14 +2954,14 @@
             <a:pPr algn="l">
               <a:defRPr sz="788" b="0">
                 <a:solidFill>
-                  <a:srgbClr val="656A67"/>
+                  <a:srgbClr val="6B655E"/>
                 </a:solidFill>
               </a:defRPr>
             </a:pPr>
             <a:r>
               <a:rPr sz="788" b="0">
                 <a:solidFill>
-                  <a:srgbClr val="656A67"/>
+                  <a:srgbClr val="6B655E"/>
                 </a:solidFill>
               </a:rPr>
               <a:t>6 fields · source IDs validated against this profile’s two retained sources</a:t>
@@ -2974,7 +2974,7 @@
           <p:cNvPr id="44" name="tool-1">
             <a:extLst xmlns:a="http://schemas.openxmlformats.org/drawingml/2006/main">
               <a:ext uri="{FF2B5EF4-FFF2-40B4-BE49-F238E27FC236}">
-                <a16:creationId xmlns:a16="http://schemas.microsoft.com/office/drawing/2014/main" id="{4645637F-779F-4636-AA6B-AD1D09EE6952}"/>
+                <a16:creationId xmlns:a16="http://schemas.microsoft.com/office/drawing/2014/main" id="{117386EB-D26D-47B7-89B8-F4A2187B0EAB}"/>
               </a:ext>
             </a:extLst>
           </p:cNvPr>
@@ -3004,14 +3004,14 @@
             <a:pPr algn="l">
               <a:defRPr sz="1350" b="1">
                 <a:solidFill>
-                  <a:srgbClr val="2B6F9E"/>
+                  <a:srgbClr val="B85F36"/>
                 </a:solidFill>
               </a:defRPr>
             </a:pPr>
             <a:r>
               <a:rPr sz="1350" b="1">
                 <a:solidFill>
-                  <a:srgbClr val="2B6F9E"/>
+                  <a:srgbClr val="B85F36"/>
                 </a:solidFill>
               </a:rPr>
               <a:t>Pinecone</a:t>
@@ -3024,7 +3024,7 @@
           <p:cNvPr id="45" name="status-1">
             <a:extLst xmlns:a="http://schemas.openxmlformats.org/drawingml/2006/main">
               <a:ext uri="{FF2B5EF4-FFF2-40B4-BE49-F238E27FC236}">
-                <a16:creationId xmlns:a16="http://schemas.microsoft.com/office/drawing/2014/main" id="{EA44F0DC-0BA3-435D-8865-18317999E06E}"/>
+                <a16:creationId xmlns:a16="http://schemas.microsoft.com/office/drawing/2014/main" id="{80927E18-7FDC-4DB2-96DF-80978DD7160A}"/>
               </a:ext>
             </a:extLst>
           </p:cNvPr>
@@ -3054,14 +3054,14 @@
             <a:pPr algn="l">
               <a:defRPr sz="825" b="0">
                 <a:solidFill>
-                  <a:srgbClr val="656A67"/>
+                  <a:srgbClr val="6B655E"/>
                 </a:solidFill>
               </a:defRPr>
             </a:pPr>
             <a:r>
               <a:rPr sz="825" b="0">
                 <a:solidFill>
-                  <a:srgbClr val="656A67"/>
+                  <a:srgbClr val="6B655E"/>
                 </a:solidFill>
               </a:rPr>
               <a:t>complete</a:t>
@@ -3074,7 +3074,7 @@
           <p:cNvPr id="46" name="source-doc-1">
             <a:extLst xmlns:a="http://schemas.openxmlformats.org/drawingml/2006/main">
               <a:ext uri="{FF2B5EF4-FFF2-40B4-BE49-F238E27FC236}">
-                <a16:creationId xmlns:a16="http://schemas.microsoft.com/office/drawing/2014/main" id="{07331A3B-1519-4A63-B70C-F944120A803E}"/>
+                <a16:creationId xmlns:a16="http://schemas.microsoft.com/office/drawing/2014/main" id="{E56F2C24-8964-4515-8FEF-0CF3AFBF25A2}"/>
               </a:ext>
             </a:extLst>
           </p:cNvPr>
@@ -3094,11 +3094,11 @@
             </a:avLst>
           </a:prstGeom>
           <a:solidFill xmlns:a="http://schemas.openxmlformats.org/drawingml/2006/main">
-            <a:srgbClr val="FFFFFF"/>
+            <a:srgbClr val="FFFDF7"/>
           </a:solidFill>
           <a:ln xmlns:a="http://schemas.openxmlformats.org/drawingml/2006/main" w="9525">
             <a:solidFill>
-              <a:srgbClr val="2B6F9E"/>
+              <a:srgbClr val="B85F36"/>
             </a:solidFill>
             <a:prstDash val="solid"/>
           </a:ln>
@@ -3109,7 +3109,7 @@
           <p:cNvPr id="47" name="source-doc-text-1">
             <a:extLst xmlns:a="http://schemas.openxmlformats.org/drawingml/2006/main">
               <a:ext uri="{FF2B5EF4-FFF2-40B4-BE49-F238E27FC236}">
-                <a16:creationId xmlns:a16="http://schemas.microsoft.com/office/drawing/2014/main" id="{B6E37971-88F1-4C1F-AB8A-EEC078057B77}"/>
+                <a16:creationId xmlns:a16="http://schemas.microsoft.com/office/drawing/2014/main" id="{CD033F29-325E-4AB0-B27C-6111EEF7527C}"/>
               </a:ext>
             </a:extLst>
           </p:cNvPr>
@@ -3139,14 +3139,14 @@
             <a:pPr algn="l">
               <a:defRPr sz="900" b="1">
                 <a:solidFill>
-                  <a:srgbClr val="2B6F9E"/>
+                  <a:srgbClr val="B85F36"/>
                 </a:solidFill>
               </a:defRPr>
             </a:pPr>
             <a:r>
               <a:rPr sz="900" b="1">
                 <a:solidFill>
-                  <a:srgbClr val="2B6F9E"/>
+                  <a:srgbClr val="B85F36"/>
                 </a:solidFill>
               </a:rPr>
               <a:t>S1  docs</a:t>
@@ -3159,7 +3159,7 @@
           <p:cNvPr id="48" name="source-price-1">
             <a:extLst xmlns:a="http://schemas.openxmlformats.org/drawingml/2006/main">
               <a:ext uri="{FF2B5EF4-FFF2-40B4-BE49-F238E27FC236}">
-                <a16:creationId xmlns:a16="http://schemas.microsoft.com/office/drawing/2014/main" id="{B255DC8F-3442-4D54-94C1-78E9A81B11E5}"/>
+                <a16:creationId xmlns:a16="http://schemas.microsoft.com/office/drawing/2014/main" id="{43E6AAE3-F2BD-4465-8082-F36B445409AB}"/>
               </a:ext>
             </a:extLst>
           </p:cNvPr>
@@ -3179,11 +3179,11 @@
             </a:avLst>
           </a:prstGeom>
           <a:solidFill xmlns:a="http://schemas.openxmlformats.org/drawingml/2006/main">
-            <a:srgbClr val="FFFFFF"/>
+            <a:srgbClr val="FFFDF7"/>
           </a:solidFill>
           <a:ln xmlns:a="http://schemas.openxmlformats.org/drawingml/2006/main" w="9525">
             <a:solidFill>
-              <a:srgbClr val="2B6F9E"/>
+              <a:srgbClr val="B85F36"/>
             </a:solidFill>
             <a:prstDash val="solid"/>
           </a:ln>
@@ -3194,7 +3194,7 @@
           <p:cNvPr id="49" name="source-price-text-1">
             <a:extLst xmlns:a="http://schemas.openxmlformats.org/drawingml/2006/main">
               <a:ext uri="{FF2B5EF4-FFF2-40B4-BE49-F238E27FC236}">
-                <a16:creationId xmlns:a16="http://schemas.microsoft.com/office/drawing/2014/main" id="{54CCEED2-9B07-4444-83DF-86EABFDE3E28}"/>
+                <a16:creationId xmlns:a16="http://schemas.microsoft.com/office/drawing/2014/main" id="{22098DAE-BB36-4E2E-AD38-58AA137A7A94}"/>
               </a:ext>
             </a:extLst>
           </p:cNvPr>
@@ -3224,14 +3224,14 @@
             <a:pPr algn="l">
               <a:defRPr sz="900" b="1">
                 <a:solidFill>
-                  <a:srgbClr val="2B6F9E"/>
+                  <a:srgbClr val="B85F36"/>
                 </a:solidFill>
               </a:defRPr>
             </a:pPr>
             <a:r>
               <a:rPr sz="900" b="1">
                 <a:solidFill>
-                  <a:srgbClr val="2B6F9E"/>
+                  <a:srgbClr val="B85F36"/>
                 </a:solidFill>
               </a:rPr>
               <a:t>S2  pricing</a:t>
@@ -3244,7 +3244,7 @@
           <p:cNvPr id="50" name="lane-rule-1">
             <a:extLst xmlns:a="http://schemas.openxmlformats.org/drawingml/2006/main">
               <a:ext uri="{FF2B5EF4-FFF2-40B4-BE49-F238E27FC236}">
-                <a16:creationId xmlns:a16="http://schemas.microsoft.com/office/drawing/2014/main" id="{1AF8A273-7BDC-4F96-AAF0-422BAF4A3530}"/>
+                <a16:creationId xmlns:a16="http://schemas.microsoft.com/office/drawing/2014/main" id="{051F8ACD-2E43-4E68-8723-C8B18A9B59DF}"/>
               </a:ext>
             </a:extLst>
           </p:cNvPr>
@@ -3264,7 +3264,7 @@
           <a:noFill xmlns:a="http://schemas.openxmlformats.org/drawingml/2006/main"/>
           <a:ln xmlns:a="http://schemas.openxmlformats.org/drawingml/2006/main" w="11430">
             <a:solidFill>
-              <a:srgbClr val="2B6F9E"/>
+              <a:srgbClr val="B85F36"/>
             </a:solidFill>
             <a:prstDash val="solid"/>
           </a:ln>
@@ -3275,7 +3275,7 @@
           <p:cNvPr id="51" name="field-1-0">
             <a:extLst xmlns:a="http://schemas.openxmlformats.org/drawingml/2006/main">
               <a:ext uri="{FF2B5EF4-FFF2-40B4-BE49-F238E27FC236}">
-                <a16:creationId xmlns:a16="http://schemas.microsoft.com/office/drawing/2014/main" id="{F702C33A-E9A5-4EFE-A1EB-EDEBEA10ADDF}"/>
+                <a16:creationId xmlns:a16="http://schemas.microsoft.com/office/drawing/2014/main" id="{430B6D40-8D0A-4426-BB10-23A8CA6FC2FB}"/>
               </a:ext>
             </a:extLst>
           </p:cNvPr>
@@ -3295,11 +3295,11 @@
             </a:avLst>
           </a:prstGeom>
           <a:solidFill xmlns:a="http://schemas.openxmlformats.org/drawingml/2006/main">
-            <a:srgbClr val="E7EFF5"/>
+            <a:srgbClr val="F4E3D9"/>
           </a:solidFill>
           <a:ln xmlns:a="http://schemas.openxmlformats.org/drawingml/2006/main" w="9525">
             <a:solidFill>
-              <a:srgbClr val="2B6F9E"/>
+              <a:srgbClr val="B85F36"/>
             </a:solidFill>
             <a:prstDash val="solid"/>
           </a:ln>
@@ -3310,7 +3310,7 @@
           <p:cNvPr id="52" name="field-name-1-0">
             <a:extLst xmlns:a="http://schemas.openxmlformats.org/drawingml/2006/main">
               <a:ext uri="{FF2B5EF4-FFF2-40B4-BE49-F238E27FC236}">
-                <a16:creationId xmlns:a16="http://schemas.microsoft.com/office/drawing/2014/main" id="{5C25AC96-B269-43AA-8262-E7E5091E66F7}"/>
+                <a16:creationId xmlns:a16="http://schemas.microsoft.com/office/drawing/2014/main" id="{284CC8E6-40AB-4783-908A-6CD909F276EF}"/>
               </a:ext>
             </a:extLst>
           </p:cNvPr>
@@ -3340,14 +3340,14 @@
             <a:pPr algn="ctr">
               <a:defRPr sz="825" b="1">
                 <a:solidFill>
-                  <a:srgbClr val="191B1A"/>
+                  <a:srgbClr val="24211D"/>
                 </a:solidFill>
               </a:defRPr>
             </a:pPr>
             <a:r>
               <a:rPr sz="825" b="1">
                 <a:solidFill>
-                  <a:srgbClr val="191B1A"/>
+                  <a:srgbClr val="24211D"/>
                 </a:solidFill>
               </a:rPr>
               <a:t>profile</a:t>
@@ -3360,7 +3360,7 @@
           <p:cNvPr id="53" name="field-source-1-0">
             <a:extLst xmlns:a="http://schemas.openxmlformats.org/drawingml/2006/main">
               <a:ext uri="{FF2B5EF4-FFF2-40B4-BE49-F238E27FC236}">
-                <a16:creationId xmlns:a16="http://schemas.microsoft.com/office/drawing/2014/main" id="{260D5C40-D7E1-4147-8EE0-40FD1548DD40}"/>
+                <a16:creationId xmlns:a16="http://schemas.microsoft.com/office/drawing/2014/main" id="{BBFE1C44-EDDA-4D6B-9A8D-088E77C26B24}"/>
               </a:ext>
             </a:extLst>
           </p:cNvPr>
@@ -3390,14 +3390,14 @@
             <a:pPr algn="ctr">
               <a:defRPr sz="900" b="1">
                 <a:solidFill>
-                  <a:srgbClr val="2B6F9E"/>
+                  <a:srgbClr val="B85F36"/>
                 </a:solidFill>
               </a:defRPr>
             </a:pPr>
             <a:r>
               <a:rPr sz="900" b="1">
                 <a:solidFill>
-                  <a:srgbClr val="2B6F9E"/>
+                  <a:srgbClr val="B85F36"/>
                 </a:solidFill>
               </a:rPr>
               <a:t>S1</a:t>
@@ -3410,7 +3410,7 @@
           <p:cNvPr id="54" name="field-1-1">
             <a:extLst xmlns:a="http://schemas.openxmlformats.org/drawingml/2006/main">
               <a:ext uri="{FF2B5EF4-FFF2-40B4-BE49-F238E27FC236}">
-                <a16:creationId xmlns:a16="http://schemas.microsoft.com/office/drawing/2014/main" id="{37AD4832-1961-4CCC-BBBE-B452C04EDED7}"/>
+                <a16:creationId xmlns:a16="http://schemas.microsoft.com/office/drawing/2014/main" id="{5B3E4DB4-A20E-47D9-BB40-237C8BC09363}"/>
               </a:ext>
             </a:extLst>
           </p:cNvPr>
@@ -3430,11 +3430,11 @@
             </a:avLst>
           </a:prstGeom>
           <a:solidFill xmlns:a="http://schemas.openxmlformats.org/drawingml/2006/main">
-            <a:srgbClr val="E7EFF5"/>
+            <a:srgbClr val="F4E3D9"/>
           </a:solidFill>
           <a:ln xmlns:a="http://schemas.openxmlformats.org/drawingml/2006/main" w="9525">
             <a:solidFill>
-              <a:srgbClr val="2B6F9E"/>
+              <a:srgbClr val="B85F36"/>
             </a:solidFill>
             <a:prstDash val="solid"/>
           </a:ln>
@@ -3445,7 +3445,7 @@
           <p:cNvPr id="55" name="field-name-1-1">
             <a:extLst xmlns:a="http://schemas.openxmlformats.org/drawingml/2006/main">
               <a:ext uri="{FF2B5EF4-FFF2-40B4-BE49-F238E27FC236}">
-                <a16:creationId xmlns:a16="http://schemas.microsoft.com/office/drawing/2014/main" id="{8EC0EDCC-6E61-4612-A178-907CEA5F3CE5}"/>
+                <a16:creationId xmlns:a16="http://schemas.microsoft.com/office/drawing/2014/main" id="{531D6C2C-92AE-4268-A0EC-0376472A59D1}"/>
               </a:ext>
             </a:extLst>
           </p:cNvPr>
@@ -3475,14 +3475,14 @@
             <a:pPr algn="ctr">
               <a:defRPr sz="825" b="1">
                 <a:solidFill>
-                  <a:srgbClr val="191B1A"/>
+                  <a:srgbClr val="24211D"/>
                 </a:solidFill>
               </a:defRPr>
             </a:pPr>
             <a:r>
               <a:rPr sz="825" b="1">
                 <a:solidFill>
-                  <a:srgbClr val="191B1A"/>
+                  <a:srgbClr val="24211D"/>
                 </a:solidFill>
               </a:rPr>
               <a:t>price</a:t>
@@ -3495,7 +3495,7 @@
           <p:cNvPr id="56" name="field-source-1-1">
             <a:extLst xmlns:a="http://schemas.openxmlformats.org/drawingml/2006/main">
               <a:ext uri="{FF2B5EF4-FFF2-40B4-BE49-F238E27FC236}">
-                <a16:creationId xmlns:a16="http://schemas.microsoft.com/office/drawing/2014/main" id="{0B8A7C9E-357D-4F4F-B91E-209184AE65CF}"/>
+                <a16:creationId xmlns:a16="http://schemas.microsoft.com/office/drawing/2014/main" id="{5721E41B-BF53-4C39-BC58-5315A7CCC60F}"/>
               </a:ext>
             </a:extLst>
           </p:cNvPr>
@@ -3525,14 +3525,14 @@
             <a:pPr algn="ctr">
               <a:defRPr sz="900" b="1">
                 <a:solidFill>
-                  <a:srgbClr val="2B6F9E"/>
+                  <a:srgbClr val="B85F36"/>
                 </a:solidFill>
               </a:defRPr>
             </a:pPr>
             <a:r>
               <a:rPr sz="900" b="1">
                 <a:solidFill>
-                  <a:srgbClr val="2B6F9E"/>
+                  <a:srgbClr val="B85F36"/>
                 </a:solidFill>
               </a:rPr>
               <a:t>S2</a:t>
@@ -3545,7 +3545,7 @@
           <p:cNvPr id="57" name="field-1-2">
             <a:extLst xmlns:a="http://schemas.openxmlformats.org/drawingml/2006/main">
               <a:ext uri="{FF2B5EF4-FFF2-40B4-BE49-F238E27FC236}">
-                <a16:creationId xmlns:a16="http://schemas.microsoft.com/office/drawing/2014/main" id="{40D8E816-D228-4E57-8912-7C6A6EE2B768}"/>
+                <a16:creationId xmlns:a16="http://schemas.microsoft.com/office/drawing/2014/main" id="{C46D1A26-FE03-4095-8E90-EA834BC7336D}"/>
               </a:ext>
             </a:extLst>
           </p:cNvPr>
@@ -3565,11 +3565,11 @@
             </a:avLst>
           </a:prstGeom>
           <a:solidFill xmlns:a="http://schemas.openxmlformats.org/drawingml/2006/main">
-            <a:srgbClr val="E7EFF5"/>
+            <a:srgbClr val="F4E3D9"/>
           </a:solidFill>
           <a:ln xmlns:a="http://schemas.openxmlformats.org/drawingml/2006/main" w="9525">
             <a:solidFill>
-              <a:srgbClr val="2B6F9E"/>
+              <a:srgbClr val="B85F36"/>
             </a:solidFill>
             <a:prstDash val="solid"/>
           </a:ln>
@@ -3580,7 +3580,7 @@
           <p:cNvPr id="58" name="field-name-1-2">
             <a:extLst xmlns:a="http://schemas.openxmlformats.org/drawingml/2006/main">
               <a:ext uri="{FF2B5EF4-FFF2-40B4-BE49-F238E27FC236}">
-                <a16:creationId xmlns:a16="http://schemas.microsoft.com/office/drawing/2014/main" id="{B53AE99E-C478-45DA-90E1-CC141224E06C}"/>
+                <a16:creationId xmlns:a16="http://schemas.microsoft.com/office/drawing/2014/main" id="{9B4556CD-C064-4920-A8E6-FA99E48E9D80}"/>
               </a:ext>
             </a:extLst>
           </p:cNvPr>
@@ -3610,14 +3610,14 @@
             <a:pPr algn="ctr">
               <a:defRPr sz="825" b="1">
                 <a:solidFill>
-                  <a:srgbClr val="191B1A"/>
+                  <a:srgbClr val="24211D"/>
                 </a:solidFill>
               </a:defRPr>
             </a:pPr>
             <a:r>
               <a:rPr sz="825" b="1">
                 <a:solidFill>
-                  <a:srgbClr val="191B1A"/>
+                  <a:srgbClr val="24211D"/>
                 </a:solidFill>
               </a:rPr>
               <a:t>OSS</a:t>
@@ -3630,7 +3630,7 @@
           <p:cNvPr id="59" name="field-source-1-2">
             <a:extLst xmlns:a="http://schemas.openxmlformats.org/drawingml/2006/main">
               <a:ext uri="{FF2B5EF4-FFF2-40B4-BE49-F238E27FC236}">
-                <a16:creationId xmlns:a16="http://schemas.microsoft.com/office/drawing/2014/main" id="{131DA625-CF26-4028-B7B9-64854148A823}"/>
+                <a16:creationId xmlns:a16="http://schemas.microsoft.com/office/drawing/2014/main" id="{B8F18657-68AB-4D52-9913-DF098CE0918F}"/>
               </a:ext>
             </a:extLst>
           </p:cNvPr>
@@ -3660,14 +3660,14 @@
             <a:pPr algn="ctr">
               <a:defRPr sz="900" b="1">
                 <a:solidFill>
-                  <a:srgbClr val="2B6F9E"/>
+                  <a:srgbClr val="B85F36"/>
                 </a:solidFill>
               </a:defRPr>
             </a:pPr>
             <a:r>
               <a:rPr sz="900" b="1">
                 <a:solidFill>
-                  <a:srgbClr val="2B6F9E"/>
+                  <a:srgbClr val="B85F36"/>
                 </a:solidFill>
               </a:rPr>
               <a:t>S1</a:t>
@@ -3680,7 +3680,7 @@
           <p:cNvPr id="60" name="field-1-3">
             <a:extLst xmlns:a="http://schemas.openxmlformats.org/drawingml/2006/main">
               <a:ext uri="{FF2B5EF4-FFF2-40B4-BE49-F238E27FC236}">
-                <a16:creationId xmlns:a16="http://schemas.microsoft.com/office/drawing/2014/main" id="{19674A3D-B612-494F-901A-92DC4E91E8B2}"/>
+                <a16:creationId xmlns:a16="http://schemas.microsoft.com/office/drawing/2014/main" id="{4BFDE87E-4B89-4090-A1D6-040A84CD390F}"/>
               </a:ext>
             </a:extLst>
           </p:cNvPr>
@@ -3700,11 +3700,11 @@
             </a:avLst>
           </a:prstGeom>
           <a:solidFill xmlns:a="http://schemas.openxmlformats.org/drawingml/2006/main">
-            <a:srgbClr val="E7EFF5"/>
+            <a:srgbClr val="F4E3D9"/>
           </a:solidFill>
           <a:ln xmlns:a="http://schemas.openxmlformats.org/drawingml/2006/main" w="9525">
             <a:solidFill>
-              <a:srgbClr val="2B6F9E"/>
+              <a:srgbClr val="B85F36"/>
             </a:solidFill>
             <a:prstDash val="solid"/>
           </a:ln>
@@ -3715,7 +3715,7 @@
           <p:cNvPr id="61" name="field-name-1-3">
             <a:extLst xmlns:a="http://schemas.openxmlformats.org/drawingml/2006/main">
               <a:ext uri="{FF2B5EF4-FFF2-40B4-BE49-F238E27FC236}">
-                <a16:creationId xmlns:a16="http://schemas.microsoft.com/office/drawing/2014/main" id="{068F06F8-C66A-4EBE-AB22-A4C59FC971A1}"/>
+                <a16:creationId xmlns:a16="http://schemas.microsoft.com/office/drawing/2014/main" id="{D970D7D7-FA4F-46D9-9ADD-D271BF418F45}"/>
               </a:ext>
             </a:extLst>
           </p:cNvPr>
@@ -3745,14 +3745,14 @@
             <a:pPr algn="ctr">
               <a:defRPr sz="825" b="1">
                 <a:solidFill>
-                  <a:srgbClr val="191B1A"/>
+                  <a:srgbClr val="24211D"/>
                 </a:solidFill>
               </a:defRPr>
             </a:pPr>
             <a:r>
               <a:rPr sz="825" b="1">
                 <a:solidFill>
-                  <a:srgbClr val="191B1A"/>
+                  <a:srgbClr val="24211D"/>
                 </a:solidFill>
               </a:rPr>
               <a:t>API</a:t>
@@ -3765,7 +3765,7 @@
           <p:cNvPr id="62" name="field-source-1-3">
             <a:extLst xmlns:a="http://schemas.openxmlformats.org/drawingml/2006/main">
               <a:ext uri="{FF2B5EF4-FFF2-40B4-BE49-F238E27FC236}">
-                <a16:creationId xmlns:a16="http://schemas.microsoft.com/office/drawing/2014/main" id="{C597BD6A-DCD7-41B0-BEFB-FE1720F97746}"/>
+                <a16:creationId xmlns:a16="http://schemas.microsoft.com/office/drawing/2014/main" id="{B59E2D88-89EB-4C42-95EF-3D9C1A2B8663}"/>
               </a:ext>
             </a:extLst>
           </p:cNvPr>
@@ -3795,14 +3795,14 @@
             <a:pPr algn="ctr">
               <a:defRPr sz="900" b="1">
                 <a:solidFill>
-                  <a:srgbClr val="2B6F9E"/>
+                  <a:srgbClr val="B85F36"/>
                 </a:solidFill>
               </a:defRPr>
             </a:pPr>
             <a:r>
               <a:rPr sz="900" b="1">
                 <a:solidFill>
-                  <a:srgbClr val="2B6F9E"/>
+                  <a:srgbClr val="B85F36"/>
                 </a:solidFill>
               </a:rPr>
               <a:t>S1</a:t>
@@ -3815,7 +3815,7 @@
           <p:cNvPr id="63" name="field-1-4">
             <a:extLst xmlns:a="http://schemas.openxmlformats.org/drawingml/2006/main">
               <a:ext uri="{FF2B5EF4-FFF2-40B4-BE49-F238E27FC236}">
-                <a16:creationId xmlns:a16="http://schemas.microsoft.com/office/drawing/2014/main" id="{468497EB-7382-49EC-99E9-187D93468F69}"/>
+                <a16:creationId xmlns:a16="http://schemas.microsoft.com/office/drawing/2014/main" id="{EF5C1B2B-C6E9-464F-9627-BB21F6C67C2B}"/>
               </a:ext>
             </a:extLst>
           </p:cNvPr>
@@ -3835,11 +3835,11 @@
             </a:avLst>
           </a:prstGeom>
           <a:solidFill xmlns:a="http://schemas.openxmlformats.org/drawingml/2006/main">
-            <a:srgbClr val="E7EFF5"/>
+            <a:srgbClr val="F4E3D9"/>
           </a:solidFill>
           <a:ln xmlns:a="http://schemas.openxmlformats.org/drawingml/2006/main" w="9525">
             <a:solidFill>
-              <a:srgbClr val="2B6F9E"/>
+              <a:srgbClr val="B85F36"/>
             </a:solidFill>
             <a:prstDash val="solid"/>
           </a:ln>
@@ -3850,7 +3850,7 @@
           <p:cNvPr id="64" name="field-name-1-4">
             <a:extLst xmlns:a="http://schemas.openxmlformats.org/drawingml/2006/main">
               <a:ext uri="{FF2B5EF4-FFF2-40B4-BE49-F238E27FC236}">
-                <a16:creationId xmlns:a16="http://schemas.microsoft.com/office/drawing/2014/main" id="{5EBD75C3-45BD-4E0F-A3BD-5C5DF895C3B1}"/>
+                <a16:creationId xmlns:a16="http://schemas.microsoft.com/office/drawing/2014/main" id="{4CBC8221-303C-412E-A50B-446436D17C44}"/>
               </a:ext>
             </a:extLst>
           </p:cNvPr>
@@ -3880,14 +3880,14 @@
             <a:pPr algn="ctr">
               <a:defRPr sz="825" b="1">
                 <a:solidFill>
-                  <a:srgbClr val="191B1A"/>
+                  <a:srgbClr val="24211D"/>
                 </a:solidFill>
               </a:defRPr>
             </a:pPr>
             <a:r>
               <a:rPr sz="825" b="1">
                 <a:solidFill>
-                  <a:srgbClr val="191B1A"/>
+                  <a:srgbClr val="24211D"/>
                 </a:solidFill>
               </a:rPr>
               <a:t>SDKs</a:t>
@@ -3900,7 +3900,7 @@
           <p:cNvPr id="65" name="field-source-1-4">
             <a:extLst xmlns:a="http://schemas.openxmlformats.org/drawingml/2006/main">
               <a:ext uri="{FF2B5EF4-FFF2-40B4-BE49-F238E27FC236}">
-                <a16:creationId xmlns:a16="http://schemas.microsoft.com/office/drawing/2014/main" id="{9018EB86-E932-4D3B-ABD2-66E76D5611EE}"/>
+                <a16:creationId xmlns:a16="http://schemas.microsoft.com/office/drawing/2014/main" id="{05CE1EE4-1176-4DAA-BA32-A2F3810017B6}"/>
               </a:ext>
             </a:extLst>
           </p:cNvPr>
@@ -3930,14 +3930,14 @@
             <a:pPr algn="ctr">
               <a:defRPr sz="900" b="1">
                 <a:solidFill>
-                  <a:srgbClr val="2B6F9E"/>
+                  <a:srgbClr val="B85F36"/>
                 </a:solidFill>
               </a:defRPr>
             </a:pPr>
             <a:r>
               <a:rPr sz="900" b="1">
                 <a:solidFill>
-                  <a:srgbClr val="2B6F9E"/>
+                  <a:srgbClr val="B85F36"/>
                 </a:solidFill>
               </a:rPr>
               <a:t>S1</a:t>
@@ -3950,7 +3950,7 @@
           <p:cNvPr id="66" name="field-1-5">
             <a:extLst xmlns:a="http://schemas.openxmlformats.org/drawingml/2006/main">
               <a:ext uri="{FF2B5EF4-FFF2-40B4-BE49-F238E27FC236}">
-                <a16:creationId xmlns:a16="http://schemas.microsoft.com/office/drawing/2014/main" id="{29B47D80-449E-489E-9E1C-DA1EBCB07B14}"/>
+                <a16:creationId xmlns:a16="http://schemas.microsoft.com/office/drawing/2014/main" id="{799069C6-BDF9-41CA-9BE0-DCB498C8794E}"/>
               </a:ext>
             </a:extLst>
           </p:cNvPr>
@@ -3970,11 +3970,11 @@
             </a:avLst>
           </a:prstGeom>
           <a:solidFill xmlns:a="http://schemas.openxmlformats.org/drawingml/2006/main">
-            <a:srgbClr val="E7EFF5"/>
+            <a:srgbClr val="F4E3D9"/>
           </a:solidFill>
           <a:ln xmlns:a="http://schemas.openxmlformats.org/drawingml/2006/main" w="9525">
             <a:solidFill>
-              <a:srgbClr val="2B6F9E"/>
+              <a:srgbClr val="B85F36"/>
             </a:solidFill>
             <a:prstDash val="solid"/>
           </a:ln>
@@ -3985,7 +3985,7 @@
           <p:cNvPr id="67" name="field-name-1-5">
             <a:extLst xmlns:a="http://schemas.openxmlformats.org/drawingml/2006/main">
               <a:ext uri="{FF2B5EF4-FFF2-40B4-BE49-F238E27FC236}">
-                <a16:creationId xmlns:a16="http://schemas.microsoft.com/office/drawing/2014/main" id="{1336EFEB-9B3D-4758-B74F-5264389C5669}"/>
+                <a16:creationId xmlns:a16="http://schemas.microsoft.com/office/drawing/2014/main" id="{113807FA-64EE-495A-866A-94492AC21DA8}"/>
               </a:ext>
             </a:extLst>
           </p:cNvPr>
@@ -4015,14 +4015,14 @@
             <a:pPr algn="ctr">
               <a:defRPr sz="825" b="1">
                 <a:solidFill>
-                  <a:srgbClr val="191B1A"/>
+                  <a:srgbClr val="24211D"/>
                 </a:solidFill>
               </a:defRPr>
             </a:pPr>
             <a:r>
               <a:rPr sz="825" b="1">
                 <a:solidFill>
-                  <a:srgbClr val="191B1A"/>
+                  <a:srgbClr val="24211D"/>
                 </a:solidFill>
               </a:rPr>
               <a:t>integr.</a:t>
@@ -4035,7 +4035,7 @@
           <p:cNvPr id="68" name="field-source-1-5">
             <a:extLst xmlns:a="http://schemas.openxmlformats.org/drawingml/2006/main">
               <a:ext uri="{FF2B5EF4-FFF2-40B4-BE49-F238E27FC236}">
-                <a16:creationId xmlns:a16="http://schemas.microsoft.com/office/drawing/2014/main" id="{7CA509A0-53ED-4927-9125-0C18FD81E860}"/>
+                <a16:creationId xmlns:a16="http://schemas.microsoft.com/office/drawing/2014/main" id="{ADAB6F35-86F7-4A9E-97E5-F704D3760D88}"/>
               </a:ext>
             </a:extLst>
           </p:cNvPr>
@@ -4065,14 +4065,14 @@
             <a:pPr algn="ctr">
               <a:defRPr sz="900" b="1">
                 <a:solidFill>
-                  <a:srgbClr val="2B6F9E"/>
+                  <a:srgbClr val="B85F36"/>
                 </a:solidFill>
               </a:defRPr>
             </a:pPr>
             <a:r>
               <a:rPr sz="900" b="1">
                 <a:solidFill>
-                  <a:srgbClr val="2B6F9E"/>
+                  <a:srgbClr val="B85F36"/>
                 </a:solidFill>
               </a:rPr>
               <a:t>S1</a:t>
@@ -4085,7 +4085,7 @@
           <p:cNvPr id="69" name="validation-1">
             <a:extLst xmlns:a="http://schemas.openxmlformats.org/drawingml/2006/main">
               <a:ext uri="{FF2B5EF4-FFF2-40B4-BE49-F238E27FC236}">
-                <a16:creationId xmlns:a16="http://schemas.microsoft.com/office/drawing/2014/main" id="{FA84E753-1E55-4255-844F-0FA79984D951}"/>
+                <a16:creationId xmlns:a16="http://schemas.microsoft.com/office/drawing/2014/main" id="{264D269F-427D-4D36-9463-BCD14CC8F48A}"/>
               </a:ext>
             </a:extLst>
           </p:cNvPr>
@@ -4115,14 +4115,14 @@
             <a:pPr algn="l">
               <a:defRPr sz="788" b="0">
                 <a:solidFill>
-                  <a:srgbClr val="656A67"/>
+                  <a:srgbClr val="6B655E"/>
                 </a:solidFill>
               </a:defRPr>
             </a:pPr>
             <a:r>
               <a:rPr sz="788" b="0">
                 <a:solidFill>
-                  <a:srgbClr val="656A67"/>
+                  <a:srgbClr val="6B655E"/>
                 </a:solidFill>
               </a:rPr>
               <a:t>6 fields · source IDs validated against this profile’s two retained sources</a:t>
@@ -4135,7 +4135,7 @@
           <p:cNvPr id="70" name="tool-2">
             <a:extLst xmlns:a="http://schemas.openxmlformats.org/drawingml/2006/main">
               <a:ext uri="{FF2B5EF4-FFF2-40B4-BE49-F238E27FC236}">
-                <a16:creationId xmlns:a16="http://schemas.microsoft.com/office/drawing/2014/main" id="{427E5F74-0CBB-4C60-8FAC-576245C3A247}"/>
+                <a16:creationId xmlns:a16="http://schemas.microsoft.com/office/drawing/2014/main" id="{6714475D-70A4-4719-918A-F47D7911ED25}"/>
               </a:ext>
             </a:extLst>
           </p:cNvPr>
@@ -4165,14 +4165,14 @@
             <a:pPr algn="l">
               <a:defRPr sz="1350" b="1">
                 <a:solidFill>
-                  <a:srgbClr val="73527E"/>
+                  <a:srgbClr val="6C4F70"/>
                 </a:solidFill>
               </a:defRPr>
             </a:pPr>
             <a:r>
               <a:rPr sz="1350" b="1">
                 <a:solidFill>
-                  <a:srgbClr val="73527E"/>
+                  <a:srgbClr val="6C4F70"/>
                 </a:solidFill>
               </a:rPr>
               <a:t>Qdrant</a:t>
@@ -4185,7 +4185,7 @@
           <p:cNvPr id="71" name="status-2">
             <a:extLst xmlns:a="http://schemas.openxmlformats.org/drawingml/2006/main">
               <a:ext uri="{FF2B5EF4-FFF2-40B4-BE49-F238E27FC236}">
-                <a16:creationId xmlns:a16="http://schemas.microsoft.com/office/drawing/2014/main" id="{F25F2DA0-E9A4-4EEB-B609-E1CDDF983EA1}"/>
+                <a16:creationId xmlns:a16="http://schemas.microsoft.com/office/drawing/2014/main" id="{D0654078-CA98-438D-81BE-B592AF724D64}"/>
               </a:ext>
             </a:extLst>
           </p:cNvPr>
@@ -4215,14 +4215,14 @@
             <a:pPr algn="l">
               <a:defRPr sz="825" b="0">
                 <a:solidFill>
-                  <a:srgbClr val="656A67"/>
+                  <a:srgbClr val="6B655E"/>
                 </a:solidFill>
               </a:defRPr>
             </a:pPr>
             <a:r>
               <a:rPr sz="825" b="0">
                 <a:solidFill>
-                  <a:srgbClr val="656A67"/>
+                  <a:srgbClr val="6B655E"/>
                 </a:solidFill>
               </a:rPr>
               <a:t>complete</a:t>
@@ -4235,7 +4235,7 @@
           <p:cNvPr id="72" name="source-doc-2">
             <a:extLst xmlns:a="http://schemas.openxmlformats.org/drawingml/2006/main">
               <a:ext uri="{FF2B5EF4-FFF2-40B4-BE49-F238E27FC236}">
-                <a16:creationId xmlns:a16="http://schemas.microsoft.com/office/drawing/2014/main" id="{E925B201-CEA6-49A6-9F82-7318E3FB9D3B}"/>
+                <a16:creationId xmlns:a16="http://schemas.microsoft.com/office/drawing/2014/main" id="{819F7937-5927-402D-9623-B4301B86879B}"/>
               </a:ext>
             </a:extLst>
           </p:cNvPr>
@@ -4255,11 +4255,11 @@
             </a:avLst>
           </a:prstGeom>
           <a:solidFill xmlns:a="http://schemas.openxmlformats.org/drawingml/2006/main">
-            <a:srgbClr val="FFFFFF"/>
+            <a:srgbClr val="FFFDF7"/>
           </a:solidFill>
           <a:ln xmlns:a="http://schemas.openxmlformats.org/drawingml/2006/main" w="9525">
             <a:solidFill>
-              <a:srgbClr val="73527E"/>
+              <a:srgbClr val="6C4F70"/>
             </a:solidFill>
             <a:prstDash val="solid"/>
           </a:ln>
@@ -4270,7 +4270,7 @@
           <p:cNvPr id="73" name="source-doc-text-2">
             <a:extLst xmlns:a="http://schemas.openxmlformats.org/drawingml/2006/main">
               <a:ext uri="{FF2B5EF4-FFF2-40B4-BE49-F238E27FC236}">
-                <a16:creationId xmlns:a16="http://schemas.microsoft.com/office/drawing/2014/main" id="{82913ABF-B2DD-4B87-B4D6-34255E548452}"/>
+                <a16:creationId xmlns:a16="http://schemas.microsoft.com/office/drawing/2014/main" id="{A2E1D899-BC90-426D-B9E0-506CA6CCDCC3}"/>
               </a:ext>
             </a:extLst>
           </p:cNvPr>
@@ -4300,14 +4300,14 @@
             <a:pPr algn="l">
               <a:defRPr sz="900" b="1">
                 <a:solidFill>
-                  <a:srgbClr val="73527E"/>
+                  <a:srgbClr val="6C4F70"/>
                 </a:solidFill>
               </a:defRPr>
             </a:pPr>
             <a:r>
               <a:rPr sz="900" b="1">
                 <a:solidFill>
-                  <a:srgbClr val="73527E"/>
+                  <a:srgbClr val="6C4F70"/>
                 </a:solidFill>
               </a:rPr>
               <a:t>S1  docs</a:t>
@@ -4320,7 +4320,7 @@
           <p:cNvPr id="74" name="source-price-2">
             <a:extLst xmlns:a="http://schemas.openxmlformats.org/drawingml/2006/main">
               <a:ext uri="{FF2B5EF4-FFF2-40B4-BE49-F238E27FC236}">
-                <a16:creationId xmlns:a16="http://schemas.microsoft.com/office/drawing/2014/main" id="{95001C9D-D34E-4B4A-A48C-C79053D87F8A}"/>
+                <a16:creationId xmlns:a16="http://schemas.microsoft.com/office/drawing/2014/main" id="{AA89C3DB-BC6F-4E16-8994-7C1B5372CCDB}"/>
               </a:ext>
             </a:extLst>
           </p:cNvPr>
@@ -4340,11 +4340,11 @@
             </a:avLst>
           </a:prstGeom>
           <a:solidFill xmlns:a="http://schemas.openxmlformats.org/drawingml/2006/main">
-            <a:srgbClr val="FFFFFF"/>
+            <a:srgbClr val="FFFDF7"/>
           </a:solidFill>
           <a:ln xmlns:a="http://schemas.openxmlformats.org/drawingml/2006/main" w="9525">
             <a:solidFill>
-              <a:srgbClr val="73527E"/>
+              <a:srgbClr val="6C4F70"/>
             </a:solidFill>
             <a:prstDash val="solid"/>
           </a:ln>
@@ -4355,7 +4355,7 @@
           <p:cNvPr id="75" name="source-price-text-2">
             <a:extLst xmlns:a="http://schemas.openxmlformats.org/drawingml/2006/main">
               <a:ext uri="{FF2B5EF4-FFF2-40B4-BE49-F238E27FC236}">
-                <a16:creationId xmlns:a16="http://schemas.microsoft.com/office/drawing/2014/main" id="{579CD25A-BA1C-4A95-836D-78B51B45294E}"/>
+                <a16:creationId xmlns:a16="http://schemas.microsoft.com/office/drawing/2014/main" id="{7E7BDC65-6FE7-4856-9AA1-01AAA07AA152}"/>
               </a:ext>
             </a:extLst>
           </p:cNvPr>
@@ -4385,14 +4385,14 @@
             <a:pPr algn="l">
               <a:defRPr sz="900" b="1">
                 <a:solidFill>
-                  <a:srgbClr val="73527E"/>
+                  <a:srgbClr val="6C4F70"/>
                 </a:solidFill>
               </a:defRPr>
             </a:pPr>
             <a:r>
               <a:rPr sz="900" b="1">
                 <a:solidFill>
-                  <a:srgbClr val="73527E"/>
+                  <a:srgbClr val="6C4F70"/>
                 </a:solidFill>
               </a:rPr>
               <a:t>S2  pricing</a:t>
@@ -4405,7 +4405,7 @@
           <p:cNvPr id="76" name="lane-rule-2">
             <a:extLst xmlns:a="http://schemas.openxmlformats.org/drawingml/2006/main">
               <a:ext uri="{FF2B5EF4-FFF2-40B4-BE49-F238E27FC236}">
-                <a16:creationId xmlns:a16="http://schemas.microsoft.com/office/drawing/2014/main" id="{2A01E583-D8FA-41BC-BF0F-D2CE98162FDD}"/>
+                <a16:creationId xmlns:a16="http://schemas.microsoft.com/office/drawing/2014/main" id="{43DDA174-2E7E-403F-9A1D-BECED3A1E1BA}"/>
               </a:ext>
             </a:extLst>
           </p:cNvPr>
@@ -4425,7 +4425,7 @@
           <a:noFill xmlns:a="http://schemas.openxmlformats.org/drawingml/2006/main"/>
           <a:ln xmlns:a="http://schemas.openxmlformats.org/drawingml/2006/main" w="11430">
             <a:solidFill>
-              <a:srgbClr val="73527E"/>
+              <a:srgbClr val="6C4F70"/>
             </a:solidFill>
             <a:prstDash val="solid"/>
           </a:ln>
@@ -4436,7 +4436,7 @@
           <p:cNvPr id="77" name="field-2-0">
             <a:extLst xmlns:a="http://schemas.openxmlformats.org/drawingml/2006/main">
               <a:ext uri="{FF2B5EF4-FFF2-40B4-BE49-F238E27FC236}">
-                <a16:creationId xmlns:a16="http://schemas.microsoft.com/office/drawing/2014/main" id="{D61A8607-3ED2-4CE8-9B71-F87F52E25E43}"/>
+                <a16:creationId xmlns:a16="http://schemas.microsoft.com/office/drawing/2014/main" id="{ACD588B1-E36E-4135-AAB1-9DFCCE9099E3}"/>
               </a:ext>
             </a:extLst>
           </p:cNvPr>
@@ -4456,11 +4456,11 @@
             </a:avLst>
           </a:prstGeom>
           <a:solidFill xmlns:a="http://schemas.openxmlformats.org/drawingml/2006/main">
-            <a:srgbClr val="F0EBF2"/>
+            <a:srgbClr val="EFE7F0"/>
           </a:solidFill>
           <a:ln xmlns:a="http://schemas.openxmlformats.org/drawingml/2006/main" w="9525">
             <a:solidFill>
-              <a:srgbClr val="73527E"/>
+              <a:srgbClr val="6C4F70"/>
             </a:solidFill>
             <a:prstDash val="solid"/>
           </a:ln>
@@ -4471,7 +4471,7 @@
           <p:cNvPr id="78" name="field-name-2-0">
             <a:extLst xmlns:a="http://schemas.openxmlformats.org/drawingml/2006/main">
               <a:ext uri="{FF2B5EF4-FFF2-40B4-BE49-F238E27FC236}">
-                <a16:creationId xmlns:a16="http://schemas.microsoft.com/office/drawing/2014/main" id="{9AB45977-DA3B-4583-93DE-14122AEC37F7}"/>
+                <a16:creationId xmlns:a16="http://schemas.microsoft.com/office/drawing/2014/main" id="{1D374FFA-9A51-4726-9490-29C8153A56FC}"/>
               </a:ext>
             </a:extLst>
           </p:cNvPr>
@@ -4501,14 +4501,14 @@
             <a:pPr algn="ctr">
               <a:defRPr sz="825" b="1">
                 <a:solidFill>
-                  <a:srgbClr val="191B1A"/>
+                  <a:srgbClr val="24211D"/>
                 </a:solidFill>
               </a:defRPr>
             </a:pPr>
             <a:r>
               <a:rPr sz="825" b="1">
                 <a:solidFill>
-                  <a:srgbClr val="191B1A"/>
+                  <a:srgbClr val="24211D"/>
                 </a:solidFill>
               </a:rPr>
               <a:t>profile</a:t>
@@ -4521,7 +4521,7 @@
           <p:cNvPr id="79" name="field-source-2-0">
             <a:extLst xmlns:a="http://schemas.openxmlformats.org/drawingml/2006/main">
               <a:ext uri="{FF2B5EF4-FFF2-40B4-BE49-F238E27FC236}">
-                <a16:creationId xmlns:a16="http://schemas.microsoft.com/office/drawing/2014/main" id="{965DCCAD-B13E-49B0-A314-374E1E310BB0}"/>
+                <a16:creationId xmlns:a16="http://schemas.microsoft.com/office/drawing/2014/main" id="{1838B262-2260-4751-A2DE-61493C237E53}"/>
               </a:ext>
             </a:extLst>
           </p:cNvPr>
@@ -4551,14 +4551,14 @@
             <a:pPr algn="ctr">
               <a:defRPr sz="900" b="1">
                 <a:solidFill>
-                  <a:srgbClr val="73527E"/>
+                  <a:srgbClr val="6C4F70"/>
                 </a:solidFill>
               </a:defRPr>
             </a:pPr>
             <a:r>
               <a:rPr sz="900" b="1">
                 <a:solidFill>
-                  <a:srgbClr val="73527E"/>
+                  <a:srgbClr val="6C4F70"/>
                 </a:solidFill>
               </a:rPr>
               <a:t>S1</a:t>
@@ -4571,7 +4571,7 @@
           <p:cNvPr id="80" name="field-2-1">
             <a:extLst xmlns:a="http://schemas.openxmlformats.org/drawingml/2006/main">
               <a:ext uri="{FF2B5EF4-FFF2-40B4-BE49-F238E27FC236}">
-                <a16:creationId xmlns:a16="http://schemas.microsoft.com/office/drawing/2014/main" id="{7221CE16-59DF-4381-BF00-EAB8A50DA69F}"/>
+                <a16:creationId xmlns:a16="http://schemas.microsoft.com/office/drawing/2014/main" id="{528657E0-1AB1-40AD-AFC0-93854228FEC8}"/>
               </a:ext>
             </a:extLst>
           </p:cNvPr>
@@ -4591,11 +4591,11 @@
             </a:avLst>
           </a:prstGeom>
           <a:solidFill xmlns:a="http://schemas.openxmlformats.org/drawingml/2006/main">
-            <a:srgbClr val="F0EBF2"/>
+            <a:srgbClr val="EFE7F0"/>
           </a:solidFill>
           <a:ln xmlns:a="http://schemas.openxmlformats.org/drawingml/2006/main" w="9525">
             <a:solidFill>
-              <a:srgbClr val="73527E"/>
+              <a:srgbClr val="6C4F70"/>
             </a:solidFill>
             <a:prstDash val="solid"/>
           </a:ln>
@@ -4606,7 +4606,7 @@
           <p:cNvPr id="81" name="field-name-2-1">
             <a:extLst xmlns:a="http://schemas.openxmlformats.org/drawingml/2006/main">
               <a:ext uri="{FF2B5EF4-FFF2-40B4-BE49-F238E27FC236}">
-                <a16:creationId xmlns:a16="http://schemas.microsoft.com/office/drawing/2014/main" id="{AA8F3F40-ACE9-412F-9046-C57E03AAC901}"/>
+                <a16:creationId xmlns:a16="http://schemas.microsoft.com/office/drawing/2014/main" id="{BBBB4171-2651-4EAD-87E5-60755B45AC5B}"/>
               </a:ext>
             </a:extLst>
           </p:cNvPr>
@@ -4636,14 +4636,14 @@
             <a:pPr algn="ctr">
               <a:defRPr sz="825" b="1">
                 <a:solidFill>
-                  <a:srgbClr val="191B1A"/>
+                  <a:srgbClr val="24211D"/>
                 </a:solidFill>
               </a:defRPr>
             </a:pPr>
             <a:r>
               <a:rPr sz="825" b="1">
                 <a:solidFill>
-                  <a:srgbClr val="191B1A"/>
+                  <a:srgbClr val="24211D"/>
                 </a:solidFill>
               </a:rPr>
               <a:t>price</a:t>
@@ -4656,7 +4656,7 @@
           <p:cNvPr id="82" name="field-source-2-1">
             <a:extLst xmlns:a="http://schemas.openxmlformats.org/drawingml/2006/main">
               <a:ext uri="{FF2B5EF4-FFF2-40B4-BE49-F238E27FC236}">
-                <a16:creationId xmlns:a16="http://schemas.microsoft.com/office/drawing/2014/main" id="{96BE0DFC-4E41-488D-A4E5-02E04E17BA52}"/>
+                <a16:creationId xmlns:a16="http://schemas.microsoft.com/office/drawing/2014/main" id="{6508F30C-D5A4-4B2D-B909-341A55A58A09}"/>
               </a:ext>
             </a:extLst>
           </p:cNvPr>
@@ -4686,14 +4686,14 @@
             <a:pPr algn="ctr">
               <a:defRPr sz="900" b="1">
                 <a:solidFill>
-                  <a:srgbClr val="73527E"/>
+                  <a:srgbClr val="6C4F70"/>
                 </a:solidFill>
               </a:defRPr>
             </a:pPr>
             <a:r>
               <a:rPr sz="900" b="1">
                 <a:solidFill>
-                  <a:srgbClr val="73527E"/>
+                  <a:srgbClr val="6C4F70"/>
                 </a:solidFill>
               </a:rPr>
               <a:t>S2</a:t>
@@ -4706,7 +4706,7 @@
           <p:cNvPr id="83" name="field-2-2">
             <a:extLst xmlns:a="http://schemas.openxmlformats.org/drawingml/2006/main">
               <a:ext uri="{FF2B5EF4-FFF2-40B4-BE49-F238E27FC236}">
-                <a16:creationId xmlns:a16="http://schemas.microsoft.com/office/drawing/2014/main" id="{949F204A-2C1A-4BBD-9EAA-EECD18835DF4}"/>
+                <a16:creationId xmlns:a16="http://schemas.microsoft.com/office/drawing/2014/main" id="{749F4216-F2D1-453F-BBDE-3785D1F94227}"/>
               </a:ext>
             </a:extLst>
           </p:cNvPr>
@@ -4726,11 +4726,11 @@
             </a:avLst>
           </a:prstGeom>
           <a:solidFill xmlns:a="http://schemas.openxmlformats.org/drawingml/2006/main">
-            <a:srgbClr val="F0EBF2"/>
+            <a:srgbClr val="EFE7F0"/>
           </a:solidFill>
           <a:ln xmlns:a="http://schemas.openxmlformats.org/drawingml/2006/main" w="9525">
             <a:solidFill>
-              <a:srgbClr val="73527E"/>
+              <a:srgbClr val="6C4F70"/>
             </a:solidFill>
             <a:prstDash val="solid"/>
           </a:ln>
@@ -4741,7 +4741,7 @@
           <p:cNvPr id="84" name="field-name-2-2">
             <a:extLst xmlns:a="http://schemas.openxmlformats.org/drawingml/2006/main">
               <a:ext uri="{FF2B5EF4-FFF2-40B4-BE49-F238E27FC236}">
-                <a16:creationId xmlns:a16="http://schemas.microsoft.com/office/drawing/2014/main" id="{E7986915-DB78-4F29-863F-A26E412F2A08}"/>
+                <a16:creationId xmlns:a16="http://schemas.microsoft.com/office/drawing/2014/main" id="{9A53ECDE-7CD3-4355-B155-589F568A4840}"/>
               </a:ext>
             </a:extLst>
           </p:cNvPr>
@@ -4771,14 +4771,14 @@
             <a:pPr algn="ctr">
               <a:defRPr sz="825" b="1">
                 <a:solidFill>
-                  <a:srgbClr val="191B1A"/>
+                  <a:srgbClr val="24211D"/>
                 </a:solidFill>
               </a:defRPr>
             </a:pPr>
             <a:r>
               <a:rPr sz="825" b="1">
                 <a:solidFill>
-                  <a:srgbClr val="191B1A"/>
+                  <a:srgbClr val="24211D"/>
                 </a:solidFill>
               </a:rPr>
               <a:t>OSS</a:t>
@@ -4791,7 +4791,7 @@
           <p:cNvPr id="85" name="field-source-2-2">
             <a:extLst xmlns:a="http://schemas.openxmlformats.org/drawingml/2006/main">
               <a:ext uri="{FF2B5EF4-FFF2-40B4-BE49-F238E27FC236}">
-                <a16:creationId xmlns:a16="http://schemas.microsoft.com/office/drawing/2014/main" id="{C80E4645-C435-4FB1-AB1F-ECADA61DF8FD}"/>
+                <a16:creationId xmlns:a16="http://schemas.microsoft.com/office/drawing/2014/main" id="{39E107B8-BBE5-402B-A712-8E240CA63E14}"/>
               </a:ext>
             </a:extLst>
           </p:cNvPr>
@@ -4821,14 +4821,14 @@
             <a:pPr algn="ctr">
               <a:defRPr sz="900" b="1">
                 <a:solidFill>
-                  <a:srgbClr val="73527E"/>
+                  <a:srgbClr val="6C4F70"/>
                 </a:solidFill>
               </a:defRPr>
             </a:pPr>
             <a:r>
               <a:rPr sz="900" b="1">
                 <a:solidFill>
-                  <a:srgbClr val="73527E"/>
+                  <a:srgbClr val="6C4F70"/>
                 </a:solidFill>
               </a:rPr>
               <a:t>S1</a:t>
@@ -4841,7 +4841,7 @@
           <p:cNvPr id="86" name="field-2-3">
             <a:extLst xmlns:a="http://schemas.openxmlformats.org/drawingml/2006/main">
               <a:ext uri="{FF2B5EF4-FFF2-40B4-BE49-F238E27FC236}">
-                <a16:creationId xmlns:a16="http://schemas.microsoft.com/office/drawing/2014/main" id="{E775665E-6A79-4500-A12E-50CED8E7AA24}"/>
+                <a16:creationId xmlns:a16="http://schemas.microsoft.com/office/drawing/2014/main" id="{B0612573-9BF9-435D-AE8A-F751B6CB27FA}"/>
               </a:ext>
             </a:extLst>
           </p:cNvPr>
@@ -4861,11 +4861,11 @@
             </a:avLst>
           </a:prstGeom>
           <a:solidFill xmlns:a="http://schemas.openxmlformats.org/drawingml/2006/main">
-            <a:srgbClr val="F0EBF2"/>
+            <a:srgbClr val="EFE7F0"/>
           </a:solidFill>
           <a:ln xmlns:a="http://schemas.openxmlformats.org/drawingml/2006/main" w="9525">
             <a:solidFill>
-              <a:srgbClr val="73527E"/>
+              <a:srgbClr val="6C4F70"/>
             </a:solidFill>
             <a:prstDash val="solid"/>
           </a:ln>
@@ -4876,7 +4876,7 @@
           <p:cNvPr id="87" name="field-name-2-3">
             <a:extLst xmlns:a="http://schemas.openxmlformats.org/drawingml/2006/main">
               <a:ext uri="{FF2B5EF4-FFF2-40B4-BE49-F238E27FC236}">
-                <a16:creationId xmlns:a16="http://schemas.microsoft.com/office/drawing/2014/main" id="{41E8275E-B3C7-4669-9474-4B640E570175}"/>
+                <a16:creationId xmlns:a16="http://schemas.microsoft.com/office/drawing/2014/main" id="{9720E642-DB81-4A46-B66F-33E86C559E2A}"/>
               </a:ext>
             </a:extLst>
           </p:cNvPr>
@@ -4906,14 +4906,14 @@
             <a:pPr algn="ctr">
               <a:defRPr sz="825" b="1">
                 <a:solidFill>
-                  <a:srgbClr val="191B1A"/>
+                  <a:srgbClr val="24211D"/>
                 </a:solidFill>
               </a:defRPr>
             </a:pPr>
             <a:r>
               <a:rPr sz="825" b="1">
                 <a:solidFill>
-                  <a:srgbClr val="191B1A"/>
+                  <a:srgbClr val="24211D"/>
                 </a:solidFill>
               </a:rPr>
               <a:t>API</a:t>
@@ -4926,7 +4926,7 @@
           <p:cNvPr id="88" name="field-source-2-3">
             <a:extLst xmlns:a="http://schemas.openxmlformats.org/drawingml/2006/main">
               <a:ext uri="{FF2B5EF4-FFF2-40B4-BE49-F238E27FC236}">
-                <a16:creationId xmlns:a16="http://schemas.microsoft.com/office/drawing/2014/main" id="{012F7CBB-2D02-48D5-8310-F566E304A32B}"/>
+                <a16:creationId xmlns:a16="http://schemas.microsoft.com/office/drawing/2014/main" id="{105E3FF3-CB57-48DD-86A0-D1335D22424A}"/>
               </a:ext>
             </a:extLst>
           </p:cNvPr>
@@ -4956,14 +4956,14 @@
             <a:pPr algn="ctr">
               <a:defRPr sz="900" b="1">
                 <a:solidFill>
-                  <a:srgbClr val="73527E"/>
+                  <a:srgbClr val="6C4F70"/>
                 </a:solidFill>
               </a:defRPr>
             </a:pPr>
             <a:r>
               <a:rPr sz="900" b="1">
                 <a:solidFill>
-                  <a:srgbClr val="73527E"/>
+                  <a:srgbClr val="6C4F70"/>
                 </a:solidFill>
               </a:rPr>
               <a:t>S1</a:t>
@@ -4976,7 +4976,7 @@
           <p:cNvPr id="89" name="field-2-4">
             <a:extLst xmlns:a="http://schemas.openxmlformats.org/drawingml/2006/main">
               <a:ext uri="{FF2B5EF4-FFF2-40B4-BE49-F238E27FC236}">
-                <a16:creationId xmlns:a16="http://schemas.microsoft.com/office/drawing/2014/main" id="{A3DBC6C1-CF0D-4234-AF43-37606C624D3E}"/>
+                <a16:creationId xmlns:a16="http://schemas.microsoft.com/office/drawing/2014/main" id="{105981FF-5897-414A-837C-A56C0B299165}"/>
               </a:ext>
             </a:extLst>
           </p:cNvPr>
@@ -4996,11 +4996,11 @@
             </a:avLst>
           </a:prstGeom>
           <a:solidFill xmlns:a="http://schemas.openxmlformats.org/drawingml/2006/main">
-            <a:srgbClr val="F0EBF2"/>
+            <a:srgbClr val="EFE7F0"/>
           </a:solidFill>
           <a:ln xmlns:a="http://schemas.openxmlformats.org/drawingml/2006/main" w="9525">
             <a:solidFill>
-              <a:srgbClr val="73527E"/>
+              <a:srgbClr val="6C4F70"/>
             </a:solidFill>
             <a:prstDash val="solid"/>
           </a:ln>
@@ -5011,7 +5011,7 @@
           <p:cNvPr id="90" name="field-name-2-4">
             <a:extLst xmlns:a="http://schemas.openxmlformats.org/drawingml/2006/main">
               <a:ext uri="{FF2B5EF4-FFF2-40B4-BE49-F238E27FC236}">
-                <a16:creationId xmlns:a16="http://schemas.microsoft.com/office/drawing/2014/main" id="{6F48A599-84C4-4142-A911-5A4BD16AA453}"/>
+                <a16:creationId xmlns:a16="http://schemas.microsoft.com/office/drawing/2014/main" id="{34C6A487-B1A5-4A5F-835B-24D7E49842DD}"/>
               </a:ext>
             </a:extLst>
           </p:cNvPr>
@@ -5041,14 +5041,14 @@
             <a:pPr algn="ctr">
               <a:defRPr sz="825" b="1">
                 <a:solidFill>
-                  <a:srgbClr val="191B1A"/>
+                  <a:srgbClr val="24211D"/>
                 </a:solidFill>
               </a:defRPr>
             </a:pPr>
             <a:r>
               <a:rPr sz="825" b="1">
                 <a:solidFill>
-                  <a:srgbClr val="191B1A"/>
+                  <a:srgbClr val="24211D"/>
                 </a:solidFill>
               </a:rPr>
               <a:t>SDKs</a:t>
@@ -5061,7 +5061,7 @@
           <p:cNvPr id="91" name="field-source-2-4">
             <a:extLst xmlns:a="http://schemas.openxmlformats.org/drawingml/2006/main">
               <a:ext uri="{FF2B5EF4-FFF2-40B4-BE49-F238E27FC236}">
-                <a16:creationId xmlns:a16="http://schemas.microsoft.com/office/drawing/2014/main" id="{C71145B5-E05B-4EEB-94D4-51737F343FEC}"/>
+                <a16:creationId xmlns:a16="http://schemas.microsoft.com/office/drawing/2014/main" id="{93DDAC05-480B-4265-86C7-8B88418FA529}"/>
               </a:ext>
             </a:extLst>
           </p:cNvPr>
@@ -5091,14 +5091,14 @@
             <a:pPr algn="ctr">
               <a:defRPr sz="900" b="1">
                 <a:solidFill>
-                  <a:srgbClr val="73527E"/>
+                  <a:srgbClr val="6C4F70"/>
                 </a:solidFill>
               </a:defRPr>
             </a:pPr>
             <a:r>
               <a:rPr sz="900" b="1">
                 <a:solidFill>
-                  <a:srgbClr val="73527E"/>
+                  <a:srgbClr val="6C4F70"/>
                 </a:solidFill>
               </a:rPr>
               <a:t>S1</a:t>
@@ -5111,7 +5111,7 @@
           <p:cNvPr id="92" name="field-2-5">
             <a:extLst xmlns:a="http://schemas.openxmlformats.org/drawingml/2006/main">
               <a:ext uri="{FF2B5EF4-FFF2-40B4-BE49-F238E27FC236}">
-                <a16:creationId xmlns:a16="http://schemas.microsoft.com/office/drawing/2014/main" id="{5B3C9689-D971-4715-AF94-3090F09534A9}"/>
+                <a16:creationId xmlns:a16="http://schemas.microsoft.com/office/drawing/2014/main" id="{5654015D-AF98-461E-A910-BD1C58057FDD}"/>
               </a:ext>
             </a:extLst>
           </p:cNvPr>
@@ -5131,11 +5131,11 @@
             </a:avLst>
           </a:prstGeom>
           <a:solidFill xmlns:a="http://schemas.openxmlformats.org/drawingml/2006/main">
-            <a:srgbClr val="F0EBF2"/>
+            <a:srgbClr val="EFE7F0"/>
           </a:solidFill>
           <a:ln xmlns:a="http://schemas.openxmlformats.org/drawingml/2006/main" w="9525">
             <a:solidFill>
-              <a:srgbClr val="73527E"/>
+              <a:srgbClr val="6C4F70"/>
             </a:solidFill>
             <a:prstDash val="solid"/>
           </a:ln>
@@ -5146,7 +5146,7 @@
           <p:cNvPr id="93" name="field-name-2-5">
             <a:extLst xmlns:a="http://schemas.openxmlformats.org/drawingml/2006/main">
               <a:ext uri="{FF2B5EF4-FFF2-40B4-BE49-F238E27FC236}">
-                <a16:creationId xmlns:a16="http://schemas.microsoft.com/office/drawing/2014/main" id="{8A298ECD-328A-4FA4-949A-1F1E41AE6D8A}"/>
+                <a16:creationId xmlns:a16="http://schemas.microsoft.com/office/drawing/2014/main" id="{54B7A540-1089-4DAF-8519-0B29E9590D91}"/>
               </a:ext>
             </a:extLst>
           </p:cNvPr>
@@ -5176,14 +5176,14 @@
             <a:pPr algn="ctr">
               <a:defRPr sz="825" b="1">
                 <a:solidFill>
-                  <a:srgbClr val="191B1A"/>
+                  <a:srgbClr val="24211D"/>
                 </a:solidFill>
               </a:defRPr>
             </a:pPr>
             <a:r>
               <a:rPr sz="825" b="1">
                 <a:solidFill>
-                  <a:srgbClr val="191B1A"/>
+                  <a:srgbClr val="24211D"/>
                 </a:solidFill>
               </a:rPr>
               <a:t>integr.</a:t>
@@ -5196,7 +5196,7 @@
           <p:cNvPr id="94" name="field-source-2-5">
             <a:extLst xmlns:a="http://schemas.openxmlformats.org/drawingml/2006/main">
               <a:ext uri="{FF2B5EF4-FFF2-40B4-BE49-F238E27FC236}">
-                <a16:creationId xmlns:a16="http://schemas.microsoft.com/office/drawing/2014/main" id="{A7A9E633-8782-4ED5-82AC-76298D6F7CC2}"/>
+                <a16:creationId xmlns:a16="http://schemas.microsoft.com/office/drawing/2014/main" id="{AA706005-AA2E-4851-9B37-D44FBB4107B9}"/>
               </a:ext>
             </a:extLst>
           </p:cNvPr>
@@ -5226,14 +5226,14 @@
             <a:pPr algn="ctr">
               <a:defRPr sz="900" b="1">
                 <a:solidFill>
-                  <a:srgbClr val="73527E"/>
+                  <a:srgbClr val="6C4F70"/>
                 </a:solidFill>
               </a:defRPr>
             </a:pPr>
             <a:r>
               <a:rPr sz="900" b="1">
                 <a:solidFill>
-                  <a:srgbClr val="73527E"/>
+                  <a:srgbClr val="6C4F70"/>
                 </a:solidFill>
               </a:rPr>
               <a:t>S1</a:t>
@@ -5246,7 +5246,7 @@
           <p:cNvPr id="95" name="validation-2">
             <a:extLst xmlns:a="http://schemas.openxmlformats.org/drawingml/2006/main">
               <a:ext uri="{FF2B5EF4-FFF2-40B4-BE49-F238E27FC236}">
-                <a16:creationId xmlns:a16="http://schemas.microsoft.com/office/drawing/2014/main" id="{8C9112E8-C830-4B84-A292-AEF4A4ED31EA}"/>
+                <a16:creationId xmlns:a16="http://schemas.microsoft.com/office/drawing/2014/main" id="{760901AA-9C0E-4281-A8E8-D605E7FF4A52}"/>
               </a:ext>
             </a:extLst>
           </p:cNvPr>
@@ -5276,14 +5276,14 @@
             <a:pPr algn="l">
               <a:defRPr sz="788" b="0">
                 <a:solidFill>
-                  <a:srgbClr val="656A67"/>
+                  <a:srgbClr val="6B655E"/>
                 </a:solidFill>
               </a:defRPr>
             </a:pPr>
             <a:r>
               <a:rPr sz="788" b="0">
                 <a:solidFill>
-                  <a:srgbClr val="656A67"/>
+                  <a:srgbClr val="6B655E"/>
                 </a:solidFill>
               </a:rPr>
               <a:t>6 fields · source IDs validated against this profile’s two retained sources</a:t>
@@ -5296,7 +5296,7 @@
           <p:cNvPr id="96" name="report-label">
             <a:extLst xmlns:a="http://schemas.openxmlformats.org/drawingml/2006/main">
               <a:ext uri="{FF2B5EF4-FFF2-40B4-BE49-F238E27FC236}">
-                <a16:creationId xmlns:a16="http://schemas.microsoft.com/office/drawing/2014/main" id="{059C3B87-44A5-4D40-AE20-B39950A77DC1}"/>
+                <a16:creationId xmlns:a16="http://schemas.microsoft.com/office/drawing/2014/main" id="{88482165-5BCD-4137-932E-45D0854C4036}"/>
               </a:ext>
             </a:extLst>
           </p:cNvPr>
@@ -5326,14 +5326,14 @@
             <a:pPr algn="l">
               <a:defRPr sz="900" b="1">
                 <a:solidFill>
-                  <a:srgbClr val="9C3451"/>
+                  <a:srgbClr val="9B3A2B"/>
                 </a:solidFill>
               </a:defRPr>
             </a:pPr>
             <a:r>
               <a:rPr sz="900" b="1">
                 <a:solidFill>
-                  <a:srgbClr val="9C3451"/>
+                  <a:srgbClr val="9B3A2B"/>
                 </a:solidFill>
               </a:rPr>
               <a:t>VALIDATED REPORT</a:t>
@@ -5346,7 +5346,7 @@
           <p:cNvPr id="97" name="report">
             <a:extLst xmlns:a="http://schemas.openxmlformats.org/drawingml/2006/main">
               <a:ext uri="{FF2B5EF4-FFF2-40B4-BE49-F238E27FC236}">
-                <a16:creationId xmlns:a16="http://schemas.microsoft.com/office/drawing/2014/main" id="{CCD9F2AB-A0F0-451D-8785-73C8AB189661}"/>
+                <a16:creationId xmlns:a16="http://schemas.microsoft.com/office/drawing/2014/main" id="{01793EF1-3228-4446-9EA2-D35BF5E44251}"/>
               </a:ext>
             </a:extLst>
           </p:cNvPr>
@@ -5366,11 +5366,11 @@
             </a:avLst>
           </a:prstGeom>
           <a:solidFill xmlns:a="http://schemas.openxmlformats.org/drawingml/2006/main">
-            <a:srgbClr val="FFFFFF"/>
+            <a:srgbClr val="FFFDF7"/>
           </a:solidFill>
           <a:ln xmlns:a="http://schemas.openxmlformats.org/drawingml/2006/main" w="11430">
             <a:solidFill>
-              <a:srgbClr val="183B5C"/>
+              <a:srgbClr val="36453B"/>
             </a:solidFill>
             <a:prstDash val="solid"/>
           </a:ln>
@@ -5381,7 +5381,7 @@
           <p:cNvPr id="98" name="report-count">
             <a:extLst xmlns:a="http://schemas.openxmlformats.org/drawingml/2006/main">
               <a:ext uri="{FF2B5EF4-FFF2-40B4-BE49-F238E27FC236}">
-                <a16:creationId xmlns:a16="http://schemas.microsoft.com/office/drawing/2014/main" id="{9299E947-4825-4E27-B62F-9789EE453DFF}"/>
+                <a16:creationId xmlns:a16="http://schemas.microsoft.com/office/drawing/2014/main" id="{A32DA189-0003-42E4-8096-1C89E954B672}"/>
               </a:ext>
             </a:extLst>
           </p:cNvPr>
@@ -5411,14 +5411,14 @@
             <a:pPr algn="ctr">
               <a:defRPr sz="2175" b="1">
                 <a:solidFill>
-                  <a:srgbClr val="183B5C"/>
+                  <a:srgbClr val="36453B"/>
                 </a:solidFill>
               </a:defRPr>
             </a:pPr>
             <a:r>
               <a:rPr sz="2175" b="1">
                 <a:solidFill>
-                  <a:srgbClr val="183B5C"/>
+                  <a:srgbClr val="36453B"/>
                 </a:solidFill>
               </a:rPr>
               <a:t>3</a:t>
@@ -5431,7 +5431,7 @@
           <p:cNvPr id="99" name="report-profiles">
             <a:extLst xmlns:a="http://schemas.openxmlformats.org/drawingml/2006/main">
               <a:ext uri="{FF2B5EF4-FFF2-40B4-BE49-F238E27FC236}">
-                <a16:creationId xmlns:a16="http://schemas.microsoft.com/office/drawing/2014/main" id="{F410D84A-9A9A-40EC-AA33-1ED8C46C3F23}"/>
+                <a16:creationId xmlns:a16="http://schemas.microsoft.com/office/drawing/2014/main" id="{18ED12A7-FB83-423C-9C19-EC78C4B41F8A}"/>
               </a:ext>
             </a:extLst>
           </p:cNvPr>
@@ -5461,14 +5461,14 @@
             <a:pPr algn="ctr">
               <a:defRPr sz="900" b="1">
                 <a:solidFill>
-                  <a:srgbClr val="191B1A"/>
+                  <a:srgbClr val="24211D"/>
                 </a:solidFill>
               </a:defRPr>
             </a:pPr>
             <a:r>
               <a:rPr sz="900" b="1">
                 <a:solidFill>
-                  <a:srgbClr val="191B1A"/>
+                  <a:srgbClr val="24211D"/>
                 </a:solidFill>
               </a:rPr>
               <a:t>complete</a:t>
@@ -5478,14 +5478,14 @@
             <a:pPr algn="ctr">
               <a:defRPr sz="900" b="1">
                 <a:solidFill>
-                  <a:srgbClr val="191B1A"/>
+                  <a:srgbClr val="24211D"/>
                 </a:solidFill>
               </a:defRPr>
             </a:pPr>
             <a:r>
               <a:rPr sz="900" b="1">
                 <a:solidFill>
-                  <a:srgbClr val="191B1A"/>
+                  <a:srgbClr val="24211D"/>
                 </a:solidFill>
               </a:rPr>
               <a:t>profiles</a:t>
@@ -5498,7 +5498,7 @@
           <p:cNvPr id="100" name="report-rule-1">
             <a:extLst xmlns:a="http://schemas.openxmlformats.org/drawingml/2006/main">
               <a:ext uri="{FF2B5EF4-FFF2-40B4-BE49-F238E27FC236}">
-                <a16:creationId xmlns:a16="http://schemas.microsoft.com/office/drawing/2014/main" id="{2B71C77D-271C-4035-B8CA-5C8317E7E0F1}"/>
+                <a16:creationId xmlns:a16="http://schemas.microsoft.com/office/drawing/2014/main" id="{BCCA4401-5716-4EC6-A488-FF92D9A33C7D}"/>
               </a:ext>
             </a:extLst>
           </p:cNvPr>
@@ -5518,7 +5518,7 @@
           <a:noFill xmlns:a="http://schemas.openxmlformats.org/drawingml/2006/main"/>
           <a:ln xmlns:a="http://schemas.openxmlformats.org/drawingml/2006/main" w="9525">
             <a:solidFill>
-              <a:srgbClr val="C7CBC7"/>
+              <a:srgbClr val="C9C0B1"/>
             </a:solidFill>
             <a:prstDash val="solid"/>
           </a:ln>
@@ -5529,7 +5529,7 @@
           <p:cNvPr id="101" name="report-citations">
             <a:extLst xmlns:a="http://schemas.openxmlformats.org/drawingml/2006/main">
               <a:ext uri="{FF2B5EF4-FFF2-40B4-BE49-F238E27FC236}">
-                <a16:creationId xmlns:a16="http://schemas.microsoft.com/office/drawing/2014/main" id="{F1A0B8F7-140E-4046-AC5E-997F86D1BD9D}"/>
+                <a16:creationId xmlns:a16="http://schemas.microsoft.com/office/drawing/2014/main" id="{70C20826-D921-4B1E-B24A-D61D1D315DAD}"/>
               </a:ext>
             </a:extLst>
           </p:cNvPr>
@@ -5559,14 +5559,14 @@
             <a:pPr algn="ctr">
               <a:defRPr sz="2025" b="1">
                 <a:solidFill>
-                  <a:srgbClr val="183B5C"/>
+                  <a:srgbClr val="36453B"/>
                 </a:solidFill>
               </a:defRPr>
             </a:pPr>
             <a:r>
               <a:rPr sz="2025" b="1">
                 <a:solidFill>
-                  <a:srgbClr val="183B5C"/>
+                  <a:srgbClr val="36453B"/>
                 </a:solidFill>
               </a:rPr>
               <a:t>6</a:t>
@@ -5579,7 +5579,7 @@
           <p:cNvPr id="102" name="report-citation-label">
             <a:extLst xmlns:a="http://schemas.openxmlformats.org/drawingml/2006/main">
               <a:ext uri="{FF2B5EF4-FFF2-40B4-BE49-F238E27FC236}">
-                <a16:creationId xmlns:a16="http://schemas.microsoft.com/office/drawing/2014/main" id="{9D2658B9-E4A6-40C2-B34D-1C9E5ABF7036}"/>
+                <a16:creationId xmlns:a16="http://schemas.microsoft.com/office/drawing/2014/main" id="{8700E7FC-94F7-4B8F-96A3-B41B09779F17}"/>
               </a:ext>
             </a:extLst>
           </p:cNvPr>
@@ -5609,14 +5609,14 @@
             <a:pPr algn="ctr">
               <a:defRPr sz="900" b="1">
                 <a:solidFill>
-                  <a:srgbClr val="191B1A"/>
+                  <a:srgbClr val="24211D"/>
                 </a:solidFill>
               </a:defRPr>
             </a:pPr>
             <a:r>
               <a:rPr sz="900" b="1">
                 <a:solidFill>
-                  <a:srgbClr val="191B1A"/>
+                  <a:srgbClr val="24211D"/>
                 </a:solidFill>
               </a:rPr>
               <a:t>public</a:t>
@@ -5626,14 +5626,14 @@
             <a:pPr algn="ctr">
               <a:defRPr sz="900" b="1">
                 <a:solidFill>
-                  <a:srgbClr val="191B1A"/>
+                  <a:srgbClr val="24211D"/>
                 </a:solidFill>
               </a:defRPr>
             </a:pPr>
             <a:r>
               <a:rPr sz="900" b="1">
                 <a:solidFill>
-                  <a:srgbClr val="191B1A"/>
+                  <a:srgbClr val="24211D"/>
                 </a:solidFill>
               </a:rPr>
               <a:t>citations</a:t>
@@ -5646,7 +5646,7 @@
           <p:cNvPr id="103" name="report-rule-2">
             <a:extLst xmlns:a="http://schemas.openxmlformats.org/drawingml/2006/main">
               <a:ext uri="{FF2B5EF4-FFF2-40B4-BE49-F238E27FC236}">
-                <a16:creationId xmlns:a16="http://schemas.microsoft.com/office/drawing/2014/main" id="{6C9322CC-B901-4570-B4AA-C177B0E56C8C}"/>
+                <a16:creationId xmlns:a16="http://schemas.microsoft.com/office/drawing/2014/main" id="{54763CB8-6EF9-4F71-8EB6-4519115738F9}"/>
               </a:ext>
             </a:extLst>
           </p:cNvPr>
@@ -5666,7 +5666,7 @@
           <a:noFill xmlns:a="http://schemas.openxmlformats.org/drawingml/2006/main"/>
           <a:ln xmlns:a="http://schemas.openxmlformats.org/drawingml/2006/main" w="9525">
             <a:solidFill>
-              <a:srgbClr val="C7CBC7"/>
+              <a:srgbClr val="C9C0B1"/>
             </a:solidFill>
             <a:prstDash val="solid"/>
           </a:ln>
@@ -5677,7 +5677,7 @@
           <p:cNvPr id="104" name="report-warnings">
             <a:extLst xmlns:a="http://schemas.openxmlformats.org/drawingml/2006/main">
               <a:ext uri="{FF2B5EF4-FFF2-40B4-BE49-F238E27FC236}">
-                <a16:creationId xmlns:a16="http://schemas.microsoft.com/office/drawing/2014/main" id="{8C5F65F0-E3C9-4123-9B94-972E2BC7325A}"/>
+                <a16:creationId xmlns:a16="http://schemas.microsoft.com/office/drawing/2014/main" id="{9AFC557E-E998-43CD-8322-E9562CED551E}"/>
               </a:ext>
             </a:extLst>
           </p:cNvPr>
@@ -5707,14 +5707,14 @@
             <a:pPr algn="ctr">
               <a:defRPr sz="2025" b="1">
                 <a:solidFill>
-                  <a:srgbClr val="2E7752"/>
+                  <a:srgbClr val="466B4A"/>
                 </a:solidFill>
               </a:defRPr>
             </a:pPr>
             <a:r>
               <a:rPr sz="2025" b="1">
                 <a:solidFill>
-                  <a:srgbClr val="2E7752"/>
+                  <a:srgbClr val="466B4A"/>
                 </a:solidFill>
               </a:rPr>
               <a:t>0</a:t>
@@ -5727,7 +5727,7 @@
           <p:cNvPr id="105" name="report-warning-label">
             <a:extLst xmlns:a="http://schemas.openxmlformats.org/drawingml/2006/main">
               <a:ext uri="{FF2B5EF4-FFF2-40B4-BE49-F238E27FC236}">
-                <a16:creationId xmlns:a16="http://schemas.microsoft.com/office/drawing/2014/main" id="{7954332D-B979-41D6-9020-A3BA6C506EA2}"/>
+                <a16:creationId xmlns:a16="http://schemas.microsoft.com/office/drawing/2014/main" id="{FCAB1E44-00A9-4FF5-972E-61DF01FAF814}"/>
               </a:ext>
             </a:extLst>
           </p:cNvPr>
@@ -5757,14 +5757,14 @@
             <a:pPr algn="ctr">
               <a:defRPr sz="900" b="1">
                 <a:solidFill>
-                  <a:srgbClr val="191B1A"/>
+                  <a:srgbClr val="24211D"/>
                 </a:solidFill>
               </a:defRPr>
             </a:pPr>
             <a:r>
               <a:rPr sz="900" b="1">
                 <a:solidFill>
-                  <a:srgbClr val="191B1A"/>
+                  <a:srgbClr val="24211D"/>
                 </a:solidFill>
               </a:rPr>
               <a:t>warnings</a:t>
@@ -5777,7 +5777,7 @@
           <p:cNvPr id="106" name="report-note">
             <a:extLst xmlns:a="http://schemas.openxmlformats.org/drawingml/2006/main">
               <a:ext uri="{FF2B5EF4-FFF2-40B4-BE49-F238E27FC236}">
-                <a16:creationId xmlns:a16="http://schemas.microsoft.com/office/drawing/2014/main" id="{2126C76B-57ED-4CF4-8078-21F56262E4EC}"/>
+                <a16:creationId xmlns:a16="http://schemas.microsoft.com/office/drawing/2014/main" id="{2281AD0B-D519-442E-8D69-CC7DAA220BEF}"/>
               </a:ext>
             </a:extLst>
           </p:cNvPr>
@@ -5807,14 +5807,14 @@
             <a:pPr algn="ctr">
               <a:defRPr sz="713" b="0">
                 <a:solidFill>
-                  <a:srgbClr val="656A67"/>
+                  <a:srgbClr val="6B655E"/>
                 </a:solidFill>
               </a:defRPr>
             </a:pPr>
             <a:r>
               <a:rPr sz="713" b="0">
                 <a:solidFill>
-                  <a:srgbClr val="656A67"/>
+                  <a:srgbClr val="6B655E"/>
                 </a:solidFill>
               </a:rPr>
               <a:t>validated</a:t>
@@ -5824,14 +5824,14 @@
             <a:pPr algn="ctr">
               <a:defRPr sz="713" b="0">
                 <a:solidFill>
-                  <a:srgbClr val="656A67"/>
+                  <a:srgbClr val="6B655E"/>
                 </a:solidFill>
               </a:defRPr>
             </a:pPr>
             <a:r>
               <a:rPr sz="713" b="0">
                 <a:solidFill>
-                  <a:srgbClr val="656A67"/>
+                  <a:srgbClr val="6B655E"/>
                 </a:solidFill>
               </a:rPr>
               <a:t>recommendation</a:t>
@@ -5844,7 +5844,7 @@
           <p:cNvPr id="107" name="exports-label">
             <a:extLst xmlns:a="http://schemas.openxmlformats.org/drawingml/2006/main">
               <a:ext uri="{FF2B5EF4-FFF2-40B4-BE49-F238E27FC236}">
-                <a16:creationId xmlns:a16="http://schemas.microsoft.com/office/drawing/2014/main" id="{83539D61-D2C3-4B0D-8C30-EB0154D61378}"/>
+                <a16:creationId xmlns:a16="http://schemas.microsoft.com/office/drawing/2014/main" id="{729F00A6-5F05-4930-812A-81F6A3289D51}"/>
               </a:ext>
             </a:extLst>
           </p:cNvPr>
@@ -5874,14 +5874,14 @@
             <a:pPr algn="ctr">
               <a:defRPr sz="788" b="1">
                 <a:solidFill>
-                  <a:srgbClr val="9C3451"/>
+                  <a:srgbClr val="9B3A2B"/>
                 </a:solidFill>
               </a:defRPr>
             </a:pPr>
             <a:r>
               <a:rPr sz="788" b="1">
                 <a:solidFill>
-                  <a:srgbClr val="9C3451"/>
+                  <a:srgbClr val="9B3A2B"/>
                 </a:solidFill>
               </a:rPr>
               <a:t>FOUR VIEWS</a:t>
@@ -5894,7 +5894,7 @@
           <p:cNvPr id="108" name="export-0">
             <a:extLst xmlns:a="http://schemas.openxmlformats.org/drawingml/2006/main">
               <a:ext uri="{FF2B5EF4-FFF2-40B4-BE49-F238E27FC236}">
-                <a16:creationId xmlns:a16="http://schemas.microsoft.com/office/drawing/2014/main" id="{5E218888-807A-47C1-9646-44C06B69A5A6}"/>
+                <a16:creationId xmlns:a16="http://schemas.microsoft.com/office/drawing/2014/main" id="{3B52C87F-C18E-4A0F-B235-FD9E731BCAF4}"/>
               </a:ext>
             </a:extLst>
           </p:cNvPr>
@@ -5914,11 +5914,11 @@
             </a:avLst>
           </a:prstGeom>
           <a:solidFill xmlns:a="http://schemas.openxmlformats.org/drawingml/2006/main">
-            <a:srgbClr val="F5E9D8"/>
+            <a:srgbClr val="F6E9C9"/>
           </a:solidFill>
           <a:ln xmlns:a="http://schemas.openxmlformats.org/drawingml/2006/main" w="9525">
             <a:solidFill>
-              <a:srgbClr val="A4660A"/>
+              <a:srgbClr val="B97916"/>
             </a:solidFill>
             <a:prstDash val="solid"/>
           </a:ln>
@@ -5929,7 +5929,7 @@
           <p:cNvPr id="109" name="export-label-0">
             <a:extLst xmlns:a="http://schemas.openxmlformats.org/drawingml/2006/main">
               <a:ext uri="{FF2B5EF4-FFF2-40B4-BE49-F238E27FC236}">
-                <a16:creationId xmlns:a16="http://schemas.microsoft.com/office/drawing/2014/main" id="{9CEE1344-B11A-454D-83E9-5258987B65D5}"/>
+                <a16:creationId xmlns:a16="http://schemas.microsoft.com/office/drawing/2014/main" id="{EFDD0C9D-3745-4606-8E56-2D4402F3E026}"/>
               </a:ext>
             </a:extLst>
           </p:cNvPr>
@@ -5959,14 +5959,14 @@
             <a:pPr algn="ctr">
               <a:defRPr sz="900" b="1">
                 <a:solidFill>
-                  <a:srgbClr val="A4660A"/>
+                  <a:srgbClr val="B97916"/>
                 </a:solidFill>
               </a:defRPr>
             </a:pPr>
             <a:r>
               <a:rPr sz="900" b="1">
                 <a:solidFill>
-                  <a:srgbClr val="A4660A"/>
+                  <a:srgbClr val="B97916"/>
                 </a:solidFill>
               </a:rPr>
               <a:t>TBL</a:t>
@@ -5979,7 +5979,7 @@
           <p:cNvPr id="110" name="export-1">
             <a:extLst xmlns:a="http://schemas.openxmlformats.org/drawingml/2006/main">
               <a:ext uri="{FF2B5EF4-FFF2-40B4-BE49-F238E27FC236}">
-                <a16:creationId xmlns:a16="http://schemas.microsoft.com/office/drawing/2014/main" id="{653524E6-76EE-4BAE-B752-AC3B03F94002}"/>
+                <a16:creationId xmlns:a16="http://schemas.microsoft.com/office/drawing/2014/main" id="{81B911FA-60D4-4706-A330-C4E22958CC28}"/>
               </a:ext>
             </a:extLst>
           </p:cNvPr>
@@ -5999,11 +5999,11 @@
             </a:avLst>
           </a:prstGeom>
           <a:solidFill xmlns:a="http://schemas.openxmlformats.org/drawingml/2006/main">
-            <a:srgbClr val="ECEDEA"/>
+            <a:srgbClr val="E8E3D9"/>
           </a:solidFill>
           <a:ln xmlns:a="http://schemas.openxmlformats.org/drawingml/2006/main" w="9525">
             <a:solidFill>
-              <a:srgbClr val="C7CBC7"/>
+              <a:srgbClr val="C9C0B1"/>
             </a:solidFill>
             <a:prstDash val="solid"/>
           </a:ln>
@@ -6014,7 +6014,7 @@
           <p:cNvPr id="111" name="export-label-1">
             <a:extLst xmlns:a="http://schemas.openxmlformats.org/drawingml/2006/main">
               <a:ext uri="{FF2B5EF4-FFF2-40B4-BE49-F238E27FC236}">
-                <a16:creationId xmlns:a16="http://schemas.microsoft.com/office/drawing/2014/main" id="{8CBD22BE-E4F0-4791-9C67-7D80FFC32BD8}"/>
+                <a16:creationId xmlns:a16="http://schemas.microsoft.com/office/drawing/2014/main" id="{B2ACBA17-FE6E-4E97-B2FF-6A2B06F0EAB1}"/>
               </a:ext>
             </a:extLst>
           </p:cNvPr>
@@ -6044,14 +6044,14 @@
             <a:pPr algn="ctr">
               <a:defRPr sz="788" b="1">
                 <a:solidFill>
-                  <a:srgbClr val="183B5C"/>
+                  <a:srgbClr val="36453B"/>
                 </a:solidFill>
               </a:defRPr>
             </a:pPr>
             <a:r>
               <a:rPr sz="788" b="1">
                 <a:solidFill>
-                  <a:srgbClr val="183B5C"/>
+                  <a:srgbClr val="36453B"/>
                 </a:solidFill>
               </a:rPr>
               <a:t>MD</a:t>
@@ -6064,7 +6064,7 @@
           <p:cNvPr id="112" name="export-2">
             <a:extLst xmlns:a="http://schemas.openxmlformats.org/drawingml/2006/main">
               <a:ext uri="{FF2B5EF4-FFF2-40B4-BE49-F238E27FC236}">
-                <a16:creationId xmlns:a16="http://schemas.microsoft.com/office/drawing/2014/main" id="{98ACC30A-A833-42F3-BB19-79EC0C2CCEF8}"/>
+                <a16:creationId xmlns:a16="http://schemas.microsoft.com/office/drawing/2014/main" id="{8CD4D586-4EBF-4044-B1C3-1F028EC5A54D}"/>
               </a:ext>
             </a:extLst>
           </p:cNvPr>
@@ -6084,11 +6084,11 @@
             </a:avLst>
           </a:prstGeom>
           <a:solidFill xmlns:a="http://schemas.openxmlformats.org/drawingml/2006/main">
-            <a:srgbClr val="ECEDEA"/>
+            <a:srgbClr val="E8E3D9"/>
           </a:solidFill>
           <a:ln xmlns:a="http://schemas.openxmlformats.org/drawingml/2006/main" w="9525">
             <a:solidFill>
-              <a:srgbClr val="C7CBC7"/>
+              <a:srgbClr val="C9C0B1"/>
             </a:solidFill>
             <a:prstDash val="solid"/>
           </a:ln>
@@ -6099,7 +6099,7 @@
           <p:cNvPr id="113" name="export-label-2">
             <a:extLst xmlns:a="http://schemas.openxmlformats.org/drawingml/2006/main">
               <a:ext uri="{FF2B5EF4-FFF2-40B4-BE49-F238E27FC236}">
-                <a16:creationId xmlns:a16="http://schemas.microsoft.com/office/drawing/2014/main" id="{C03D0486-0D24-4CA1-8AEF-38373D50D60A}"/>
+                <a16:creationId xmlns:a16="http://schemas.microsoft.com/office/drawing/2014/main" id="{6D859359-3FF2-40E3-8214-96676B64731C}"/>
               </a:ext>
             </a:extLst>
           </p:cNvPr>
@@ -6129,14 +6129,14 @@
             <a:pPr algn="ctr">
               <a:defRPr sz="788" b="1">
                 <a:solidFill>
-                  <a:srgbClr val="183B5C"/>
+                  <a:srgbClr val="36453B"/>
                 </a:solidFill>
               </a:defRPr>
             </a:pPr>
             <a:r>
               <a:rPr sz="788" b="1">
                 <a:solidFill>
-                  <a:srgbClr val="183B5C"/>
+                  <a:srgbClr val="36453B"/>
                 </a:solidFill>
               </a:rPr>
               <a:t>JSON</a:t>
@@ -6149,7 +6149,7 @@
           <p:cNvPr id="114" name="export-3">
             <a:extLst xmlns:a="http://schemas.openxmlformats.org/drawingml/2006/main">
               <a:ext uri="{FF2B5EF4-FFF2-40B4-BE49-F238E27FC236}">
-                <a16:creationId xmlns:a16="http://schemas.microsoft.com/office/drawing/2014/main" id="{AD5CF342-E8A7-4E9C-A373-76281D301499}"/>
+                <a16:creationId xmlns:a16="http://schemas.microsoft.com/office/drawing/2014/main" id="{32CFADD4-9F09-49B0-8E4C-50DA202D549A}"/>
               </a:ext>
             </a:extLst>
           </p:cNvPr>
@@ -6169,11 +6169,11 @@
             </a:avLst>
           </a:prstGeom>
           <a:solidFill xmlns:a="http://schemas.openxmlformats.org/drawingml/2006/main">
-            <a:srgbClr val="ECEDEA"/>
+            <a:srgbClr val="E8E3D9"/>
           </a:solidFill>
           <a:ln xmlns:a="http://schemas.openxmlformats.org/drawingml/2006/main" w="9525">
             <a:solidFill>
-              <a:srgbClr val="C7CBC7"/>
+              <a:srgbClr val="C9C0B1"/>
             </a:solidFill>
             <a:prstDash val="solid"/>
           </a:ln>
@@ -6184,7 +6184,7 @@
           <p:cNvPr id="115" name="export-label-3">
             <a:extLst xmlns:a="http://schemas.openxmlformats.org/drawingml/2006/main">
               <a:ext uri="{FF2B5EF4-FFF2-40B4-BE49-F238E27FC236}">
-                <a16:creationId xmlns:a16="http://schemas.microsoft.com/office/drawing/2014/main" id="{50E22A1C-6673-4DA3-B5E4-75C76CA84C98}"/>
+                <a16:creationId xmlns:a16="http://schemas.microsoft.com/office/drawing/2014/main" id="{AAFA2849-060C-4E44-B2E6-7843A5DBE214}"/>
               </a:ext>
             </a:extLst>
           </p:cNvPr>
@@ -6214,14 +6214,14 @@
             <a:pPr algn="ctr">
               <a:defRPr sz="788" b="1">
                 <a:solidFill>
-                  <a:srgbClr val="183B5C"/>
+                  <a:srgbClr val="36453B"/>
                 </a:solidFill>
               </a:defRPr>
             </a:pPr>
             <a:r>
               <a:rPr sz="788" b="1">
                 <a:solidFill>
-                  <a:srgbClr val="183B5C"/>
+                  <a:srgbClr val="36453B"/>
                 </a:solidFill>
               </a:rPr>
               <a:t>CSV</a:t>
@@ -6234,7 +6234,7 @@
           <p:cNvPr id="116" name="footer-rule">
             <a:extLst xmlns:a="http://schemas.openxmlformats.org/drawingml/2006/main">
               <a:ext uri="{FF2B5EF4-FFF2-40B4-BE49-F238E27FC236}">
-                <a16:creationId xmlns:a16="http://schemas.microsoft.com/office/drawing/2014/main" id="{DFCDAC26-3775-49D8-A720-06E7B5EABCC4}"/>
+                <a16:creationId xmlns:a16="http://schemas.microsoft.com/office/drawing/2014/main" id="{A522A2F7-F3D5-4F16-B35D-AA42DFB3B4AD}"/>
               </a:ext>
             </a:extLst>
           </p:cNvPr>
@@ -6254,7 +6254,7 @@
           <a:noFill xmlns:a="http://schemas.openxmlformats.org/drawingml/2006/main"/>
           <a:ln xmlns:a="http://schemas.openxmlformats.org/drawingml/2006/main" w="13335">
             <a:solidFill>
-              <a:srgbClr val="191B1A"/>
+              <a:srgbClr val="24211D"/>
             </a:solidFill>
             <a:prstDash val="solid"/>
           </a:ln>
@@ -6265,7 +6265,7 @@
           <p:cNvPr id="117" name="failure-label">
             <a:extLst xmlns:a="http://schemas.openxmlformats.org/drawingml/2006/main">
               <a:ext uri="{FF2B5EF4-FFF2-40B4-BE49-F238E27FC236}">
-                <a16:creationId xmlns:a16="http://schemas.microsoft.com/office/drawing/2014/main" id="{57F59F64-265D-46E5-B14F-D04F612E688D}"/>
+                <a16:creationId xmlns:a16="http://schemas.microsoft.com/office/drawing/2014/main" id="{440DEBA1-3B1B-4961-9A02-5CE912EFD100}"/>
               </a:ext>
             </a:extLst>
           </p:cNvPr>
@@ -6295,14 +6295,14 @@
             <a:pPr algn="l">
               <a:defRPr sz="900" b="1">
                 <a:solidFill>
-                  <a:srgbClr val="9C3451"/>
+                  <a:srgbClr val="9B3A2B"/>
                 </a:solidFill>
               </a:defRPr>
             </a:pPr>
             <a:r>
               <a:rPr sz="900" b="1">
                 <a:solidFill>
-                  <a:srgbClr val="9C3451"/>
+                  <a:srgbClr val="9B3A2B"/>
                 </a:solidFill>
               </a:rPr>
               <a:t>FAILURE SEMANTICS</a:t>
@@ -6315,7 +6315,7 @@
           <p:cNvPr id="118" name="failure-copy">
             <a:extLst xmlns:a="http://schemas.openxmlformats.org/drawingml/2006/main">
               <a:ext uri="{FF2B5EF4-FFF2-40B4-BE49-F238E27FC236}">
-                <a16:creationId xmlns:a16="http://schemas.microsoft.com/office/drawing/2014/main" id="{E964BCD7-F030-4103-A426-C9C1B10DE7BB}"/>
+                <a16:creationId xmlns:a16="http://schemas.microsoft.com/office/drawing/2014/main" id="{4D8995DD-941B-444C-9732-9AC1E7366813}"/>
               </a:ext>
             </a:extLst>
           </p:cNvPr>
@@ -6345,14 +6345,14 @@
             <a:pPr algn="l">
               <a:defRPr sz="1050" b="1">
                 <a:solidFill>
-                  <a:srgbClr val="183B5C"/>
+                  <a:srgbClr val="36453B"/>
                 </a:solidFill>
               </a:defRPr>
             </a:pPr>
             <a:r>
               <a:rPr sz="1050" b="1">
                 <a:solidFill>
-                  <a:srgbClr val="183B5C"/>
+                  <a:srgbClr val="36453B"/>
                 </a:solidFill>
               </a:rPr>
               <a:t>missing field → partial profile   ·   failed provider → warning   ·   no sourced profile → no report</a:t>
@@ -6365,7 +6365,7 @@
           <p:cNvPr id="119" name="boundary-label">
             <a:extLst xmlns:a="http://schemas.openxmlformats.org/drawingml/2006/main">
               <a:ext uri="{FF2B5EF4-FFF2-40B4-BE49-F238E27FC236}">
-                <a16:creationId xmlns:a16="http://schemas.microsoft.com/office/drawing/2014/main" id="{A4A14432-5F83-46D2-A85F-24A8D1FB1BF5}"/>
+                <a16:creationId xmlns:a16="http://schemas.microsoft.com/office/drawing/2014/main" id="{586D16FD-BA9A-4AC0-A9D5-B8576393A116}"/>
               </a:ext>
             </a:extLst>
           </p:cNvPr>
@@ -6395,14 +6395,14 @@
             <a:pPr algn="l">
               <a:defRPr sz="900" b="1">
                 <a:solidFill>
-                  <a:srgbClr val="9C3451"/>
+                  <a:srgbClr val="9B3A2B"/>
                 </a:solidFill>
               </a:defRPr>
             </a:pPr>
             <a:r>
               <a:rPr sz="900" b="1">
                 <a:solidFill>
-                  <a:srgbClr val="9C3451"/>
+                  <a:srgbClr val="9B3A2B"/>
                 </a:solidFill>
               </a:rPr>
               <a:t>EVIDENCE BOUNDARY</a:t>
@@ -6415,7 +6415,7 @@
           <p:cNvPr id="120" name="boundary-copy">
             <a:extLst xmlns:a="http://schemas.openxmlformats.org/drawingml/2006/main">
               <a:ext uri="{FF2B5EF4-FFF2-40B4-BE49-F238E27FC236}">
-                <a16:creationId xmlns:a16="http://schemas.microsoft.com/office/drawing/2014/main" id="{E86A51E2-6D9C-4342-BC81-8F233E44CF81}"/>
+                <a16:creationId xmlns:a16="http://schemas.microsoft.com/office/drawing/2014/main" id="{4FFF401A-3280-46BB-A28A-799B7A2FB225}"/>
               </a:ext>
             </a:extLst>
           </p:cNvPr>
@@ -6445,14 +6445,14 @@
             <a:pPr algn="l">
               <a:defRPr sz="1013" b="0">
                 <a:solidFill>
-                  <a:srgbClr val="191B1A"/>
+                  <a:srgbClr val="24211D"/>
                 </a:solidFill>
               </a:defRPr>
             </a:pPr>
             <a:r>
               <a:rPr sz="1013" b="0">
                 <a:solidFill>
-                  <a:srgbClr val="191B1A"/>
+                  <a:srgbClr val="24211D"/>
                 </a:solidFill>
               </a:rPr>
               <a:t>Complete deterministic fixture—not a live crawl, current market comparison, recommendation-quality study, or factuality evaluation.</a:t>
@@ -6465,7 +6465,7 @@
           <p:cNvPr id="121" name="sources">
             <a:extLst xmlns:a="http://schemas.openxmlformats.org/drawingml/2006/main">
               <a:ext uri="{FF2B5EF4-FFF2-40B4-BE49-F238E27FC236}">
-                <a16:creationId xmlns:a16="http://schemas.microsoft.com/office/drawing/2014/main" id="{8A2AC8F3-3187-4E6D-BC10-24A5E8DFDC8B}"/>
+                <a16:creationId xmlns:a16="http://schemas.microsoft.com/office/drawing/2014/main" id="{A8B65906-1762-45AF-967A-B73553E270FC}"/>
               </a:ext>
             </a:extLst>
           </p:cNvPr>
@@ -6495,14 +6495,14 @@
             <a:pPr algn="ctr">
               <a:defRPr sz="750" b="0">
                 <a:solidFill>
-                  <a:srgbClr val="656A67"/>
+                  <a:srgbClr val="6B655E"/>
                 </a:solidFill>
               </a:defRPr>
             </a:pPr>
             <a:r>
               <a:rPr sz="750" b="0">
                 <a:solidFill>
-                  <a:srgbClr val="656A67"/>
+                  <a:srgbClr val="6B655E"/>
                 </a:solidFill>
               </a:rPr>
               <a:t>Sources: examples/demo-report.json · src/intellicrawl/pipeline.py · demo.py · renderers.py</a:t>
@@ -6513,7 +6513,7 @@
     </p:spTree>
     <p:extLst>
       <p:ext uri="{BB962C8B-B14F-4D97-AF65-F5344CB8AC3E}">
-        <p14:creationId xmlns:p14="http://schemas.microsoft.com/office/powerpoint/2010/main" val="1093139077"/>
+        <p14:creationId xmlns:p14="http://schemas.microsoft.com/office/powerpoint/2010/main" val="734845620"/>
       </p:ext>
     </p:extLst>
   </p:cSld>

</xml_diff>

<commit_message>
Give the evidence figure a distinct cartographic palette (#8)
## What changed

- replaced the shared blue-and-cream treatment with a warm cartographic
identity
- uses juniper, terracotta, ochre, and plum to separate the provenance
paths
- documented the semantic color roles and retained explicit source
labels
- regenerated editable and publication exports plus preflight artifacts

## Why

The figure layout was distinct, but its palette still felt like the same
template used by unrelated repositories. This revision gives
IntelliCrawl an earthy research-map character that matches provenance
and exploration.

## Validation

- make check: 49 tests passed, 94.20% coverage
- PowerPoint overflow test: passed
- final-size and grayscale inspection: passed
- PDF preflight: zero raster images
</commit_message>
<xml_diff>
--- a/docs/figures/evidence-trace/editable/intellicrawl-evidence-trace.pptx
+++ b/docs/figures/evidence-trace/editable/intellicrawl-evidence-trace.pptx
@@ -2,13 +2,13 @@
 <file path=ppt/presentation.xml><?xml version="1.0" encoding="utf-8"?>
 <p:presentation xmlns:p="http://schemas.openxmlformats.org/presentationml/2006/main">
   <p:sldMasterIdLst>
-    <p:sldMasterId xmlns:r="http://schemas.openxmlformats.org/officeDocument/2006/relationships" id="2147483648" r:id="R0b0adfbfb50b4331"/>
+    <p:sldMasterId xmlns:r="http://schemas.openxmlformats.org/officeDocument/2006/relationships" id="2147483648" r:id="R5e6e566ba32d4828"/>
   </p:sldMasterIdLst>
   <p:notesMasterIdLst>
-    <p:notesMasterId xmlns:r="http://schemas.openxmlformats.org/officeDocument/2006/relationships" r:id="R33f30813e1ec4c5d"/>
+    <p:notesMasterId xmlns:r="http://schemas.openxmlformats.org/officeDocument/2006/relationships" r:id="Rbd0a7bc4784c483e"/>
   </p:notesMasterIdLst>
   <p:sldIdLst>
-    <p:sldId xmlns:r="http://schemas.openxmlformats.org/officeDocument/2006/relationships" id="256" r:id="Rcd587aa0b8324e1d"/>
+    <p:sldId xmlns:r="http://schemas.openxmlformats.org/officeDocument/2006/relationships" id="256" r:id="Rbc5625743a8b40ed"/>
   </p:sldIdLst>
   <p:sldSz cx="12192000" cy="6858000"/>
   <p:notesSz cx="6858000" cy="9144000"/>
@@ -601,7 +601,7 @@
   </p:cSld>
   <p:clrMap bg1="lt1" tx1="dk1" bg2="lt2" tx2="dk2" accent1="accent1" accent2="accent2" accent3="accent3" accent4="accent4" accent5="accent5" accent6="accent6" hlink="hlink" folHlink="folHlink"/>
   <p:sldLayoutIdLst>
-    <p:sldLayoutId xmlns:r="http://schemas.openxmlformats.org/officeDocument/2006/relationships" id="2147483649" r:id="R9edb96dee95e4bda"/>
+    <p:sldLayoutId xmlns:r="http://schemas.openxmlformats.org/officeDocument/2006/relationships" id="2147483649" r:id="Rd9a520d8574d4f2e"/>
   </p:sldLayoutIdLst>
   <p:txStyles>
     <p:titleStyle>
@@ -1134,7 +1134,7 @@
     <p:bg>
       <p:bgPr>
         <a:solidFill xmlns:a="http://schemas.openxmlformats.org/drawingml/2006/main">
-          <a:srgbClr val="F7F4ED"/>
+          <a:srgbClr val="F3EFE6"/>
         </a:solidFill>
       </p:bgPr>
     </p:bg>
@@ -1152,7 +1152,7 @@
           <p:cNvPr id="122" name="title">
             <a:extLst xmlns:a="http://schemas.openxmlformats.org/drawingml/2006/main">
               <a:ext uri="{FF2B5EF4-FFF2-40B4-BE49-F238E27FC236}">
-                <a16:creationId xmlns:a16="http://schemas.microsoft.com/office/drawing/2014/main" id="{1E0FACC0-FCAB-45C1-9506-BC855968AB55}"/>
+                <a16:creationId xmlns:a16="http://schemas.microsoft.com/office/drawing/2014/main" id="{85A491DB-7A16-47B7-AE05-B128E4D64DA0}"/>
               </a:ext>
             </a:extLst>
           </p:cNvPr>
@@ -1182,14 +1182,14 @@
             <a:pPr algn="l">
               <a:defRPr sz="2550" b="1">
                 <a:solidFill>
-                  <a:srgbClr val="191B1A"/>
+                  <a:srgbClr val="24211D"/>
                 </a:solidFill>
               </a:defRPr>
             </a:pPr>
             <a:r>
               <a:rPr sz="2550" b="1">
                 <a:solidFill>
-                  <a:srgbClr val="191B1A"/>
+                  <a:srgbClr val="24211D"/>
                 </a:solidFill>
               </a:rPr>
               <a:t>IntelliCrawl exposes the source behind every normalized field</a:t>
@@ -1202,7 +1202,7 @@
           <p:cNvPr id="2" name="subtitle">
             <a:extLst xmlns:a="http://schemas.openxmlformats.org/drawingml/2006/main">
               <a:ext uri="{FF2B5EF4-FFF2-40B4-BE49-F238E27FC236}">
-                <a16:creationId xmlns:a16="http://schemas.microsoft.com/office/drawing/2014/main" id="{193676A9-AF46-4194-8DEE-F20983CD3459}"/>
+                <a16:creationId xmlns:a16="http://schemas.microsoft.com/office/drawing/2014/main" id="{5C8D5E13-C8D2-4934-9862-E75B0A6E3F61}"/>
               </a:ext>
             </a:extLst>
           </p:cNvPr>
@@ -1232,14 +1232,14 @@
             <a:pPr algn="l">
               <a:defRPr sz="1200" b="0">
                 <a:solidFill>
-                  <a:srgbClr val="656A67"/>
+                  <a:srgbClr val="6B655E"/>
                 </a:solidFill>
               </a:defRPr>
             </a:pPr>
             <a:r>
               <a:rPr sz="1200" b="0">
                 <a:solidFill>
-                  <a:srgbClr val="656A67"/>
+                  <a:srgbClr val="6B655E"/>
                 </a:solidFill>
               </a:rPr>
               <a:t>The dated fixture fans one research question into three parallel profiles, then validates each field-level source tag before export.</a:t>
@@ -1252,7 +1252,7 @@
           <p:cNvPr id="3" name="header-rule">
             <a:extLst xmlns:a="http://schemas.openxmlformats.org/drawingml/2006/main">
               <a:ext uri="{FF2B5EF4-FFF2-40B4-BE49-F238E27FC236}">
-                <a16:creationId xmlns:a16="http://schemas.microsoft.com/office/drawing/2014/main" id="{FC26C0A3-4EDB-4DBF-B529-EC7E065FA1A8}"/>
+                <a16:creationId xmlns:a16="http://schemas.microsoft.com/office/drawing/2014/main" id="{8B98FB42-97D9-4C6E-954C-9C8D5EA6F9ED}"/>
               </a:ext>
             </a:extLst>
           </p:cNvPr>
@@ -1272,7 +1272,7 @@
           <a:noFill xmlns:a="http://schemas.openxmlformats.org/drawingml/2006/main"/>
           <a:ln xmlns:a="http://schemas.openxmlformats.org/drawingml/2006/main" w="14288">
             <a:solidFill>
-              <a:srgbClr val="191B1A"/>
+              <a:srgbClr val="24211D"/>
             </a:solidFill>
             <a:prstDash val="solid"/>
           </a:ln>
@@ -1283,7 +1283,7 @@
           <p:cNvPr id="4" name="question-to-spine">
             <a:extLst xmlns:a="http://schemas.openxmlformats.org/drawingml/2006/main">
               <a:ext uri="{FF2B5EF4-FFF2-40B4-BE49-F238E27FC236}">
-                <a16:creationId xmlns:a16="http://schemas.microsoft.com/office/drawing/2014/main" id="{0016F4BE-8C83-4A12-89DC-AA6CAB54FE95}"/>
+                <a16:creationId xmlns:a16="http://schemas.microsoft.com/office/drawing/2014/main" id="{F28C4657-00BF-45C0-AEE1-91F17F6D8846}"/>
               </a:ext>
             </a:extLst>
           </p:cNvPr>
@@ -1301,11 +1301,11 @@
             <a:avLst/>
           </a:prstGeom>
           <a:solidFill xmlns:a="http://schemas.openxmlformats.org/drawingml/2006/main">
-            <a:srgbClr val="183B5C"/>
+            <a:srgbClr val="36453B"/>
           </a:solidFill>
           <a:ln xmlns:a="http://schemas.openxmlformats.org/drawingml/2006/main" w="0">
             <a:solidFill>
-              <a:srgbClr val="183B5C"/>
+              <a:srgbClr val="36453B"/>
             </a:solidFill>
             <a:prstDash val="solid"/>
           </a:ln>
@@ -1316,7 +1316,7 @@
           <p:cNvPr id="5" name="fanout-spine">
             <a:extLst xmlns:a="http://schemas.openxmlformats.org/drawingml/2006/main">
               <a:ext uri="{FF2B5EF4-FFF2-40B4-BE49-F238E27FC236}">
-                <a16:creationId xmlns:a16="http://schemas.microsoft.com/office/drawing/2014/main" id="{D50E1C2D-C2DC-4BDE-BAF7-B6289279A498}"/>
+                <a16:creationId xmlns:a16="http://schemas.microsoft.com/office/drawing/2014/main" id="{5C846AE7-2E1C-4687-8B38-02BFFCD6C658}"/>
               </a:ext>
             </a:extLst>
           </p:cNvPr>
@@ -1336,7 +1336,7 @@
           <a:noFill xmlns:a="http://schemas.openxmlformats.org/drawingml/2006/main"/>
           <a:ln xmlns:a="http://schemas.openxmlformats.org/drawingml/2006/main" w="15240">
             <a:solidFill>
-              <a:srgbClr val="183B5C"/>
+              <a:srgbClr val="36453B"/>
             </a:solidFill>
             <a:prstDash val="solid"/>
           </a:ln>
@@ -1347,7 +1347,7 @@
           <p:cNvPr id="6" name="spine-to-lane-0">
             <a:extLst xmlns:a="http://schemas.openxmlformats.org/drawingml/2006/main">
               <a:ext uri="{FF2B5EF4-FFF2-40B4-BE49-F238E27FC236}">
-                <a16:creationId xmlns:a16="http://schemas.microsoft.com/office/drawing/2014/main" id="{3D2A0B8C-F638-4E61-B9C7-DA50B9D744AD}"/>
+                <a16:creationId xmlns:a16="http://schemas.microsoft.com/office/drawing/2014/main" id="{1CBC9286-AD21-4A3D-8DF4-93C0F68FEBED}"/>
               </a:ext>
             </a:extLst>
           </p:cNvPr>
@@ -1365,11 +1365,11 @@
             <a:avLst/>
           </a:prstGeom>
           <a:solidFill xmlns:a="http://schemas.openxmlformats.org/drawingml/2006/main">
-            <a:srgbClr val="183B5C"/>
+            <a:srgbClr val="36453B"/>
           </a:solidFill>
           <a:ln xmlns:a="http://schemas.openxmlformats.org/drawingml/2006/main" w="0">
             <a:solidFill>
-              <a:srgbClr val="183B5C"/>
+              <a:srgbClr val="36453B"/>
             </a:solidFill>
             <a:prstDash val="solid"/>
           </a:ln>
@@ -1380,7 +1380,7 @@
           <p:cNvPr id="7" name="spine-to-lane-1">
             <a:extLst xmlns:a="http://schemas.openxmlformats.org/drawingml/2006/main">
               <a:ext uri="{FF2B5EF4-FFF2-40B4-BE49-F238E27FC236}">
-                <a16:creationId xmlns:a16="http://schemas.microsoft.com/office/drawing/2014/main" id="{9DE3EB53-2E15-44EF-BD90-287BC3CB700C}"/>
+                <a16:creationId xmlns:a16="http://schemas.microsoft.com/office/drawing/2014/main" id="{B159F6AA-193E-41B2-A1C7-D95173B76DE4}"/>
               </a:ext>
             </a:extLst>
           </p:cNvPr>
@@ -1398,11 +1398,11 @@
             <a:avLst/>
           </a:prstGeom>
           <a:solidFill xmlns:a="http://schemas.openxmlformats.org/drawingml/2006/main">
-            <a:srgbClr val="183B5C"/>
+            <a:srgbClr val="36453B"/>
           </a:solidFill>
           <a:ln xmlns:a="http://schemas.openxmlformats.org/drawingml/2006/main" w="0">
             <a:solidFill>
-              <a:srgbClr val="183B5C"/>
+              <a:srgbClr val="36453B"/>
             </a:solidFill>
             <a:prstDash val="solid"/>
           </a:ln>
@@ -1413,7 +1413,7 @@
           <p:cNvPr id="8" name="spine-to-lane-2">
             <a:extLst xmlns:a="http://schemas.openxmlformats.org/drawingml/2006/main">
               <a:ext uri="{FF2B5EF4-FFF2-40B4-BE49-F238E27FC236}">
-                <a16:creationId xmlns:a16="http://schemas.microsoft.com/office/drawing/2014/main" id="{0DE84638-C8A0-49A6-AC91-B8400EAA7C03}"/>
+                <a16:creationId xmlns:a16="http://schemas.microsoft.com/office/drawing/2014/main" id="{AC7D9B9B-939D-4976-AEEE-1E8D678BF745}"/>
               </a:ext>
             </a:extLst>
           </p:cNvPr>
@@ -1431,11 +1431,11 @@
             <a:avLst/>
           </a:prstGeom>
           <a:solidFill xmlns:a="http://schemas.openxmlformats.org/drawingml/2006/main">
-            <a:srgbClr val="183B5C"/>
+            <a:srgbClr val="36453B"/>
           </a:solidFill>
           <a:ln xmlns:a="http://schemas.openxmlformats.org/drawingml/2006/main" w="0">
             <a:solidFill>
-              <a:srgbClr val="183B5C"/>
+              <a:srgbClr val="36453B"/>
             </a:solidFill>
             <a:prstDash val="solid"/>
           </a:ln>
@@ -1446,7 +1446,7 @@
           <p:cNvPr id="9" name="lane-to-report-0">
             <a:extLst xmlns:a="http://schemas.openxmlformats.org/drawingml/2006/main">
               <a:ext uri="{FF2B5EF4-FFF2-40B4-BE49-F238E27FC236}">
-                <a16:creationId xmlns:a16="http://schemas.microsoft.com/office/drawing/2014/main" id="{B76C4EB1-0E7B-4C9D-8E50-E887F38470A7}"/>
+                <a16:creationId xmlns:a16="http://schemas.microsoft.com/office/drawing/2014/main" id="{E3D10DDD-84B4-4663-A91D-997A080814E4}"/>
               </a:ext>
             </a:extLst>
           </p:cNvPr>
@@ -1464,11 +1464,11 @@
             <a:avLst/>
           </a:prstGeom>
           <a:solidFill xmlns:a="http://schemas.openxmlformats.org/drawingml/2006/main">
-            <a:srgbClr val="183B5C"/>
+            <a:srgbClr val="36453B"/>
           </a:solidFill>
           <a:ln xmlns:a="http://schemas.openxmlformats.org/drawingml/2006/main" w="0">
             <a:solidFill>
-              <a:srgbClr val="183B5C"/>
+              <a:srgbClr val="36453B"/>
             </a:solidFill>
             <a:prstDash val="solid"/>
           </a:ln>
@@ -1479,7 +1479,7 @@
           <p:cNvPr id="10" name="lane-to-report-1">
             <a:extLst xmlns:a="http://schemas.openxmlformats.org/drawingml/2006/main">
               <a:ext uri="{FF2B5EF4-FFF2-40B4-BE49-F238E27FC236}">
-                <a16:creationId xmlns:a16="http://schemas.microsoft.com/office/drawing/2014/main" id="{22E6AEFF-F4B5-4275-96B2-F4C3AA3172D0}"/>
+                <a16:creationId xmlns:a16="http://schemas.microsoft.com/office/drawing/2014/main" id="{2681069E-3564-47A5-B434-9973A9FE2B86}"/>
               </a:ext>
             </a:extLst>
           </p:cNvPr>
@@ -1497,11 +1497,11 @@
             <a:avLst/>
           </a:prstGeom>
           <a:solidFill xmlns:a="http://schemas.openxmlformats.org/drawingml/2006/main">
-            <a:srgbClr val="183B5C"/>
+            <a:srgbClr val="36453B"/>
           </a:solidFill>
           <a:ln xmlns:a="http://schemas.openxmlformats.org/drawingml/2006/main" w="0">
             <a:solidFill>
-              <a:srgbClr val="183B5C"/>
+              <a:srgbClr val="36453B"/>
             </a:solidFill>
             <a:prstDash val="solid"/>
           </a:ln>
@@ -1512,7 +1512,7 @@
           <p:cNvPr id="11" name="lane-to-report-2">
             <a:extLst xmlns:a="http://schemas.openxmlformats.org/drawingml/2006/main">
               <a:ext uri="{FF2B5EF4-FFF2-40B4-BE49-F238E27FC236}">
-                <a16:creationId xmlns:a16="http://schemas.microsoft.com/office/drawing/2014/main" id="{2435375C-94A4-461F-95B8-36FAFE13DD3D}"/>
+                <a16:creationId xmlns:a16="http://schemas.microsoft.com/office/drawing/2014/main" id="{0F1F8FC4-12ED-435F-8714-DDDDF1DB9E1E}"/>
               </a:ext>
             </a:extLst>
           </p:cNvPr>
@@ -1530,11 +1530,11 @@
             <a:avLst/>
           </a:prstGeom>
           <a:solidFill xmlns:a="http://schemas.openxmlformats.org/drawingml/2006/main">
-            <a:srgbClr val="183B5C"/>
+            <a:srgbClr val="36453B"/>
           </a:solidFill>
           <a:ln xmlns:a="http://schemas.openxmlformats.org/drawingml/2006/main" w="0">
             <a:solidFill>
-              <a:srgbClr val="183B5C"/>
+              <a:srgbClr val="36453B"/>
             </a:solidFill>
             <a:prstDash val="solid"/>
           </a:ln>
@@ -1545,7 +1545,7 @@
           <p:cNvPr id="12" name="report-to-exports">
             <a:extLst xmlns:a="http://schemas.openxmlformats.org/drawingml/2006/main">
               <a:ext uri="{FF2B5EF4-FFF2-40B4-BE49-F238E27FC236}">
-                <a16:creationId xmlns:a16="http://schemas.microsoft.com/office/drawing/2014/main" id="{048CC96A-1355-4593-87AD-101F9B2D791C}"/>
+                <a16:creationId xmlns:a16="http://schemas.microsoft.com/office/drawing/2014/main" id="{EE5C67B0-F9A2-4994-925A-51227FA00571}"/>
               </a:ext>
             </a:extLst>
           </p:cNvPr>
@@ -1563,11 +1563,11 @@
             <a:avLst/>
           </a:prstGeom>
           <a:solidFill xmlns:a="http://schemas.openxmlformats.org/drawingml/2006/main">
-            <a:srgbClr val="9C3451"/>
+            <a:srgbClr val="9B3A2B"/>
           </a:solidFill>
           <a:ln xmlns:a="http://schemas.openxmlformats.org/drawingml/2006/main" w="0">
             <a:solidFill>
-              <a:srgbClr val="9C3451"/>
+              <a:srgbClr val="9B3A2B"/>
             </a:solidFill>
             <a:prstDash val="solid"/>
           </a:ln>
@@ -1578,7 +1578,7 @@
           <p:cNvPr id="13" name="input-label">
             <a:extLst xmlns:a="http://schemas.openxmlformats.org/drawingml/2006/main">
               <a:ext uri="{FF2B5EF4-FFF2-40B4-BE49-F238E27FC236}">
-                <a16:creationId xmlns:a16="http://schemas.microsoft.com/office/drawing/2014/main" id="{88214B90-E15C-4297-AA86-B76B67BB3D5D}"/>
+                <a16:creationId xmlns:a16="http://schemas.microsoft.com/office/drawing/2014/main" id="{000EDABD-9AE0-4514-AA86-392E9D2BF8B7}"/>
               </a:ext>
             </a:extLst>
           </p:cNvPr>
@@ -1608,14 +1608,14 @@
             <a:pPr algn="l">
               <a:defRPr sz="900" b="1">
                 <a:solidFill>
-                  <a:srgbClr val="9C3451"/>
+                  <a:srgbClr val="9B3A2B"/>
                 </a:solidFill>
               </a:defRPr>
             </a:pPr>
             <a:r>
               <a:rPr sz="900" b="1">
                 <a:solidFill>
-                  <a:srgbClr val="9C3451"/>
+                  <a:srgbClr val="9B3A2B"/>
                 </a:solidFill>
               </a:rPr>
               <a:t>ONE RESEARCH QUESTION</a:t>
@@ -1628,7 +1628,7 @@
           <p:cNvPr id="14" name="query">
             <a:extLst xmlns:a="http://schemas.openxmlformats.org/drawingml/2006/main">
               <a:ext uri="{FF2B5EF4-FFF2-40B4-BE49-F238E27FC236}">
-                <a16:creationId xmlns:a16="http://schemas.microsoft.com/office/drawing/2014/main" id="{9EB46CBA-FAEA-4D9A-9AB1-742E1034D2F5}"/>
+                <a16:creationId xmlns:a16="http://schemas.microsoft.com/office/drawing/2014/main" id="{BEFCBF34-DE8C-4B42-9775-1AB60EF16F59}"/>
               </a:ext>
             </a:extLst>
           </p:cNvPr>
@@ -1648,11 +1648,11 @@
             </a:avLst>
           </a:prstGeom>
           <a:solidFill xmlns:a="http://schemas.openxmlformats.org/drawingml/2006/main">
-            <a:srgbClr val="E7EDF2"/>
+            <a:srgbClr val="E7E4D7"/>
           </a:solidFill>
           <a:ln xmlns:a="http://schemas.openxmlformats.org/drawingml/2006/main" w="11430">
             <a:solidFill>
-              <a:srgbClr val="183B5C"/>
+              <a:srgbClr val="36453B"/>
             </a:solidFill>
             <a:prstDash val="solid"/>
           </a:ln>
@@ -1663,7 +1663,7 @@
           <p:cNvPr id="15" name="query-text">
             <a:extLst xmlns:a="http://schemas.openxmlformats.org/drawingml/2006/main">
               <a:ext uri="{FF2B5EF4-FFF2-40B4-BE49-F238E27FC236}">
-                <a16:creationId xmlns:a16="http://schemas.microsoft.com/office/drawing/2014/main" id="{8DAADE54-A78F-4D64-953A-F759648E146D}"/>
+                <a16:creationId xmlns:a16="http://schemas.microsoft.com/office/drawing/2014/main" id="{5EAD1D8F-9A28-43D6-B0A3-141EA373508F}"/>
               </a:ext>
             </a:extLst>
           </p:cNvPr>
@@ -1693,14 +1693,14 @@
             <a:pPr algn="l">
               <a:defRPr sz="1275" b="1">
                 <a:solidFill>
-                  <a:srgbClr val="183B5C"/>
+                  <a:srgbClr val="36453B"/>
                 </a:solidFill>
               </a:defRPr>
             </a:pPr>
             <a:r>
               <a:rPr sz="1275" b="1">
                 <a:solidFill>
-                  <a:srgbClr val="183B5C"/>
+                  <a:srgbClr val="36453B"/>
                 </a:solidFill>
               </a:rPr>
               <a:t>vector databases for production RAG</a:t>
@@ -1713,7 +1713,7 @@
           <p:cNvPr id="16" name="query-date">
             <a:extLst xmlns:a="http://schemas.openxmlformats.org/drawingml/2006/main">
               <a:ext uri="{FF2B5EF4-FFF2-40B4-BE49-F238E27FC236}">
-                <a16:creationId xmlns:a16="http://schemas.microsoft.com/office/drawing/2014/main" id="{E1CF7D9E-C95D-493C-980A-A47E9220604E}"/>
+                <a16:creationId xmlns:a16="http://schemas.microsoft.com/office/drawing/2014/main" id="{F5CCCF3B-1DEE-4E68-B23B-ABC2E9C3E473}"/>
               </a:ext>
             </a:extLst>
           </p:cNvPr>
@@ -1743,14 +1743,14 @@
             <a:pPr algn="l">
               <a:defRPr sz="825" b="0">
                 <a:solidFill>
-                  <a:srgbClr val="656A67"/>
+                  <a:srgbClr val="6B655E"/>
                 </a:solidFill>
               </a:defRPr>
             </a:pPr>
             <a:r>
               <a:rPr sz="825" b="0">
                 <a:solidFill>
-                  <a:srgbClr val="656A67"/>
+                  <a:srgbClr val="6B655E"/>
                 </a:solidFill>
               </a:rPr>
               <a:t>dated fixture · 2026-07-11</a:t>
@@ -1763,7 +1763,7 @@
           <p:cNvPr id="17" name="parallel-label">
             <a:extLst xmlns:a="http://schemas.openxmlformats.org/drawingml/2006/main">
               <a:ext uri="{FF2B5EF4-FFF2-40B4-BE49-F238E27FC236}">
-                <a16:creationId xmlns:a16="http://schemas.microsoft.com/office/drawing/2014/main" id="{3B2CAED1-45BD-40C4-95D9-FC7CEDF66116}"/>
+                <a16:creationId xmlns:a16="http://schemas.microsoft.com/office/drawing/2014/main" id="{AE1F63CF-FE0C-441A-B5A3-2674E43BD297}"/>
               </a:ext>
             </a:extLst>
           </p:cNvPr>
@@ -1793,14 +1793,14 @@
             <a:pPr algn="l">
               <a:defRPr sz="900" b="1">
                 <a:solidFill>
-                  <a:srgbClr val="9C3451"/>
+                  <a:srgbClr val="9B3A2B"/>
                 </a:solidFill>
               </a:defRPr>
             </a:pPr>
             <a:r>
               <a:rPr sz="900" b="1">
                 <a:solidFill>
-                  <a:srgbClr val="9C3451"/>
+                  <a:srgbClr val="9B3A2B"/>
                 </a:solidFill>
               </a:rPr>
               <a:t>PARALLEL PROFILES WITH LOCAL SOURCE TAGS</a:t>
@@ -1813,7 +1813,7 @@
           <p:cNvPr id="18" name="tool-0">
             <a:extLst xmlns:a="http://schemas.openxmlformats.org/drawingml/2006/main">
               <a:ext uri="{FF2B5EF4-FFF2-40B4-BE49-F238E27FC236}">
-                <a16:creationId xmlns:a16="http://schemas.microsoft.com/office/drawing/2014/main" id="{7CA322E5-20A5-426D-A0D0-0CDA4B8056DA}"/>
+                <a16:creationId xmlns:a16="http://schemas.microsoft.com/office/drawing/2014/main" id="{FCB4B0D9-3AE2-43D7-A056-B9F5A89015F9}"/>
               </a:ext>
             </a:extLst>
           </p:cNvPr>
@@ -1843,14 +1843,14 @@
             <a:pPr algn="l">
               <a:defRPr sz="1350" b="1">
                 <a:solidFill>
-                  <a:srgbClr val="2E7752"/>
+                  <a:srgbClr val="466B4A"/>
                 </a:solidFill>
               </a:defRPr>
             </a:pPr>
             <a:r>
               <a:rPr sz="1350" b="1">
                 <a:solidFill>
-                  <a:srgbClr val="2E7752"/>
+                  <a:srgbClr val="466B4A"/>
                 </a:solidFill>
               </a:rPr>
               <a:t>Weaviate</a:t>
@@ -1863,7 +1863,7 @@
           <p:cNvPr id="19" name="status-0">
             <a:extLst xmlns:a="http://schemas.openxmlformats.org/drawingml/2006/main">
               <a:ext uri="{FF2B5EF4-FFF2-40B4-BE49-F238E27FC236}">
-                <a16:creationId xmlns:a16="http://schemas.microsoft.com/office/drawing/2014/main" id="{47C0BAE7-2883-492A-B078-D5713C131FF6}"/>
+                <a16:creationId xmlns:a16="http://schemas.microsoft.com/office/drawing/2014/main" id="{2D8A37C4-18AA-4652-80A9-A923D6C1CCF8}"/>
               </a:ext>
             </a:extLst>
           </p:cNvPr>
@@ -1893,14 +1893,14 @@
             <a:pPr algn="l">
               <a:defRPr sz="825" b="0">
                 <a:solidFill>
-                  <a:srgbClr val="656A67"/>
+                  <a:srgbClr val="6B655E"/>
                 </a:solidFill>
               </a:defRPr>
             </a:pPr>
             <a:r>
               <a:rPr sz="825" b="0">
                 <a:solidFill>
-                  <a:srgbClr val="656A67"/>
+                  <a:srgbClr val="6B655E"/>
                 </a:solidFill>
               </a:rPr>
               <a:t>complete</a:t>
@@ -1913,7 +1913,7 @@
           <p:cNvPr id="20" name="source-doc-0">
             <a:extLst xmlns:a="http://schemas.openxmlformats.org/drawingml/2006/main">
               <a:ext uri="{FF2B5EF4-FFF2-40B4-BE49-F238E27FC236}">
-                <a16:creationId xmlns:a16="http://schemas.microsoft.com/office/drawing/2014/main" id="{0E680222-B6FF-43B0-B2F0-6308AAE7DC89}"/>
+                <a16:creationId xmlns:a16="http://schemas.microsoft.com/office/drawing/2014/main" id="{FE044190-0394-48E5-B727-6D503B2A232D}"/>
               </a:ext>
             </a:extLst>
           </p:cNvPr>
@@ -1933,11 +1933,11 @@
             </a:avLst>
           </a:prstGeom>
           <a:solidFill xmlns:a="http://schemas.openxmlformats.org/drawingml/2006/main">
-            <a:srgbClr val="FFFFFF"/>
+            <a:srgbClr val="FFFDF7"/>
           </a:solidFill>
           <a:ln xmlns:a="http://schemas.openxmlformats.org/drawingml/2006/main" w="9525">
             <a:solidFill>
-              <a:srgbClr val="2E7752"/>
+              <a:srgbClr val="466B4A"/>
             </a:solidFill>
             <a:prstDash val="solid"/>
           </a:ln>
@@ -1948,7 +1948,7 @@
           <p:cNvPr id="21" name="source-doc-text-0">
             <a:extLst xmlns:a="http://schemas.openxmlformats.org/drawingml/2006/main">
               <a:ext uri="{FF2B5EF4-FFF2-40B4-BE49-F238E27FC236}">
-                <a16:creationId xmlns:a16="http://schemas.microsoft.com/office/drawing/2014/main" id="{E4335EAC-318A-443D-8C56-8F53F8D740AB}"/>
+                <a16:creationId xmlns:a16="http://schemas.microsoft.com/office/drawing/2014/main" id="{6DD876BE-D9AE-4B85-A50A-B013D005BAE4}"/>
               </a:ext>
             </a:extLst>
           </p:cNvPr>
@@ -1978,14 +1978,14 @@
             <a:pPr algn="l">
               <a:defRPr sz="900" b="1">
                 <a:solidFill>
-                  <a:srgbClr val="2E7752"/>
+                  <a:srgbClr val="466B4A"/>
                 </a:solidFill>
               </a:defRPr>
             </a:pPr>
             <a:r>
               <a:rPr sz="900" b="1">
                 <a:solidFill>
-                  <a:srgbClr val="2E7752"/>
+                  <a:srgbClr val="466B4A"/>
                 </a:solidFill>
               </a:rPr>
               <a:t>S1  docs</a:t>
@@ -1998,7 +1998,7 @@
           <p:cNvPr id="22" name="source-price-0">
             <a:extLst xmlns:a="http://schemas.openxmlformats.org/drawingml/2006/main">
               <a:ext uri="{FF2B5EF4-FFF2-40B4-BE49-F238E27FC236}">
-                <a16:creationId xmlns:a16="http://schemas.microsoft.com/office/drawing/2014/main" id="{B01A9A34-8DD1-4FB8-96F0-5A56C68A68B6}"/>
+                <a16:creationId xmlns:a16="http://schemas.microsoft.com/office/drawing/2014/main" id="{B58520B7-125A-4ECA-B2AD-E1B17E8E944F}"/>
               </a:ext>
             </a:extLst>
           </p:cNvPr>
@@ -2018,11 +2018,11 @@
             </a:avLst>
           </a:prstGeom>
           <a:solidFill xmlns:a="http://schemas.openxmlformats.org/drawingml/2006/main">
-            <a:srgbClr val="FFFFFF"/>
+            <a:srgbClr val="FFFDF7"/>
           </a:solidFill>
           <a:ln xmlns:a="http://schemas.openxmlformats.org/drawingml/2006/main" w="9525">
             <a:solidFill>
-              <a:srgbClr val="2E7752"/>
+              <a:srgbClr val="466B4A"/>
             </a:solidFill>
             <a:prstDash val="solid"/>
           </a:ln>
@@ -2033,7 +2033,7 @@
           <p:cNvPr id="23" name="source-price-text-0">
             <a:extLst xmlns:a="http://schemas.openxmlformats.org/drawingml/2006/main">
               <a:ext uri="{FF2B5EF4-FFF2-40B4-BE49-F238E27FC236}">
-                <a16:creationId xmlns:a16="http://schemas.microsoft.com/office/drawing/2014/main" id="{D1EEF16C-1FC8-4ACA-838C-803B31F12D51}"/>
+                <a16:creationId xmlns:a16="http://schemas.microsoft.com/office/drawing/2014/main" id="{DD51B30A-F71C-4EAE-AC55-8B276ECD9BB8}"/>
               </a:ext>
             </a:extLst>
           </p:cNvPr>
@@ -2063,14 +2063,14 @@
             <a:pPr algn="l">
               <a:defRPr sz="900" b="1">
                 <a:solidFill>
-                  <a:srgbClr val="2E7752"/>
+                  <a:srgbClr val="466B4A"/>
                 </a:solidFill>
               </a:defRPr>
             </a:pPr>
             <a:r>
               <a:rPr sz="900" b="1">
                 <a:solidFill>
-                  <a:srgbClr val="2E7752"/>
+                  <a:srgbClr val="466B4A"/>
                 </a:solidFill>
               </a:rPr>
               <a:t>S2  pricing</a:t>
@@ -2083,7 +2083,7 @@
           <p:cNvPr id="24" name="lane-rule-0">
             <a:extLst xmlns:a="http://schemas.openxmlformats.org/drawingml/2006/main">
               <a:ext uri="{FF2B5EF4-FFF2-40B4-BE49-F238E27FC236}">
-                <a16:creationId xmlns:a16="http://schemas.microsoft.com/office/drawing/2014/main" id="{9905CAEE-9117-4E98-B20F-67F8433D381F}"/>
+                <a16:creationId xmlns:a16="http://schemas.microsoft.com/office/drawing/2014/main" id="{C404C95A-09A1-400D-8697-CEC5BE48F8C4}"/>
               </a:ext>
             </a:extLst>
           </p:cNvPr>
@@ -2103,7 +2103,7 @@
           <a:noFill xmlns:a="http://schemas.openxmlformats.org/drawingml/2006/main"/>
           <a:ln xmlns:a="http://schemas.openxmlformats.org/drawingml/2006/main" w="11430">
             <a:solidFill>
-              <a:srgbClr val="2E7752"/>
+              <a:srgbClr val="466B4A"/>
             </a:solidFill>
             <a:prstDash val="solid"/>
           </a:ln>
@@ -2114,7 +2114,7 @@
           <p:cNvPr id="25" name="field-0-0">
             <a:extLst xmlns:a="http://schemas.openxmlformats.org/drawingml/2006/main">
               <a:ext uri="{FF2B5EF4-FFF2-40B4-BE49-F238E27FC236}">
-                <a16:creationId xmlns:a16="http://schemas.microsoft.com/office/drawing/2014/main" id="{1C147F74-B64B-4631-A661-090C8F5F2B13}"/>
+                <a16:creationId xmlns:a16="http://schemas.microsoft.com/office/drawing/2014/main" id="{3A3B2D84-F910-484C-A335-214E7F5D1627}"/>
               </a:ext>
             </a:extLst>
           </p:cNvPr>
@@ -2134,11 +2134,11 @@
             </a:avLst>
           </a:prstGeom>
           <a:solidFill xmlns:a="http://schemas.openxmlformats.org/drawingml/2006/main">
-            <a:srgbClr val="E7F0EA"/>
+            <a:srgbClr val="E8EFE4"/>
           </a:solidFill>
           <a:ln xmlns:a="http://schemas.openxmlformats.org/drawingml/2006/main" w="9525">
             <a:solidFill>
-              <a:srgbClr val="2E7752"/>
+              <a:srgbClr val="466B4A"/>
             </a:solidFill>
             <a:prstDash val="solid"/>
           </a:ln>
@@ -2149,7 +2149,7 @@
           <p:cNvPr id="26" name="field-name-0-0">
             <a:extLst xmlns:a="http://schemas.openxmlformats.org/drawingml/2006/main">
               <a:ext uri="{FF2B5EF4-FFF2-40B4-BE49-F238E27FC236}">
-                <a16:creationId xmlns:a16="http://schemas.microsoft.com/office/drawing/2014/main" id="{FCEB5378-BF3E-4222-828C-77D63323A3E3}"/>
+                <a16:creationId xmlns:a16="http://schemas.microsoft.com/office/drawing/2014/main" id="{7D00552F-34D7-49FF-9AF2-F42B46DDE29D}"/>
               </a:ext>
             </a:extLst>
           </p:cNvPr>
@@ -2179,14 +2179,14 @@
             <a:pPr algn="ctr">
               <a:defRPr sz="825" b="1">
                 <a:solidFill>
-                  <a:srgbClr val="191B1A"/>
+                  <a:srgbClr val="24211D"/>
                 </a:solidFill>
               </a:defRPr>
             </a:pPr>
             <a:r>
               <a:rPr sz="825" b="1">
                 <a:solidFill>
-                  <a:srgbClr val="191B1A"/>
+                  <a:srgbClr val="24211D"/>
                 </a:solidFill>
               </a:rPr>
               <a:t>profile</a:t>
@@ -2199,7 +2199,7 @@
           <p:cNvPr id="27" name="field-source-0-0">
             <a:extLst xmlns:a="http://schemas.openxmlformats.org/drawingml/2006/main">
               <a:ext uri="{FF2B5EF4-FFF2-40B4-BE49-F238E27FC236}">
-                <a16:creationId xmlns:a16="http://schemas.microsoft.com/office/drawing/2014/main" id="{714708BF-3146-433C-928D-8D03F9051EFF}"/>
+                <a16:creationId xmlns:a16="http://schemas.microsoft.com/office/drawing/2014/main" id="{E3423096-E8C3-429D-A462-E569A1C1E76E}"/>
               </a:ext>
             </a:extLst>
           </p:cNvPr>
@@ -2229,14 +2229,14 @@
             <a:pPr algn="ctr">
               <a:defRPr sz="900" b="1">
                 <a:solidFill>
-                  <a:srgbClr val="2E7752"/>
+                  <a:srgbClr val="466B4A"/>
                 </a:solidFill>
               </a:defRPr>
             </a:pPr>
             <a:r>
               <a:rPr sz="900" b="1">
                 <a:solidFill>
-                  <a:srgbClr val="2E7752"/>
+                  <a:srgbClr val="466B4A"/>
                 </a:solidFill>
               </a:rPr>
               <a:t>S1</a:t>
@@ -2249,7 +2249,7 @@
           <p:cNvPr id="28" name="field-0-1">
             <a:extLst xmlns:a="http://schemas.openxmlformats.org/drawingml/2006/main">
               <a:ext uri="{FF2B5EF4-FFF2-40B4-BE49-F238E27FC236}">
-                <a16:creationId xmlns:a16="http://schemas.microsoft.com/office/drawing/2014/main" id="{A92E7ABA-DBFC-4C59-A663-7211DFB77714}"/>
+                <a16:creationId xmlns:a16="http://schemas.microsoft.com/office/drawing/2014/main" id="{40A02BA5-473C-42D2-B506-151B2795ADF2}"/>
               </a:ext>
             </a:extLst>
           </p:cNvPr>
@@ -2269,11 +2269,11 @@
             </a:avLst>
           </a:prstGeom>
           <a:solidFill xmlns:a="http://schemas.openxmlformats.org/drawingml/2006/main">
-            <a:srgbClr val="E7F0EA"/>
+            <a:srgbClr val="E8EFE4"/>
           </a:solidFill>
           <a:ln xmlns:a="http://schemas.openxmlformats.org/drawingml/2006/main" w="9525">
             <a:solidFill>
-              <a:srgbClr val="2E7752"/>
+              <a:srgbClr val="466B4A"/>
             </a:solidFill>
             <a:prstDash val="solid"/>
           </a:ln>
@@ -2284,7 +2284,7 @@
           <p:cNvPr id="29" name="field-name-0-1">
             <a:extLst xmlns:a="http://schemas.openxmlformats.org/drawingml/2006/main">
               <a:ext uri="{FF2B5EF4-FFF2-40B4-BE49-F238E27FC236}">
-                <a16:creationId xmlns:a16="http://schemas.microsoft.com/office/drawing/2014/main" id="{E9FAC96E-9E6F-4FF1-B1E0-0646330B2C6E}"/>
+                <a16:creationId xmlns:a16="http://schemas.microsoft.com/office/drawing/2014/main" id="{AD2AF719-7C95-453F-97DC-EEF090A12AE0}"/>
               </a:ext>
             </a:extLst>
           </p:cNvPr>
@@ -2314,14 +2314,14 @@
             <a:pPr algn="ctr">
               <a:defRPr sz="825" b="1">
                 <a:solidFill>
-                  <a:srgbClr val="191B1A"/>
+                  <a:srgbClr val="24211D"/>
                 </a:solidFill>
               </a:defRPr>
             </a:pPr>
             <a:r>
               <a:rPr sz="825" b="1">
                 <a:solidFill>
-                  <a:srgbClr val="191B1A"/>
+                  <a:srgbClr val="24211D"/>
                 </a:solidFill>
               </a:rPr>
               <a:t>price</a:t>
@@ -2334,7 +2334,7 @@
           <p:cNvPr id="30" name="field-source-0-1">
             <a:extLst xmlns:a="http://schemas.openxmlformats.org/drawingml/2006/main">
               <a:ext uri="{FF2B5EF4-FFF2-40B4-BE49-F238E27FC236}">
-                <a16:creationId xmlns:a16="http://schemas.microsoft.com/office/drawing/2014/main" id="{9CE97D37-CBD0-4D7A-9AE2-F991AEEC26D0}"/>
+                <a16:creationId xmlns:a16="http://schemas.microsoft.com/office/drawing/2014/main" id="{1A850C04-23FD-49E0-87C8-781DDE5C831B}"/>
               </a:ext>
             </a:extLst>
           </p:cNvPr>
@@ -2364,14 +2364,14 @@
             <a:pPr algn="ctr">
               <a:defRPr sz="900" b="1">
                 <a:solidFill>
-                  <a:srgbClr val="2E7752"/>
+                  <a:srgbClr val="466B4A"/>
                 </a:solidFill>
               </a:defRPr>
             </a:pPr>
             <a:r>
               <a:rPr sz="900" b="1">
                 <a:solidFill>
-                  <a:srgbClr val="2E7752"/>
+                  <a:srgbClr val="466B4A"/>
                 </a:solidFill>
               </a:rPr>
               <a:t>S2</a:t>
@@ -2384,7 +2384,7 @@
           <p:cNvPr id="31" name="field-0-2">
             <a:extLst xmlns:a="http://schemas.openxmlformats.org/drawingml/2006/main">
               <a:ext uri="{FF2B5EF4-FFF2-40B4-BE49-F238E27FC236}">
-                <a16:creationId xmlns:a16="http://schemas.microsoft.com/office/drawing/2014/main" id="{39F3502B-2308-41C7-A129-B39497CCF60E}"/>
+                <a16:creationId xmlns:a16="http://schemas.microsoft.com/office/drawing/2014/main" id="{E4B2D5A9-F348-4290-8877-1C1FF3CF868E}"/>
               </a:ext>
             </a:extLst>
           </p:cNvPr>
@@ -2404,11 +2404,11 @@
             </a:avLst>
           </a:prstGeom>
           <a:solidFill xmlns:a="http://schemas.openxmlformats.org/drawingml/2006/main">
-            <a:srgbClr val="E7F0EA"/>
+            <a:srgbClr val="E8EFE4"/>
           </a:solidFill>
           <a:ln xmlns:a="http://schemas.openxmlformats.org/drawingml/2006/main" w="9525">
             <a:solidFill>
-              <a:srgbClr val="2E7752"/>
+              <a:srgbClr val="466B4A"/>
             </a:solidFill>
             <a:prstDash val="solid"/>
           </a:ln>
@@ -2419,7 +2419,7 @@
           <p:cNvPr id="32" name="field-name-0-2">
             <a:extLst xmlns:a="http://schemas.openxmlformats.org/drawingml/2006/main">
               <a:ext uri="{FF2B5EF4-FFF2-40B4-BE49-F238E27FC236}">
-                <a16:creationId xmlns:a16="http://schemas.microsoft.com/office/drawing/2014/main" id="{BC7DFBCE-1FA2-4C90-9DCA-3096F436576B}"/>
+                <a16:creationId xmlns:a16="http://schemas.microsoft.com/office/drawing/2014/main" id="{EADCABBE-7E19-4834-AB52-CBFEF850D14A}"/>
               </a:ext>
             </a:extLst>
           </p:cNvPr>
@@ -2449,14 +2449,14 @@
             <a:pPr algn="ctr">
               <a:defRPr sz="825" b="1">
                 <a:solidFill>
-                  <a:srgbClr val="191B1A"/>
+                  <a:srgbClr val="24211D"/>
                 </a:solidFill>
               </a:defRPr>
             </a:pPr>
             <a:r>
               <a:rPr sz="825" b="1">
                 <a:solidFill>
-                  <a:srgbClr val="191B1A"/>
+                  <a:srgbClr val="24211D"/>
                 </a:solidFill>
               </a:rPr>
               <a:t>OSS</a:t>
@@ -2469,7 +2469,7 @@
           <p:cNvPr id="33" name="field-source-0-2">
             <a:extLst xmlns:a="http://schemas.openxmlformats.org/drawingml/2006/main">
               <a:ext uri="{FF2B5EF4-FFF2-40B4-BE49-F238E27FC236}">
-                <a16:creationId xmlns:a16="http://schemas.microsoft.com/office/drawing/2014/main" id="{CDCBA724-7CF1-4290-BD5C-CD48CF180800}"/>
+                <a16:creationId xmlns:a16="http://schemas.microsoft.com/office/drawing/2014/main" id="{08873A0E-A22E-4469-98D3-6C1613EAB214}"/>
               </a:ext>
             </a:extLst>
           </p:cNvPr>
@@ -2499,14 +2499,14 @@
             <a:pPr algn="ctr">
               <a:defRPr sz="900" b="1">
                 <a:solidFill>
-                  <a:srgbClr val="2E7752"/>
+                  <a:srgbClr val="466B4A"/>
                 </a:solidFill>
               </a:defRPr>
             </a:pPr>
             <a:r>
               <a:rPr sz="900" b="1">
                 <a:solidFill>
-                  <a:srgbClr val="2E7752"/>
+                  <a:srgbClr val="466B4A"/>
                 </a:solidFill>
               </a:rPr>
               <a:t>S1</a:t>
@@ -2519,7 +2519,7 @@
           <p:cNvPr id="34" name="field-0-3">
             <a:extLst xmlns:a="http://schemas.openxmlformats.org/drawingml/2006/main">
               <a:ext uri="{FF2B5EF4-FFF2-40B4-BE49-F238E27FC236}">
-                <a16:creationId xmlns:a16="http://schemas.microsoft.com/office/drawing/2014/main" id="{D0AC3028-F153-4EC3-B08B-BFEA8E11EE5D}"/>
+                <a16:creationId xmlns:a16="http://schemas.microsoft.com/office/drawing/2014/main" id="{54D6870A-EBC4-4364-A61D-B868AD9A91D5}"/>
               </a:ext>
             </a:extLst>
           </p:cNvPr>
@@ -2539,11 +2539,11 @@
             </a:avLst>
           </a:prstGeom>
           <a:solidFill xmlns:a="http://schemas.openxmlformats.org/drawingml/2006/main">
-            <a:srgbClr val="E7F0EA"/>
+            <a:srgbClr val="E8EFE4"/>
           </a:solidFill>
           <a:ln xmlns:a="http://schemas.openxmlformats.org/drawingml/2006/main" w="9525">
             <a:solidFill>
-              <a:srgbClr val="2E7752"/>
+              <a:srgbClr val="466B4A"/>
             </a:solidFill>
             <a:prstDash val="solid"/>
           </a:ln>
@@ -2554,7 +2554,7 @@
           <p:cNvPr id="35" name="field-name-0-3">
             <a:extLst xmlns:a="http://schemas.openxmlformats.org/drawingml/2006/main">
               <a:ext uri="{FF2B5EF4-FFF2-40B4-BE49-F238E27FC236}">
-                <a16:creationId xmlns:a16="http://schemas.microsoft.com/office/drawing/2014/main" id="{558A9B4A-84DA-40A0-AE30-505361539CD4}"/>
+                <a16:creationId xmlns:a16="http://schemas.microsoft.com/office/drawing/2014/main" id="{F3F707C0-1858-4E86-B542-186CB031CE19}"/>
               </a:ext>
             </a:extLst>
           </p:cNvPr>
@@ -2584,14 +2584,14 @@
             <a:pPr algn="ctr">
               <a:defRPr sz="825" b="1">
                 <a:solidFill>
-                  <a:srgbClr val="191B1A"/>
+                  <a:srgbClr val="24211D"/>
                 </a:solidFill>
               </a:defRPr>
             </a:pPr>
             <a:r>
               <a:rPr sz="825" b="1">
                 <a:solidFill>
-                  <a:srgbClr val="191B1A"/>
+                  <a:srgbClr val="24211D"/>
                 </a:solidFill>
               </a:rPr>
               <a:t>API</a:t>
@@ -2604,7 +2604,7 @@
           <p:cNvPr id="36" name="field-source-0-3">
             <a:extLst xmlns:a="http://schemas.openxmlformats.org/drawingml/2006/main">
               <a:ext uri="{FF2B5EF4-FFF2-40B4-BE49-F238E27FC236}">
-                <a16:creationId xmlns:a16="http://schemas.microsoft.com/office/drawing/2014/main" id="{E695A77C-D2B5-4B08-8FD5-873AD21D8FB6}"/>
+                <a16:creationId xmlns:a16="http://schemas.microsoft.com/office/drawing/2014/main" id="{2FDD91C2-97C7-4834-A65B-03248682562E}"/>
               </a:ext>
             </a:extLst>
           </p:cNvPr>
@@ -2634,14 +2634,14 @@
             <a:pPr algn="ctr">
               <a:defRPr sz="900" b="1">
                 <a:solidFill>
-                  <a:srgbClr val="2E7752"/>
+                  <a:srgbClr val="466B4A"/>
                 </a:solidFill>
               </a:defRPr>
             </a:pPr>
             <a:r>
               <a:rPr sz="900" b="1">
                 <a:solidFill>
-                  <a:srgbClr val="2E7752"/>
+                  <a:srgbClr val="466B4A"/>
                 </a:solidFill>
               </a:rPr>
               <a:t>S1</a:t>
@@ -2654,7 +2654,7 @@
           <p:cNvPr id="37" name="field-0-4">
             <a:extLst xmlns:a="http://schemas.openxmlformats.org/drawingml/2006/main">
               <a:ext uri="{FF2B5EF4-FFF2-40B4-BE49-F238E27FC236}">
-                <a16:creationId xmlns:a16="http://schemas.microsoft.com/office/drawing/2014/main" id="{036AEF1F-A565-4CA8-ACC5-CC7154AF062D}"/>
+                <a16:creationId xmlns:a16="http://schemas.microsoft.com/office/drawing/2014/main" id="{2F3B2731-18A5-423D-9736-EAE2107607DE}"/>
               </a:ext>
             </a:extLst>
           </p:cNvPr>
@@ -2674,11 +2674,11 @@
             </a:avLst>
           </a:prstGeom>
           <a:solidFill xmlns:a="http://schemas.openxmlformats.org/drawingml/2006/main">
-            <a:srgbClr val="E7F0EA"/>
+            <a:srgbClr val="E8EFE4"/>
           </a:solidFill>
           <a:ln xmlns:a="http://schemas.openxmlformats.org/drawingml/2006/main" w="9525">
             <a:solidFill>
-              <a:srgbClr val="2E7752"/>
+              <a:srgbClr val="466B4A"/>
             </a:solidFill>
             <a:prstDash val="solid"/>
           </a:ln>
@@ -2689,7 +2689,7 @@
           <p:cNvPr id="38" name="field-name-0-4">
             <a:extLst xmlns:a="http://schemas.openxmlformats.org/drawingml/2006/main">
               <a:ext uri="{FF2B5EF4-FFF2-40B4-BE49-F238E27FC236}">
-                <a16:creationId xmlns:a16="http://schemas.microsoft.com/office/drawing/2014/main" id="{A5B60F9E-1901-462A-A1C1-4C31852A1F6E}"/>
+                <a16:creationId xmlns:a16="http://schemas.microsoft.com/office/drawing/2014/main" id="{182C9F33-5423-4BAC-A885-7C444B0DC306}"/>
               </a:ext>
             </a:extLst>
           </p:cNvPr>
@@ -2719,14 +2719,14 @@
             <a:pPr algn="ctr">
               <a:defRPr sz="825" b="1">
                 <a:solidFill>
-                  <a:srgbClr val="191B1A"/>
+                  <a:srgbClr val="24211D"/>
                 </a:solidFill>
               </a:defRPr>
             </a:pPr>
             <a:r>
               <a:rPr sz="825" b="1">
                 <a:solidFill>
-                  <a:srgbClr val="191B1A"/>
+                  <a:srgbClr val="24211D"/>
                 </a:solidFill>
               </a:rPr>
               <a:t>SDKs</a:t>
@@ -2739,7 +2739,7 @@
           <p:cNvPr id="39" name="field-source-0-4">
             <a:extLst xmlns:a="http://schemas.openxmlformats.org/drawingml/2006/main">
               <a:ext uri="{FF2B5EF4-FFF2-40B4-BE49-F238E27FC236}">
-                <a16:creationId xmlns:a16="http://schemas.microsoft.com/office/drawing/2014/main" id="{D4652FAB-75F3-4F9E-BC69-3DC8B8D845CA}"/>
+                <a16:creationId xmlns:a16="http://schemas.microsoft.com/office/drawing/2014/main" id="{1AB9BBE8-F6DC-45FB-B498-59A98DF7D070}"/>
               </a:ext>
             </a:extLst>
           </p:cNvPr>
@@ -2769,14 +2769,14 @@
             <a:pPr algn="ctr">
               <a:defRPr sz="900" b="1">
                 <a:solidFill>
-                  <a:srgbClr val="2E7752"/>
+                  <a:srgbClr val="466B4A"/>
                 </a:solidFill>
               </a:defRPr>
             </a:pPr>
             <a:r>
               <a:rPr sz="900" b="1">
                 <a:solidFill>
-                  <a:srgbClr val="2E7752"/>
+                  <a:srgbClr val="466B4A"/>
                 </a:solidFill>
               </a:rPr>
               <a:t>S1</a:t>
@@ -2789,7 +2789,7 @@
           <p:cNvPr id="40" name="field-0-5">
             <a:extLst xmlns:a="http://schemas.openxmlformats.org/drawingml/2006/main">
               <a:ext uri="{FF2B5EF4-FFF2-40B4-BE49-F238E27FC236}">
-                <a16:creationId xmlns:a16="http://schemas.microsoft.com/office/drawing/2014/main" id="{CF7AB387-CC09-420C-8CA0-45C21F79A136}"/>
+                <a16:creationId xmlns:a16="http://schemas.microsoft.com/office/drawing/2014/main" id="{071DE66D-8566-40F8-A7B4-A0CF64C99579}"/>
               </a:ext>
             </a:extLst>
           </p:cNvPr>
@@ -2809,11 +2809,11 @@
             </a:avLst>
           </a:prstGeom>
           <a:solidFill xmlns:a="http://schemas.openxmlformats.org/drawingml/2006/main">
-            <a:srgbClr val="E7F0EA"/>
+            <a:srgbClr val="E8EFE4"/>
           </a:solidFill>
           <a:ln xmlns:a="http://schemas.openxmlformats.org/drawingml/2006/main" w="9525">
             <a:solidFill>
-              <a:srgbClr val="2E7752"/>
+              <a:srgbClr val="466B4A"/>
             </a:solidFill>
             <a:prstDash val="solid"/>
           </a:ln>
@@ -2824,7 +2824,7 @@
           <p:cNvPr id="41" name="field-name-0-5">
             <a:extLst xmlns:a="http://schemas.openxmlformats.org/drawingml/2006/main">
               <a:ext uri="{FF2B5EF4-FFF2-40B4-BE49-F238E27FC236}">
-                <a16:creationId xmlns:a16="http://schemas.microsoft.com/office/drawing/2014/main" id="{BFEFA6D7-EA39-41F1-8D91-E63FF42E3F34}"/>
+                <a16:creationId xmlns:a16="http://schemas.microsoft.com/office/drawing/2014/main" id="{F6068AB6-6ACC-40C2-BD07-75868FCC66D8}"/>
               </a:ext>
             </a:extLst>
           </p:cNvPr>
@@ -2854,14 +2854,14 @@
             <a:pPr algn="ctr">
               <a:defRPr sz="825" b="1">
                 <a:solidFill>
-                  <a:srgbClr val="191B1A"/>
+                  <a:srgbClr val="24211D"/>
                 </a:solidFill>
               </a:defRPr>
             </a:pPr>
             <a:r>
               <a:rPr sz="825" b="1">
                 <a:solidFill>
-                  <a:srgbClr val="191B1A"/>
+                  <a:srgbClr val="24211D"/>
                 </a:solidFill>
               </a:rPr>
               <a:t>integr.</a:t>
@@ -2874,7 +2874,7 @@
           <p:cNvPr id="42" name="field-source-0-5">
             <a:extLst xmlns:a="http://schemas.openxmlformats.org/drawingml/2006/main">
               <a:ext uri="{FF2B5EF4-FFF2-40B4-BE49-F238E27FC236}">
-                <a16:creationId xmlns:a16="http://schemas.microsoft.com/office/drawing/2014/main" id="{D5CD281A-17D7-4472-8FBF-D374A02C9C62}"/>
+                <a16:creationId xmlns:a16="http://schemas.microsoft.com/office/drawing/2014/main" id="{B1E402F7-50A5-4FE7-B219-9A69CFCE0A4A}"/>
               </a:ext>
             </a:extLst>
           </p:cNvPr>
@@ -2904,14 +2904,14 @@
             <a:pPr algn="ctr">
               <a:defRPr sz="900" b="1">
                 <a:solidFill>
-                  <a:srgbClr val="2E7752"/>
+                  <a:srgbClr val="466B4A"/>
                 </a:solidFill>
               </a:defRPr>
             </a:pPr>
             <a:r>
               <a:rPr sz="900" b="1">
                 <a:solidFill>
-                  <a:srgbClr val="2E7752"/>
+                  <a:srgbClr val="466B4A"/>
                 </a:solidFill>
               </a:rPr>
               <a:t>S1</a:t>
@@ -2924,7 +2924,7 @@
           <p:cNvPr id="43" name="validation-0">
             <a:extLst xmlns:a="http://schemas.openxmlformats.org/drawingml/2006/main">
               <a:ext uri="{FF2B5EF4-FFF2-40B4-BE49-F238E27FC236}">
-                <a16:creationId xmlns:a16="http://schemas.microsoft.com/office/drawing/2014/main" id="{E6939EDD-7971-4303-A528-51CD520DE4C1}"/>
+                <a16:creationId xmlns:a16="http://schemas.microsoft.com/office/drawing/2014/main" id="{D150C33F-908C-403E-ABFE-F6EBB7EF53BE}"/>
               </a:ext>
             </a:extLst>
           </p:cNvPr>
@@ -2954,14 +2954,14 @@
             <a:pPr algn="l">
               <a:defRPr sz="788" b="0">
                 <a:solidFill>
-                  <a:srgbClr val="656A67"/>
+                  <a:srgbClr val="6B655E"/>
                 </a:solidFill>
               </a:defRPr>
             </a:pPr>
             <a:r>
               <a:rPr sz="788" b="0">
                 <a:solidFill>
-                  <a:srgbClr val="656A67"/>
+                  <a:srgbClr val="6B655E"/>
                 </a:solidFill>
               </a:rPr>
               <a:t>6 fields · source IDs validated against this profile’s two retained sources</a:t>
@@ -2974,7 +2974,7 @@
           <p:cNvPr id="44" name="tool-1">
             <a:extLst xmlns:a="http://schemas.openxmlformats.org/drawingml/2006/main">
               <a:ext uri="{FF2B5EF4-FFF2-40B4-BE49-F238E27FC236}">
-                <a16:creationId xmlns:a16="http://schemas.microsoft.com/office/drawing/2014/main" id="{4645637F-779F-4636-AA6B-AD1D09EE6952}"/>
+                <a16:creationId xmlns:a16="http://schemas.microsoft.com/office/drawing/2014/main" id="{117386EB-D26D-47B7-89B8-F4A2187B0EAB}"/>
               </a:ext>
             </a:extLst>
           </p:cNvPr>
@@ -3004,14 +3004,14 @@
             <a:pPr algn="l">
               <a:defRPr sz="1350" b="1">
                 <a:solidFill>
-                  <a:srgbClr val="2B6F9E"/>
+                  <a:srgbClr val="B85F36"/>
                 </a:solidFill>
               </a:defRPr>
             </a:pPr>
             <a:r>
               <a:rPr sz="1350" b="1">
                 <a:solidFill>
-                  <a:srgbClr val="2B6F9E"/>
+                  <a:srgbClr val="B85F36"/>
                 </a:solidFill>
               </a:rPr>
               <a:t>Pinecone</a:t>
@@ -3024,7 +3024,7 @@
           <p:cNvPr id="45" name="status-1">
             <a:extLst xmlns:a="http://schemas.openxmlformats.org/drawingml/2006/main">
               <a:ext uri="{FF2B5EF4-FFF2-40B4-BE49-F238E27FC236}">
-                <a16:creationId xmlns:a16="http://schemas.microsoft.com/office/drawing/2014/main" id="{EA44F0DC-0BA3-435D-8865-18317999E06E}"/>
+                <a16:creationId xmlns:a16="http://schemas.microsoft.com/office/drawing/2014/main" id="{80927E18-7FDC-4DB2-96DF-80978DD7160A}"/>
               </a:ext>
             </a:extLst>
           </p:cNvPr>
@@ -3054,14 +3054,14 @@
             <a:pPr algn="l">
               <a:defRPr sz="825" b="0">
                 <a:solidFill>
-                  <a:srgbClr val="656A67"/>
+                  <a:srgbClr val="6B655E"/>
                 </a:solidFill>
               </a:defRPr>
             </a:pPr>
             <a:r>
               <a:rPr sz="825" b="0">
                 <a:solidFill>
-                  <a:srgbClr val="656A67"/>
+                  <a:srgbClr val="6B655E"/>
                 </a:solidFill>
               </a:rPr>
               <a:t>complete</a:t>
@@ -3074,7 +3074,7 @@
           <p:cNvPr id="46" name="source-doc-1">
             <a:extLst xmlns:a="http://schemas.openxmlformats.org/drawingml/2006/main">
               <a:ext uri="{FF2B5EF4-FFF2-40B4-BE49-F238E27FC236}">
-                <a16:creationId xmlns:a16="http://schemas.microsoft.com/office/drawing/2014/main" id="{07331A3B-1519-4A63-B70C-F944120A803E}"/>
+                <a16:creationId xmlns:a16="http://schemas.microsoft.com/office/drawing/2014/main" id="{E56F2C24-8964-4515-8FEF-0CF3AFBF25A2}"/>
               </a:ext>
             </a:extLst>
           </p:cNvPr>
@@ -3094,11 +3094,11 @@
             </a:avLst>
           </a:prstGeom>
           <a:solidFill xmlns:a="http://schemas.openxmlformats.org/drawingml/2006/main">
-            <a:srgbClr val="FFFFFF"/>
+            <a:srgbClr val="FFFDF7"/>
           </a:solidFill>
           <a:ln xmlns:a="http://schemas.openxmlformats.org/drawingml/2006/main" w="9525">
             <a:solidFill>
-              <a:srgbClr val="2B6F9E"/>
+              <a:srgbClr val="B85F36"/>
             </a:solidFill>
             <a:prstDash val="solid"/>
           </a:ln>
@@ -3109,7 +3109,7 @@
           <p:cNvPr id="47" name="source-doc-text-1">
             <a:extLst xmlns:a="http://schemas.openxmlformats.org/drawingml/2006/main">
               <a:ext uri="{FF2B5EF4-FFF2-40B4-BE49-F238E27FC236}">
-                <a16:creationId xmlns:a16="http://schemas.microsoft.com/office/drawing/2014/main" id="{B6E37971-88F1-4C1F-AB8A-EEC078057B77}"/>
+                <a16:creationId xmlns:a16="http://schemas.microsoft.com/office/drawing/2014/main" id="{CD033F29-325E-4AB0-B27C-6111EEF7527C}"/>
               </a:ext>
             </a:extLst>
           </p:cNvPr>
@@ -3139,14 +3139,14 @@
             <a:pPr algn="l">
               <a:defRPr sz="900" b="1">
                 <a:solidFill>
-                  <a:srgbClr val="2B6F9E"/>
+                  <a:srgbClr val="B85F36"/>
                 </a:solidFill>
               </a:defRPr>
             </a:pPr>
             <a:r>
               <a:rPr sz="900" b="1">
                 <a:solidFill>
-                  <a:srgbClr val="2B6F9E"/>
+                  <a:srgbClr val="B85F36"/>
                 </a:solidFill>
               </a:rPr>
               <a:t>S1  docs</a:t>
@@ -3159,7 +3159,7 @@
           <p:cNvPr id="48" name="source-price-1">
             <a:extLst xmlns:a="http://schemas.openxmlformats.org/drawingml/2006/main">
               <a:ext uri="{FF2B5EF4-FFF2-40B4-BE49-F238E27FC236}">
-                <a16:creationId xmlns:a16="http://schemas.microsoft.com/office/drawing/2014/main" id="{B255DC8F-3442-4D54-94C1-78E9A81B11E5}"/>
+                <a16:creationId xmlns:a16="http://schemas.microsoft.com/office/drawing/2014/main" id="{43E6AAE3-F2BD-4465-8082-F36B445409AB}"/>
               </a:ext>
             </a:extLst>
           </p:cNvPr>
@@ -3179,11 +3179,11 @@
             </a:avLst>
           </a:prstGeom>
           <a:solidFill xmlns:a="http://schemas.openxmlformats.org/drawingml/2006/main">
-            <a:srgbClr val="FFFFFF"/>
+            <a:srgbClr val="FFFDF7"/>
           </a:solidFill>
           <a:ln xmlns:a="http://schemas.openxmlformats.org/drawingml/2006/main" w="9525">
             <a:solidFill>
-              <a:srgbClr val="2B6F9E"/>
+              <a:srgbClr val="B85F36"/>
             </a:solidFill>
             <a:prstDash val="solid"/>
           </a:ln>
@@ -3194,7 +3194,7 @@
           <p:cNvPr id="49" name="source-price-text-1">
             <a:extLst xmlns:a="http://schemas.openxmlformats.org/drawingml/2006/main">
               <a:ext uri="{FF2B5EF4-FFF2-40B4-BE49-F238E27FC236}">
-                <a16:creationId xmlns:a16="http://schemas.microsoft.com/office/drawing/2014/main" id="{54CCEED2-9B07-4444-83DF-86EABFDE3E28}"/>
+                <a16:creationId xmlns:a16="http://schemas.microsoft.com/office/drawing/2014/main" id="{22098DAE-BB36-4E2E-AD38-58AA137A7A94}"/>
               </a:ext>
             </a:extLst>
           </p:cNvPr>
@@ -3224,14 +3224,14 @@
             <a:pPr algn="l">
               <a:defRPr sz="900" b="1">
                 <a:solidFill>
-                  <a:srgbClr val="2B6F9E"/>
+                  <a:srgbClr val="B85F36"/>
                 </a:solidFill>
               </a:defRPr>
             </a:pPr>
             <a:r>
               <a:rPr sz="900" b="1">
                 <a:solidFill>
-                  <a:srgbClr val="2B6F9E"/>
+                  <a:srgbClr val="B85F36"/>
                 </a:solidFill>
               </a:rPr>
               <a:t>S2  pricing</a:t>
@@ -3244,7 +3244,7 @@
           <p:cNvPr id="50" name="lane-rule-1">
             <a:extLst xmlns:a="http://schemas.openxmlformats.org/drawingml/2006/main">
               <a:ext uri="{FF2B5EF4-FFF2-40B4-BE49-F238E27FC236}">
-                <a16:creationId xmlns:a16="http://schemas.microsoft.com/office/drawing/2014/main" id="{1AF8A273-7BDC-4F96-AAF0-422BAF4A3530}"/>
+                <a16:creationId xmlns:a16="http://schemas.microsoft.com/office/drawing/2014/main" id="{051F8ACD-2E43-4E68-8723-C8B18A9B59DF}"/>
               </a:ext>
             </a:extLst>
           </p:cNvPr>
@@ -3264,7 +3264,7 @@
           <a:noFill xmlns:a="http://schemas.openxmlformats.org/drawingml/2006/main"/>
           <a:ln xmlns:a="http://schemas.openxmlformats.org/drawingml/2006/main" w="11430">
             <a:solidFill>
-              <a:srgbClr val="2B6F9E"/>
+              <a:srgbClr val="B85F36"/>
             </a:solidFill>
             <a:prstDash val="solid"/>
           </a:ln>
@@ -3275,7 +3275,7 @@
           <p:cNvPr id="51" name="field-1-0">
             <a:extLst xmlns:a="http://schemas.openxmlformats.org/drawingml/2006/main">
               <a:ext uri="{FF2B5EF4-FFF2-40B4-BE49-F238E27FC236}">
-                <a16:creationId xmlns:a16="http://schemas.microsoft.com/office/drawing/2014/main" id="{F702C33A-E9A5-4EFE-A1EB-EDEBEA10ADDF}"/>
+                <a16:creationId xmlns:a16="http://schemas.microsoft.com/office/drawing/2014/main" id="{430B6D40-8D0A-4426-BB10-23A8CA6FC2FB}"/>
               </a:ext>
             </a:extLst>
           </p:cNvPr>
@@ -3295,11 +3295,11 @@
             </a:avLst>
           </a:prstGeom>
           <a:solidFill xmlns:a="http://schemas.openxmlformats.org/drawingml/2006/main">
-            <a:srgbClr val="E7EFF5"/>
+            <a:srgbClr val="F4E3D9"/>
           </a:solidFill>
           <a:ln xmlns:a="http://schemas.openxmlformats.org/drawingml/2006/main" w="9525">
             <a:solidFill>
-              <a:srgbClr val="2B6F9E"/>
+              <a:srgbClr val="B85F36"/>
             </a:solidFill>
             <a:prstDash val="solid"/>
           </a:ln>
@@ -3310,7 +3310,7 @@
           <p:cNvPr id="52" name="field-name-1-0">
             <a:extLst xmlns:a="http://schemas.openxmlformats.org/drawingml/2006/main">
               <a:ext uri="{FF2B5EF4-FFF2-40B4-BE49-F238E27FC236}">
-                <a16:creationId xmlns:a16="http://schemas.microsoft.com/office/drawing/2014/main" id="{5C25AC96-B269-43AA-8262-E7E5091E66F7}"/>
+                <a16:creationId xmlns:a16="http://schemas.microsoft.com/office/drawing/2014/main" id="{284CC8E6-40AB-4783-908A-6CD909F276EF}"/>
               </a:ext>
             </a:extLst>
           </p:cNvPr>
@@ -3340,14 +3340,14 @@
             <a:pPr algn="ctr">
               <a:defRPr sz="825" b="1">
                 <a:solidFill>
-                  <a:srgbClr val="191B1A"/>
+                  <a:srgbClr val="24211D"/>
                 </a:solidFill>
               </a:defRPr>
             </a:pPr>
             <a:r>
               <a:rPr sz="825" b="1">
                 <a:solidFill>
-                  <a:srgbClr val="191B1A"/>
+                  <a:srgbClr val="24211D"/>
                 </a:solidFill>
               </a:rPr>
               <a:t>profile</a:t>
@@ -3360,7 +3360,7 @@
           <p:cNvPr id="53" name="field-source-1-0">
             <a:extLst xmlns:a="http://schemas.openxmlformats.org/drawingml/2006/main">
               <a:ext uri="{FF2B5EF4-FFF2-40B4-BE49-F238E27FC236}">
-                <a16:creationId xmlns:a16="http://schemas.microsoft.com/office/drawing/2014/main" id="{260D5C40-D7E1-4147-8EE0-40FD1548DD40}"/>
+                <a16:creationId xmlns:a16="http://schemas.microsoft.com/office/drawing/2014/main" id="{BBFE1C44-EDDA-4D6B-9A8D-088E77C26B24}"/>
               </a:ext>
             </a:extLst>
           </p:cNvPr>
@@ -3390,14 +3390,14 @@
             <a:pPr algn="ctr">
               <a:defRPr sz="900" b="1">
                 <a:solidFill>
-                  <a:srgbClr val="2B6F9E"/>
+                  <a:srgbClr val="B85F36"/>
                 </a:solidFill>
               </a:defRPr>
             </a:pPr>
             <a:r>
               <a:rPr sz="900" b="1">
                 <a:solidFill>
-                  <a:srgbClr val="2B6F9E"/>
+                  <a:srgbClr val="B85F36"/>
                 </a:solidFill>
               </a:rPr>
               <a:t>S1</a:t>
@@ -3410,7 +3410,7 @@
           <p:cNvPr id="54" name="field-1-1">
             <a:extLst xmlns:a="http://schemas.openxmlformats.org/drawingml/2006/main">
               <a:ext uri="{FF2B5EF4-FFF2-40B4-BE49-F238E27FC236}">
-                <a16:creationId xmlns:a16="http://schemas.microsoft.com/office/drawing/2014/main" id="{37AD4832-1961-4CCC-BBBE-B452C04EDED7}"/>
+                <a16:creationId xmlns:a16="http://schemas.microsoft.com/office/drawing/2014/main" id="{5B3E4DB4-A20E-47D9-BB40-237C8BC09363}"/>
               </a:ext>
             </a:extLst>
           </p:cNvPr>
@@ -3430,11 +3430,11 @@
             </a:avLst>
           </a:prstGeom>
           <a:solidFill xmlns:a="http://schemas.openxmlformats.org/drawingml/2006/main">
-            <a:srgbClr val="E7EFF5"/>
+            <a:srgbClr val="F4E3D9"/>
           </a:solidFill>
           <a:ln xmlns:a="http://schemas.openxmlformats.org/drawingml/2006/main" w="9525">
             <a:solidFill>
-              <a:srgbClr val="2B6F9E"/>
+              <a:srgbClr val="B85F36"/>
             </a:solidFill>
             <a:prstDash val="solid"/>
           </a:ln>
@@ -3445,7 +3445,7 @@
           <p:cNvPr id="55" name="field-name-1-1">
             <a:extLst xmlns:a="http://schemas.openxmlformats.org/drawingml/2006/main">
               <a:ext uri="{FF2B5EF4-FFF2-40B4-BE49-F238E27FC236}">
-                <a16:creationId xmlns:a16="http://schemas.microsoft.com/office/drawing/2014/main" id="{8EC0EDCC-6E61-4612-A178-907CEA5F3CE5}"/>
+                <a16:creationId xmlns:a16="http://schemas.microsoft.com/office/drawing/2014/main" id="{531D6C2C-92AE-4268-A0EC-0376472A59D1}"/>
               </a:ext>
             </a:extLst>
           </p:cNvPr>
@@ -3475,14 +3475,14 @@
             <a:pPr algn="ctr">
               <a:defRPr sz="825" b="1">
                 <a:solidFill>
-                  <a:srgbClr val="191B1A"/>
+                  <a:srgbClr val="24211D"/>
                 </a:solidFill>
               </a:defRPr>
             </a:pPr>
             <a:r>
               <a:rPr sz="825" b="1">
                 <a:solidFill>
-                  <a:srgbClr val="191B1A"/>
+                  <a:srgbClr val="24211D"/>
                 </a:solidFill>
               </a:rPr>
               <a:t>price</a:t>
@@ -3495,7 +3495,7 @@
           <p:cNvPr id="56" name="field-source-1-1">
             <a:extLst xmlns:a="http://schemas.openxmlformats.org/drawingml/2006/main">
               <a:ext uri="{FF2B5EF4-FFF2-40B4-BE49-F238E27FC236}">
-                <a16:creationId xmlns:a16="http://schemas.microsoft.com/office/drawing/2014/main" id="{0B8A7C9E-357D-4F4F-B91E-209184AE65CF}"/>
+                <a16:creationId xmlns:a16="http://schemas.microsoft.com/office/drawing/2014/main" id="{5721E41B-BF53-4C39-BC58-5315A7CCC60F}"/>
               </a:ext>
             </a:extLst>
           </p:cNvPr>
@@ -3525,14 +3525,14 @@
             <a:pPr algn="ctr">
               <a:defRPr sz="900" b="1">
                 <a:solidFill>
-                  <a:srgbClr val="2B6F9E"/>
+                  <a:srgbClr val="B85F36"/>
                 </a:solidFill>
               </a:defRPr>
             </a:pPr>
             <a:r>
               <a:rPr sz="900" b="1">
                 <a:solidFill>
-                  <a:srgbClr val="2B6F9E"/>
+                  <a:srgbClr val="B85F36"/>
                 </a:solidFill>
               </a:rPr>
               <a:t>S2</a:t>
@@ -3545,7 +3545,7 @@
           <p:cNvPr id="57" name="field-1-2">
             <a:extLst xmlns:a="http://schemas.openxmlformats.org/drawingml/2006/main">
               <a:ext uri="{FF2B5EF4-FFF2-40B4-BE49-F238E27FC236}">
-                <a16:creationId xmlns:a16="http://schemas.microsoft.com/office/drawing/2014/main" id="{40D8E816-D228-4E57-8912-7C6A6EE2B768}"/>
+                <a16:creationId xmlns:a16="http://schemas.microsoft.com/office/drawing/2014/main" id="{C46D1A26-FE03-4095-8E90-EA834BC7336D}"/>
               </a:ext>
             </a:extLst>
           </p:cNvPr>
@@ -3565,11 +3565,11 @@
             </a:avLst>
           </a:prstGeom>
           <a:solidFill xmlns:a="http://schemas.openxmlformats.org/drawingml/2006/main">
-            <a:srgbClr val="E7EFF5"/>
+            <a:srgbClr val="F4E3D9"/>
           </a:solidFill>
           <a:ln xmlns:a="http://schemas.openxmlformats.org/drawingml/2006/main" w="9525">
             <a:solidFill>
-              <a:srgbClr val="2B6F9E"/>
+              <a:srgbClr val="B85F36"/>
             </a:solidFill>
             <a:prstDash val="solid"/>
           </a:ln>
@@ -3580,7 +3580,7 @@
           <p:cNvPr id="58" name="field-name-1-2">
             <a:extLst xmlns:a="http://schemas.openxmlformats.org/drawingml/2006/main">
               <a:ext uri="{FF2B5EF4-FFF2-40B4-BE49-F238E27FC236}">
-                <a16:creationId xmlns:a16="http://schemas.microsoft.com/office/drawing/2014/main" id="{B53AE99E-C478-45DA-90E1-CC141224E06C}"/>
+                <a16:creationId xmlns:a16="http://schemas.microsoft.com/office/drawing/2014/main" id="{9B4556CD-C064-4920-A8E6-FA99E48E9D80}"/>
               </a:ext>
             </a:extLst>
           </p:cNvPr>
@@ -3610,14 +3610,14 @@
             <a:pPr algn="ctr">
               <a:defRPr sz="825" b="1">
                 <a:solidFill>
-                  <a:srgbClr val="191B1A"/>
+                  <a:srgbClr val="24211D"/>
                 </a:solidFill>
               </a:defRPr>
             </a:pPr>
             <a:r>
               <a:rPr sz="825" b="1">
                 <a:solidFill>
-                  <a:srgbClr val="191B1A"/>
+                  <a:srgbClr val="24211D"/>
                 </a:solidFill>
               </a:rPr>
               <a:t>OSS</a:t>
@@ -3630,7 +3630,7 @@
           <p:cNvPr id="59" name="field-source-1-2">
             <a:extLst xmlns:a="http://schemas.openxmlformats.org/drawingml/2006/main">
               <a:ext uri="{FF2B5EF4-FFF2-40B4-BE49-F238E27FC236}">
-                <a16:creationId xmlns:a16="http://schemas.microsoft.com/office/drawing/2014/main" id="{131DA625-CF26-4028-B7B9-64854148A823}"/>
+                <a16:creationId xmlns:a16="http://schemas.microsoft.com/office/drawing/2014/main" id="{B8F18657-68AB-4D52-9913-DF098CE0918F}"/>
               </a:ext>
             </a:extLst>
           </p:cNvPr>
@@ -3660,14 +3660,14 @@
             <a:pPr algn="ctr">
               <a:defRPr sz="900" b="1">
                 <a:solidFill>
-                  <a:srgbClr val="2B6F9E"/>
+                  <a:srgbClr val="B85F36"/>
                 </a:solidFill>
               </a:defRPr>
             </a:pPr>
             <a:r>
               <a:rPr sz="900" b="1">
                 <a:solidFill>
-                  <a:srgbClr val="2B6F9E"/>
+                  <a:srgbClr val="B85F36"/>
                 </a:solidFill>
               </a:rPr>
               <a:t>S1</a:t>
@@ -3680,7 +3680,7 @@
           <p:cNvPr id="60" name="field-1-3">
             <a:extLst xmlns:a="http://schemas.openxmlformats.org/drawingml/2006/main">
               <a:ext uri="{FF2B5EF4-FFF2-40B4-BE49-F238E27FC236}">
-                <a16:creationId xmlns:a16="http://schemas.microsoft.com/office/drawing/2014/main" id="{19674A3D-B612-494F-901A-92DC4E91E8B2}"/>
+                <a16:creationId xmlns:a16="http://schemas.microsoft.com/office/drawing/2014/main" id="{4BFDE87E-4B89-4090-A1D6-040A84CD390F}"/>
               </a:ext>
             </a:extLst>
           </p:cNvPr>
@@ -3700,11 +3700,11 @@
             </a:avLst>
           </a:prstGeom>
           <a:solidFill xmlns:a="http://schemas.openxmlformats.org/drawingml/2006/main">
-            <a:srgbClr val="E7EFF5"/>
+            <a:srgbClr val="F4E3D9"/>
           </a:solidFill>
           <a:ln xmlns:a="http://schemas.openxmlformats.org/drawingml/2006/main" w="9525">
             <a:solidFill>
-              <a:srgbClr val="2B6F9E"/>
+              <a:srgbClr val="B85F36"/>
             </a:solidFill>
             <a:prstDash val="solid"/>
           </a:ln>
@@ -3715,7 +3715,7 @@
           <p:cNvPr id="61" name="field-name-1-3">
             <a:extLst xmlns:a="http://schemas.openxmlformats.org/drawingml/2006/main">
               <a:ext uri="{FF2B5EF4-FFF2-40B4-BE49-F238E27FC236}">
-                <a16:creationId xmlns:a16="http://schemas.microsoft.com/office/drawing/2014/main" id="{068F06F8-C66A-4EBE-AB22-A4C59FC971A1}"/>
+                <a16:creationId xmlns:a16="http://schemas.microsoft.com/office/drawing/2014/main" id="{D970D7D7-FA4F-46D9-9ADD-D271BF418F45}"/>
               </a:ext>
             </a:extLst>
           </p:cNvPr>
@@ -3745,14 +3745,14 @@
             <a:pPr algn="ctr">
               <a:defRPr sz="825" b="1">
                 <a:solidFill>
-                  <a:srgbClr val="191B1A"/>
+                  <a:srgbClr val="24211D"/>
                 </a:solidFill>
               </a:defRPr>
             </a:pPr>
             <a:r>
               <a:rPr sz="825" b="1">
                 <a:solidFill>
-                  <a:srgbClr val="191B1A"/>
+                  <a:srgbClr val="24211D"/>
                 </a:solidFill>
               </a:rPr>
               <a:t>API</a:t>
@@ -3765,7 +3765,7 @@
           <p:cNvPr id="62" name="field-source-1-3">
             <a:extLst xmlns:a="http://schemas.openxmlformats.org/drawingml/2006/main">
               <a:ext uri="{FF2B5EF4-FFF2-40B4-BE49-F238E27FC236}">
-                <a16:creationId xmlns:a16="http://schemas.microsoft.com/office/drawing/2014/main" id="{C597BD6A-DCD7-41B0-BEFB-FE1720F97746}"/>
+                <a16:creationId xmlns:a16="http://schemas.microsoft.com/office/drawing/2014/main" id="{B59E2D88-89EB-4C42-95EF-3D9C1A2B8663}"/>
               </a:ext>
             </a:extLst>
           </p:cNvPr>
@@ -3795,14 +3795,14 @@
             <a:pPr algn="ctr">
               <a:defRPr sz="900" b="1">
                 <a:solidFill>
-                  <a:srgbClr val="2B6F9E"/>
+                  <a:srgbClr val="B85F36"/>
                 </a:solidFill>
               </a:defRPr>
             </a:pPr>
             <a:r>
               <a:rPr sz="900" b="1">
                 <a:solidFill>
-                  <a:srgbClr val="2B6F9E"/>
+                  <a:srgbClr val="B85F36"/>
                 </a:solidFill>
               </a:rPr>
               <a:t>S1</a:t>
@@ -3815,7 +3815,7 @@
           <p:cNvPr id="63" name="field-1-4">
             <a:extLst xmlns:a="http://schemas.openxmlformats.org/drawingml/2006/main">
               <a:ext uri="{FF2B5EF4-FFF2-40B4-BE49-F238E27FC236}">
-                <a16:creationId xmlns:a16="http://schemas.microsoft.com/office/drawing/2014/main" id="{468497EB-7382-49EC-99E9-187D93468F69}"/>
+                <a16:creationId xmlns:a16="http://schemas.microsoft.com/office/drawing/2014/main" id="{EF5C1B2B-C6E9-464F-9627-BB21F6C67C2B}"/>
               </a:ext>
             </a:extLst>
           </p:cNvPr>
@@ -3835,11 +3835,11 @@
             </a:avLst>
           </a:prstGeom>
           <a:solidFill xmlns:a="http://schemas.openxmlformats.org/drawingml/2006/main">
-            <a:srgbClr val="E7EFF5"/>
+            <a:srgbClr val="F4E3D9"/>
           </a:solidFill>
           <a:ln xmlns:a="http://schemas.openxmlformats.org/drawingml/2006/main" w="9525">
             <a:solidFill>
-              <a:srgbClr val="2B6F9E"/>
+              <a:srgbClr val="B85F36"/>
             </a:solidFill>
             <a:prstDash val="solid"/>
           </a:ln>
@@ -3850,7 +3850,7 @@
           <p:cNvPr id="64" name="field-name-1-4">
             <a:extLst xmlns:a="http://schemas.openxmlformats.org/drawingml/2006/main">
               <a:ext uri="{FF2B5EF4-FFF2-40B4-BE49-F238E27FC236}">
-                <a16:creationId xmlns:a16="http://schemas.microsoft.com/office/drawing/2014/main" id="{5EBD75C3-45BD-4E0F-A3BD-5C5DF895C3B1}"/>
+                <a16:creationId xmlns:a16="http://schemas.microsoft.com/office/drawing/2014/main" id="{4CBC8221-303C-412E-A50B-446436D17C44}"/>
               </a:ext>
             </a:extLst>
           </p:cNvPr>
@@ -3880,14 +3880,14 @@
             <a:pPr algn="ctr">
               <a:defRPr sz="825" b="1">
                 <a:solidFill>
-                  <a:srgbClr val="191B1A"/>
+                  <a:srgbClr val="24211D"/>
                 </a:solidFill>
               </a:defRPr>
             </a:pPr>
             <a:r>
               <a:rPr sz="825" b="1">
                 <a:solidFill>
-                  <a:srgbClr val="191B1A"/>
+                  <a:srgbClr val="24211D"/>
                 </a:solidFill>
               </a:rPr>
               <a:t>SDKs</a:t>
@@ -3900,7 +3900,7 @@
           <p:cNvPr id="65" name="field-source-1-4">
             <a:extLst xmlns:a="http://schemas.openxmlformats.org/drawingml/2006/main">
               <a:ext uri="{FF2B5EF4-FFF2-40B4-BE49-F238E27FC236}">
-                <a16:creationId xmlns:a16="http://schemas.microsoft.com/office/drawing/2014/main" id="{9018EB86-E932-4D3B-ABD2-66E76D5611EE}"/>
+                <a16:creationId xmlns:a16="http://schemas.microsoft.com/office/drawing/2014/main" id="{05CE1EE4-1176-4DAA-BA32-A2F3810017B6}"/>
               </a:ext>
             </a:extLst>
           </p:cNvPr>
@@ -3930,14 +3930,14 @@
             <a:pPr algn="ctr">
               <a:defRPr sz="900" b="1">
                 <a:solidFill>
-                  <a:srgbClr val="2B6F9E"/>
+                  <a:srgbClr val="B85F36"/>
                 </a:solidFill>
               </a:defRPr>
             </a:pPr>
             <a:r>
               <a:rPr sz="900" b="1">
                 <a:solidFill>
-                  <a:srgbClr val="2B6F9E"/>
+                  <a:srgbClr val="B85F36"/>
                 </a:solidFill>
               </a:rPr>
               <a:t>S1</a:t>
@@ -3950,7 +3950,7 @@
           <p:cNvPr id="66" name="field-1-5">
             <a:extLst xmlns:a="http://schemas.openxmlformats.org/drawingml/2006/main">
               <a:ext uri="{FF2B5EF4-FFF2-40B4-BE49-F238E27FC236}">
-                <a16:creationId xmlns:a16="http://schemas.microsoft.com/office/drawing/2014/main" id="{29B47D80-449E-489E-9E1C-DA1EBCB07B14}"/>
+                <a16:creationId xmlns:a16="http://schemas.microsoft.com/office/drawing/2014/main" id="{799069C6-BDF9-41CA-9BE0-DCB498C8794E}"/>
               </a:ext>
             </a:extLst>
           </p:cNvPr>
@@ -3970,11 +3970,11 @@
             </a:avLst>
           </a:prstGeom>
           <a:solidFill xmlns:a="http://schemas.openxmlformats.org/drawingml/2006/main">
-            <a:srgbClr val="E7EFF5"/>
+            <a:srgbClr val="F4E3D9"/>
           </a:solidFill>
           <a:ln xmlns:a="http://schemas.openxmlformats.org/drawingml/2006/main" w="9525">
             <a:solidFill>
-              <a:srgbClr val="2B6F9E"/>
+              <a:srgbClr val="B85F36"/>
             </a:solidFill>
             <a:prstDash val="solid"/>
           </a:ln>
@@ -3985,7 +3985,7 @@
           <p:cNvPr id="67" name="field-name-1-5">
             <a:extLst xmlns:a="http://schemas.openxmlformats.org/drawingml/2006/main">
               <a:ext uri="{FF2B5EF4-FFF2-40B4-BE49-F238E27FC236}">
-                <a16:creationId xmlns:a16="http://schemas.microsoft.com/office/drawing/2014/main" id="{1336EFEB-9B3D-4758-B74F-5264389C5669}"/>
+                <a16:creationId xmlns:a16="http://schemas.microsoft.com/office/drawing/2014/main" id="{113807FA-64EE-495A-866A-94492AC21DA8}"/>
               </a:ext>
             </a:extLst>
           </p:cNvPr>
@@ -4015,14 +4015,14 @@
             <a:pPr algn="ctr">
               <a:defRPr sz="825" b="1">
                 <a:solidFill>
-                  <a:srgbClr val="191B1A"/>
+                  <a:srgbClr val="24211D"/>
                 </a:solidFill>
               </a:defRPr>
             </a:pPr>
             <a:r>
               <a:rPr sz="825" b="1">
                 <a:solidFill>
-                  <a:srgbClr val="191B1A"/>
+                  <a:srgbClr val="24211D"/>
                 </a:solidFill>
               </a:rPr>
               <a:t>integr.</a:t>
@@ -4035,7 +4035,7 @@
           <p:cNvPr id="68" name="field-source-1-5">
             <a:extLst xmlns:a="http://schemas.openxmlformats.org/drawingml/2006/main">
               <a:ext uri="{FF2B5EF4-FFF2-40B4-BE49-F238E27FC236}">
-                <a16:creationId xmlns:a16="http://schemas.microsoft.com/office/drawing/2014/main" id="{7CA509A0-53ED-4927-9125-0C18FD81E860}"/>
+                <a16:creationId xmlns:a16="http://schemas.microsoft.com/office/drawing/2014/main" id="{ADAB6F35-86F7-4A9E-97E5-F704D3760D88}"/>
               </a:ext>
             </a:extLst>
           </p:cNvPr>
@@ -4065,14 +4065,14 @@
             <a:pPr algn="ctr">
               <a:defRPr sz="900" b="1">
                 <a:solidFill>
-                  <a:srgbClr val="2B6F9E"/>
+                  <a:srgbClr val="B85F36"/>
                 </a:solidFill>
               </a:defRPr>
             </a:pPr>
             <a:r>
               <a:rPr sz="900" b="1">
                 <a:solidFill>
-                  <a:srgbClr val="2B6F9E"/>
+                  <a:srgbClr val="B85F36"/>
                 </a:solidFill>
               </a:rPr>
               <a:t>S1</a:t>
@@ -4085,7 +4085,7 @@
           <p:cNvPr id="69" name="validation-1">
             <a:extLst xmlns:a="http://schemas.openxmlformats.org/drawingml/2006/main">
               <a:ext uri="{FF2B5EF4-FFF2-40B4-BE49-F238E27FC236}">
-                <a16:creationId xmlns:a16="http://schemas.microsoft.com/office/drawing/2014/main" id="{FA84E753-1E55-4255-844F-0FA79984D951}"/>
+                <a16:creationId xmlns:a16="http://schemas.microsoft.com/office/drawing/2014/main" id="{264D269F-427D-4D36-9463-BCD14CC8F48A}"/>
               </a:ext>
             </a:extLst>
           </p:cNvPr>
@@ -4115,14 +4115,14 @@
             <a:pPr algn="l">
               <a:defRPr sz="788" b="0">
                 <a:solidFill>
-                  <a:srgbClr val="656A67"/>
+                  <a:srgbClr val="6B655E"/>
                 </a:solidFill>
               </a:defRPr>
             </a:pPr>
             <a:r>
               <a:rPr sz="788" b="0">
                 <a:solidFill>
-                  <a:srgbClr val="656A67"/>
+                  <a:srgbClr val="6B655E"/>
                 </a:solidFill>
               </a:rPr>
               <a:t>6 fields · source IDs validated against this profile’s two retained sources</a:t>
@@ -4135,7 +4135,7 @@
           <p:cNvPr id="70" name="tool-2">
             <a:extLst xmlns:a="http://schemas.openxmlformats.org/drawingml/2006/main">
               <a:ext uri="{FF2B5EF4-FFF2-40B4-BE49-F238E27FC236}">
-                <a16:creationId xmlns:a16="http://schemas.microsoft.com/office/drawing/2014/main" id="{427E5F74-0CBB-4C60-8FAC-576245C3A247}"/>
+                <a16:creationId xmlns:a16="http://schemas.microsoft.com/office/drawing/2014/main" id="{6714475D-70A4-4719-918A-F47D7911ED25}"/>
               </a:ext>
             </a:extLst>
           </p:cNvPr>
@@ -4165,14 +4165,14 @@
             <a:pPr algn="l">
               <a:defRPr sz="1350" b="1">
                 <a:solidFill>
-                  <a:srgbClr val="73527E"/>
+                  <a:srgbClr val="6C4F70"/>
                 </a:solidFill>
               </a:defRPr>
             </a:pPr>
             <a:r>
               <a:rPr sz="1350" b="1">
                 <a:solidFill>
-                  <a:srgbClr val="73527E"/>
+                  <a:srgbClr val="6C4F70"/>
                 </a:solidFill>
               </a:rPr>
               <a:t>Qdrant</a:t>
@@ -4185,7 +4185,7 @@
           <p:cNvPr id="71" name="status-2">
             <a:extLst xmlns:a="http://schemas.openxmlformats.org/drawingml/2006/main">
               <a:ext uri="{FF2B5EF4-FFF2-40B4-BE49-F238E27FC236}">
-                <a16:creationId xmlns:a16="http://schemas.microsoft.com/office/drawing/2014/main" id="{F25F2DA0-E9A4-4EEB-B609-E1CDDF983EA1}"/>
+                <a16:creationId xmlns:a16="http://schemas.microsoft.com/office/drawing/2014/main" id="{D0654078-CA98-438D-81BE-B592AF724D64}"/>
               </a:ext>
             </a:extLst>
           </p:cNvPr>
@@ -4215,14 +4215,14 @@
             <a:pPr algn="l">
               <a:defRPr sz="825" b="0">
                 <a:solidFill>
-                  <a:srgbClr val="656A67"/>
+                  <a:srgbClr val="6B655E"/>
                 </a:solidFill>
               </a:defRPr>
             </a:pPr>
             <a:r>
               <a:rPr sz="825" b="0">
                 <a:solidFill>
-                  <a:srgbClr val="656A67"/>
+                  <a:srgbClr val="6B655E"/>
                 </a:solidFill>
               </a:rPr>
               <a:t>complete</a:t>
@@ -4235,7 +4235,7 @@
           <p:cNvPr id="72" name="source-doc-2">
             <a:extLst xmlns:a="http://schemas.openxmlformats.org/drawingml/2006/main">
               <a:ext uri="{FF2B5EF4-FFF2-40B4-BE49-F238E27FC236}">
-                <a16:creationId xmlns:a16="http://schemas.microsoft.com/office/drawing/2014/main" id="{E925B201-CEA6-49A6-9F82-7318E3FB9D3B}"/>
+                <a16:creationId xmlns:a16="http://schemas.microsoft.com/office/drawing/2014/main" id="{819F7937-5927-402D-9623-B4301B86879B}"/>
               </a:ext>
             </a:extLst>
           </p:cNvPr>
@@ -4255,11 +4255,11 @@
             </a:avLst>
           </a:prstGeom>
           <a:solidFill xmlns:a="http://schemas.openxmlformats.org/drawingml/2006/main">
-            <a:srgbClr val="FFFFFF"/>
+            <a:srgbClr val="FFFDF7"/>
           </a:solidFill>
           <a:ln xmlns:a="http://schemas.openxmlformats.org/drawingml/2006/main" w="9525">
             <a:solidFill>
-              <a:srgbClr val="73527E"/>
+              <a:srgbClr val="6C4F70"/>
             </a:solidFill>
             <a:prstDash val="solid"/>
           </a:ln>
@@ -4270,7 +4270,7 @@
           <p:cNvPr id="73" name="source-doc-text-2">
             <a:extLst xmlns:a="http://schemas.openxmlformats.org/drawingml/2006/main">
               <a:ext uri="{FF2B5EF4-FFF2-40B4-BE49-F238E27FC236}">
-                <a16:creationId xmlns:a16="http://schemas.microsoft.com/office/drawing/2014/main" id="{82913ABF-B2DD-4B87-B4D6-34255E548452}"/>
+                <a16:creationId xmlns:a16="http://schemas.microsoft.com/office/drawing/2014/main" id="{A2E1D899-BC90-426D-B9E0-506CA6CCDCC3}"/>
               </a:ext>
             </a:extLst>
           </p:cNvPr>
@@ -4300,14 +4300,14 @@
             <a:pPr algn="l">
               <a:defRPr sz="900" b="1">
                 <a:solidFill>
-                  <a:srgbClr val="73527E"/>
+                  <a:srgbClr val="6C4F70"/>
                 </a:solidFill>
               </a:defRPr>
             </a:pPr>
             <a:r>
               <a:rPr sz="900" b="1">
                 <a:solidFill>
-                  <a:srgbClr val="73527E"/>
+                  <a:srgbClr val="6C4F70"/>
                 </a:solidFill>
               </a:rPr>
               <a:t>S1  docs</a:t>
@@ -4320,7 +4320,7 @@
           <p:cNvPr id="74" name="source-price-2">
             <a:extLst xmlns:a="http://schemas.openxmlformats.org/drawingml/2006/main">
               <a:ext uri="{FF2B5EF4-FFF2-40B4-BE49-F238E27FC236}">
-                <a16:creationId xmlns:a16="http://schemas.microsoft.com/office/drawing/2014/main" id="{95001C9D-D34E-4B4A-A48C-C79053D87F8A}"/>
+                <a16:creationId xmlns:a16="http://schemas.microsoft.com/office/drawing/2014/main" id="{AA89C3DB-BC6F-4E16-8994-7C1B5372CCDB}"/>
               </a:ext>
             </a:extLst>
           </p:cNvPr>
@@ -4340,11 +4340,11 @@
             </a:avLst>
           </a:prstGeom>
           <a:solidFill xmlns:a="http://schemas.openxmlformats.org/drawingml/2006/main">
-            <a:srgbClr val="FFFFFF"/>
+            <a:srgbClr val="FFFDF7"/>
           </a:solidFill>
           <a:ln xmlns:a="http://schemas.openxmlformats.org/drawingml/2006/main" w="9525">
             <a:solidFill>
-              <a:srgbClr val="73527E"/>
+              <a:srgbClr val="6C4F70"/>
             </a:solidFill>
             <a:prstDash val="solid"/>
           </a:ln>
@@ -4355,7 +4355,7 @@
           <p:cNvPr id="75" name="source-price-text-2">
             <a:extLst xmlns:a="http://schemas.openxmlformats.org/drawingml/2006/main">
               <a:ext uri="{FF2B5EF4-FFF2-40B4-BE49-F238E27FC236}">
-                <a16:creationId xmlns:a16="http://schemas.microsoft.com/office/drawing/2014/main" id="{579CD25A-BA1C-4A95-836D-78B51B45294E}"/>
+                <a16:creationId xmlns:a16="http://schemas.microsoft.com/office/drawing/2014/main" id="{7E7BDC65-6FE7-4856-9AA1-01AAA07AA152}"/>
               </a:ext>
             </a:extLst>
           </p:cNvPr>
@@ -4385,14 +4385,14 @@
             <a:pPr algn="l">
               <a:defRPr sz="900" b="1">
                 <a:solidFill>
-                  <a:srgbClr val="73527E"/>
+                  <a:srgbClr val="6C4F70"/>
                 </a:solidFill>
               </a:defRPr>
             </a:pPr>
             <a:r>
               <a:rPr sz="900" b="1">
                 <a:solidFill>
-                  <a:srgbClr val="73527E"/>
+                  <a:srgbClr val="6C4F70"/>
                 </a:solidFill>
               </a:rPr>
               <a:t>S2  pricing</a:t>
@@ -4405,7 +4405,7 @@
           <p:cNvPr id="76" name="lane-rule-2">
             <a:extLst xmlns:a="http://schemas.openxmlformats.org/drawingml/2006/main">
               <a:ext uri="{FF2B5EF4-FFF2-40B4-BE49-F238E27FC236}">
-                <a16:creationId xmlns:a16="http://schemas.microsoft.com/office/drawing/2014/main" id="{2A01E583-D8FA-41BC-BF0F-D2CE98162FDD}"/>
+                <a16:creationId xmlns:a16="http://schemas.microsoft.com/office/drawing/2014/main" id="{43DDA174-2E7E-403F-9A1D-BECED3A1E1BA}"/>
               </a:ext>
             </a:extLst>
           </p:cNvPr>
@@ -4425,7 +4425,7 @@
           <a:noFill xmlns:a="http://schemas.openxmlformats.org/drawingml/2006/main"/>
           <a:ln xmlns:a="http://schemas.openxmlformats.org/drawingml/2006/main" w="11430">
             <a:solidFill>
-              <a:srgbClr val="73527E"/>
+              <a:srgbClr val="6C4F70"/>
             </a:solidFill>
             <a:prstDash val="solid"/>
           </a:ln>
@@ -4436,7 +4436,7 @@
           <p:cNvPr id="77" name="field-2-0">
             <a:extLst xmlns:a="http://schemas.openxmlformats.org/drawingml/2006/main">
               <a:ext uri="{FF2B5EF4-FFF2-40B4-BE49-F238E27FC236}">
-                <a16:creationId xmlns:a16="http://schemas.microsoft.com/office/drawing/2014/main" id="{D61A8607-3ED2-4CE8-9B71-F87F52E25E43}"/>
+                <a16:creationId xmlns:a16="http://schemas.microsoft.com/office/drawing/2014/main" id="{ACD588B1-E36E-4135-AAB1-9DFCCE9099E3}"/>
               </a:ext>
             </a:extLst>
           </p:cNvPr>
@@ -4456,11 +4456,11 @@
             </a:avLst>
           </a:prstGeom>
           <a:solidFill xmlns:a="http://schemas.openxmlformats.org/drawingml/2006/main">
-            <a:srgbClr val="F0EBF2"/>
+            <a:srgbClr val="EFE7F0"/>
           </a:solidFill>
           <a:ln xmlns:a="http://schemas.openxmlformats.org/drawingml/2006/main" w="9525">
             <a:solidFill>
-              <a:srgbClr val="73527E"/>
+              <a:srgbClr val="6C4F70"/>
             </a:solidFill>
             <a:prstDash val="solid"/>
           </a:ln>
@@ -4471,7 +4471,7 @@
           <p:cNvPr id="78" name="field-name-2-0">
             <a:extLst xmlns:a="http://schemas.openxmlformats.org/drawingml/2006/main">
               <a:ext uri="{FF2B5EF4-FFF2-40B4-BE49-F238E27FC236}">
-                <a16:creationId xmlns:a16="http://schemas.microsoft.com/office/drawing/2014/main" id="{9AB45977-DA3B-4583-93DE-14122AEC37F7}"/>
+                <a16:creationId xmlns:a16="http://schemas.microsoft.com/office/drawing/2014/main" id="{1D374FFA-9A51-4726-9490-29C8153A56FC}"/>
               </a:ext>
             </a:extLst>
           </p:cNvPr>
@@ -4501,14 +4501,14 @@
             <a:pPr algn="ctr">
               <a:defRPr sz="825" b="1">
                 <a:solidFill>
-                  <a:srgbClr val="191B1A"/>
+                  <a:srgbClr val="24211D"/>
                 </a:solidFill>
               </a:defRPr>
             </a:pPr>
             <a:r>
               <a:rPr sz="825" b="1">
                 <a:solidFill>
-                  <a:srgbClr val="191B1A"/>
+                  <a:srgbClr val="24211D"/>
                 </a:solidFill>
               </a:rPr>
               <a:t>profile</a:t>
@@ -4521,7 +4521,7 @@
           <p:cNvPr id="79" name="field-source-2-0">
             <a:extLst xmlns:a="http://schemas.openxmlformats.org/drawingml/2006/main">
               <a:ext uri="{FF2B5EF4-FFF2-40B4-BE49-F238E27FC236}">
-                <a16:creationId xmlns:a16="http://schemas.microsoft.com/office/drawing/2014/main" id="{965DCCAD-B13E-49B0-A314-374E1E310BB0}"/>
+                <a16:creationId xmlns:a16="http://schemas.microsoft.com/office/drawing/2014/main" id="{1838B262-2260-4751-A2DE-61493C237E53}"/>
               </a:ext>
             </a:extLst>
           </p:cNvPr>
@@ -4551,14 +4551,14 @@
             <a:pPr algn="ctr">
               <a:defRPr sz="900" b="1">
                 <a:solidFill>
-                  <a:srgbClr val="73527E"/>
+                  <a:srgbClr val="6C4F70"/>
                 </a:solidFill>
               </a:defRPr>
             </a:pPr>
             <a:r>
               <a:rPr sz="900" b="1">
                 <a:solidFill>
-                  <a:srgbClr val="73527E"/>
+                  <a:srgbClr val="6C4F70"/>
                 </a:solidFill>
               </a:rPr>
               <a:t>S1</a:t>
@@ -4571,7 +4571,7 @@
           <p:cNvPr id="80" name="field-2-1">
             <a:extLst xmlns:a="http://schemas.openxmlformats.org/drawingml/2006/main">
               <a:ext uri="{FF2B5EF4-FFF2-40B4-BE49-F238E27FC236}">
-                <a16:creationId xmlns:a16="http://schemas.microsoft.com/office/drawing/2014/main" id="{7221CE16-59DF-4381-BF00-EAB8A50DA69F}"/>
+                <a16:creationId xmlns:a16="http://schemas.microsoft.com/office/drawing/2014/main" id="{528657E0-1AB1-40AD-AFC0-93854228FEC8}"/>
               </a:ext>
             </a:extLst>
           </p:cNvPr>
@@ -4591,11 +4591,11 @@
             </a:avLst>
           </a:prstGeom>
           <a:solidFill xmlns:a="http://schemas.openxmlformats.org/drawingml/2006/main">
-            <a:srgbClr val="F0EBF2"/>
+            <a:srgbClr val="EFE7F0"/>
           </a:solidFill>
           <a:ln xmlns:a="http://schemas.openxmlformats.org/drawingml/2006/main" w="9525">
             <a:solidFill>
-              <a:srgbClr val="73527E"/>
+              <a:srgbClr val="6C4F70"/>
             </a:solidFill>
             <a:prstDash val="solid"/>
           </a:ln>
@@ -4606,7 +4606,7 @@
           <p:cNvPr id="81" name="field-name-2-1">
             <a:extLst xmlns:a="http://schemas.openxmlformats.org/drawingml/2006/main">
               <a:ext uri="{FF2B5EF4-FFF2-40B4-BE49-F238E27FC236}">
-                <a16:creationId xmlns:a16="http://schemas.microsoft.com/office/drawing/2014/main" id="{AA8F3F40-ACE9-412F-9046-C57E03AAC901}"/>
+                <a16:creationId xmlns:a16="http://schemas.microsoft.com/office/drawing/2014/main" id="{BBBB4171-2651-4EAD-87E5-60755B45AC5B}"/>
               </a:ext>
             </a:extLst>
           </p:cNvPr>
@@ -4636,14 +4636,14 @@
             <a:pPr algn="ctr">
               <a:defRPr sz="825" b="1">
                 <a:solidFill>
-                  <a:srgbClr val="191B1A"/>
+                  <a:srgbClr val="24211D"/>
                 </a:solidFill>
               </a:defRPr>
             </a:pPr>
             <a:r>
               <a:rPr sz="825" b="1">
                 <a:solidFill>
-                  <a:srgbClr val="191B1A"/>
+                  <a:srgbClr val="24211D"/>
                 </a:solidFill>
               </a:rPr>
               <a:t>price</a:t>
@@ -4656,7 +4656,7 @@
           <p:cNvPr id="82" name="field-source-2-1">
             <a:extLst xmlns:a="http://schemas.openxmlformats.org/drawingml/2006/main">
               <a:ext uri="{FF2B5EF4-FFF2-40B4-BE49-F238E27FC236}">
-                <a16:creationId xmlns:a16="http://schemas.microsoft.com/office/drawing/2014/main" id="{96BE0DFC-4E41-488D-A4E5-02E04E17BA52}"/>
+                <a16:creationId xmlns:a16="http://schemas.microsoft.com/office/drawing/2014/main" id="{6508F30C-D5A4-4B2D-B909-341A55A58A09}"/>
               </a:ext>
             </a:extLst>
           </p:cNvPr>
@@ -4686,14 +4686,14 @@
             <a:pPr algn="ctr">
               <a:defRPr sz="900" b="1">
                 <a:solidFill>
-                  <a:srgbClr val="73527E"/>
+                  <a:srgbClr val="6C4F70"/>
                 </a:solidFill>
               </a:defRPr>
             </a:pPr>
             <a:r>
               <a:rPr sz="900" b="1">
                 <a:solidFill>
-                  <a:srgbClr val="73527E"/>
+                  <a:srgbClr val="6C4F70"/>
                 </a:solidFill>
               </a:rPr>
               <a:t>S2</a:t>
@@ -4706,7 +4706,7 @@
           <p:cNvPr id="83" name="field-2-2">
             <a:extLst xmlns:a="http://schemas.openxmlformats.org/drawingml/2006/main">
               <a:ext uri="{FF2B5EF4-FFF2-40B4-BE49-F238E27FC236}">
-                <a16:creationId xmlns:a16="http://schemas.microsoft.com/office/drawing/2014/main" id="{949F204A-2C1A-4BBD-9EAA-EECD18835DF4}"/>
+                <a16:creationId xmlns:a16="http://schemas.microsoft.com/office/drawing/2014/main" id="{749F4216-F2D1-453F-BBDE-3785D1F94227}"/>
               </a:ext>
             </a:extLst>
           </p:cNvPr>
@@ -4726,11 +4726,11 @@
             </a:avLst>
           </a:prstGeom>
           <a:solidFill xmlns:a="http://schemas.openxmlformats.org/drawingml/2006/main">
-            <a:srgbClr val="F0EBF2"/>
+            <a:srgbClr val="EFE7F0"/>
           </a:solidFill>
           <a:ln xmlns:a="http://schemas.openxmlformats.org/drawingml/2006/main" w="9525">
             <a:solidFill>
-              <a:srgbClr val="73527E"/>
+              <a:srgbClr val="6C4F70"/>
             </a:solidFill>
             <a:prstDash val="solid"/>
           </a:ln>
@@ -4741,7 +4741,7 @@
           <p:cNvPr id="84" name="field-name-2-2">
             <a:extLst xmlns:a="http://schemas.openxmlformats.org/drawingml/2006/main">
               <a:ext uri="{FF2B5EF4-FFF2-40B4-BE49-F238E27FC236}">
-                <a16:creationId xmlns:a16="http://schemas.microsoft.com/office/drawing/2014/main" id="{E7986915-DB78-4F29-863F-A26E412F2A08}"/>
+                <a16:creationId xmlns:a16="http://schemas.microsoft.com/office/drawing/2014/main" id="{9A53ECDE-7CD3-4355-B155-589F568A4840}"/>
               </a:ext>
             </a:extLst>
           </p:cNvPr>
@@ -4771,14 +4771,14 @@
             <a:pPr algn="ctr">
               <a:defRPr sz="825" b="1">
                 <a:solidFill>
-                  <a:srgbClr val="191B1A"/>
+                  <a:srgbClr val="24211D"/>
                 </a:solidFill>
               </a:defRPr>
             </a:pPr>
             <a:r>
               <a:rPr sz="825" b="1">
                 <a:solidFill>
-                  <a:srgbClr val="191B1A"/>
+                  <a:srgbClr val="24211D"/>
                 </a:solidFill>
               </a:rPr>
               <a:t>OSS</a:t>
@@ -4791,7 +4791,7 @@
           <p:cNvPr id="85" name="field-source-2-2">
             <a:extLst xmlns:a="http://schemas.openxmlformats.org/drawingml/2006/main">
               <a:ext uri="{FF2B5EF4-FFF2-40B4-BE49-F238E27FC236}">
-                <a16:creationId xmlns:a16="http://schemas.microsoft.com/office/drawing/2014/main" id="{C80E4645-C435-4FB1-AB1F-ECADA61DF8FD}"/>
+                <a16:creationId xmlns:a16="http://schemas.microsoft.com/office/drawing/2014/main" id="{39E107B8-BBE5-402B-A712-8E240CA63E14}"/>
               </a:ext>
             </a:extLst>
           </p:cNvPr>
@@ -4821,14 +4821,14 @@
             <a:pPr algn="ctr">
               <a:defRPr sz="900" b="1">
                 <a:solidFill>
-                  <a:srgbClr val="73527E"/>
+                  <a:srgbClr val="6C4F70"/>
                 </a:solidFill>
               </a:defRPr>
             </a:pPr>
             <a:r>
               <a:rPr sz="900" b="1">
                 <a:solidFill>
-                  <a:srgbClr val="73527E"/>
+                  <a:srgbClr val="6C4F70"/>
                 </a:solidFill>
               </a:rPr>
               <a:t>S1</a:t>
@@ -4841,7 +4841,7 @@
           <p:cNvPr id="86" name="field-2-3">
             <a:extLst xmlns:a="http://schemas.openxmlformats.org/drawingml/2006/main">
               <a:ext uri="{FF2B5EF4-FFF2-40B4-BE49-F238E27FC236}">
-                <a16:creationId xmlns:a16="http://schemas.microsoft.com/office/drawing/2014/main" id="{E775665E-6A79-4500-A12E-50CED8E7AA24}"/>
+                <a16:creationId xmlns:a16="http://schemas.microsoft.com/office/drawing/2014/main" id="{B0612573-9BF9-435D-AE8A-F751B6CB27FA}"/>
               </a:ext>
             </a:extLst>
           </p:cNvPr>
@@ -4861,11 +4861,11 @@
             </a:avLst>
           </a:prstGeom>
           <a:solidFill xmlns:a="http://schemas.openxmlformats.org/drawingml/2006/main">
-            <a:srgbClr val="F0EBF2"/>
+            <a:srgbClr val="EFE7F0"/>
           </a:solidFill>
           <a:ln xmlns:a="http://schemas.openxmlformats.org/drawingml/2006/main" w="9525">
             <a:solidFill>
-              <a:srgbClr val="73527E"/>
+              <a:srgbClr val="6C4F70"/>
             </a:solidFill>
             <a:prstDash val="solid"/>
           </a:ln>
@@ -4876,7 +4876,7 @@
           <p:cNvPr id="87" name="field-name-2-3">
             <a:extLst xmlns:a="http://schemas.openxmlformats.org/drawingml/2006/main">
               <a:ext uri="{FF2B5EF4-FFF2-40B4-BE49-F238E27FC236}">
-                <a16:creationId xmlns:a16="http://schemas.microsoft.com/office/drawing/2014/main" id="{41E8275E-B3C7-4669-9474-4B640E570175}"/>
+                <a16:creationId xmlns:a16="http://schemas.microsoft.com/office/drawing/2014/main" id="{9720E642-DB81-4A46-B66F-33E86C559E2A}"/>
               </a:ext>
             </a:extLst>
           </p:cNvPr>
@@ -4906,14 +4906,14 @@
             <a:pPr algn="ctr">
               <a:defRPr sz="825" b="1">
                 <a:solidFill>
-                  <a:srgbClr val="191B1A"/>
+                  <a:srgbClr val="24211D"/>
                 </a:solidFill>
               </a:defRPr>
             </a:pPr>
             <a:r>
               <a:rPr sz="825" b="1">
                 <a:solidFill>
-                  <a:srgbClr val="191B1A"/>
+                  <a:srgbClr val="24211D"/>
                 </a:solidFill>
               </a:rPr>
               <a:t>API</a:t>
@@ -4926,7 +4926,7 @@
           <p:cNvPr id="88" name="field-source-2-3">
             <a:extLst xmlns:a="http://schemas.openxmlformats.org/drawingml/2006/main">
               <a:ext uri="{FF2B5EF4-FFF2-40B4-BE49-F238E27FC236}">
-                <a16:creationId xmlns:a16="http://schemas.microsoft.com/office/drawing/2014/main" id="{012F7CBB-2D02-48D5-8310-F566E304A32B}"/>
+                <a16:creationId xmlns:a16="http://schemas.microsoft.com/office/drawing/2014/main" id="{105E3FF3-CB57-48DD-86A0-D1335D22424A}"/>
               </a:ext>
             </a:extLst>
           </p:cNvPr>
@@ -4956,14 +4956,14 @@
             <a:pPr algn="ctr">
               <a:defRPr sz="900" b="1">
                 <a:solidFill>
-                  <a:srgbClr val="73527E"/>
+                  <a:srgbClr val="6C4F70"/>
                 </a:solidFill>
               </a:defRPr>
             </a:pPr>
             <a:r>
               <a:rPr sz="900" b="1">
                 <a:solidFill>
-                  <a:srgbClr val="73527E"/>
+                  <a:srgbClr val="6C4F70"/>
                 </a:solidFill>
               </a:rPr>
               <a:t>S1</a:t>
@@ -4976,7 +4976,7 @@
           <p:cNvPr id="89" name="field-2-4">
             <a:extLst xmlns:a="http://schemas.openxmlformats.org/drawingml/2006/main">
               <a:ext uri="{FF2B5EF4-FFF2-40B4-BE49-F238E27FC236}">
-                <a16:creationId xmlns:a16="http://schemas.microsoft.com/office/drawing/2014/main" id="{A3DBC6C1-CF0D-4234-AF43-37606C624D3E}"/>
+                <a16:creationId xmlns:a16="http://schemas.microsoft.com/office/drawing/2014/main" id="{105981FF-5897-414A-837C-A56C0B299165}"/>
               </a:ext>
             </a:extLst>
           </p:cNvPr>
@@ -4996,11 +4996,11 @@
             </a:avLst>
           </a:prstGeom>
           <a:solidFill xmlns:a="http://schemas.openxmlformats.org/drawingml/2006/main">
-            <a:srgbClr val="F0EBF2"/>
+            <a:srgbClr val="EFE7F0"/>
           </a:solidFill>
           <a:ln xmlns:a="http://schemas.openxmlformats.org/drawingml/2006/main" w="9525">
             <a:solidFill>
-              <a:srgbClr val="73527E"/>
+              <a:srgbClr val="6C4F70"/>
             </a:solidFill>
             <a:prstDash val="solid"/>
           </a:ln>
@@ -5011,7 +5011,7 @@
           <p:cNvPr id="90" name="field-name-2-4">
             <a:extLst xmlns:a="http://schemas.openxmlformats.org/drawingml/2006/main">
               <a:ext uri="{FF2B5EF4-FFF2-40B4-BE49-F238E27FC236}">
-                <a16:creationId xmlns:a16="http://schemas.microsoft.com/office/drawing/2014/main" id="{6F48A599-84C4-4142-A911-5A4BD16AA453}"/>
+                <a16:creationId xmlns:a16="http://schemas.microsoft.com/office/drawing/2014/main" id="{34C6A487-B1A5-4A5F-835B-24D7E49842DD}"/>
               </a:ext>
             </a:extLst>
           </p:cNvPr>
@@ -5041,14 +5041,14 @@
             <a:pPr algn="ctr">
               <a:defRPr sz="825" b="1">
                 <a:solidFill>
-                  <a:srgbClr val="191B1A"/>
+                  <a:srgbClr val="24211D"/>
                 </a:solidFill>
               </a:defRPr>
             </a:pPr>
             <a:r>
               <a:rPr sz="825" b="1">
                 <a:solidFill>
-                  <a:srgbClr val="191B1A"/>
+                  <a:srgbClr val="24211D"/>
                 </a:solidFill>
               </a:rPr>
               <a:t>SDKs</a:t>
@@ -5061,7 +5061,7 @@
           <p:cNvPr id="91" name="field-source-2-4">
             <a:extLst xmlns:a="http://schemas.openxmlformats.org/drawingml/2006/main">
               <a:ext uri="{FF2B5EF4-FFF2-40B4-BE49-F238E27FC236}">
-                <a16:creationId xmlns:a16="http://schemas.microsoft.com/office/drawing/2014/main" id="{C71145B5-E05B-4EEB-94D4-51737F343FEC}"/>
+                <a16:creationId xmlns:a16="http://schemas.microsoft.com/office/drawing/2014/main" id="{93DDAC05-480B-4265-86C7-8B88418FA529}"/>
               </a:ext>
             </a:extLst>
           </p:cNvPr>
@@ -5091,14 +5091,14 @@
             <a:pPr algn="ctr">
               <a:defRPr sz="900" b="1">
                 <a:solidFill>
-                  <a:srgbClr val="73527E"/>
+                  <a:srgbClr val="6C4F70"/>
                 </a:solidFill>
               </a:defRPr>
             </a:pPr>
             <a:r>
               <a:rPr sz="900" b="1">
                 <a:solidFill>
-                  <a:srgbClr val="73527E"/>
+                  <a:srgbClr val="6C4F70"/>
                 </a:solidFill>
               </a:rPr>
               <a:t>S1</a:t>
@@ -5111,7 +5111,7 @@
           <p:cNvPr id="92" name="field-2-5">
             <a:extLst xmlns:a="http://schemas.openxmlformats.org/drawingml/2006/main">
               <a:ext uri="{FF2B5EF4-FFF2-40B4-BE49-F238E27FC236}">
-                <a16:creationId xmlns:a16="http://schemas.microsoft.com/office/drawing/2014/main" id="{5B3C9689-D971-4715-AF94-3090F09534A9}"/>
+                <a16:creationId xmlns:a16="http://schemas.microsoft.com/office/drawing/2014/main" id="{5654015D-AF98-461E-A910-BD1C58057FDD}"/>
               </a:ext>
             </a:extLst>
           </p:cNvPr>
@@ -5131,11 +5131,11 @@
             </a:avLst>
           </a:prstGeom>
           <a:solidFill xmlns:a="http://schemas.openxmlformats.org/drawingml/2006/main">
-            <a:srgbClr val="F0EBF2"/>
+            <a:srgbClr val="EFE7F0"/>
           </a:solidFill>
           <a:ln xmlns:a="http://schemas.openxmlformats.org/drawingml/2006/main" w="9525">
             <a:solidFill>
-              <a:srgbClr val="73527E"/>
+              <a:srgbClr val="6C4F70"/>
             </a:solidFill>
             <a:prstDash val="solid"/>
           </a:ln>
@@ -5146,7 +5146,7 @@
           <p:cNvPr id="93" name="field-name-2-5">
             <a:extLst xmlns:a="http://schemas.openxmlformats.org/drawingml/2006/main">
               <a:ext uri="{FF2B5EF4-FFF2-40B4-BE49-F238E27FC236}">
-                <a16:creationId xmlns:a16="http://schemas.microsoft.com/office/drawing/2014/main" id="{8A298ECD-328A-4FA4-949A-1F1E41AE6D8A}"/>
+                <a16:creationId xmlns:a16="http://schemas.microsoft.com/office/drawing/2014/main" id="{54B7A540-1089-4DAF-8519-0B29E9590D91}"/>
               </a:ext>
             </a:extLst>
           </p:cNvPr>
@@ -5176,14 +5176,14 @@
             <a:pPr algn="ctr">
               <a:defRPr sz="825" b="1">
                 <a:solidFill>
-                  <a:srgbClr val="191B1A"/>
+                  <a:srgbClr val="24211D"/>
                 </a:solidFill>
               </a:defRPr>
             </a:pPr>
             <a:r>
               <a:rPr sz="825" b="1">
                 <a:solidFill>
-                  <a:srgbClr val="191B1A"/>
+                  <a:srgbClr val="24211D"/>
                 </a:solidFill>
               </a:rPr>
               <a:t>integr.</a:t>
@@ -5196,7 +5196,7 @@
           <p:cNvPr id="94" name="field-source-2-5">
             <a:extLst xmlns:a="http://schemas.openxmlformats.org/drawingml/2006/main">
               <a:ext uri="{FF2B5EF4-FFF2-40B4-BE49-F238E27FC236}">
-                <a16:creationId xmlns:a16="http://schemas.microsoft.com/office/drawing/2014/main" id="{A7A9E633-8782-4ED5-82AC-76298D6F7CC2}"/>
+                <a16:creationId xmlns:a16="http://schemas.microsoft.com/office/drawing/2014/main" id="{AA706005-AA2E-4851-9B37-D44FBB4107B9}"/>
               </a:ext>
             </a:extLst>
           </p:cNvPr>
@@ -5226,14 +5226,14 @@
             <a:pPr algn="ctr">
               <a:defRPr sz="900" b="1">
                 <a:solidFill>
-                  <a:srgbClr val="73527E"/>
+                  <a:srgbClr val="6C4F70"/>
                 </a:solidFill>
               </a:defRPr>
             </a:pPr>
             <a:r>
               <a:rPr sz="900" b="1">
                 <a:solidFill>
-                  <a:srgbClr val="73527E"/>
+                  <a:srgbClr val="6C4F70"/>
                 </a:solidFill>
               </a:rPr>
               <a:t>S1</a:t>
@@ -5246,7 +5246,7 @@
           <p:cNvPr id="95" name="validation-2">
             <a:extLst xmlns:a="http://schemas.openxmlformats.org/drawingml/2006/main">
               <a:ext uri="{FF2B5EF4-FFF2-40B4-BE49-F238E27FC236}">
-                <a16:creationId xmlns:a16="http://schemas.microsoft.com/office/drawing/2014/main" id="{8C9112E8-C830-4B84-A292-AEF4A4ED31EA}"/>
+                <a16:creationId xmlns:a16="http://schemas.microsoft.com/office/drawing/2014/main" id="{760901AA-9C0E-4281-A8E8-D605E7FF4A52}"/>
               </a:ext>
             </a:extLst>
           </p:cNvPr>
@@ -5276,14 +5276,14 @@
             <a:pPr algn="l">
               <a:defRPr sz="788" b="0">
                 <a:solidFill>
-                  <a:srgbClr val="656A67"/>
+                  <a:srgbClr val="6B655E"/>
                 </a:solidFill>
               </a:defRPr>
             </a:pPr>
             <a:r>
               <a:rPr sz="788" b="0">
                 <a:solidFill>
-                  <a:srgbClr val="656A67"/>
+                  <a:srgbClr val="6B655E"/>
                 </a:solidFill>
               </a:rPr>
               <a:t>6 fields · source IDs validated against this profile’s two retained sources</a:t>
@@ -5296,7 +5296,7 @@
           <p:cNvPr id="96" name="report-label">
             <a:extLst xmlns:a="http://schemas.openxmlformats.org/drawingml/2006/main">
               <a:ext uri="{FF2B5EF4-FFF2-40B4-BE49-F238E27FC236}">
-                <a16:creationId xmlns:a16="http://schemas.microsoft.com/office/drawing/2014/main" id="{059C3B87-44A5-4D40-AE20-B39950A77DC1}"/>
+                <a16:creationId xmlns:a16="http://schemas.microsoft.com/office/drawing/2014/main" id="{88482165-5BCD-4137-932E-45D0854C4036}"/>
               </a:ext>
             </a:extLst>
           </p:cNvPr>
@@ -5326,14 +5326,14 @@
             <a:pPr algn="l">
               <a:defRPr sz="900" b="1">
                 <a:solidFill>
-                  <a:srgbClr val="9C3451"/>
+                  <a:srgbClr val="9B3A2B"/>
                 </a:solidFill>
               </a:defRPr>
             </a:pPr>
             <a:r>
               <a:rPr sz="900" b="1">
                 <a:solidFill>
-                  <a:srgbClr val="9C3451"/>
+                  <a:srgbClr val="9B3A2B"/>
                 </a:solidFill>
               </a:rPr>
               <a:t>VALIDATED REPORT</a:t>
@@ -5346,7 +5346,7 @@
           <p:cNvPr id="97" name="report">
             <a:extLst xmlns:a="http://schemas.openxmlformats.org/drawingml/2006/main">
               <a:ext uri="{FF2B5EF4-FFF2-40B4-BE49-F238E27FC236}">
-                <a16:creationId xmlns:a16="http://schemas.microsoft.com/office/drawing/2014/main" id="{CCD9F2AB-A0F0-451D-8785-73C8AB189661}"/>
+                <a16:creationId xmlns:a16="http://schemas.microsoft.com/office/drawing/2014/main" id="{01793EF1-3228-4446-9EA2-D35BF5E44251}"/>
               </a:ext>
             </a:extLst>
           </p:cNvPr>
@@ -5366,11 +5366,11 @@
             </a:avLst>
           </a:prstGeom>
           <a:solidFill xmlns:a="http://schemas.openxmlformats.org/drawingml/2006/main">
-            <a:srgbClr val="FFFFFF"/>
+            <a:srgbClr val="FFFDF7"/>
           </a:solidFill>
           <a:ln xmlns:a="http://schemas.openxmlformats.org/drawingml/2006/main" w="11430">
             <a:solidFill>
-              <a:srgbClr val="183B5C"/>
+              <a:srgbClr val="36453B"/>
             </a:solidFill>
             <a:prstDash val="solid"/>
           </a:ln>
@@ -5381,7 +5381,7 @@
           <p:cNvPr id="98" name="report-count">
             <a:extLst xmlns:a="http://schemas.openxmlformats.org/drawingml/2006/main">
               <a:ext uri="{FF2B5EF4-FFF2-40B4-BE49-F238E27FC236}">
-                <a16:creationId xmlns:a16="http://schemas.microsoft.com/office/drawing/2014/main" id="{9299E947-4825-4E27-B62F-9789EE453DFF}"/>
+                <a16:creationId xmlns:a16="http://schemas.microsoft.com/office/drawing/2014/main" id="{A32DA189-0003-42E4-8096-1C89E954B672}"/>
               </a:ext>
             </a:extLst>
           </p:cNvPr>
@@ -5411,14 +5411,14 @@
             <a:pPr algn="ctr">
               <a:defRPr sz="2175" b="1">
                 <a:solidFill>
-                  <a:srgbClr val="183B5C"/>
+                  <a:srgbClr val="36453B"/>
                 </a:solidFill>
               </a:defRPr>
             </a:pPr>
             <a:r>
               <a:rPr sz="2175" b="1">
                 <a:solidFill>
-                  <a:srgbClr val="183B5C"/>
+                  <a:srgbClr val="36453B"/>
                 </a:solidFill>
               </a:rPr>
               <a:t>3</a:t>
@@ -5431,7 +5431,7 @@
           <p:cNvPr id="99" name="report-profiles">
             <a:extLst xmlns:a="http://schemas.openxmlformats.org/drawingml/2006/main">
               <a:ext uri="{FF2B5EF4-FFF2-40B4-BE49-F238E27FC236}">
-                <a16:creationId xmlns:a16="http://schemas.microsoft.com/office/drawing/2014/main" id="{F410D84A-9A9A-40EC-AA33-1ED8C46C3F23}"/>
+                <a16:creationId xmlns:a16="http://schemas.microsoft.com/office/drawing/2014/main" id="{18ED12A7-FB83-423C-9C19-EC78C4B41F8A}"/>
               </a:ext>
             </a:extLst>
           </p:cNvPr>
@@ -5461,14 +5461,14 @@
             <a:pPr algn="ctr">
               <a:defRPr sz="900" b="1">
                 <a:solidFill>
-                  <a:srgbClr val="191B1A"/>
+                  <a:srgbClr val="24211D"/>
                 </a:solidFill>
               </a:defRPr>
             </a:pPr>
             <a:r>
               <a:rPr sz="900" b="1">
                 <a:solidFill>
-                  <a:srgbClr val="191B1A"/>
+                  <a:srgbClr val="24211D"/>
                 </a:solidFill>
               </a:rPr>
               <a:t>complete</a:t>
@@ -5478,14 +5478,14 @@
             <a:pPr algn="ctr">
               <a:defRPr sz="900" b="1">
                 <a:solidFill>
-                  <a:srgbClr val="191B1A"/>
+                  <a:srgbClr val="24211D"/>
                 </a:solidFill>
               </a:defRPr>
             </a:pPr>
             <a:r>
               <a:rPr sz="900" b="1">
                 <a:solidFill>
-                  <a:srgbClr val="191B1A"/>
+                  <a:srgbClr val="24211D"/>
                 </a:solidFill>
               </a:rPr>
               <a:t>profiles</a:t>
@@ -5498,7 +5498,7 @@
           <p:cNvPr id="100" name="report-rule-1">
             <a:extLst xmlns:a="http://schemas.openxmlformats.org/drawingml/2006/main">
               <a:ext uri="{FF2B5EF4-FFF2-40B4-BE49-F238E27FC236}">
-                <a16:creationId xmlns:a16="http://schemas.microsoft.com/office/drawing/2014/main" id="{2B71C77D-271C-4035-B8CA-5C8317E7E0F1}"/>
+                <a16:creationId xmlns:a16="http://schemas.microsoft.com/office/drawing/2014/main" id="{BCCA4401-5716-4EC6-A488-FF92D9A33C7D}"/>
               </a:ext>
             </a:extLst>
           </p:cNvPr>
@@ -5518,7 +5518,7 @@
           <a:noFill xmlns:a="http://schemas.openxmlformats.org/drawingml/2006/main"/>
           <a:ln xmlns:a="http://schemas.openxmlformats.org/drawingml/2006/main" w="9525">
             <a:solidFill>
-              <a:srgbClr val="C7CBC7"/>
+              <a:srgbClr val="C9C0B1"/>
             </a:solidFill>
             <a:prstDash val="solid"/>
           </a:ln>
@@ -5529,7 +5529,7 @@
           <p:cNvPr id="101" name="report-citations">
             <a:extLst xmlns:a="http://schemas.openxmlformats.org/drawingml/2006/main">
               <a:ext uri="{FF2B5EF4-FFF2-40B4-BE49-F238E27FC236}">
-                <a16:creationId xmlns:a16="http://schemas.microsoft.com/office/drawing/2014/main" id="{F1A0B8F7-140E-4046-AC5E-997F86D1BD9D}"/>
+                <a16:creationId xmlns:a16="http://schemas.microsoft.com/office/drawing/2014/main" id="{70C20826-D921-4B1E-B24A-D61D1D315DAD}"/>
               </a:ext>
             </a:extLst>
           </p:cNvPr>
@@ -5559,14 +5559,14 @@
             <a:pPr algn="ctr">
               <a:defRPr sz="2025" b="1">
                 <a:solidFill>
-                  <a:srgbClr val="183B5C"/>
+                  <a:srgbClr val="36453B"/>
                 </a:solidFill>
               </a:defRPr>
             </a:pPr>
             <a:r>
               <a:rPr sz="2025" b="1">
                 <a:solidFill>
-                  <a:srgbClr val="183B5C"/>
+                  <a:srgbClr val="36453B"/>
                 </a:solidFill>
               </a:rPr>
               <a:t>6</a:t>
@@ -5579,7 +5579,7 @@
           <p:cNvPr id="102" name="report-citation-label">
             <a:extLst xmlns:a="http://schemas.openxmlformats.org/drawingml/2006/main">
               <a:ext uri="{FF2B5EF4-FFF2-40B4-BE49-F238E27FC236}">
-                <a16:creationId xmlns:a16="http://schemas.microsoft.com/office/drawing/2014/main" id="{9D2658B9-E4A6-40C2-B34D-1C9E5ABF7036}"/>
+                <a16:creationId xmlns:a16="http://schemas.microsoft.com/office/drawing/2014/main" id="{8700E7FC-94F7-4B8F-96A3-B41B09779F17}"/>
               </a:ext>
             </a:extLst>
           </p:cNvPr>
@@ -5609,14 +5609,14 @@
             <a:pPr algn="ctr">
               <a:defRPr sz="900" b="1">
                 <a:solidFill>
-                  <a:srgbClr val="191B1A"/>
+                  <a:srgbClr val="24211D"/>
                 </a:solidFill>
               </a:defRPr>
             </a:pPr>
             <a:r>
               <a:rPr sz="900" b="1">
                 <a:solidFill>
-                  <a:srgbClr val="191B1A"/>
+                  <a:srgbClr val="24211D"/>
                 </a:solidFill>
               </a:rPr>
               <a:t>public</a:t>
@@ -5626,14 +5626,14 @@
             <a:pPr algn="ctr">
               <a:defRPr sz="900" b="1">
                 <a:solidFill>
-                  <a:srgbClr val="191B1A"/>
+                  <a:srgbClr val="24211D"/>
                 </a:solidFill>
               </a:defRPr>
             </a:pPr>
             <a:r>
               <a:rPr sz="900" b="1">
                 <a:solidFill>
-                  <a:srgbClr val="191B1A"/>
+                  <a:srgbClr val="24211D"/>
                 </a:solidFill>
               </a:rPr>
               <a:t>citations</a:t>
@@ -5646,7 +5646,7 @@
           <p:cNvPr id="103" name="report-rule-2">
             <a:extLst xmlns:a="http://schemas.openxmlformats.org/drawingml/2006/main">
               <a:ext uri="{FF2B5EF4-FFF2-40B4-BE49-F238E27FC236}">
-                <a16:creationId xmlns:a16="http://schemas.microsoft.com/office/drawing/2014/main" id="{6C9322CC-B901-4570-B4AA-C177B0E56C8C}"/>
+                <a16:creationId xmlns:a16="http://schemas.microsoft.com/office/drawing/2014/main" id="{54763CB8-6EF9-4F71-8EB6-4519115738F9}"/>
               </a:ext>
             </a:extLst>
           </p:cNvPr>
@@ -5666,7 +5666,7 @@
           <a:noFill xmlns:a="http://schemas.openxmlformats.org/drawingml/2006/main"/>
           <a:ln xmlns:a="http://schemas.openxmlformats.org/drawingml/2006/main" w="9525">
             <a:solidFill>
-              <a:srgbClr val="C7CBC7"/>
+              <a:srgbClr val="C9C0B1"/>
             </a:solidFill>
             <a:prstDash val="solid"/>
           </a:ln>
@@ -5677,7 +5677,7 @@
           <p:cNvPr id="104" name="report-warnings">
             <a:extLst xmlns:a="http://schemas.openxmlformats.org/drawingml/2006/main">
               <a:ext uri="{FF2B5EF4-FFF2-40B4-BE49-F238E27FC236}">
-                <a16:creationId xmlns:a16="http://schemas.microsoft.com/office/drawing/2014/main" id="{8C5F65F0-E3C9-4123-9B94-972E2BC7325A}"/>
+                <a16:creationId xmlns:a16="http://schemas.microsoft.com/office/drawing/2014/main" id="{9AFC557E-E998-43CD-8322-E9562CED551E}"/>
               </a:ext>
             </a:extLst>
           </p:cNvPr>
@@ -5707,14 +5707,14 @@
             <a:pPr algn="ctr">
               <a:defRPr sz="2025" b="1">
                 <a:solidFill>
-                  <a:srgbClr val="2E7752"/>
+                  <a:srgbClr val="466B4A"/>
                 </a:solidFill>
               </a:defRPr>
             </a:pPr>
             <a:r>
               <a:rPr sz="2025" b="1">
                 <a:solidFill>
-                  <a:srgbClr val="2E7752"/>
+                  <a:srgbClr val="466B4A"/>
                 </a:solidFill>
               </a:rPr>
               <a:t>0</a:t>
@@ -5727,7 +5727,7 @@
           <p:cNvPr id="105" name="report-warning-label">
             <a:extLst xmlns:a="http://schemas.openxmlformats.org/drawingml/2006/main">
               <a:ext uri="{FF2B5EF4-FFF2-40B4-BE49-F238E27FC236}">
-                <a16:creationId xmlns:a16="http://schemas.microsoft.com/office/drawing/2014/main" id="{7954332D-B979-41D6-9020-A3BA6C506EA2}"/>
+                <a16:creationId xmlns:a16="http://schemas.microsoft.com/office/drawing/2014/main" id="{FCAB1E44-00A9-4FF5-972E-61DF01FAF814}"/>
               </a:ext>
             </a:extLst>
           </p:cNvPr>
@@ -5757,14 +5757,14 @@
             <a:pPr algn="ctr">
               <a:defRPr sz="900" b="1">
                 <a:solidFill>
-                  <a:srgbClr val="191B1A"/>
+                  <a:srgbClr val="24211D"/>
                 </a:solidFill>
               </a:defRPr>
             </a:pPr>
             <a:r>
               <a:rPr sz="900" b="1">
                 <a:solidFill>
-                  <a:srgbClr val="191B1A"/>
+                  <a:srgbClr val="24211D"/>
                 </a:solidFill>
               </a:rPr>
               <a:t>warnings</a:t>
@@ -5777,7 +5777,7 @@
           <p:cNvPr id="106" name="report-note">
             <a:extLst xmlns:a="http://schemas.openxmlformats.org/drawingml/2006/main">
               <a:ext uri="{FF2B5EF4-FFF2-40B4-BE49-F238E27FC236}">
-                <a16:creationId xmlns:a16="http://schemas.microsoft.com/office/drawing/2014/main" id="{2126C76B-57ED-4CF4-8078-21F56262E4EC}"/>
+                <a16:creationId xmlns:a16="http://schemas.microsoft.com/office/drawing/2014/main" id="{2281AD0B-D519-442E-8D69-CC7DAA220BEF}"/>
               </a:ext>
             </a:extLst>
           </p:cNvPr>
@@ -5807,14 +5807,14 @@
             <a:pPr algn="ctr">
               <a:defRPr sz="713" b="0">
                 <a:solidFill>
-                  <a:srgbClr val="656A67"/>
+                  <a:srgbClr val="6B655E"/>
                 </a:solidFill>
               </a:defRPr>
             </a:pPr>
             <a:r>
               <a:rPr sz="713" b="0">
                 <a:solidFill>
-                  <a:srgbClr val="656A67"/>
+                  <a:srgbClr val="6B655E"/>
                 </a:solidFill>
               </a:rPr>
               <a:t>validated</a:t>
@@ -5824,14 +5824,14 @@
             <a:pPr algn="ctr">
               <a:defRPr sz="713" b="0">
                 <a:solidFill>
-                  <a:srgbClr val="656A67"/>
+                  <a:srgbClr val="6B655E"/>
                 </a:solidFill>
               </a:defRPr>
             </a:pPr>
             <a:r>
               <a:rPr sz="713" b="0">
                 <a:solidFill>
-                  <a:srgbClr val="656A67"/>
+                  <a:srgbClr val="6B655E"/>
                 </a:solidFill>
               </a:rPr>
               <a:t>recommendation</a:t>
@@ -5844,7 +5844,7 @@
           <p:cNvPr id="107" name="exports-label">
             <a:extLst xmlns:a="http://schemas.openxmlformats.org/drawingml/2006/main">
               <a:ext uri="{FF2B5EF4-FFF2-40B4-BE49-F238E27FC236}">
-                <a16:creationId xmlns:a16="http://schemas.microsoft.com/office/drawing/2014/main" id="{83539D61-D2C3-4B0D-8C30-EB0154D61378}"/>
+                <a16:creationId xmlns:a16="http://schemas.microsoft.com/office/drawing/2014/main" id="{729F00A6-5F05-4930-812A-81F6A3289D51}"/>
               </a:ext>
             </a:extLst>
           </p:cNvPr>
@@ -5874,14 +5874,14 @@
             <a:pPr algn="ctr">
               <a:defRPr sz="788" b="1">
                 <a:solidFill>
-                  <a:srgbClr val="9C3451"/>
+                  <a:srgbClr val="9B3A2B"/>
                 </a:solidFill>
               </a:defRPr>
             </a:pPr>
             <a:r>
               <a:rPr sz="788" b="1">
                 <a:solidFill>
-                  <a:srgbClr val="9C3451"/>
+                  <a:srgbClr val="9B3A2B"/>
                 </a:solidFill>
               </a:rPr>
               <a:t>FOUR VIEWS</a:t>
@@ -5894,7 +5894,7 @@
           <p:cNvPr id="108" name="export-0">
             <a:extLst xmlns:a="http://schemas.openxmlformats.org/drawingml/2006/main">
               <a:ext uri="{FF2B5EF4-FFF2-40B4-BE49-F238E27FC236}">
-                <a16:creationId xmlns:a16="http://schemas.microsoft.com/office/drawing/2014/main" id="{5E218888-807A-47C1-9646-44C06B69A5A6}"/>
+                <a16:creationId xmlns:a16="http://schemas.microsoft.com/office/drawing/2014/main" id="{3B52C87F-C18E-4A0F-B235-FD9E731BCAF4}"/>
               </a:ext>
             </a:extLst>
           </p:cNvPr>
@@ -5914,11 +5914,11 @@
             </a:avLst>
           </a:prstGeom>
           <a:solidFill xmlns:a="http://schemas.openxmlformats.org/drawingml/2006/main">
-            <a:srgbClr val="F5E9D8"/>
+            <a:srgbClr val="F6E9C9"/>
           </a:solidFill>
           <a:ln xmlns:a="http://schemas.openxmlformats.org/drawingml/2006/main" w="9525">
             <a:solidFill>
-              <a:srgbClr val="A4660A"/>
+              <a:srgbClr val="B97916"/>
             </a:solidFill>
             <a:prstDash val="solid"/>
           </a:ln>
@@ -5929,7 +5929,7 @@
           <p:cNvPr id="109" name="export-label-0">
             <a:extLst xmlns:a="http://schemas.openxmlformats.org/drawingml/2006/main">
               <a:ext uri="{FF2B5EF4-FFF2-40B4-BE49-F238E27FC236}">
-                <a16:creationId xmlns:a16="http://schemas.microsoft.com/office/drawing/2014/main" id="{9CEE1344-B11A-454D-83E9-5258987B65D5}"/>
+                <a16:creationId xmlns:a16="http://schemas.microsoft.com/office/drawing/2014/main" id="{EFDD0C9D-3745-4606-8E56-2D4402F3E026}"/>
               </a:ext>
             </a:extLst>
           </p:cNvPr>
@@ -5959,14 +5959,14 @@
             <a:pPr algn="ctr">
               <a:defRPr sz="900" b="1">
                 <a:solidFill>
-                  <a:srgbClr val="A4660A"/>
+                  <a:srgbClr val="B97916"/>
                 </a:solidFill>
               </a:defRPr>
             </a:pPr>
             <a:r>
               <a:rPr sz="900" b="1">
                 <a:solidFill>
-                  <a:srgbClr val="A4660A"/>
+                  <a:srgbClr val="B97916"/>
                 </a:solidFill>
               </a:rPr>
               <a:t>TBL</a:t>
@@ -5979,7 +5979,7 @@
           <p:cNvPr id="110" name="export-1">
             <a:extLst xmlns:a="http://schemas.openxmlformats.org/drawingml/2006/main">
               <a:ext uri="{FF2B5EF4-FFF2-40B4-BE49-F238E27FC236}">
-                <a16:creationId xmlns:a16="http://schemas.microsoft.com/office/drawing/2014/main" id="{653524E6-76EE-4BAE-B752-AC3B03F94002}"/>
+                <a16:creationId xmlns:a16="http://schemas.microsoft.com/office/drawing/2014/main" id="{81B911FA-60D4-4706-A330-C4E22958CC28}"/>
               </a:ext>
             </a:extLst>
           </p:cNvPr>
@@ -5999,11 +5999,11 @@
             </a:avLst>
           </a:prstGeom>
           <a:solidFill xmlns:a="http://schemas.openxmlformats.org/drawingml/2006/main">
-            <a:srgbClr val="ECEDEA"/>
+            <a:srgbClr val="E8E3D9"/>
           </a:solidFill>
           <a:ln xmlns:a="http://schemas.openxmlformats.org/drawingml/2006/main" w="9525">
             <a:solidFill>
-              <a:srgbClr val="C7CBC7"/>
+              <a:srgbClr val="C9C0B1"/>
             </a:solidFill>
             <a:prstDash val="solid"/>
           </a:ln>
@@ -6014,7 +6014,7 @@
           <p:cNvPr id="111" name="export-label-1">
             <a:extLst xmlns:a="http://schemas.openxmlformats.org/drawingml/2006/main">
               <a:ext uri="{FF2B5EF4-FFF2-40B4-BE49-F238E27FC236}">
-                <a16:creationId xmlns:a16="http://schemas.microsoft.com/office/drawing/2014/main" id="{8CBD22BE-E4F0-4791-9C67-7D80FFC32BD8}"/>
+                <a16:creationId xmlns:a16="http://schemas.microsoft.com/office/drawing/2014/main" id="{B2ACBA17-FE6E-4E97-B2FF-6A2B06F0EAB1}"/>
               </a:ext>
             </a:extLst>
           </p:cNvPr>
@@ -6044,14 +6044,14 @@
             <a:pPr algn="ctr">
               <a:defRPr sz="788" b="1">
                 <a:solidFill>
-                  <a:srgbClr val="183B5C"/>
+                  <a:srgbClr val="36453B"/>
                 </a:solidFill>
               </a:defRPr>
             </a:pPr>
             <a:r>
               <a:rPr sz="788" b="1">
                 <a:solidFill>
-                  <a:srgbClr val="183B5C"/>
+                  <a:srgbClr val="36453B"/>
                 </a:solidFill>
               </a:rPr>
               <a:t>MD</a:t>
@@ -6064,7 +6064,7 @@
           <p:cNvPr id="112" name="export-2">
             <a:extLst xmlns:a="http://schemas.openxmlformats.org/drawingml/2006/main">
               <a:ext uri="{FF2B5EF4-FFF2-40B4-BE49-F238E27FC236}">
-                <a16:creationId xmlns:a16="http://schemas.microsoft.com/office/drawing/2014/main" id="{98ACC30A-A833-42F3-BB19-79EC0C2CCEF8}"/>
+                <a16:creationId xmlns:a16="http://schemas.microsoft.com/office/drawing/2014/main" id="{8CD4D586-4EBF-4044-B1C3-1F028EC5A54D}"/>
               </a:ext>
             </a:extLst>
           </p:cNvPr>
@@ -6084,11 +6084,11 @@
             </a:avLst>
           </a:prstGeom>
           <a:solidFill xmlns:a="http://schemas.openxmlformats.org/drawingml/2006/main">
-            <a:srgbClr val="ECEDEA"/>
+            <a:srgbClr val="E8E3D9"/>
           </a:solidFill>
           <a:ln xmlns:a="http://schemas.openxmlformats.org/drawingml/2006/main" w="9525">
             <a:solidFill>
-              <a:srgbClr val="C7CBC7"/>
+              <a:srgbClr val="C9C0B1"/>
             </a:solidFill>
             <a:prstDash val="solid"/>
           </a:ln>
@@ -6099,7 +6099,7 @@
           <p:cNvPr id="113" name="export-label-2">
             <a:extLst xmlns:a="http://schemas.openxmlformats.org/drawingml/2006/main">
               <a:ext uri="{FF2B5EF4-FFF2-40B4-BE49-F238E27FC236}">
-                <a16:creationId xmlns:a16="http://schemas.microsoft.com/office/drawing/2014/main" id="{C03D0486-0D24-4CA1-8AEF-38373D50D60A}"/>
+                <a16:creationId xmlns:a16="http://schemas.microsoft.com/office/drawing/2014/main" id="{6D859359-3FF2-40E3-8214-96676B64731C}"/>
               </a:ext>
             </a:extLst>
           </p:cNvPr>
@@ -6129,14 +6129,14 @@
             <a:pPr algn="ctr">
               <a:defRPr sz="788" b="1">
                 <a:solidFill>
-                  <a:srgbClr val="183B5C"/>
+                  <a:srgbClr val="36453B"/>
                 </a:solidFill>
               </a:defRPr>
             </a:pPr>
             <a:r>
               <a:rPr sz="788" b="1">
                 <a:solidFill>
-                  <a:srgbClr val="183B5C"/>
+                  <a:srgbClr val="36453B"/>
                 </a:solidFill>
               </a:rPr>
               <a:t>JSON</a:t>
@@ -6149,7 +6149,7 @@
           <p:cNvPr id="114" name="export-3">
             <a:extLst xmlns:a="http://schemas.openxmlformats.org/drawingml/2006/main">
               <a:ext uri="{FF2B5EF4-FFF2-40B4-BE49-F238E27FC236}">
-                <a16:creationId xmlns:a16="http://schemas.microsoft.com/office/drawing/2014/main" id="{AD5CF342-E8A7-4E9C-A373-76281D301499}"/>
+                <a16:creationId xmlns:a16="http://schemas.microsoft.com/office/drawing/2014/main" id="{32CFADD4-9F09-49B0-8E4C-50DA202D549A}"/>
               </a:ext>
             </a:extLst>
           </p:cNvPr>
@@ -6169,11 +6169,11 @@
             </a:avLst>
           </a:prstGeom>
           <a:solidFill xmlns:a="http://schemas.openxmlformats.org/drawingml/2006/main">
-            <a:srgbClr val="ECEDEA"/>
+            <a:srgbClr val="E8E3D9"/>
           </a:solidFill>
           <a:ln xmlns:a="http://schemas.openxmlformats.org/drawingml/2006/main" w="9525">
             <a:solidFill>
-              <a:srgbClr val="C7CBC7"/>
+              <a:srgbClr val="C9C0B1"/>
             </a:solidFill>
             <a:prstDash val="solid"/>
           </a:ln>
@@ -6184,7 +6184,7 @@
           <p:cNvPr id="115" name="export-label-3">
             <a:extLst xmlns:a="http://schemas.openxmlformats.org/drawingml/2006/main">
               <a:ext uri="{FF2B5EF4-FFF2-40B4-BE49-F238E27FC236}">
-                <a16:creationId xmlns:a16="http://schemas.microsoft.com/office/drawing/2014/main" id="{50E22A1C-6673-4DA3-B5E4-75C76CA84C98}"/>
+                <a16:creationId xmlns:a16="http://schemas.microsoft.com/office/drawing/2014/main" id="{AAFA2849-060C-4E44-B2E6-7843A5DBE214}"/>
               </a:ext>
             </a:extLst>
           </p:cNvPr>
@@ -6214,14 +6214,14 @@
             <a:pPr algn="ctr">
               <a:defRPr sz="788" b="1">
                 <a:solidFill>
-                  <a:srgbClr val="183B5C"/>
+                  <a:srgbClr val="36453B"/>
                 </a:solidFill>
               </a:defRPr>
             </a:pPr>
             <a:r>
               <a:rPr sz="788" b="1">
                 <a:solidFill>
-                  <a:srgbClr val="183B5C"/>
+                  <a:srgbClr val="36453B"/>
                 </a:solidFill>
               </a:rPr>
               <a:t>CSV</a:t>
@@ -6234,7 +6234,7 @@
           <p:cNvPr id="116" name="footer-rule">
             <a:extLst xmlns:a="http://schemas.openxmlformats.org/drawingml/2006/main">
               <a:ext uri="{FF2B5EF4-FFF2-40B4-BE49-F238E27FC236}">
-                <a16:creationId xmlns:a16="http://schemas.microsoft.com/office/drawing/2014/main" id="{DFCDAC26-3775-49D8-A720-06E7B5EABCC4}"/>
+                <a16:creationId xmlns:a16="http://schemas.microsoft.com/office/drawing/2014/main" id="{A522A2F7-F3D5-4F16-B35D-AA42DFB3B4AD}"/>
               </a:ext>
             </a:extLst>
           </p:cNvPr>
@@ -6254,7 +6254,7 @@
           <a:noFill xmlns:a="http://schemas.openxmlformats.org/drawingml/2006/main"/>
           <a:ln xmlns:a="http://schemas.openxmlformats.org/drawingml/2006/main" w="13335">
             <a:solidFill>
-              <a:srgbClr val="191B1A"/>
+              <a:srgbClr val="24211D"/>
             </a:solidFill>
             <a:prstDash val="solid"/>
           </a:ln>
@@ -6265,7 +6265,7 @@
           <p:cNvPr id="117" name="failure-label">
             <a:extLst xmlns:a="http://schemas.openxmlformats.org/drawingml/2006/main">
               <a:ext uri="{FF2B5EF4-FFF2-40B4-BE49-F238E27FC236}">
-                <a16:creationId xmlns:a16="http://schemas.microsoft.com/office/drawing/2014/main" id="{57F59F64-265D-46E5-B14F-D04F612E688D}"/>
+                <a16:creationId xmlns:a16="http://schemas.microsoft.com/office/drawing/2014/main" id="{440DEBA1-3B1B-4961-9A02-5CE912EFD100}"/>
               </a:ext>
             </a:extLst>
           </p:cNvPr>
@@ -6295,14 +6295,14 @@
             <a:pPr algn="l">
               <a:defRPr sz="900" b="1">
                 <a:solidFill>
-                  <a:srgbClr val="9C3451"/>
+                  <a:srgbClr val="9B3A2B"/>
                 </a:solidFill>
               </a:defRPr>
             </a:pPr>
             <a:r>
               <a:rPr sz="900" b="1">
                 <a:solidFill>
-                  <a:srgbClr val="9C3451"/>
+                  <a:srgbClr val="9B3A2B"/>
                 </a:solidFill>
               </a:rPr>
               <a:t>FAILURE SEMANTICS</a:t>
@@ -6315,7 +6315,7 @@
           <p:cNvPr id="118" name="failure-copy">
             <a:extLst xmlns:a="http://schemas.openxmlformats.org/drawingml/2006/main">
               <a:ext uri="{FF2B5EF4-FFF2-40B4-BE49-F238E27FC236}">
-                <a16:creationId xmlns:a16="http://schemas.microsoft.com/office/drawing/2014/main" id="{E964BCD7-F030-4103-A426-C9C1B10DE7BB}"/>
+                <a16:creationId xmlns:a16="http://schemas.microsoft.com/office/drawing/2014/main" id="{4D8995DD-941B-444C-9732-9AC1E7366813}"/>
               </a:ext>
             </a:extLst>
           </p:cNvPr>
@@ -6345,14 +6345,14 @@
             <a:pPr algn="l">
               <a:defRPr sz="1050" b="1">
                 <a:solidFill>
-                  <a:srgbClr val="183B5C"/>
+                  <a:srgbClr val="36453B"/>
                 </a:solidFill>
               </a:defRPr>
             </a:pPr>
             <a:r>
               <a:rPr sz="1050" b="1">
                 <a:solidFill>
-                  <a:srgbClr val="183B5C"/>
+                  <a:srgbClr val="36453B"/>
                 </a:solidFill>
               </a:rPr>
               <a:t>missing field → partial profile   ·   failed provider → warning   ·   no sourced profile → no report</a:t>
@@ -6365,7 +6365,7 @@
           <p:cNvPr id="119" name="boundary-label">
             <a:extLst xmlns:a="http://schemas.openxmlformats.org/drawingml/2006/main">
               <a:ext uri="{FF2B5EF4-FFF2-40B4-BE49-F238E27FC236}">
-                <a16:creationId xmlns:a16="http://schemas.microsoft.com/office/drawing/2014/main" id="{A4A14432-5F83-46D2-A85F-24A8D1FB1BF5}"/>
+                <a16:creationId xmlns:a16="http://schemas.microsoft.com/office/drawing/2014/main" id="{586D16FD-BA9A-4AC0-A9D5-B8576393A116}"/>
               </a:ext>
             </a:extLst>
           </p:cNvPr>
@@ -6395,14 +6395,14 @@
             <a:pPr algn="l">
               <a:defRPr sz="900" b="1">
                 <a:solidFill>
-                  <a:srgbClr val="9C3451"/>
+                  <a:srgbClr val="9B3A2B"/>
                 </a:solidFill>
               </a:defRPr>
             </a:pPr>
             <a:r>
               <a:rPr sz="900" b="1">
                 <a:solidFill>
-                  <a:srgbClr val="9C3451"/>
+                  <a:srgbClr val="9B3A2B"/>
                 </a:solidFill>
               </a:rPr>
               <a:t>EVIDENCE BOUNDARY</a:t>
@@ -6415,7 +6415,7 @@
           <p:cNvPr id="120" name="boundary-copy">
             <a:extLst xmlns:a="http://schemas.openxmlformats.org/drawingml/2006/main">
               <a:ext uri="{FF2B5EF4-FFF2-40B4-BE49-F238E27FC236}">
-                <a16:creationId xmlns:a16="http://schemas.microsoft.com/office/drawing/2014/main" id="{E86A51E2-6D9C-4342-BC81-8F233E44CF81}"/>
+                <a16:creationId xmlns:a16="http://schemas.microsoft.com/office/drawing/2014/main" id="{4FFF401A-3280-46BB-A28A-799B7A2FB225}"/>
               </a:ext>
             </a:extLst>
           </p:cNvPr>
@@ -6445,14 +6445,14 @@
             <a:pPr algn="l">
               <a:defRPr sz="1013" b="0">
                 <a:solidFill>
-                  <a:srgbClr val="191B1A"/>
+                  <a:srgbClr val="24211D"/>
                 </a:solidFill>
               </a:defRPr>
             </a:pPr>
             <a:r>
               <a:rPr sz="1013" b="0">
                 <a:solidFill>
-                  <a:srgbClr val="191B1A"/>
+                  <a:srgbClr val="24211D"/>
                 </a:solidFill>
               </a:rPr>
               <a:t>Complete deterministic fixture—not a live crawl, current market comparison, recommendation-quality study, or factuality evaluation.</a:t>
@@ -6465,7 +6465,7 @@
           <p:cNvPr id="121" name="sources">
             <a:extLst xmlns:a="http://schemas.openxmlformats.org/drawingml/2006/main">
               <a:ext uri="{FF2B5EF4-FFF2-40B4-BE49-F238E27FC236}">
-                <a16:creationId xmlns:a16="http://schemas.microsoft.com/office/drawing/2014/main" id="{8A2AC8F3-3187-4E6D-BC10-24A5E8DFDC8B}"/>
+                <a16:creationId xmlns:a16="http://schemas.microsoft.com/office/drawing/2014/main" id="{A8B65906-1762-45AF-967A-B73553E270FC}"/>
               </a:ext>
             </a:extLst>
           </p:cNvPr>
@@ -6495,14 +6495,14 @@
             <a:pPr algn="ctr">
               <a:defRPr sz="750" b="0">
                 <a:solidFill>
-                  <a:srgbClr val="656A67"/>
+                  <a:srgbClr val="6B655E"/>
                 </a:solidFill>
               </a:defRPr>
             </a:pPr>
             <a:r>
               <a:rPr sz="750" b="0">
                 <a:solidFill>
-                  <a:srgbClr val="656A67"/>
+                  <a:srgbClr val="6B655E"/>
                 </a:solidFill>
               </a:rPr>
               <a:t>Sources: examples/demo-report.json · src/intellicrawl/pipeline.py · demo.py · renderers.py</a:t>
@@ -6513,7 +6513,7 @@
     </p:spTree>
     <p:extLst>
       <p:ext uri="{BB962C8B-B14F-4D97-AF65-F5344CB8AC3E}">
-        <p14:creationId xmlns:p14="http://schemas.microsoft.com/office/powerpoint/2010/main" val="1093139077"/>
+        <p14:creationId xmlns:p14="http://schemas.microsoft.com/office/powerpoint/2010/main" val="734845620"/>
       </p:ext>
     </p:extLst>
   </p:cSld>

</xml_diff>

<commit_message>
Align architecture figure with the project visual language
</commit_message>
<xml_diff>
--- a/docs/figures/evidence-trace/editable/intellicrawl-evidence-trace.pptx
+++ b/docs/figures/evidence-trace/editable/intellicrawl-evidence-trace.pptx
@@ -2,13 +2,13 @@
 <file path=ppt/presentation.xml><?xml version="1.0" encoding="utf-8"?>
 <p:presentation xmlns:p="http://schemas.openxmlformats.org/presentationml/2006/main">
   <p:sldMasterIdLst>
-    <p:sldMasterId xmlns:r="http://schemas.openxmlformats.org/officeDocument/2006/relationships" id="2147483648" r:id="R709051e2cdb64471"/>
+    <p:sldMasterId xmlns:r="http://schemas.openxmlformats.org/officeDocument/2006/relationships" id="2147483648" r:id="Rc28a7ad03daf4a75"/>
   </p:sldMasterIdLst>
   <p:notesMasterIdLst>
-    <p:notesMasterId xmlns:r="http://schemas.openxmlformats.org/officeDocument/2006/relationships" r:id="Rca785600a9d64195"/>
+    <p:notesMasterId xmlns:r="http://schemas.openxmlformats.org/officeDocument/2006/relationships" r:id="Rba8c3fdb0a964fa2"/>
   </p:notesMasterIdLst>
   <p:sldIdLst>
-    <p:sldId xmlns:r="http://schemas.openxmlformats.org/officeDocument/2006/relationships" id="256" r:id="Rc65f6466d3b345c1"/>
+    <p:sldId xmlns:r="http://schemas.openxmlformats.org/officeDocument/2006/relationships" id="256" r:id="Rcc3edeaed6b8438e"/>
   </p:sldIdLst>
   <p:sldSz cx="12192000" cy="6858000"/>
   <p:notesSz cx="6858000" cy="9144000"/>
@@ -601,7 +601,7 @@
   </p:cSld>
   <p:clrMap bg1="lt1" tx1="dk1" bg2="lt2" tx2="dk2" accent1="accent1" accent2="accent2" accent3="accent3" accent4="accent4" accent5="accent5" accent6="accent6" hlink="hlink" folHlink="folHlink"/>
   <p:sldLayoutIdLst>
-    <p:sldLayoutId xmlns:r="http://schemas.openxmlformats.org/officeDocument/2006/relationships" id="2147483649" r:id="R364b8fe773ec41c5"/>
+    <p:sldLayoutId xmlns:r="http://schemas.openxmlformats.org/officeDocument/2006/relationships" id="2147483649" r:id="R54f6e25696df4d21"/>
   </p:sldLayoutIdLst>
   <p:txStyles>
     <p:titleStyle>
@@ -1134,7 +1134,7 @@
     <p:bg>
       <p:bgPr>
         <a:solidFill xmlns:a="http://schemas.openxmlformats.org/drawingml/2006/main">
-          <a:srgbClr val="F4F0E8"/>
+          <a:srgbClr val="FFFFFF"/>
         </a:solidFill>
       </p:bgPr>
     </p:bg>
@@ -1149,32 +1149,184 @@
       </p:grpSpPr>
       <p:sp>
         <p:nvSpPr>
-          <p:cNvPr id="94" name="editorial-rail">
-            <a:extLst xmlns:a="http://schemas.openxmlformats.org/drawingml/2006/main">
-              <a:ext uri="{FF2B5EF4-FFF2-40B4-BE49-F238E27FC236}">
-                <a16:creationId xmlns:a16="http://schemas.microsoft.com/office/drawing/2014/main" id="{3EAE890B-2283-44DD-A5A7-B3BC5BE0D054}"/>
-              </a:ext>
-            </a:extLst>
-          </p:cNvPr>
-          <p:cNvSpPr>
-            <a:spLocks xmlns:a="http://schemas.openxmlformats.org/drawingml/2006/main" noGrp="1"/>
-          </p:cNvSpPr>
-          <p:nvPr/>
-        </p:nvSpPr>
-        <p:spPr>
-          <a:xfrm xmlns:a="http://schemas.openxmlformats.org/drawingml/2006/main">
-            <a:off x="0" y="0"/>
-            <a:ext cx="2400300" cy="6858000"/>
-          </a:xfrm>
-          <a:prstGeom xmlns:a="http://schemas.openxmlformats.org/drawingml/2006/main" prst="rect">
-            <a:avLst/>
+          <p:cNvPr id="95" name="title">
+            <a:extLst xmlns:a="http://schemas.openxmlformats.org/drawingml/2006/main">
+              <a:ext uri="{FF2B5EF4-FFF2-40B4-BE49-F238E27FC236}">
+                <a16:creationId xmlns:a16="http://schemas.microsoft.com/office/drawing/2014/main" id="{0B35D5EE-4BFC-4D02-BD22-22270C9A0840}"/>
+              </a:ext>
+            </a:extLst>
+          </p:cNvPr>
+          <p:cNvSpPr>
+            <a:spLocks xmlns:a="http://schemas.openxmlformats.org/drawingml/2006/main" noGrp="1"/>
+          </p:cNvSpPr>
+          <p:nvPr/>
+        </p:nvSpPr>
+        <p:spPr>
+          <a:xfrm xmlns:a="http://schemas.openxmlformats.org/drawingml/2006/main">
+            <a:off x="323850" y="228600"/>
+            <a:ext cx="9048750" cy="361950"/>
+          </a:xfrm>
+          <a:prstGeom xmlns:a="http://schemas.openxmlformats.org/drawingml/2006/main" prst="rect">
+            <a:avLst/>
+          </a:prstGeom>
+          <a:noFill xmlns:a="http://schemas.openxmlformats.org/drawingml/2006/main"/>
+          <a:ln xmlns:a="http://schemas.openxmlformats.org/drawingml/2006/main" w="0">
+            <a:noFill/>
+            <a:prstDash val="solid"/>
+          </a:ln>
+        </p:spPr>
+        <p:txBody>
+          <a:bodyPr xmlns:a="http://schemas.openxmlformats.org/drawingml/2006/main"/>
+          <a:lstStyle xmlns:a="http://schemas.openxmlformats.org/drawingml/2006/main"/>
+          <a:p xmlns:a="http://schemas.openxmlformats.org/drawingml/2006/main">
+            <a:pPr algn="l">
+              <a:defRPr sz="2025" b="1">
+                <a:solidFill>
+                  <a:srgbClr val="1C2430"/>
+                </a:solidFill>
+              </a:defRPr>
+            </a:pPr>
+            <a:r>
+              <a:rPr sz="2025" b="1">
+                <a:solidFill>
+                  <a:srgbClr val="1C2430"/>
+                </a:solidFill>
+              </a:rPr>
+              <a:t>IntelliCrawl: replaceable providers, one typed research graph</a:t>
+            </a:r>
+          </a:p>
+        </p:txBody>
+      </p:sp>
+      <p:sp>
+        <p:nvSpPr>
+          <p:cNvPr id="2" name="subtitle">
+            <a:extLst xmlns:a="http://schemas.openxmlformats.org/drawingml/2006/main">
+              <a:ext uri="{FF2B5EF4-FFF2-40B4-BE49-F238E27FC236}">
+                <a16:creationId xmlns:a16="http://schemas.microsoft.com/office/drawing/2014/main" id="{0DD85B4D-91EA-4C32-8474-C1BCF1A53CF9}"/>
+              </a:ext>
+            </a:extLst>
+          </p:cNvPr>
+          <p:cNvSpPr>
+            <a:spLocks xmlns:a="http://schemas.openxmlformats.org/drawingml/2006/main" noGrp="1"/>
+          </p:cNvSpPr>
+          <p:nvPr/>
+        </p:nvSpPr>
+        <p:spPr>
+          <a:xfrm xmlns:a="http://schemas.openxmlformats.org/drawingml/2006/main">
+            <a:off x="323850" y="619125"/>
+            <a:ext cx="8763000" cy="209550"/>
+          </a:xfrm>
+          <a:prstGeom xmlns:a="http://schemas.openxmlformats.org/drawingml/2006/main" prst="rect">
+            <a:avLst/>
+          </a:prstGeom>
+          <a:noFill xmlns:a="http://schemas.openxmlformats.org/drawingml/2006/main"/>
+          <a:ln xmlns:a="http://schemas.openxmlformats.org/drawingml/2006/main" w="0">
+            <a:noFill/>
+            <a:prstDash val="solid"/>
+          </a:ln>
+        </p:spPr>
+        <p:txBody>
+          <a:bodyPr xmlns:a="http://schemas.openxmlformats.org/drawingml/2006/main"/>
+          <a:lstStyle xmlns:a="http://schemas.openxmlformats.org/drawingml/2006/main"/>
+          <a:p xmlns:a="http://schemas.openxmlformats.org/drawingml/2006/main">
+            <a:pPr algn="l">
+              <a:defRPr sz="1050" b="0">
+                <a:solidFill>
+                  <a:srgbClr val="667085"/>
+                </a:solidFill>
+              </a:defRPr>
+            </a:pPr>
+            <a:r>
+              <a:rPr sz="1050" b="0">
+                <a:solidFill>
+                  <a:srgbClr val="667085"/>
+                </a:solidFill>
+              </a:rPr>
+              <a:t>Demo and live assemblies enter the same code-grounded LangGraph; validation remains inside the execution path.</a:t>
+            </a:r>
+          </a:p>
+        </p:txBody>
+      </p:sp>
+      <p:sp>
+        <p:nvSpPr>
+          <p:cNvPr id="3" name="graph-type">
+            <a:extLst xmlns:a="http://schemas.openxmlformats.org/drawingml/2006/main">
+              <a:ext uri="{FF2B5EF4-FFF2-40B4-BE49-F238E27FC236}">
+                <a16:creationId xmlns:a16="http://schemas.microsoft.com/office/drawing/2014/main" id="{4E0927B8-2605-4D43-B376-FEC97F8D2809}"/>
+              </a:ext>
+            </a:extLst>
+          </p:cNvPr>
+          <p:cNvSpPr>
+            <a:spLocks xmlns:a="http://schemas.openxmlformats.org/drawingml/2006/main" noGrp="1"/>
+          </p:cNvSpPr>
+          <p:nvPr/>
+        </p:nvSpPr>
+        <p:spPr>
+          <a:xfrm xmlns:a="http://schemas.openxmlformats.org/drawingml/2006/main">
+            <a:off x="9525000" y="323850"/>
+            <a:ext cx="2247900" cy="171450"/>
+          </a:xfrm>
+          <a:prstGeom xmlns:a="http://schemas.openxmlformats.org/drawingml/2006/main" prst="rect">
+            <a:avLst/>
+          </a:prstGeom>
+          <a:noFill xmlns:a="http://schemas.openxmlformats.org/drawingml/2006/main"/>
+          <a:ln xmlns:a="http://schemas.openxmlformats.org/drawingml/2006/main" w="0">
+            <a:noFill/>
+            <a:prstDash val="solid"/>
+          </a:ln>
+        </p:spPr>
+        <p:txBody>
+          <a:bodyPr xmlns:a="http://schemas.openxmlformats.org/drawingml/2006/main"/>
+          <a:lstStyle xmlns:a="http://schemas.openxmlformats.org/drawingml/2006/main"/>
+          <a:p xmlns:a="http://schemas.openxmlformats.org/drawingml/2006/main">
+            <a:pPr algn="r">
+              <a:defRPr sz="788" b="1">
+                <a:solidFill>
+                  <a:srgbClr val="397EA5"/>
+                </a:solidFill>
+              </a:defRPr>
+            </a:pPr>
+            <a:r>
+              <a:rPr sz="788" b="1">
+                <a:solidFill>
+                  <a:srgbClr val="397EA5"/>
+                </a:solidFill>
+              </a:rPr>
+              <a:t>ResearchPipeline / LangGraph</a:t>
+            </a:r>
+          </a:p>
+        </p:txBody>
+      </p:sp>
+      <p:sp>
+        <p:nvSpPr>
+          <p:cNvPr id="4" name="editorial-rail">
+            <a:extLst xmlns:a="http://schemas.openxmlformats.org/drawingml/2006/main">
+              <a:ext uri="{FF2B5EF4-FFF2-40B4-BE49-F238E27FC236}">
+                <a16:creationId xmlns:a16="http://schemas.microsoft.com/office/drawing/2014/main" id="{0A96221A-C1D6-458A-A785-074C7708365A}"/>
+              </a:ext>
+            </a:extLst>
+          </p:cNvPr>
+          <p:cNvSpPr>
+            <a:spLocks xmlns:a="http://schemas.openxmlformats.org/drawingml/2006/main" noGrp="1"/>
+          </p:cNvSpPr>
+          <p:nvPr/>
+        </p:nvSpPr>
+        <p:spPr>
+          <a:xfrm xmlns:a="http://schemas.openxmlformats.org/drawingml/2006/main">
+            <a:off x="266700" y="1066800"/>
+            <a:ext cx="2152650" cy="4914900"/>
+          </a:xfrm>
+          <a:prstGeom xmlns:a="http://schemas.openxmlformats.org/drawingml/2006/main" prst="roundRect">
+            <a:avLst>
+              <a:gd name="adj" fmla="val 4425"/>
+            </a:avLst>
           </a:prstGeom>
           <a:solidFill xmlns:a="http://schemas.openxmlformats.org/drawingml/2006/main">
-            <a:srgbClr val="263B35"/>
+            <a:srgbClr val="F3F4F5"/>
           </a:solidFill>
           <a:ln xmlns:a="http://schemas.openxmlformats.org/drawingml/2006/main" w="9525">
             <a:solidFill>
-              <a:srgbClr val="263B35"/>
+              <a:srgbClr val="C9CED6"/>
             </a:solidFill>
             <a:prstDash val="solid"/>
           </a:ln>
@@ -1182,32 +1334,32 @@
       </p:sp>
       <p:sp>
         <p:nvSpPr>
-          <p:cNvPr id="2" name="rail-accent">
-            <a:extLst xmlns:a="http://schemas.openxmlformats.org/drawingml/2006/main">
-              <a:ext uri="{FF2B5EF4-FFF2-40B4-BE49-F238E27FC236}">
-                <a16:creationId xmlns:a16="http://schemas.microsoft.com/office/drawing/2014/main" id="{C5048EFA-EE45-47F2-880C-C1B080A3FBC1}"/>
-              </a:ext>
-            </a:extLst>
-          </p:cNvPr>
-          <p:cNvSpPr>
-            <a:spLocks xmlns:a="http://schemas.openxmlformats.org/drawingml/2006/main" noGrp="1"/>
-          </p:cNvSpPr>
-          <p:nvPr/>
-        </p:nvSpPr>
-        <p:spPr>
-          <a:xfrm xmlns:a="http://schemas.openxmlformats.org/drawingml/2006/main">
-            <a:off x="0" y="0"/>
-            <a:ext cx="114300" cy="6858000"/>
+          <p:cNvPr id="5" name="rail-accent">
+            <a:extLst xmlns:a="http://schemas.openxmlformats.org/drawingml/2006/main">
+              <a:ext uri="{FF2B5EF4-FFF2-40B4-BE49-F238E27FC236}">
+                <a16:creationId xmlns:a16="http://schemas.microsoft.com/office/drawing/2014/main" id="{758DDAB9-517C-493E-9DA7-C6779A79D2C9}"/>
+              </a:ext>
+            </a:extLst>
+          </p:cNvPr>
+          <p:cNvSpPr>
+            <a:spLocks xmlns:a="http://schemas.openxmlformats.org/drawingml/2006/main" noGrp="1"/>
+          </p:cNvSpPr>
+          <p:nvPr/>
+        </p:nvSpPr>
+        <p:spPr>
+          <a:xfrm xmlns:a="http://schemas.openxmlformats.org/drawingml/2006/main">
+            <a:off x="266700" y="1066800"/>
+            <a:ext cx="57150" cy="4914900"/>
           </a:xfrm>
           <a:prstGeom xmlns:a="http://schemas.openxmlformats.org/drawingml/2006/main" prst="rect">
             <a:avLst/>
           </a:prstGeom>
           <a:solidFill xmlns:a="http://schemas.openxmlformats.org/drawingml/2006/main">
-            <a:srgbClr val="C6653E"/>
+            <a:srgbClr val="D05A2A"/>
           </a:solidFill>
           <a:ln xmlns:a="http://schemas.openxmlformats.org/drawingml/2006/main" w="9525">
             <a:solidFill>
-              <a:srgbClr val="C6653E"/>
+              <a:srgbClr val="D05A2A"/>
             </a:solidFill>
             <a:prstDash val="solid"/>
           </a:ln>
@@ -1215,22 +1367,22 @@
       </p:sp>
       <p:sp>
         <p:nvSpPr>
-          <p:cNvPr id="3" name="rail-kicker">
-            <a:extLst xmlns:a="http://schemas.openxmlformats.org/drawingml/2006/main">
-              <a:ext uri="{FF2B5EF4-FFF2-40B4-BE49-F238E27FC236}">
-                <a16:creationId xmlns:a16="http://schemas.microsoft.com/office/drawing/2014/main" id="{8B74C024-3FCA-42D0-9479-0051BF000534}"/>
-              </a:ext>
-            </a:extLst>
-          </p:cNvPr>
-          <p:cNvSpPr>
-            <a:spLocks xmlns:a="http://schemas.openxmlformats.org/drawingml/2006/main" noGrp="1"/>
-          </p:cNvSpPr>
-          <p:nvPr/>
-        </p:nvSpPr>
-        <p:spPr>
-          <a:xfrm xmlns:a="http://schemas.openxmlformats.org/drawingml/2006/main">
-            <a:off x="323850" y="333375"/>
-            <a:ext cx="1809750" cy="171450"/>
+          <p:cNvPr id="6" name="rail-kicker">
+            <a:extLst xmlns:a="http://schemas.openxmlformats.org/drawingml/2006/main">
+              <a:ext uri="{FF2B5EF4-FFF2-40B4-BE49-F238E27FC236}">
+                <a16:creationId xmlns:a16="http://schemas.microsoft.com/office/drawing/2014/main" id="{C56A2925-D9E7-4164-99AA-6A2D86155674}"/>
+              </a:ext>
+            </a:extLst>
+          </p:cNvPr>
+          <p:cNvSpPr>
+            <a:spLocks xmlns:a="http://schemas.openxmlformats.org/drawingml/2006/main" noGrp="1"/>
+          </p:cNvSpPr>
+          <p:nvPr/>
+        </p:nvSpPr>
+        <p:spPr>
+          <a:xfrm xmlns:a="http://schemas.openxmlformats.org/drawingml/2006/main">
+            <a:off x="457200" y="1257300"/>
+            <a:ext cx="1676400" cy="171450"/>
           </a:xfrm>
           <a:prstGeom xmlns:a="http://schemas.openxmlformats.org/drawingml/2006/main" prst="rect">
             <a:avLst/>
@@ -1248,39 +1400,39 @@
             <a:pPr algn="l">
               <a:defRPr sz="788" b="1">
                 <a:solidFill>
-                  <a:srgbClr val="C8D8D0"/>
+                  <a:srgbClr val="D05A2A"/>
                 </a:solidFill>
               </a:defRPr>
             </a:pPr>
             <a:r>
               <a:rPr sz="788" b="1">
                 <a:solidFill>
-                  <a:srgbClr val="C8D8D0"/>
-                </a:solidFill>
-              </a:rPr>
-              <a:t>SYSTEM MAP · CODE-GROUNDED</a:t>
-            </a:r>
-          </a:p>
-        </p:txBody>
-      </p:sp>
-      <p:sp>
-        <p:nvSpPr>
-          <p:cNvPr id="4" name="rail-title">
-            <a:extLst xmlns:a="http://schemas.openxmlformats.org/drawingml/2006/main">
-              <a:ext uri="{FF2B5EF4-FFF2-40B4-BE49-F238E27FC236}">
-                <a16:creationId xmlns:a16="http://schemas.microsoft.com/office/drawing/2014/main" id="{888755AE-3826-44AC-8478-72E28AD2D21E}"/>
-              </a:ext>
-            </a:extLst>
-          </p:cNvPr>
-          <p:cNvSpPr>
-            <a:spLocks xmlns:a="http://schemas.openxmlformats.org/drawingml/2006/main" noGrp="1"/>
-          </p:cNvSpPr>
-          <p:nvPr/>
-        </p:nvSpPr>
-        <p:spPr>
-          <a:xfrm xmlns:a="http://schemas.openxmlformats.org/drawingml/2006/main">
-            <a:off x="323850" y="695325"/>
-            <a:ext cx="1809750" cy="952500"/>
+                  <a:srgbClr val="D05A2A"/>
+                </a:solidFill>
+              </a:rPr>
+              <a:t>REPLACEABLE INPUTS</a:t>
+            </a:r>
+          </a:p>
+        </p:txBody>
+      </p:sp>
+      <p:sp>
+        <p:nvSpPr>
+          <p:cNvPr id="7" name="rail-title">
+            <a:extLst xmlns:a="http://schemas.openxmlformats.org/drawingml/2006/main">
+              <a:ext uri="{FF2B5EF4-FFF2-40B4-BE49-F238E27FC236}">
+                <a16:creationId xmlns:a16="http://schemas.microsoft.com/office/drawing/2014/main" id="{4CA6B870-F2A6-4D3F-8CCE-6C9E8DF04D5E}"/>
+              </a:ext>
+            </a:extLst>
+          </p:cNvPr>
+          <p:cNvSpPr>
+            <a:spLocks xmlns:a="http://schemas.openxmlformats.org/drawingml/2006/main" noGrp="1"/>
+          </p:cNvSpPr>
+          <p:nvPr/>
+        </p:nvSpPr>
+        <p:spPr>
+          <a:xfrm xmlns:a="http://schemas.openxmlformats.org/drawingml/2006/main">
+            <a:off x="457200" y="1514475"/>
+            <a:ext cx="1676400" cy="238125"/>
           </a:xfrm>
           <a:prstGeom xmlns:a="http://schemas.openxmlformats.org/drawingml/2006/main" prst="rect">
             <a:avLst/>
@@ -1296,116 +1448,99 @@
           <a:lstStyle xmlns:a="http://schemas.openxmlformats.org/drawingml/2006/main"/>
           <a:p xmlns:a="http://schemas.openxmlformats.org/drawingml/2006/main">
             <a:pPr algn="l">
-              <a:defRPr sz="2100" b="1">
-                <a:solidFill>
-                  <a:srgbClr val="FFFDF8"/>
-                </a:solidFill>
-              </a:defRPr>
-            </a:pPr>
-            <a:r>
-              <a:rPr sz="2100" b="1">
-                <a:solidFill>
-                  <a:srgbClr val="FFFDF8"/>
-                </a:solidFill>
-              </a:rPr>
-              <a:t>IntelliCrawl</a:t>
-            </a:r>
-          </a:p>
+              <a:defRPr sz="1275" b="1">
+                <a:solidFill>
+                  <a:srgbClr val="1C2430"/>
+                </a:solidFill>
+              </a:defRPr>
+            </a:pPr>
+            <a:r>
+              <a:rPr sz="1275" b="1">
+                <a:solidFill>
+                  <a:srgbClr val="1C2430"/>
+                </a:solidFill>
+              </a:rPr>
+              <a:t>Provider boundary</a:t>
+            </a:r>
+          </a:p>
+        </p:txBody>
+      </p:sp>
+      <p:sp>
+        <p:nvSpPr>
+          <p:cNvPr id="8" name="rail-copy">
+            <a:extLst xmlns:a="http://schemas.openxmlformats.org/drawingml/2006/main">
+              <a:ext uri="{FF2B5EF4-FFF2-40B4-BE49-F238E27FC236}">
+                <a16:creationId xmlns:a16="http://schemas.microsoft.com/office/drawing/2014/main" id="{8D921B38-CBE8-47B2-A52C-91CCA89B7631}"/>
+              </a:ext>
+            </a:extLst>
+          </p:cNvPr>
+          <p:cNvSpPr>
+            <a:spLocks xmlns:a="http://schemas.openxmlformats.org/drawingml/2006/main" noGrp="1"/>
+          </p:cNvSpPr>
+          <p:nvPr/>
+        </p:nvSpPr>
+        <p:spPr>
+          <a:xfrm xmlns:a="http://schemas.openxmlformats.org/drawingml/2006/main">
+            <a:off x="457200" y="1809750"/>
+            <a:ext cx="1619250" cy="457200"/>
+          </a:xfrm>
+          <a:prstGeom xmlns:a="http://schemas.openxmlformats.org/drawingml/2006/main" prst="rect">
+            <a:avLst/>
+          </a:prstGeom>
+          <a:noFill xmlns:a="http://schemas.openxmlformats.org/drawingml/2006/main"/>
+          <a:ln xmlns:a="http://schemas.openxmlformats.org/drawingml/2006/main" w="0">
+            <a:noFill/>
+            <a:prstDash val="solid"/>
+          </a:ln>
+        </p:spPr>
+        <p:txBody>
+          <a:bodyPr xmlns:a="http://schemas.openxmlformats.org/drawingml/2006/main"/>
+          <a:lstStyle xmlns:a="http://schemas.openxmlformats.org/drawingml/2006/main"/>
           <a:p xmlns:a="http://schemas.openxmlformats.org/drawingml/2006/main">
             <a:pPr algn="l">
-              <a:defRPr sz="2100" b="1">
-                <a:solidFill>
-                  <a:srgbClr val="FFFDF8"/>
-                </a:solidFill>
-              </a:defRPr>
-            </a:pPr>
-            <a:r>
-              <a:rPr sz="2100" b="1">
-                <a:solidFill>
-                  <a:srgbClr val="FFFDF8"/>
-                </a:solidFill>
-              </a:rPr>
-              <a:t>research graph</a:t>
-            </a:r>
-          </a:p>
-        </p:txBody>
-      </p:sp>
-      <p:sp>
-        <p:nvSpPr>
-          <p:cNvPr id="5" name="rail-copy">
-            <a:extLst xmlns:a="http://schemas.openxmlformats.org/drawingml/2006/main">
-              <a:ext uri="{FF2B5EF4-FFF2-40B4-BE49-F238E27FC236}">
-                <a16:creationId xmlns:a16="http://schemas.microsoft.com/office/drawing/2014/main" id="{38112ACD-72B8-4264-80A8-1CC87FF6BF35}"/>
-              </a:ext>
-            </a:extLst>
-          </p:cNvPr>
-          <p:cNvSpPr>
-            <a:spLocks xmlns:a="http://schemas.openxmlformats.org/drawingml/2006/main" noGrp="1"/>
-          </p:cNvSpPr>
-          <p:nvPr/>
-        </p:nvSpPr>
-        <p:spPr>
-          <a:xfrm xmlns:a="http://schemas.openxmlformats.org/drawingml/2006/main">
-            <a:off x="323850" y="1771650"/>
-            <a:ext cx="1752600" cy="666750"/>
-          </a:xfrm>
-          <a:prstGeom xmlns:a="http://schemas.openxmlformats.org/drawingml/2006/main" prst="rect">
-            <a:avLst/>
-          </a:prstGeom>
-          <a:noFill xmlns:a="http://schemas.openxmlformats.org/drawingml/2006/main"/>
-          <a:ln xmlns:a="http://schemas.openxmlformats.org/drawingml/2006/main" w="0">
-            <a:noFill/>
-            <a:prstDash val="solid"/>
-          </a:ln>
-        </p:spPr>
-        <p:txBody>
-          <a:bodyPr xmlns:a="http://schemas.openxmlformats.org/drawingml/2006/main"/>
-          <a:lstStyle xmlns:a="http://schemas.openxmlformats.org/drawingml/2006/main"/>
-          <a:p xmlns:a="http://schemas.openxmlformats.org/drawingml/2006/main">
-            <a:pPr algn="l">
-              <a:defRPr sz="975" b="0">
-                <a:solidFill>
-                  <a:srgbClr val="D8E3DE"/>
-                </a:solidFill>
-              </a:defRPr>
-            </a:pPr>
-            <a:r>
-              <a:rPr sz="975" b="0">
-                <a:solidFill>
-                  <a:srgbClr val="D8E3DE"/>
-                </a:solidFill>
-              </a:rPr>
-              <a:t>One LangGraph owns control flow. Providers can change without changing the graph.</a:t>
-            </a:r>
-          </a:p>
-        </p:txBody>
-      </p:sp>
-      <p:sp>
-        <p:nvSpPr>
-          <p:cNvPr id="6" name="rail-rule">
-            <a:extLst xmlns:a="http://schemas.openxmlformats.org/drawingml/2006/main">
-              <a:ext uri="{FF2B5EF4-FFF2-40B4-BE49-F238E27FC236}">
-                <a16:creationId xmlns:a16="http://schemas.microsoft.com/office/drawing/2014/main" id="{F79F303D-7DDF-4106-A76A-A2A84B4EF791}"/>
-              </a:ext>
-            </a:extLst>
-          </p:cNvPr>
-          <p:cNvSpPr>
-            <a:spLocks xmlns:a="http://schemas.openxmlformats.org/drawingml/2006/main" noGrp="1"/>
-          </p:cNvSpPr>
-          <p:nvPr/>
-        </p:nvSpPr>
-        <p:spPr>
-          <a:xfrm xmlns:a="http://schemas.openxmlformats.org/drawingml/2006/main">
-            <a:off x="323850" y="2667000"/>
-            <a:ext cx="1752600" cy="0"/>
+              <a:defRPr sz="863" b="0">
+                <a:solidFill>
+                  <a:srgbClr val="667085"/>
+                </a:solidFill>
+              </a:defRPr>
+            </a:pPr>
+            <a:r>
+              <a:rPr sz="863" b="0">
+                <a:solidFill>
+                  <a:srgbClr val="667085"/>
+                </a:solidFill>
+              </a:rPr>
+              <a:t>Implementations change; graph state and output contracts do not.</a:t>
+            </a:r>
+          </a:p>
+        </p:txBody>
+      </p:sp>
+      <p:sp>
+        <p:nvSpPr>
+          <p:cNvPr id="9" name="rail-rule">
+            <a:extLst xmlns:a="http://schemas.openxmlformats.org/drawingml/2006/main">
+              <a:ext uri="{FF2B5EF4-FFF2-40B4-BE49-F238E27FC236}">
+                <a16:creationId xmlns:a16="http://schemas.microsoft.com/office/drawing/2014/main" id="{EE228B12-C131-4475-BC71-044AFE89C49C}"/>
+              </a:ext>
+            </a:extLst>
+          </p:cNvPr>
+          <p:cNvSpPr>
+            <a:spLocks xmlns:a="http://schemas.openxmlformats.org/drawingml/2006/main" noGrp="1"/>
+          </p:cNvSpPr>
+          <p:nvPr/>
+        </p:nvSpPr>
+        <p:spPr>
+          <a:xfrm xmlns:a="http://schemas.openxmlformats.org/drawingml/2006/main">
+            <a:off x="457200" y="2381250"/>
+            <a:ext cx="1695450" cy="0"/>
           </a:xfrm>
           <a:prstGeom xmlns:a="http://schemas.openxmlformats.org/drawingml/2006/main" prst="line">
             <a:avLst/>
           </a:prstGeom>
           <a:noFill xmlns:a="http://schemas.openxmlformats.org/drawingml/2006/main"/>
-          <a:ln xmlns:a="http://schemas.openxmlformats.org/drawingml/2006/main" w="11430">
+          <a:ln xmlns:a="http://schemas.openxmlformats.org/drawingml/2006/main" w="10478">
             <a:solidFill>
-              <a:srgbClr val="648076"/>
+              <a:srgbClr val="C9CED6"/>
             </a:solidFill>
             <a:prstDash val="solid"/>
           </a:ln>
@@ -1413,22 +1548,22 @@
       </p:sp>
       <p:sp>
         <p:nvSpPr>
-          <p:cNvPr id="7" name="rail-assemblies">
-            <a:extLst xmlns:a="http://schemas.openxmlformats.org/drawingml/2006/main">
-              <a:ext uri="{FF2B5EF4-FFF2-40B4-BE49-F238E27FC236}">
-                <a16:creationId xmlns:a16="http://schemas.microsoft.com/office/drawing/2014/main" id="{AE3B9B4A-7DBF-4A5E-BB30-DCF12D888C04}"/>
-              </a:ext>
-            </a:extLst>
-          </p:cNvPr>
-          <p:cNvSpPr>
-            <a:spLocks xmlns:a="http://schemas.openxmlformats.org/drawingml/2006/main" noGrp="1"/>
-          </p:cNvSpPr>
-          <p:nvPr/>
-        </p:nvSpPr>
-        <p:spPr>
-          <a:xfrm xmlns:a="http://schemas.openxmlformats.org/drawingml/2006/main">
-            <a:off x="323850" y="2876550"/>
-            <a:ext cx="1714500" cy="171450"/>
+          <p:cNvPr id="10" name="rail-assemblies">
+            <a:extLst xmlns:a="http://schemas.openxmlformats.org/drawingml/2006/main">
+              <a:ext uri="{FF2B5EF4-FFF2-40B4-BE49-F238E27FC236}">
+                <a16:creationId xmlns:a16="http://schemas.microsoft.com/office/drawing/2014/main" id="{D76EB637-D768-4B45-8FF4-F67539F9427E}"/>
+              </a:ext>
+            </a:extLst>
+          </p:cNvPr>
+          <p:cNvSpPr>
+            <a:spLocks xmlns:a="http://schemas.openxmlformats.org/drawingml/2006/main" noGrp="1"/>
+          </p:cNvSpPr>
+          <p:nvPr/>
+        </p:nvSpPr>
+        <p:spPr>
+          <a:xfrm xmlns:a="http://schemas.openxmlformats.org/drawingml/2006/main">
+            <a:off x="457200" y="2562225"/>
+            <a:ext cx="1524000" cy="171450"/>
           </a:xfrm>
           <a:prstGeom xmlns:a="http://schemas.openxmlformats.org/drawingml/2006/main" prst="rect">
             <a:avLst/>
@@ -1446,39 +1581,39 @@
             <a:pPr algn="l">
               <a:defRPr sz="788" b="1">
                 <a:solidFill>
-                  <a:srgbClr val="AFC4BA"/>
+                  <a:srgbClr val="667085"/>
                 </a:solidFill>
               </a:defRPr>
             </a:pPr>
             <a:r>
               <a:rPr sz="788" b="1">
                 <a:solidFill>
-                  <a:srgbClr val="AFC4BA"/>
-                </a:solidFill>
-              </a:rPr>
-              <a:t>PROVIDER ASSEMBLIES</a:t>
-            </a:r>
-          </a:p>
-        </p:txBody>
-      </p:sp>
-      <p:sp>
-        <p:nvSpPr>
-          <p:cNvPr id="8" name="rail-demo">
-            <a:extLst xmlns:a="http://schemas.openxmlformats.org/drawingml/2006/main">
-              <a:ext uri="{FF2B5EF4-FFF2-40B4-BE49-F238E27FC236}">
-                <a16:creationId xmlns:a16="http://schemas.microsoft.com/office/drawing/2014/main" id="{3908851B-0D92-47F5-B0B3-1AFA92FC067E}"/>
-              </a:ext>
-            </a:extLst>
-          </p:cNvPr>
-          <p:cNvSpPr>
-            <a:spLocks xmlns:a="http://schemas.openxmlformats.org/drawingml/2006/main" noGrp="1"/>
-          </p:cNvSpPr>
-          <p:nvPr/>
-        </p:nvSpPr>
-        <p:spPr>
-          <a:xfrm xmlns:a="http://schemas.openxmlformats.org/drawingml/2006/main">
-            <a:off x="323850" y="3209925"/>
-            <a:ext cx="495300" cy="171450"/>
+                  <a:srgbClr val="667085"/>
+                </a:solidFill>
+              </a:rPr>
+              <a:t>ASSEMBLIES</a:t>
+            </a:r>
+          </a:p>
+        </p:txBody>
+      </p:sp>
+      <p:sp>
+        <p:nvSpPr>
+          <p:cNvPr id="11" name="rail-demo">
+            <a:extLst xmlns:a="http://schemas.openxmlformats.org/drawingml/2006/main">
+              <a:ext uri="{FF2B5EF4-FFF2-40B4-BE49-F238E27FC236}">
+                <a16:creationId xmlns:a16="http://schemas.microsoft.com/office/drawing/2014/main" id="{7CA8C776-1360-42DC-A040-071312AE2C3C}"/>
+              </a:ext>
+            </a:extLst>
+          </p:cNvPr>
+          <p:cNvSpPr>
+            <a:spLocks xmlns:a="http://schemas.openxmlformats.org/drawingml/2006/main" noGrp="1"/>
+          </p:cNvSpPr>
+          <p:nvPr/>
+        </p:nvSpPr>
+        <p:spPr>
+          <a:xfrm xmlns:a="http://schemas.openxmlformats.org/drawingml/2006/main">
+            <a:off x="457200" y="2867025"/>
+            <a:ext cx="590550" cy="171450"/>
           </a:xfrm>
           <a:prstGeom xmlns:a="http://schemas.openxmlformats.org/drawingml/2006/main" prst="rect">
             <a:avLst/>
@@ -1494,16 +1629,16 @@
           <a:lstStyle xmlns:a="http://schemas.openxmlformats.org/drawingml/2006/main"/>
           <a:p xmlns:a="http://schemas.openxmlformats.org/drawingml/2006/main">
             <a:pPr algn="l">
-              <a:defRPr sz="750" b="1">
-                <a:solidFill>
-                  <a:srgbClr val="A9D1AE"/>
-                </a:solidFill>
-              </a:defRPr>
-            </a:pPr>
-            <a:r>
-              <a:rPr sz="750" b="1">
-                <a:solidFill>
-                  <a:srgbClr val="A9D1AE"/>
+              <a:defRPr sz="713" b="1">
+                <a:solidFill>
+                  <a:srgbClr val="397EA5"/>
+                </a:solidFill>
+              </a:defRPr>
+            </a:pPr>
+            <a:r>
+              <a:rPr sz="713" b="1">
+                <a:solidFill>
+                  <a:srgbClr val="397EA5"/>
                 </a:solidFill>
               </a:rPr>
               <a:t>DEMO</a:t>
@@ -1513,22 +1648,22 @@
       </p:sp>
       <p:sp>
         <p:nvSpPr>
-          <p:cNvPr id="9" name="rail-demo-copy">
-            <a:extLst xmlns:a="http://schemas.openxmlformats.org/drawingml/2006/main">
-              <a:ext uri="{FF2B5EF4-FFF2-40B4-BE49-F238E27FC236}">
-                <a16:creationId xmlns:a16="http://schemas.microsoft.com/office/drawing/2014/main" id="{86CD9237-FDFA-4E34-AAEC-7CC66CDB6EB7}"/>
-              </a:ext>
-            </a:extLst>
-          </p:cNvPr>
-          <p:cNvSpPr>
-            <a:spLocks xmlns:a="http://schemas.openxmlformats.org/drawingml/2006/main" noGrp="1"/>
-          </p:cNvSpPr>
-          <p:nvPr/>
-        </p:nvSpPr>
-        <p:spPr>
-          <a:xfrm xmlns:a="http://schemas.openxmlformats.org/drawingml/2006/main">
-            <a:off x="857250" y="3181350"/>
-            <a:ext cx="1219200" cy="400050"/>
+          <p:cNvPr id="12" name="rail-demo-copy">
+            <a:extLst xmlns:a="http://schemas.openxmlformats.org/drawingml/2006/main">
+              <a:ext uri="{FF2B5EF4-FFF2-40B4-BE49-F238E27FC236}">
+                <a16:creationId xmlns:a16="http://schemas.microsoft.com/office/drawing/2014/main" id="{7627E05E-177B-4727-B5D4-87A2D6B11C71}"/>
+              </a:ext>
+            </a:extLst>
+          </p:cNvPr>
+          <p:cNvSpPr>
+            <a:spLocks xmlns:a="http://schemas.openxmlformats.org/drawingml/2006/main" noGrp="1"/>
+          </p:cNvSpPr>
+          <p:nvPr/>
+        </p:nvSpPr>
+        <p:spPr>
+          <a:xfrm xmlns:a="http://schemas.openxmlformats.org/drawingml/2006/main">
+            <a:off x="1066800" y="2838450"/>
+            <a:ext cx="1028700" cy="400050"/>
           </a:xfrm>
           <a:prstGeom xmlns:a="http://schemas.openxmlformats.org/drawingml/2006/main" prst="rect">
             <a:avLst/>
@@ -1544,16 +1679,16 @@
           <a:lstStyle xmlns:a="http://schemas.openxmlformats.org/drawingml/2006/main"/>
           <a:p xmlns:a="http://schemas.openxmlformats.org/drawingml/2006/main">
             <a:pPr algn="l">
-              <a:defRPr sz="863" b="0">
-                <a:solidFill>
-                  <a:srgbClr val="FFFDF8"/>
-                </a:solidFill>
-              </a:defRPr>
-            </a:pPr>
-            <a:r>
-              <a:rPr sz="863" b="0">
-                <a:solidFill>
-                  <a:srgbClr val="FFFDF8"/>
+              <a:defRPr sz="788" b="0">
+                <a:solidFill>
+                  <a:srgbClr val="1C2430"/>
+                </a:solidFill>
+              </a:defRPr>
+            </a:pPr>
+            <a:r>
+              <a:rPr sz="788" b="0">
+                <a:solidFill>
+                  <a:srgbClr val="1C2430"/>
                 </a:solidFill>
               </a:rPr>
               <a:t>deterministic search</a:t>
@@ -1561,16 +1696,16 @@
           </a:p>
           <a:p xmlns:a="http://schemas.openxmlformats.org/drawingml/2006/main">
             <a:pPr algn="l">
-              <a:defRPr sz="863" b="0">
-                <a:solidFill>
-                  <a:srgbClr val="FFFDF8"/>
-                </a:solidFill>
-              </a:defRPr>
-            </a:pPr>
-            <a:r>
-              <a:rPr sz="863" b="0">
-                <a:solidFill>
-                  <a:srgbClr val="FFFDF8"/>
+              <a:defRPr sz="788" b="0">
+                <a:solidFill>
+                  <a:srgbClr val="1C2430"/>
+                </a:solidFill>
+              </a:defRPr>
+            </a:pPr>
+            <a:r>
+              <a:rPr sz="788" b="0">
+                <a:solidFill>
+                  <a:srgbClr val="1C2430"/>
                 </a:solidFill>
               </a:rPr>
               <a:t>+ analysis fixtures</a:t>
@@ -1580,22 +1715,22 @@
       </p:sp>
       <p:sp>
         <p:nvSpPr>
-          <p:cNvPr id="10" name="rail-live">
-            <a:extLst xmlns:a="http://schemas.openxmlformats.org/drawingml/2006/main">
-              <a:ext uri="{FF2B5EF4-FFF2-40B4-BE49-F238E27FC236}">
-                <a16:creationId xmlns:a16="http://schemas.microsoft.com/office/drawing/2014/main" id="{4BA49A36-3210-4CB8-8BA4-CEE9B4E86AE6}"/>
-              </a:ext>
-            </a:extLst>
-          </p:cNvPr>
-          <p:cNvSpPr>
-            <a:spLocks xmlns:a="http://schemas.openxmlformats.org/drawingml/2006/main" noGrp="1"/>
-          </p:cNvSpPr>
-          <p:nvPr/>
-        </p:nvSpPr>
-        <p:spPr>
-          <a:xfrm xmlns:a="http://schemas.openxmlformats.org/drawingml/2006/main">
-            <a:off x="323850" y="3781425"/>
-            <a:ext cx="495300" cy="171450"/>
+          <p:cNvPr id="13" name="rail-live">
+            <a:extLst xmlns:a="http://schemas.openxmlformats.org/drawingml/2006/main">
+              <a:ext uri="{FF2B5EF4-FFF2-40B4-BE49-F238E27FC236}">
+                <a16:creationId xmlns:a16="http://schemas.microsoft.com/office/drawing/2014/main" id="{5A247251-BABD-4140-86BF-963BFA63E849}"/>
+              </a:ext>
+            </a:extLst>
+          </p:cNvPr>
+          <p:cNvSpPr>
+            <a:spLocks xmlns:a="http://schemas.openxmlformats.org/drawingml/2006/main" noGrp="1"/>
+          </p:cNvSpPr>
+          <p:nvPr/>
+        </p:nvSpPr>
+        <p:spPr>
+          <a:xfrm xmlns:a="http://schemas.openxmlformats.org/drawingml/2006/main">
+            <a:off x="457200" y="3362325"/>
+            <a:ext cx="590550" cy="171450"/>
           </a:xfrm>
           <a:prstGeom xmlns:a="http://schemas.openxmlformats.org/drawingml/2006/main" prst="rect">
             <a:avLst/>
@@ -1611,16 +1746,16 @@
           <a:lstStyle xmlns:a="http://schemas.openxmlformats.org/drawingml/2006/main"/>
           <a:p xmlns:a="http://schemas.openxmlformats.org/drawingml/2006/main">
             <a:pPr algn="l">
-              <a:defRPr sz="750" b="1">
-                <a:solidFill>
-                  <a:srgbClr val="F2A077"/>
-                </a:solidFill>
-              </a:defRPr>
-            </a:pPr>
-            <a:r>
-              <a:rPr sz="750" b="1">
-                <a:solidFill>
-                  <a:srgbClr val="F2A077"/>
+              <a:defRPr sz="713" b="1">
+                <a:solidFill>
+                  <a:srgbClr val="D05A2A"/>
+                </a:solidFill>
+              </a:defRPr>
+            </a:pPr>
+            <a:r>
+              <a:rPr sz="713" b="1">
+                <a:solidFill>
+                  <a:srgbClr val="D05A2A"/>
                 </a:solidFill>
               </a:rPr>
               <a:t>LIVE</a:t>
@@ -1630,22 +1765,22 @@
       </p:sp>
       <p:sp>
         <p:nvSpPr>
-          <p:cNvPr id="11" name="rail-live-copy">
-            <a:extLst xmlns:a="http://schemas.openxmlformats.org/drawingml/2006/main">
-              <a:ext uri="{FF2B5EF4-FFF2-40B4-BE49-F238E27FC236}">
-                <a16:creationId xmlns:a16="http://schemas.microsoft.com/office/drawing/2014/main" id="{B7D02D0B-8269-4040-B667-08DF05F48D63}"/>
-              </a:ext>
-            </a:extLst>
-          </p:cNvPr>
-          <p:cNvSpPr>
-            <a:spLocks xmlns:a="http://schemas.openxmlformats.org/drawingml/2006/main" noGrp="1"/>
-          </p:cNvSpPr>
-          <p:nvPr/>
-        </p:nvSpPr>
-        <p:spPr>
-          <a:xfrm xmlns:a="http://schemas.openxmlformats.org/drawingml/2006/main">
-            <a:off x="857250" y="3752850"/>
-            <a:ext cx="1257300" cy="400050"/>
+          <p:cNvPr id="14" name="rail-live-copy">
+            <a:extLst xmlns:a="http://schemas.openxmlformats.org/drawingml/2006/main">
+              <a:ext uri="{FF2B5EF4-FFF2-40B4-BE49-F238E27FC236}">
+                <a16:creationId xmlns:a16="http://schemas.microsoft.com/office/drawing/2014/main" id="{8794E44B-F769-4303-B3ED-5733DD521C4A}"/>
+              </a:ext>
+            </a:extLst>
+          </p:cNvPr>
+          <p:cNvSpPr>
+            <a:spLocks xmlns:a="http://schemas.openxmlformats.org/drawingml/2006/main" noGrp="1"/>
+          </p:cNvSpPr>
+          <p:nvPr/>
+        </p:nvSpPr>
+        <p:spPr>
+          <a:xfrm xmlns:a="http://schemas.openxmlformats.org/drawingml/2006/main">
+            <a:off x="1066800" y="3333750"/>
+            <a:ext cx="1028700" cy="400050"/>
           </a:xfrm>
           <a:prstGeom xmlns:a="http://schemas.openxmlformats.org/drawingml/2006/main" prst="rect">
             <a:avLst/>
@@ -1661,16 +1796,16 @@
           <a:lstStyle xmlns:a="http://schemas.openxmlformats.org/drawingml/2006/main"/>
           <a:p xmlns:a="http://schemas.openxmlformats.org/drawingml/2006/main">
             <a:pPr algn="l">
-              <a:defRPr sz="863" b="0">
-                <a:solidFill>
-                  <a:srgbClr val="FFFDF8"/>
-                </a:solidFill>
-              </a:defRPr>
-            </a:pPr>
-            <a:r>
-              <a:rPr sz="863" b="0">
-                <a:solidFill>
-                  <a:srgbClr val="FFFDF8"/>
+              <a:defRPr sz="788" b="0">
+                <a:solidFill>
+                  <a:srgbClr val="1C2430"/>
+                </a:solidFill>
+              </a:defRPr>
+            </a:pPr>
+            <a:r>
+              <a:rPr sz="788" b="0">
+                <a:solidFill>
+                  <a:srgbClr val="1C2430"/>
                 </a:solidFill>
               </a:rPr>
               <a:t>Firecrawl + cache</a:t>
@@ -1678,16 +1813,16 @@
           </a:p>
           <a:p xmlns:a="http://schemas.openxmlformats.org/drawingml/2006/main">
             <a:pPr algn="l">
-              <a:defRPr sz="863" b="0">
-                <a:solidFill>
-                  <a:srgbClr val="FFFDF8"/>
-                </a:solidFill>
-              </a:defRPr>
-            </a:pPr>
-            <a:r>
-              <a:rPr sz="863" b="0">
-                <a:solidFill>
-                  <a:srgbClr val="FFFDF8"/>
+              <a:defRPr sz="788" b="0">
+                <a:solidFill>
+                  <a:srgbClr val="1C2430"/>
+                </a:solidFill>
+              </a:defRPr>
+            </a:pPr>
+            <a:r>
+              <a:rPr sz="788" b="0">
+                <a:solidFill>
+                  <a:srgbClr val="1C2430"/>
                 </a:solidFill>
               </a:rPr>
               <a:t>OpenAI structured output</a:t>
@@ -1697,30 +1832,30 @@
       </p:sp>
       <p:sp>
         <p:nvSpPr>
-          <p:cNvPr id="12" name="rail-rule-2">
-            <a:extLst xmlns:a="http://schemas.openxmlformats.org/drawingml/2006/main">
-              <a:ext uri="{FF2B5EF4-FFF2-40B4-BE49-F238E27FC236}">
-                <a16:creationId xmlns:a16="http://schemas.microsoft.com/office/drawing/2014/main" id="{8B58D728-569A-4CB2-B6AA-41E573331F76}"/>
-              </a:ext>
-            </a:extLst>
-          </p:cNvPr>
-          <p:cNvSpPr>
-            <a:spLocks xmlns:a="http://schemas.openxmlformats.org/drawingml/2006/main" noGrp="1"/>
-          </p:cNvSpPr>
-          <p:nvPr/>
-        </p:nvSpPr>
-        <p:spPr>
-          <a:xfrm xmlns:a="http://schemas.openxmlformats.org/drawingml/2006/main">
-            <a:off x="323850" y="4400550"/>
-            <a:ext cx="1752600" cy="0"/>
+          <p:cNvPr id="15" name="rail-rule-2">
+            <a:extLst xmlns:a="http://schemas.openxmlformats.org/drawingml/2006/main">
+              <a:ext uri="{FF2B5EF4-FFF2-40B4-BE49-F238E27FC236}">
+                <a16:creationId xmlns:a16="http://schemas.microsoft.com/office/drawing/2014/main" id="{A21B816F-F9FF-4383-81E8-9DA960970A64}"/>
+              </a:ext>
+            </a:extLst>
+          </p:cNvPr>
+          <p:cNvSpPr>
+            <a:spLocks xmlns:a="http://schemas.openxmlformats.org/drawingml/2006/main" noGrp="1"/>
+          </p:cNvSpPr>
+          <p:nvPr/>
+        </p:nvSpPr>
+        <p:spPr>
+          <a:xfrm xmlns:a="http://schemas.openxmlformats.org/drawingml/2006/main">
+            <a:off x="457200" y="3905250"/>
+            <a:ext cx="1695450" cy="0"/>
           </a:xfrm>
           <a:prstGeom xmlns:a="http://schemas.openxmlformats.org/drawingml/2006/main" prst="line">
             <a:avLst/>
           </a:prstGeom>
           <a:noFill xmlns:a="http://schemas.openxmlformats.org/drawingml/2006/main"/>
-          <a:ln xmlns:a="http://schemas.openxmlformats.org/drawingml/2006/main" w="11430">
+          <a:ln xmlns:a="http://schemas.openxmlformats.org/drawingml/2006/main" w="10478">
             <a:solidFill>
-              <a:srgbClr val="648076"/>
+              <a:srgbClr val="C9CED6"/>
             </a:solidFill>
             <a:prstDash val="solid"/>
           </a:ln>
@@ -1728,22 +1863,22 @@
       </p:sp>
       <p:sp>
         <p:nvSpPr>
-          <p:cNvPr id="13" name="rail-interfaces">
-            <a:extLst xmlns:a="http://schemas.openxmlformats.org/drawingml/2006/main">
-              <a:ext uri="{FF2B5EF4-FFF2-40B4-BE49-F238E27FC236}">
-                <a16:creationId xmlns:a16="http://schemas.microsoft.com/office/drawing/2014/main" id="{27D4F76E-4D48-4BAC-B874-7C048EF6A4E4}"/>
-              </a:ext>
-            </a:extLst>
-          </p:cNvPr>
-          <p:cNvSpPr>
-            <a:spLocks xmlns:a="http://schemas.openxmlformats.org/drawingml/2006/main" noGrp="1"/>
-          </p:cNvSpPr>
-          <p:nvPr/>
-        </p:nvSpPr>
-        <p:spPr>
-          <a:xfrm xmlns:a="http://schemas.openxmlformats.org/drawingml/2006/main">
-            <a:off x="323850" y="4610100"/>
-            <a:ext cx="1714500" cy="171450"/>
+          <p:cNvPr id="16" name="rail-interfaces">
+            <a:extLst xmlns:a="http://schemas.openxmlformats.org/drawingml/2006/main">
+              <a:ext uri="{FF2B5EF4-FFF2-40B4-BE49-F238E27FC236}">
+                <a16:creationId xmlns:a16="http://schemas.microsoft.com/office/drawing/2014/main" id="{B76102D5-E951-4309-AABD-A2EEFC0266D6}"/>
+              </a:ext>
+            </a:extLst>
+          </p:cNvPr>
+          <p:cNvSpPr>
+            <a:spLocks xmlns:a="http://schemas.openxmlformats.org/drawingml/2006/main" noGrp="1"/>
+          </p:cNvSpPr>
+          <p:nvPr/>
+        </p:nvSpPr>
+        <p:spPr>
+          <a:xfrm xmlns:a="http://schemas.openxmlformats.org/drawingml/2006/main">
+            <a:off x="457200" y="4076700"/>
+            <a:ext cx="1524000" cy="171450"/>
           </a:xfrm>
           <a:prstGeom xmlns:a="http://schemas.openxmlformats.org/drawingml/2006/main" prst="rect">
             <a:avLst/>
@@ -1761,39 +1896,39 @@
             <a:pPr algn="l">
               <a:defRPr sz="788" b="1">
                 <a:solidFill>
-                  <a:srgbClr val="AFC4BA"/>
+                  <a:srgbClr val="667085"/>
                 </a:solidFill>
               </a:defRPr>
             </a:pPr>
             <a:r>
               <a:rPr sz="788" b="1">
                 <a:solidFill>
-                  <a:srgbClr val="AFC4BA"/>
-                </a:solidFill>
-              </a:rPr>
-              <a:t>REPLACEABLE PORTS</a:t>
-            </a:r>
-          </a:p>
-        </p:txBody>
-      </p:sp>
-      <p:sp>
-        <p:nvSpPr>
-          <p:cNvPr id="14" name="rail-search">
-            <a:extLst xmlns:a="http://schemas.openxmlformats.org/drawingml/2006/main">
-              <a:ext uri="{FF2B5EF4-FFF2-40B4-BE49-F238E27FC236}">
-                <a16:creationId xmlns:a16="http://schemas.microsoft.com/office/drawing/2014/main" id="{54AF017C-6C0B-4BAF-B259-91827C051EC4}"/>
-              </a:ext>
-            </a:extLst>
-          </p:cNvPr>
-          <p:cNvSpPr>
-            <a:spLocks xmlns:a="http://schemas.openxmlformats.org/drawingml/2006/main" noGrp="1"/>
-          </p:cNvSpPr>
-          <p:nvPr/>
-        </p:nvSpPr>
-        <p:spPr>
-          <a:xfrm xmlns:a="http://schemas.openxmlformats.org/drawingml/2006/main">
-            <a:off x="323850" y="4953000"/>
-            <a:ext cx="1428750" cy="190500"/>
+                  <a:srgbClr val="667085"/>
+                </a:solidFill>
+              </a:rPr>
+              <a:t>PORTS</a:t>
+            </a:r>
+          </a:p>
+        </p:txBody>
+      </p:sp>
+      <p:sp>
+        <p:nvSpPr>
+          <p:cNvPr id="17" name="rail-search">
+            <a:extLst xmlns:a="http://schemas.openxmlformats.org/drawingml/2006/main">
+              <a:ext uri="{FF2B5EF4-FFF2-40B4-BE49-F238E27FC236}">
+                <a16:creationId xmlns:a16="http://schemas.microsoft.com/office/drawing/2014/main" id="{5B0301BC-3ADD-4ECC-AFE4-EF7D47879DB7}"/>
+              </a:ext>
+            </a:extLst>
+          </p:cNvPr>
+          <p:cNvSpPr>
+            <a:spLocks xmlns:a="http://schemas.openxmlformats.org/drawingml/2006/main" noGrp="1"/>
+          </p:cNvSpPr>
+          <p:nvPr/>
+        </p:nvSpPr>
+        <p:spPr>
+          <a:xfrm xmlns:a="http://schemas.openxmlformats.org/drawingml/2006/main">
+            <a:off x="457200" y="4333875"/>
+            <a:ext cx="1466850" cy="190500"/>
           </a:xfrm>
           <a:prstGeom xmlns:a="http://schemas.openxmlformats.org/drawingml/2006/main" prst="rect">
             <a:avLst/>
@@ -1809,16 +1944,16 @@
           <a:lstStyle xmlns:a="http://schemas.openxmlformats.org/drawingml/2006/main"/>
           <a:p xmlns:a="http://schemas.openxmlformats.org/drawingml/2006/main">
             <a:pPr algn="l">
-              <a:defRPr sz="900" b="1">
-                <a:solidFill>
-                  <a:srgbClr val="FFFDF8"/>
-                </a:solidFill>
-              </a:defRPr>
-            </a:pPr>
-            <a:r>
-              <a:rPr sz="900" b="1">
-                <a:solidFill>
-                  <a:srgbClr val="FFFDF8"/>
+              <a:defRPr sz="863" b="1">
+                <a:solidFill>
+                  <a:srgbClr val="1C2430"/>
+                </a:solidFill>
+              </a:defRPr>
+            </a:pPr>
+            <a:r>
+              <a:rPr sz="863" b="1">
+                <a:solidFill>
+                  <a:srgbClr val="1C2430"/>
                 </a:solidFill>
               </a:rPr>
               <a:t>SearchProvider</a:t>
@@ -1828,172 +1963,22 @@
       </p:sp>
       <p:sp>
         <p:nvSpPr>
-          <p:cNvPr id="15" name="rail-source">
-            <a:extLst xmlns:a="http://schemas.openxmlformats.org/drawingml/2006/main">
-              <a:ext uri="{FF2B5EF4-FFF2-40B4-BE49-F238E27FC236}">
-                <a16:creationId xmlns:a16="http://schemas.microsoft.com/office/drawing/2014/main" id="{CDAC75F6-D20A-4F36-AE85-5AE53143CE22}"/>
-              </a:ext>
-            </a:extLst>
-          </p:cNvPr>
-          <p:cNvSpPr>
-            <a:spLocks xmlns:a="http://schemas.openxmlformats.org/drawingml/2006/main" noGrp="1"/>
-          </p:cNvSpPr>
-          <p:nvPr/>
-        </p:nvSpPr>
-        <p:spPr>
-          <a:xfrm xmlns:a="http://schemas.openxmlformats.org/drawingml/2006/main">
-            <a:off x="323850" y="5191125"/>
+          <p:cNvPr id="18" name="rail-source">
+            <a:extLst xmlns:a="http://schemas.openxmlformats.org/drawingml/2006/main">
+              <a:ext uri="{FF2B5EF4-FFF2-40B4-BE49-F238E27FC236}">
+                <a16:creationId xmlns:a16="http://schemas.microsoft.com/office/drawing/2014/main" id="{8CCA0B5F-74B0-41E5-B8B0-96929CD57D95}"/>
+              </a:ext>
+            </a:extLst>
+          </p:cNvPr>
+          <p:cNvSpPr>
+            <a:spLocks xmlns:a="http://schemas.openxmlformats.org/drawingml/2006/main" noGrp="1"/>
+          </p:cNvSpPr>
+          <p:nvPr/>
+        </p:nvSpPr>
+        <p:spPr>
+          <a:xfrm xmlns:a="http://schemas.openxmlformats.org/drawingml/2006/main">
+            <a:off x="457200" y="4572000"/>
             <a:ext cx="1524000" cy="171450"/>
-          </a:xfrm>
-          <a:prstGeom xmlns:a="http://schemas.openxmlformats.org/drawingml/2006/main" prst="rect">
-            <a:avLst/>
-          </a:prstGeom>
-          <a:noFill xmlns:a="http://schemas.openxmlformats.org/drawingml/2006/main"/>
-          <a:ln xmlns:a="http://schemas.openxmlformats.org/drawingml/2006/main" w="0">
-            <a:noFill/>
-            <a:prstDash val="solid"/>
-          </a:ln>
-        </p:spPr>
-        <p:txBody>
-          <a:bodyPr xmlns:a="http://schemas.openxmlformats.org/drawingml/2006/main"/>
-          <a:lstStyle xmlns:a="http://schemas.openxmlformats.org/drawingml/2006/main"/>
-          <a:p xmlns:a="http://schemas.openxmlformats.org/drawingml/2006/main">
-            <a:pPr algn="l">
-              <a:defRPr sz="750" b="0">
-                <a:solidFill>
-                  <a:srgbClr val="C8D8D0"/>
-                </a:solidFill>
-              </a:defRPr>
-            </a:pPr>
-            <a:r>
-              <a:rPr sz="750" b="0">
-                <a:solidFill>
-                  <a:srgbClr val="C8D8D0"/>
-                </a:solidFill>
-              </a:rPr>
-              <a:t>→ SourceDocument[]</a:t>
-            </a:r>
-          </a:p>
-        </p:txBody>
-      </p:sp>
-      <p:sp>
-        <p:nvSpPr>
-          <p:cNvPr id="16" name="rail-analysis">
-            <a:extLst xmlns:a="http://schemas.openxmlformats.org/drawingml/2006/main">
-              <a:ext uri="{FF2B5EF4-FFF2-40B4-BE49-F238E27FC236}">
-                <a16:creationId xmlns:a16="http://schemas.microsoft.com/office/drawing/2014/main" id="{EC269638-9C3A-4A84-B6D4-0E54159DEE9F}"/>
-              </a:ext>
-            </a:extLst>
-          </p:cNvPr>
-          <p:cNvSpPr>
-            <a:spLocks xmlns:a="http://schemas.openxmlformats.org/drawingml/2006/main" noGrp="1"/>
-          </p:cNvSpPr>
-          <p:nvPr/>
-        </p:nvSpPr>
-        <p:spPr>
-          <a:xfrm xmlns:a="http://schemas.openxmlformats.org/drawingml/2006/main">
-            <a:off x="323850" y="5505450"/>
-            <a:ext cx="1524000" cy="190500"/>
-          </a:xfrm>
-          <a:prstGeom xmlns:a="http://schemas.openxmlformats.org/drawingml/2006/main" prst="rect">
-            <a:avLst/>
-          </a:prstGeom>
-          <a:noFill xmlns:a="http://schemas.openxmlformats.org/drawingml/2006/main"/>
-          <a:ln xmlns:a="http://schemas.openxmlformats.org/drawingml/2006/main" w="0">
-            <a:noFill/>
-            <a:prstDash val="solid"/>
-          </a:ln>
-        </p:spPr>
-        <p:txBody>
-          <a:bodyPr xmlns:a="http://schemas.openxmlformats.org/drawingml/2006/main"/>
-          <a:lstStyle xmlns:a="http://schemas.openxmlformats.org/drawingml/2006/main"/>
-          <a:p xmlns:a="http://schemas.openxmlformats.org/drawingml/2006/main">
-            <a:pPr algn="l">
-              <a:defRPr sz="900" b="1">
-                <a:solidFill>
-                  <a:srgbClr val="FFFDF8"/>
-                </a:solidFill>
-              </a:defRPr>
-            </a:pPr>
-            <a:r>
-              <a:rPr sz="900" b="1">
-                <a:solidFill>
-                  <a:srgbClr val="FFFDF8"/>
-                </a:solidFill>
-              </a:rPr>
-              <a:t>AnalysisProvider</a:t>
-            </a:r>
-          </a:p>
-        </p:txBody>
-      </p:sp>
-      <p:sp>
-        <p:nvSpPr>
-          <p:cNvPr id="17" name="rail-schema">
-            <a:extLst xmlns:a="http://schemas.openxmlformats.org/drawingml/2006/main">
-              <a:ext uri="{FF2B5EF4-FFF2-40B4-BE49-F238E27FC236}">
-                <a16:creationId xmlns:a16="http://schemas.microsoft.com/office/drawing/2014/main" id="{BD0CEC5F-9192-4358-980A-ED796389D075}"/>
-              </a:ext>
-            </a:extLst>
-          </p:cNvPr>
-          <p:cNvSpPr>
-            <a:spLocks xmlns:a="http://schemas.openxmlformats.org/drawingml/2006/main" noGrp="1"/>
-          </p:cNvSpPr>
-          <p:nvPr/>
-        </p:nvSpPr>
-        <p:spPr>
-          <a:xfrm xmlns:a="http://schemas.openxmlformats.org/drawingml/2006/main">
-            <a:off x="323850" y="5743575"/>
-            <a:ext cx="1428750" cy="171450"/>
-          </a:xfrm>
-          <a:prstGeom xmlns:a="http://schemas.openxmlformats.org/drawingml/2006/main" prst="rect">
-            <a:avLst/>
-          </a:prstGeom>
-          <a:noFill xmlns:a="http://schemas.openxmlformats.org/drawingml/2006/main"/>
-          <a:ln xmlns:a="http://schemas.openxmlformats.org/drawingml/2006/main" w="0">
-            <a:noFill/>
-            <a:prstDash val="solid"/>
-          </a:ln>
-        </p:spPr>
-        <p:txBody>
-          <a:bodyPr xmlns:a="http://schemas.openxmlformats.org/drawingml/2006/main"/>
-          <a:lstStyle xmlns:a="http://schemas.openxmlformats.org/drawingml/2006/main"/>
-          <a:p xmlns:a="http://schemas.openxmlformats.org/drawingml/2006/main">
-            <a:pPr algn="l">
-              <a:defRPr sz="750" b="0">
-                <a:solidFill>
-                  <a:srgbClr val="C8D8D0"/>
-                </a:solidFill>
-              </a:defRPr>
-            </a:pPr>
-            <a:r>
-              <a:rPr sz="750" b="0">
-                <a:solidFill>
-                  <a:srgbClr val="C8D8D0"/>
-                </a:solidFill>
-              </a:rPr>
-              <a:t>→ typed schemas</a:t>
-            </a:r>
-          </a:p>
-        </p:txBody>
-      </p:sp>
-      <p:sp>
-        <p:nvSpPr>
-          <p:cNvPr id="18" name="rail-foot">
-            <a:extLst xmlns:a="http://schemas.openxmlformats.org/drawingml/2006/main">
-              <a:ext uri="{FF2B5EF4-FFF2-40B4-BE49-F238E27FC236}">
-                <a16:creationId xmlns:a16="http://schemas.microsoft.com/office/drawing/2014/main" id="{27EA839D-E1AA-483C-BD10-9B32EA6E0635}"/>
-              </a:ext>
-            </a:extLst>
-          </p:cNvPr>
-          <p:cNvSpPr>
-            <a:spLocks xmlns:a="http://schemas.openxmlformats.org/drawingml/2006/main" noGrp="1"/>
-          </p:cNvSpPr>
-          <p:nvPr/>
-        </p:nvSpPr>
-        <p:spPr>
-          <a:xfrm xmlns:a="http://schemas.openxmlformats.org/drawingml/2006/main">
-            <a:off x="323850" y="6381750"/>
-            <a:ext cx="1752600" cy="266700"/>
           </a:xfrm>
           <a:prstGeom xmlns:a="http://schemas.openxmlformats.org/drawingml/2006/main" prst="rect">
             <a:avLst/>
@@ -2011,27 +1996,177 @@
             <a:pPr algn="l">
               <a:defRPr sz="713" b="0">
                 <a:solidFill>
-                  <a:srgbClr val="9FB5AA"/>
+                  <a:srgbClr val="397EA5"/>
                 </a:solidFill>
               </a:defRPr>
             </a:pPr>
             <a:r>
               <a:rPr sz="713" b="0">
                 <a:solidFill>
-                  <a:srgbClr val="9FB5AA"/>
-                </a:solidFill>
-              </a:rPr>
-              <a:t>Public web content remains untrusted input.</a:t>
-            </a:r>
-          </a:p>
-        </p:txBody>
-      </p:sp>
-      <p:sp>
-        <p:nvSpPr>
-          <p:cNvPr id="19" name="discover-research">
-            <a:extLst xmlns:a="http://schemas.openxmlformats.org/drawingml/2006/main">
-              <a:ext uri="{FF2B5EF4-FFF2-40B4-BE49-F238E27FC236}">
-                <a16:creationId xmlns:a16="http://schemas.microsoft.com/office/drawing/2014/main" id="{D704B8A2-C8A9-4FE3-ADBC-AF115A7FE2E4}"/>
+                  <a:srgbClr val="397EA5"/>
+                </a:solidFill>
+              </a:rPr>
+              <a:t>→ SourceDocument[]</a:t>
+            </a:r>
+          </a:p>
+        </p:txBody>
+      </p:sp>
+      <p:sp>
+        <p:nvSpPr>
+          <p:cNvPr id="19" name="rail-analysis">
+            <a:extLst xmlns:a="http://schemas.openxmlformats.org/drawingml/2006/main">
+              <a:ext uri="{FF2B5EF4-FFF2-40B4-BE49-F238E27FC236}">
+                <a16:creationId xmlns:a16="http://schemas.microsoft.com/office/drawing/2014/main" id="{A943B109-BE4D-414A-8719-03A845967AE6}"/>
+              </a:ext>
+            </a:extLst>
+          </p:cNvPr>
+          <p:cNvSpPr>
+            <a:spLocks xmlns:a="http://schemas.openxmlformats.org/drawingml/2006/main" noGrp="1"/>
+          </p:cNvSpPr>
+          <p:nvPr/>
+        </p:nvSpPr>
+        <p:spPr>
+          <a:xfrm xmlns:a="http://schemas.openxmlformats.org/drawingml/2006/main">
+            <a:off x="457200" y="4895850"/>
+            <a:ext cx="1524000" cy="190500"/>
+          </a:xfrm>
+          <a:prstGeom xmlns:a="http://schemas.openxmlformats.org/drawingml/2006/main" prst="rect">
+            <a:avLst/>
+          </a:prstGeom>
+          <a:noFill xmlns:a="http://schemas.openxmlformats.org/drawingml/2006/main"/>
+          <a:ln xmlns:a="http://schemas.openxmlformats.org/drawingml/2006/main" w="0">
+            <a:noFill/>
+            <a:prstDash val="solid"/>
+          </a:ln>
+        </p:spPr>
+        <p:txBody>
+          <a:bodyPr xmlns:a="http://schemas.openxmlformats.org/drawingml/2006/main"/>
+          <a:lstStyle xmlns:a="http://schemas.openxmlformats.org/drawingml/2006/main"/>
+          <a:p xmlns:a="http://schemas.openxmlformats.org/drawingml/2006/main">
+            <a:pPr algn="l">
+              <a:defRPr sz="863" b="1">
+                <a:solidFill>
+                  <a:srgbClr val="1C2430"/>
+                </a:solidFill>
+              </a:defRPr>
+            </a:pPr>
+            <a:r>
+              <a:rPr sz="863" b="1">
+                <a:solidFill>
+                  <a:srgbClr val="1C2430"/>
+                </a:solidFill>
+              </a:rPr>
+              <a:t>AnalysisProvider</a:t>
+            </a:r>
+          </a:p>
+        </p:txBody>
+      </p:sp>
+      <p:sp>
+        <p:nvSpPr>
+          <p:cNvPr id="20" name="rail-schema">
+            <a:extLst xmlns:a="http://schemas.openxmlformats.org/drawingml/2006/main">
+              <a:ext uri="{FF2B5EF4-FFF2-40B4-BE49-F238E27FC236}">
+                <a16:creationId xmlns:a16="http://schemas.microsoft.com/office/drawing/2014/main" id="{97692019-A330-4FD9-AC09-EED9D4E4CCBF}"/>
+              </a:ext>
+            </a:extLst>
+          </p:cNvPr>
+          <p:cNvSpPr>
+            <a:spLocks xmlns:a="http://schemas.openxmlformats.org/drawingml/2006/main" noGrp="1"/>
+          </p:cNvSpPr>
+          <p:nvPr/>
+        </p:nvSpPr>
+        <p:spPr>
+          <a:xfrm xmlns:a="http://schemas.openxmlformats.org/drawingml/2006/main">
+            <a:off x="457200" y="5133975"/>
+            <a:ext cx="1428750" cy="171450"/>
+          </a:xfrm>
+          <a:prstGeom xmlns:a="http://schemas.openxmlformats.org/drawingml/2006/main" prst="rect">
+            <a:avLst/>
+          </a:prstGeom>
+          <a:noFill xmlns:a="http://schemas.openxmlformats.org/drawingml/2006/main"/>
+          <a:ln xmlns:a="http://schemas.openxmlformats.org/drawingml/2006/main" w="0">
+            <a:noFill/>
+            <a:prstDash val="solid"/>
+          </a:ln>
+        </p:spPr>
+        <p:txBody>
+          <a:bodyPr xmlns:a="http://schemas.openxmlformats.org/drawingml/2006/main"/>
+          <a:lstStyle xmlns:a="http://schemas.openxmlformats.org/drawingml/2006/main"/>
+          <a:p xmlns:a="http://schemas.openxmlformats.org/drawingml/2006/main">
+            <a:pPr algn="l">
+              <a:defRPr sz="713" b="0">
+                <a:solidFill>
+                  <a:srgbClr val="D05A2A"/>
+                </a:solidFill>
+              </a:defRPr>
+            </a:pPr>
+            <a:r>
+              <a:rPr sz="713" b="0">
+                <a:solidFill>
+                  <a:srgbClr val="D05A2A"/>
+                </a:solidFill>
+              </a:rPr>
+              <a:t>→ typed schemas</a:t>
+            </a:r>
+          </a:p>
+        </p:txBody>
+      </p:sp>
+      <p:sp>
+        <p:nvSpPr>
+          <p:cNvPr id="21" name="rail-foot">
+            <a:extLst xmlns:a="http://schemas.openxmlformats.org/drawingml/2006/main">
+              <a:ext uri="{FF2B5EF4-FFF2-40B4-BE49-F238E27FC236}">
+                <a16:creationId xmlns:a16="http://schemas.microsoft.com/office/drawing/2014/main" id="{72B8FB90-AE4F-4720-A100-6A726E07D8FC}"/>
+              </a:ext>
+            </a:extLst>
+          </p:cNvPr>
+          <p:cNvSpPr>
+            <a:spLocks xmlns:a="http://schemas.openxmlformats.org/drawingml/2006/main" noGrp="1"/>
+          </p:cNvSpPr>
+          <p:nvPr/>
+        </p:nvSpPr>
+        <p:spPr>
+          <a:xfrm xmlns:a="http://schemas.openxmlformats.org/drawingml/2006/main">
+            <a:off x="457200" y="5562600"/>
+            <a:ext cx="1619250" cy="266700"/>
+          </a:xfrm>
+          <a:prstGeom xmlns:a="http://schemas.openxmlformats.org/drawingml/2006/main" prst="rect">
+            <a:avLst/>
+          </a:prstGeom>
+          <a:noFill xmlns:a="http://schemas.openxmlformats.org/drawingml/2006/main"/>
+          <a:ln xmlns:a="http://schemas.openxmlformats.org/drawingml/2006/main" w="0">
+            <a:noFill/>
+            <a:prstDash val="solid"/>
+          </a:ln>
+        </p:spPr>
+        <p:txBody>
+          <a:bodyPr xmlns:a="http://schemas.openxmlformats.org/drawingml/2006/main"/>
+          <a:lstStyle xmlns:a="http://schemas.openxmlformats.org/drawingml/2006/main"/>
+          <a:p xmlns:a="http://schemas.openxmlformats.org/drawingml/2006/main">
+            <a:pPr algn="l">
+              <a:defRPr sz="698" b="0">
+                <a:solidFill>
+                  <a:srgbClr val="667085"/>
+                </a:solidFill>
+              </a:defRPr>
+            </a:pPr>
+            <a:r>
+              <a:rPr sz="698" b="0">
+                <a:solidFill>
+                  <a:srgbClr val="667085"/>
+                </a:solidFill>
+              </a:rPr>
+              <a:t>Public-web content remains untrusted input.</a:t>
+            </a:r>
+          </a:p>
+        </p:txBody>
+      </p:sp>
+      <p:sp>
+        <p:nvSpPr>
+          <p:cNvPr id="22" name="discover-research">
+            <a:extLst xmlns:a="http://schemas.openxmlformats.org/drawingml/2006/main">
+              <a:ext uri="{FF2B5EF4-FFF2-40B4-BE49-F238E27FC236}">
+                <a16:creationId xmlns:a16="http://schemas.microsoft.com/office/drawing/2014/main" id="{9976D371-5C05-41A2-9BEF-9C8FFD33DD86}"/>
               </a:ext>
             </a:extLst>
           </p:cNvPr>
@@ -2049,11 +2184,11 @@
             <a:avLst/>
           </a:prstGeom>
           <a:solidFill xmlns:a="http://schemas.openxmlformats.org/drawingml/2006/main">
-            <a:srgbClr val="52725D"/>
+            <a:srgbClr val="397EA5"/>
           </a:solidFill>
           <a:ln xmlns:a="http://schemas.openxmlformats.org/drawingml/2006/main" w="0">
             <a:solidFill>
-              <a:srgbClr val="52725D"/>
+              <a:srgbClr val="397EA5"/>
             </a:solidFill>
             <a:prstDash val="solid"/>
           </a:ln>
@@ -2061,10 +2196,10 @@
       </p:sp>
       <p:sp>
         <p:nvSpPr>
-          <p:cNvPr id="20" name="research-recommend">
-            <a:extLst xmlns:a="http://schemas.openxmlformats.org/drawingml/2006/main">
-              <a:ext uri="{FF2B5EF4-FFF2-40B4-BE49-F238E27FC236}">
-                <a16:creationId xmlns:a16="http://schemas.microsoft.com/office/drawing/2014/main" id="{4616D20B-CA2B-44A1-BC05-88983533FFEE}"/>
+          <p:cNvPr id="23" name="research-recommend">
+            <a:extLst xmlns:a="http://schemas.openxmlformats.org/drawingml/2006/main">
+              <a:ext uri="{FF2B5EF4-FFF2-40B4-BE49-F238E27FC236}">
+                <a16:creationId xmlns:a16="http://schemas.microsoft.com/office/drawing/2014/main" id="{E4D8D007-3A72-4F1F-B696-AA5930945F35}"/>
               </a:ext>
             </a:extLst>
           </p:cNvPr>
@@ -2082,11 +2217,11 @@
             <a:avLst/>
           </a:prstGeom>
           <a:solidFill xmlns:a="http://schemas.openxmlformats.org/drawingml/2006/main">
-            <a:srgbClr val="C6653E"/>
+            <a:srgbClr val="D05A2A"/>
           </a:solidFill>
           <a:ln xmlns:a="http://schemas.openxmlformats.org/drawingml/2006/main" w="0">
             <a:solidFill>
-              <a:srgbClr val="C6653E"/>
+              <a:srgbClr val="D05A2A"/>
             </a:solidFill>
             <a:prstDash val="solid"/>
           </a:ln>
@@ -2094,10 +2229,10 @@
       </p:sp>
       <p:sp>
         <p:nvSpPr>
-          <p:cNvPr id="21" name="recommend-report">
-            <a:extLst xmlns:a="http://schemas.openxmlformats.org/drawingml/2006/main">
-              <a:ext uri="{FF2B5EF4-FFF2-40B4-BE49-F238E27FC236}">
-                <a16:creationId xmlns:a16="http://schemas.microsoft.com/office/drawing/2014/main" id="{420A8459-5BDC-44F3-A1F6-BF25B6FE90F8}"/>
+          <p:cNvPr id="24" name="recommend-report">
+            <a:extLst xmlns:a="http://schemas.openxmlformats.org/drawingml/2006/main">
+              <a:ext uri="{FF2B5EF4-FFF2-40B4-BE49-F238E27FC236}">
+                <a16:creationId xmlns:a16="http://schemas.microsoft.com/office/drawing/2014/main" id="{C4D319ED-AC83-4DE1-9E24-5E302DE941CA}"/>
               </a:ext>
             </a:extLst>
           </p:cNvPr>
@@ -2115,11 +2250,11 @@
             <a:avLst/>
           </a:prstGeom>
           <a:solidFill xmlns:a="http://schemas.openxmlformats.org/drawingml/2006/main">
-            <a:srgbClr val="6D536F"/>
+            <a:srgbClr val="24384C"/>
           </a:solidFill>
           <a:ln xmlns:a="http://schemas.openxmlformats.org/drawingml/2006/main" w="0">
             <a:solidFill>
-              <a:srgbClr val="6D536F"/>
+              <a:srgbClr val="24384C"/>
             </a:solidFill>
             <a:prstDash val="solid"/>
           </a:ln>
@@ -2127,22 +2262,22 @@
       </p:sp>
       <p:sp>
         <p:nvSpPr>
-          <p:cNvPr id="22" name="port-search-a">
-            <a:extLst xmlns:a="http://schemas.openxmlformats.org/drawingml/2006/main">
-              <a:ext uri="{FF2B5EF4-FFF2-40B4-BE49-F238E27FC236}">
-                <a16:creationId xmlns:a16="http://schemas.microsoft.com/office/drawing/2014/main" id="{31DD95DF-6971-445D-8B40-DF16181AC07F}"/>
-              </a:ext>
-            </a:extLst>
-          </p:cNvPr>
-          <p:cNvSpPr>
-            <a:spLocks xmlns:a="http://schemas.openxmlformats.org/drawingml/2006/main" noGrp="1"/>
-          </p:cNvSpPr>
-          <p:nvPr/>
-        </p:nvSpPr>
-        <p:spPr>
-          <a:xfrm xmlns:a="http://schemas.openxmlformats.org/drawingml/2006/main">
-            <a:off x="2190750" y="5048250"/>
-            <a:ext cx="666750" cy="0"/>
+          <p:cNvPr id="25" name="port-search-a">
+            <a:extLst xmlns:a="http://schemas.openxmlformats.org/drawingml/2006/main">
+              <a:ext uri="{FF2B5EF4-FFF2-40B4-BE49-F238E27FC236}">
+                <a16:creationId xmlns:a16="http://schemas.microsoft.com/office/drawing/2014/main" id="{07921FA8-C8DD-4386-9391-095CC201EA6E}"/>
+              </a:ext>
+            </a:extLst>
+          </p:cNvPr>
+          <p:cNvSpPr>
+            <a:spLocks xmlns:a="http://schemas.openxmlformats.org/drawingml/2006/main" noGrp="1"/>
+          </p:cNvSpPr>
+          <p:nvPr/>
+        </p:nvSpPr>
+        <p:spPr>
+          <a:xfrm xmlns:a="http://schemas.openxmlformats.org/drawingml/2006/main">
+            <a:off x="2324100" y="4438650"/>
+            <a:ext cx="533400" cy="0"/>
           </a:xfrm>
           <a:prstGeom xmlns:a="http://schemas.openxmlformats.org/drawingml/2006/main" prst="line">
             <a:avLst/>
@@ -2150,7 +2285,7 @@
           <a:noFill xmlns:a="http://schemas.openxmlformats.org/drawingml/2006/main"/>
           <a:ln xmlns:a="http://schemas.openxmlformats.org/drawingml/2006/main" w="20955">
             <a:solidFill>
-              <a:srgbClr val="52725D"/>
+              <a:srgbClr val="397EA5"/>
             </a:solidFill>
             <a:prstDash val="solid"/>
           </a:ln>
@@ -2158,10 +2293,10 @@
       </p:sp>
       <p:sp>
         <p:nvSpPr>
-          <p:cNvPr id="23" name="port-search-b">
-            <a:extLst xmlns:a="http://schemas.openxmlformats.org/drawingml/2006/main">
-              <a:ext uri="{FF2B5EF4-FFF2-40B4-BE49-F238E27FC236}">
-                <a16:creationId xmlns:a16="http://schemas.microsoft.com/office/drawing/2014/main" id="{02C59DBB-BA73-4049-BAE1-A797143DAEA5}"/>
+          <p:cNvPr id="26" name="port-search-b">
+            <a:extLst xmlns:a="http://schemas.openxmlformats.org/drawingml/2006/main">
+              <a:ext uri="{FF2B5EF4-FFF2-40B4-BE49-F238E27FC236}">
+                <a16:creationId xmlns:a16="http://schemas.microsoft.com/office/drawing/2014/main" id="{1102E2EA-4B80-481C-BD4A-CA76F7062B93}"/>
               </a:ext>
             </a:extLst>
           </p:cNvPr>
@@ -2173,7 +2308,7 @@
         <p:spPr>
           <a:xfrm xmlns:a="http://schemas.openxmlformats.org/drawingml/2006/main">
             <a:off x="2857500" y="1952625"/>
-            <a:ext cx="0" cy="3095625"/>
+            <a:ext cx="0" cy="2486025"/>
           </a:xfrm>
           <a:prstGeom xmlns:a="http://schemas.openxmlformats.org/drawingml/2006/main" prst="line">
             <a:avLst/>
@@ -2181,7 +2316,7 @@
           <a:noFill xmlns:a="http://schemas.openxmlformats.org/drawingml/2006/main"/>
           <a:ln xmlns:a="http://schemas.openxmlformats.org/drawingml/2006/main" w="20955">
             <a:solidFill>
-              <a:srgbClr val="52725D"/>
+              <a:srgbClr val="397EA5"/>
             </a:solidFill>
             <a:prstDash val="solid"/>
           </a:ln>
@@ -2189,10 +2324,10 @@
       </p:sp>
       <p:sp>
         <p:nvSpPr>
-          <p:cNvPr id="24" name="port-search-c">
-            <a:extLst xmlns:a="http://schemas.openxmlformats.org/drawingml/2006/main">
-              <a:ext uri="{FF2B5EF4-FFF2-40B4-BE49-F238E27FC236}">
-                <a16:creationId xmlns:a16="http://schemas.microsoft.com/office/drawing/2014/main" id="{68E6320B-0BA3-4C31-927C-15CFB82C012A}"/>
+          <p:cNvPr id="27" name="port-search-c">
+            <a:extLst xmlns:a="http://schemas.openxmlformats.org/drawingml/2006/main">
+              <a:ext uri="{FF2B5EF4-FFF2-40B4-BE49-F238E27FC236}">
+                <a16:creationId xmlns:a16="http://schemas.microsoft.com/office/drawing/2014/main" id="{63EC019A-7155-4639-ADC4-61AECAC201A8}"/>
               </a:ext>
             </a:extLst>
           </p:cNvPr>
@@ -2212,7 +2347,7 @@
           <a:noFill xmlns:a="http://schemas.openxmlformats.org/drawingml/2006/main"/>
           <a:ln xmlns:a="http://schemas.openxmlformats.org/drawingml/2006/main" w="20955">
             <a:solidFill>
-              <a:srgbClr val="52725D"/>
+              <a:srgbClr val="397EA5"/>
             </a:solidFill>
             <a:prstDash val="solid"/>
           </a:ln>
@@ -2220,22 +2355,22 @@
       </p:sp>
       <p:sp>
         <p:nvSpPr>
-          <p:cNvPr id="25" name="port-analysis-a">
-            <a:extLst xmlns:a="http://schemas.openxmlformats.org/drawingml/2006/main">
-              <a:ext uri="{FF2B5EF4-FFF2-40B4-BE49-F238E27FC236}">
-                <a16:creationId xmlns:a16="http://schemas.microsoft.com/office/drawing/2014/main" id="{17968206-1026-4789-BDFD-56B758484430}"/>
-              </a:ext>
-            </a:extLst>
-          </p:cNvPr>
-          <p:cNvSpPr>
-            <a:spLocks xmlns:a="http://schemas.openxmlformats.org/drawingml/2006/main" noGrp="1"/>
-          </p:cNvSpPr>
-          <p:nvPr/>
-        </p:nvSpPr>
-        <p:spPr>
-          <a:xfrm xmlns:a="http://schemas.openxmlformats.org/drawingml/2006/main">
-            <a:off x="2190750" y="5619750"/>
-            <a:ext cx="952500" cy="0"/>
+          <p:cNvPr id="28" name="port-analysis-a">
+            <a:extLst xmlns:a="http://schemas.openxmlformats.org/drawingml/2006/main">
+              <a:ext uri="{FF2B5EF4-FFF2-40B4-BE49-F238E27FC236}">
+                <a16:creationId xmlns:a16="http://schemas.microsoft.com/office/drawing/2014/main" id="{4D5F3F53-2B8B-40CC-9DE1-3EA46708AF09}"/>
+              </a:ext>
+            </a:extLst>
+          </p:cNvPr>
+          <p:cNvSpPr>
+            <a:spLocks xmlns:a="http://schemas.openxmlformats.org/drawingml/2006/main" noGrp="1"/>
+          </p:cNvSpPr>
+          <p:nvPr/>
+        </p:nvSpPr>
+        <p:spPr>
+          <a:xfrm xmlns:a="http://schemas.openxmlformats.org/drawingml/2006/main">
+            <a:off x="2324100" y="5000625"/>
+            <a:ext cx="819150" cy="0"/>
           </a:xfrm>
           <a:prstGeom xmlns:a="http://schemas.openxmlformats.org/drawingml/2006/main" prst="line">
             <a:avLst/>
@@ -2243,7 +2378,7 @@
           <a:noFill xmlns:a="http://schemas.openxmlformats.org/drawingml/2006/main"/>
           <a:ln xmlns:a="http://schemas.openxmlformats.org/drawingml/2006/main" w="20955">
             <a:solidFill>
-              <a:srgbClr val="C6653E"/>
+              <a:srgbClr val="D05A2A"/>
             </a:solidFill>
             <a:prstDash val="solid"/>
           </a:ln>
@@ -2251,10 +2386,10 @@
       </p:sp>
       <p:sp>
         <p:nvSpPr>
-          <p:cNvPr id="26" name="port-analysis-b">
-            <a:extLst xmlns:a="http://schemas.openxmlformats.org/drawingml/2006/main">
-              <a:ext uri="{FF2B5EF4-FFF2-40B4-BE49-F238E27FC236}">
-                <a16:creationId xmlns:a16="http://schemas.microsoft.com/office/drawing/2014/main" id="{AED36863-DCA5-4C1C-AC69-4833073A12CF}"/>
+          <p:cNvPr id="29" name="port-analysis-b">
+            <a:extLst xmlns:a="http://schemas.openxmlformats.org/drawingml/2006/main">
+              <a:ext uri="{FF2B5EF4-FFF2-40B4-BE49-F238E27FC236}">
+                <a16:creationId xmlns:a16="http://schemas.microsoft.com/office/drawing/2014/main" id="{CEF7B853-C434-4BB0-8E70-D2A3B90CAE18}"/>
               </a:ext>
             </a:extLst>
           </p:cNvPr>
@@ -2266,7 +2401,7 @@
         <p:spPr>
           <a:xfrm xmlns:a="http://schemas.openxmlformats.org/drawingml/2006/main">
             <a:off x="3143250" y="1143000"/>
-            <a:ext cx="0" cy="4476750"/>
+            <a:ext cx="0" cy="3857625"/>
           </a:xfrm>
           <a:prstGeom xmlns:a="http://schemas.openxmlformats.org/drawingml/2006/main" prst="line">
             <a:avLst/>
@@ -2274,7 +2409,7 @@
           <a:noFill xmlns:a="http://schemas.openxmlformats.org/drawingml/2006/main"/>
           <a:ln xmlns:a="http://schemas.openxmlformats.org/drawingml/2006/main" w="20955">
             <a:solidFill>
-              <a:srgbClr val="C6653E"/>
+              <a:srgbClr val="D05A2A"/>
             </a:solidFill>
             <a:prstDash val="solid"/>
           </a:ln>
@@ -2282,10 +2417,10 @@
       </p:sp>
       <p:sp>
         <p:nvSpPr>
-          <p:cNvPr id="27" name="port-analysis-c">
-            <a:extLst xmlns:a="http://schemas.openxmlformats.org/drawingml/2006/main">
-              <a:ext uri="{FF2B5EF4-FFF2-40B4-BE49-F238E27FC236}">
-                <a16:creationId xmlns:a16="http://schemas.microsoft.com/office/drawing/2014/main" id="{AC44FA31-07CC-4B16-A530-EC912B997DE9}"/>
+          <p:cNvPr id="30" name="port-analysis-c">
+            <a:extLst xmlns:a="http://schemas.openxmlformats.org/drawingml/2006/main">
+              <a:ext uri="{FF2B5EF4-FFF2-40B4-BE49-F238E27FC236}">
+                <a16:creationId xmlns:a16="http://schemas.microsoft.com/office/drawing/2014/main" id="{3CDCAF7B-77D2-4C87-8404-2B123F90013F}"/>
               </a:ext>
             </a:extLst>
           </p:cNvPr>
@@ -2305,7 +2440,7 @@
           <a:noFill xmlns:a="http://schemas.openxmlformats.org/drawingml/2006/main"/>
           <a:ln xmlns:a="http://schemas.openxmlformats.org/drawingml/2006/main" w="20955">
             <a:solidFill>
-              <a:srgbClr val="C6653E"/>
+              <a:srgbClr val="D05A2A"/>
             </a:solidFill>
             <a:prstDash val="solid"/>
           </a:ln>
@@ -2313,10 +2448,10 @@
       </p:sp>
       <p:sp>
         <p:nvSpPr>
-          <p:cNvPr id="28" name="port-analysis-d">
-            <a:extLst xmlns:a="http://schemas.openxmlformats.org/drawingml/2006/main">
-              <a:ext uri="{FF2B5EF4-FFF2-40B4-BE49-F238E27FC236}">
-                <a16:creationId xmlns:a16="http://schemas.microsoft.com/office/drawing/2014/main" id="{62BA6CBA-4332-4251-9CB3-EA63B2551128}"/>
+          <p:cNvPr id="31" name="port-analysis-d">
+            <a:extLst xmlns:a="http://schemas.openxmlformats.org/drawingml/2006/main">
+              <a:ext uri="{FF2B5EF4-FFF2-40B4-BE49-F238E27FC236}">
+                <a16:creationId xmlns:a16="http://schemas.microsoft.com/office/drawing/2014/main" id="{7858BD48-E1CF-4902-ABEC-1A95705AFD3E}"/>
               </a:ext>
             </a:extLst>
           </p:cNvPr>
@@ -2336,7 +2471,7 @@
           <a:noFill xmlns:a="http://schemas.openxmlformats.org/drawingml/2006/main"/>
           <a:ln xmlns:a="http://schemas.openxmlformats.org/drawingml/2006/main" w="20955">
             <a:solidFill>
-              <a:srgbClr val="C6653E"/>
+              <a:srgbClr val="D05A2A"/>
             </a:solidFill>
             <a:prstDash val="solid"/>
           </a:ln>
@@ -2344,10 +2479,10 @@
       </p:sp>
       <p:sp>
         <p:nvSpPr>
-          <p:cNvPr id="29" name="research-fan-stem">
-            <a:extLst xmlns:a="http://schemas.openxmlformats.org/drawingml/2006/main">
-              <a:ext uri="{FF2B5EF4-FFF2-40B4-BE49-F238E27FC236}">
-                <a16:creationId xmlns:a16="http://schemas.microsoft.com/office/drawing/2014/main" id="{3AD52359-810C-4EAD-B62E-2376716E1CF0}"/>
+          <p:cNvPr id="32" name="research-fan-stem">
+            <a:extLst xmlns:a="http://schemas.openxmlformats.org/drawingml/2006/main">
+              <a:ext uri="{FF2B5EF4-FFF2-40B4-BE49-F238E27FC236}">
+                <a16:creationId xmlns:a16="http://schemas.microsoft.com/office/drawing/2014/main" id="{13DD8B05-FFFB-40A1-A8E5-E0F8844C7956}"/>
               </a:ext>
             </a:extLst>
           </p:cNvPr>
@@ -2367,7 +2502,7 @@
           <a:noFill xmlns:a="http://schemas.openxmlformats.org/drawingml/2006/main"/>
           <a:ln xmlns:a="http://schemas.openxmlformats.org/drawingml/2006/main" w="16193">
             <a:solidFill>
-              <a:srgbClr val="C6653E"/>
+              <a:srgbClr val="D05A2A"/>
             </a:solidFill>
             <a:prstDash val="solid"/>
           </a:ln>
@@ -2375,10 +2510,10 @@
       </p:sp>
       <p:sp>
         <p:nvSpPr>
-          <p:cNvPr id="30" name="research-fan-bus">
-            <a:extLst xmlns:a="http://schemas.openxmlformats.org/drawingml/2006/main">
-              <a:ext uri="{FF2B5EF4-FFF2-40B4-BE49-F238E27FC236}">
-                <a16:creationId xmlns:a16="http://schemas.microsoft.com/office/drawing/2014/main" id="{FE2B19B0-F298-4401-9D63-F987CD5B39E9}"/>
+          <p:cNvPr id="33" name="research-fan-bus">
+            <a:extLst xmlns:a="http://schemas.openxmlformats.org/drawingml/2006/main">
+              <a:ext uri="{FF2B5EF4-FFF2-40B4-BE49-F238E27FC236}">
+                <a16:creationId xmlns:a16="http://schemas.microsoft.com/office/drawing/2014/main" id="{F939C901-6AD8-46EE-B227-E9D72802468C}"/>
               </a:ext>
             </a:extLst>
           </p:cNvPr>
@@ -2398,7 +2533,7 @@
           <a:noFill xmlns:a="http://schemas.openxmlformats.org/drawingml/2006/main"/>
           <a:ln xmlns:a="http://schemas.openxmlformats.org/drawingml/2006/main" w="16193">
             <a:solidFill>
-              <a:srgbClr val="C6653E"/>
+              <a:srgbClr val="D05A2A"/>
             </a:solidFill>
             <a:prstDash val="solid"/>
           </a:ln>
@@ -2406,10 +2541,10 @@
       </p:sp>
       <p:sp>
         <p:nvSpPr>
-          <p:cNvPr id="31" name="research-fan-a">
-            <a:extLst xmlns:a="http://schemas.openxmlformats.org/drawingml/2006/main">
-              <a:ext uri="{FF2B5EF4-FFF2-40B4-BE49-F238E27FC236}">
-                <a16:creationId xmlns:a16="http://schemas.microsoft.com/office/drawing/2014/main" id="{D604D4F6-A0BE-4ADD-982C-5836D5489F0C}"/>
+          <p:cNvPr id="34" name="research-fan-a">
+            <a:extLst xmlns:a="http://schemas.openxmlformats.org/drawingml/2006/main">
+              <a:ext uri="{FF2B5EF4-FFF2-40B4-BE49-F238E27FC236}">
+                <a16:creationId xmlns:a16="http://schemas.microsoft.com/office/drawing/2014/main" id="{59449A6C-C348-4246-943A-C2E644C2C7C7}"/>
               </a:ext>
             </a:extLst>
           </p:cNvPr>
@@ -2429,7 +2564,7 @@
           <a:noFill xmlns:a="http://schemas.openxmlformats.org/drawingml/2006/main"/>
           <a:ln xmlns:a="http://schemas.openxmlformats.org/drawingml/2006/main" w="16193">
             <a:solidFill>
-              <a:srgbClr val="C6653E"/>
+              <a:srgbClr val="D05A2A"/>
             </a:solidFill>
             <a:prstDash val="solid"/>
           </a:ln>
@@ -2437,10 +2572,10 @@
       </p:sp>
       <p:sp>
         <p:nvSpPr>
-          <p:cNvPr id="32" name="research-fan-b">
-            <a:extLst xmlns:a="http://schemas.openxmlformats.org/drawingml/2006/main">
-              <a:ext uri="{FF2B5EF4-FFF2-40B4-BE49-F238E27FC236}">
-                <a16:creationId xmlns:a16="http://schemas.microsoft.com/office/drawing/2014/main" id="{7C7D120F-CB83-4F1C-AAFB-6F806EB03346}"/>
+          <p:cNvPr id="35" name="research-fan-b">
+            <a:extLst xmlns:a="http://schemas.openxmlformats.org/drawingml/2006/main">
+              <a:ext uri="{FF2B5EF4-FFF2-40B4-BE49-F238E27FC236}">
+                <a16:creationId xmlns:a16="http://schemas.microsoft.com/office/drawing/2014/main" id="{8E311A9B-8178-48A6-A727-F40923296EDE}"/>
               </a:ext>
             </a:extLst>
           </p:cNvPr>
@@ -2460,7 +2595,7 @@
           <a:noFill xmlns:a="http://schemas.openxmlformats.org/drawingml/2006/main"/>
           <a:ln xmlns:a="http://schemas.openxmlformats.org/drawingml/2006/main" w="16193">
             <a:solidFill>
-              <a:srgbClr val="C6653E"/>
+              <a:srgbClr val="D05A2A"/>
             </a:solidFill>
             <a:prstDash val="solid"/>
           </a:ln>
@@ -2468,10 +2603,10 @@
       </p:sp>
       <p:sp>
         <p:nvSpPr>
-          <p:cNvPr id="33" name="research-fan-c">
-            <a:extLst xmlns:a="http://schemas.openxmlformats.org/drawingml/2006/main">
-              <a:ext uri="{FF2B5EF4-FFF2-40B4-BE49-F238E27FC236}">
-                <a16:creationId xmlns:a16="http://schemas.microsoft.com/office/drawing/2014/main" id="{6D09C502-C9CC-45C8-9D61-D30C07D3A3E0}"/>
+          <p:cNvPr id="36" name="research-fan-c">
+            <a:extLst xmlns:a="http://schemas.openxmlformats.org/drawingml/2006/main">
+              <a:ext uri="{FF2B5EF4-FFF2-40B4-BE49-F238E27FC236}">
+                <a16:creationId xmlns:a16="http://schemas.microsoft.com/office/drawing/2014/main" id="{3F114B9F-542B-4DEB-ACDF-8D94D08653D6}"/>
               </a:ext>
             </a:extLst>
           </p:cNvPr>
@@ -2491,7 +2626,7 @@
           <a:noFill xmlns:a="http://schemas.openxmlformats.org/drawingml/2006/main"/>
           <a:ln xmlns:a="http://schemas.openxmlformats.org/drawingml/2006/main" w="16193">
             <a:solidFill>
-              <a:srgbClr val="C6653E"/>
+              <a:srgbClr val="D05A2A"/>
             </a:solidFill>
             <a:prstDash val="solid"/>
           </a:ln>
@@ -2499,10 +2634,10 @@
       </p:sp>
       <p:sp>
         <p:nvSpPr>
-          <p:cNvPr id="34" name="tool-a-report">
-            <a:extLst xmlns:a="http://schemas.openxmlformats.org/drawingml/2006/main">
-              <a:ext uri="{FF2B5EF4-FFF2-40B4-BE49-F238E27FC236}">
-                <a16:creationId xmlns:a16="http://schemas.microsoft.com/office/drawing/2014/main" id="{C57C6A71-D4BD-4972-8034-5B6FFF37AD4D}"/>
+          <p:cNvPr id="37" name="tool-a-report">
+            <a:extLst xmlns:a="http://schemas.openxmlformats.org/drawingml/2006/main">
+              <a:ext uri="{FF2B5EF4-FFF2-40B4-BE49-F238E27FC236}">
+                <a16:creationId xmlns:a16="http://schemas.microsoft.com/office/drawing/2014/main" id="{915C7FBC-B287-4C8D-8300-DAE9ECDD53F7}"/>
               </a:ext>
             </a:extLst>
           </p:cNvPr>
@@ -2522,7 +2657,7 @@
           <a:noFill xmlns:a="http://schemas.openxmlformats.org/drawingml/2006/main"/>
           <a:ln xmlns:a="http://schemas.openxmlformats.org/drawingml/2006/main" w="14288">
             <a:solidFill>
-              <a:srgbClr val="C6653E"/>
+              <a:srgbClr val="D05A2A"/>
             </a:solidFill>
             <a:prstDash val="solid"/>
           </a:ln>
@@ -2530,10 +2665,10 @@
       </p:sp>
       <p:sp>
         <p:nvSpPr>
-          <p:cNvPr id="35" name="tool-b-report">
-            <a:extLst xmlns:a="http://schemas.openxmlformats.org/drawingml/2006/main">
-              <a:ext uri="{FF2B5EF4-FFF2-40B4-BE49-F238E27FC236}">
-                <a16:creationId xmlns:a16="http://schemas.microsoft.com/office/drawing/2014/main" id="{37E9C19D-E6F2-4BBB-B477-E933D4EA88A8}"/>
+          <p:cNvPr id="38" name="tool-b-report">
+            <a:extLst xmlns:a="http://schemas.openxmlformats.org/drawingml/2006/main">
+              <a:ext uri="{FF2B5EF4-FFF2-40B4-BE49-F238E27FC236}">
+                <a16:creationId xmlns:a16="http://schemas.microsoft.com/office/drawing/2014/main" id="{28B9715B-F498-4889-A827-1C9C24F3FC25}"/>
               </a:ext>
             </a:extLst>
           </p:cNvPr>
@@ -2553,7 +2688,7 @@
           <a:noFill xmlns:a="http://schemas.openxmlformats.org/drawingml/2006/main"/>
           <a:ln xmlns:a="http://schemas.openxmlformats.org/drawingml/2006/main" w="14288">
             <a:solidFill>
-              <a:srgbClr val="C6653E"/>
+              <a:srgbClr val="D05A2A"/>
             </a:solidFill>
             <a:prstDash val="solid"/>
           </a:ln>
@@ -2561,10 +2696,10 @@
       </p:sp>
       <p:sp>
         <p:nvSpPr>
-          <p:cNvPr id="36" name="tool-c-report">
-            <a:extLst xmlns:a="http://schemas.openxmlformats.org/drawingml/2006/main">
-              <a:ext uri="{FF2B5EF4-FFF2-40B4-BE49-F238E27FC236}">
-                <a16:creationId xmlns:a16="http://schemas.microsoft.com/office/drawing/2014/main" id="{B0DF8526-BD77-4C90-9FA6-F34311C87A48}"/>
+          <p:cNvPr id="39" name="tool-c-report">
+            <a:extLst xmlns:a="http://schemas.openxmlformats.org/drawingml/2006/main">
+              <a:ext uri="{FF2B5EF4-FFF2-40B4-BE49-F238E27FC236}">
+                <a16:creationId xmlns:a16="http://schemas.microsoft.com/office/drawing/2014/main" id="{7A098649-0934-4F96-9778-EBAA352CCF97}"/>
               </a:ext>
             </a:extLst>
           </p:cNvPr>
@@ -2584,7 +2719,7 @@
           <a:noFill xmlns:a="http://schemas.openxmlformats.org/drawingml/2006/main"/>
           <a:ln xmlns:a="http://schemas.openxmlformats.org/drawingml/2006/main" w="14288">
             <a:solidFill>
-              <a:srgbClr val="C6653E"/>
+              <a:srgbClr val="D05A2A"/>
             </a:solidFill>
             <a:prstDash val="solid"/>
           </a:ln>
@@ -2592,10 +2727,10 @@
       </p:sp>
       <p:sp>
         <p:nvSpPr>
-          <p:cNvPr id="37" name="tool-report-bus">
-            <a:extLst xmlns:a="http://schemas.openxmlformats.org/drawingml/2006/main">
-              <a:ext uri="{FF2B5EF4-FFF2-40B4-BE49-F238E27FC236}">
-                <a16:creationId xmlns:a16="http://schemas.microsoft.com/office/drawing/2014/main" id="{9A9D3983-1EBC-4AD8-8C95-EC5949083035}"/>
+          <p:cNvPr id="40" name="tool-report-bus">
+            <a:extLst xmlns:a="http://schemas.openxmlformats.org/drawingml/2006/main">
+              <a:ext uri="{FF2B5EF4-FFF2-40B4-BE49-F238E27FC236}">
+                <a16:creationId xmlns:a16="http://schemas.microsoft.com/office/drawing/2014/main" id="{98D3263F-CE9B-404E-A123-19E0318F41C5}"/>
               </a:ext>
             </a:extLst>
           </p:cNvPr>
@@ -2615,7 +2750,7 @@
           <a:noFill xmlns:a="http://schemas.openxmlformats.org/drawingml/2006/main"/>
           <a:ln xmlns:a="http://schemas.openxmlformats.org/drawingml/2006/main" w="14288">
             <a:solidFill>
-              <a:srgbClr val="C6653E"/>
+              <a:srgbClr val="D05A2A"/>
             </a:solidFill>
             <a:prstDash val="solid"/>
           </a:ln>
@@ -2623,10 +2758,10 @@
       </p:sp>
       <p:sp>
         <p:nvSpPr>
-          <p:cNvPr id="38" name="report-renderers">
-            <a:extLst xmlns:a="http://schemas.openxmlformats.org/drawingml/2006/main">
-              <a:ext uri="{FF2B5EF4-FFF2-40B4-BE49-F238E27FC236}">
-                <a16:creationId xmlns:a16="http://schemas.microsoft.com/office/drawing/2014/main" id="{C8B69344-FF88-49C1-8AE3-1B255C4B542D}"/>
+          <p:cNvPr id="41" name="report-renderers">
+            <a:extLst xmlns:a="http://schemas.openxmlformats.org/drawingml/2006/main">
+              <a:ext uri="{FF2B5EF4-FFF2-40B4-BE49-F238E27FC236}">
+                <a16:creationId xmlns:a16="http://schemas.microsoft.com/office/drawing/2014/main" id="{DA64A598-94C8-4C7B-8429-19660B98316E}"/>
               </a:ext>
             </a:extLst>
           </p:cNvPr>
@@ -2644,11 +2779,11 @@
             <a:avLst/>
           </a:prstGeom>
           <a:solidFill xmlns:a="http://schemas.openxmlformats.org/drawingml/2006/main">
-            <a:srgbClr val="B47A1B"/>
+            <a:srgbClr val="D05A2A"/>
           </a:solidFill>
           <a:ln xmlns:a="http://schemas.openxmlformats.org/drawingml/2006/main" w="0">
             <a:solidFill>
-              <a:srgbClr val="B47A1B"/>
+              <a:srgbClr val="D05A2A"/>
             </a:solidFill>
             <a:prstDash val="solid"/>
           </a:ln>
@@ -2656,21 +2791,21 @@
       </p:sp>
       <p:sp>
         <p:nvSpPr>
-          <p:cNvPr id="39" name="map-label">
-            <a:extLst xmlns:a="http://schemas.openxmlformats.org/drawingml/2006/main">
-              <a:ext uri="{FF2B5EF4-FFF2-40B4-BE49-F238E27FC236}">
-                <a16:creationId xmlns:a16="http://schemas.microsoft.com/office/drawing/2014/main" id="{B258B445-C865-48AD-91D9-9F1FF4013D3E}"/>
-              </a:ext>
-            </a:extLst>
-          </p:cNvPr>
-          <p:cNvSpPr>
-            <a:spLocks xmlns:a="http://schemas.openxmlformats.org/drawingml/2006/main" noGrp="1"/>
-          </p:cNvSpPr>
-          <p:nvPr/>
-        </p:nvSpPr>
-        <p:spPr>
-          <a:xfrm xmlns:a="http://schemas.openxmlformats.org/drawingml/2006/main">
-            <a:off x="2705100" y="304800"/>
+          <p:cNvPr id="42" name="map-label">
+            <a:extLst xmlns:a="http://schemas.openxmlformats.org/drawingml/2006/main">
+              <a:ext uri="{FF2B5EF4-FFF2-40B4-BE49-F238E27FC236}">
+                <a16:creationId xmlns:a16="http://schemas.microsoft.com/office/drawing/2014/main" id="{A8CE9C1F-A9B5-45E5-B87B-DF989CF49A98}"/>
+              </a:ext>
+            </a:extLst>
+          </p:cNvPr>
+          <p:cNvSpPr>
+            <a:spLocks xmlns:a="http://schemas.openxmlformats.org/drawingml/2006/main" noGrp="1"/>
+          </p:cNvSpPr>
+          <p:nvPr/>
+        </p:nvSpPr>
+        <p:spPr>
+          <a:xfrm xmlns:a="http://schemas.openxmlformats.org/drawingml/2006/main">
+            <a:off x="2705100" y="971550"/>
             <a:ext cx="5905500" cy="190500"/>
           </a:xfrm>
           <a:prstGeom xmlns:a="http://schemas.openxmlformats.org/drawingml/2006/main" prst="rect">
@@ -2687,16 +2822,16 @@
           <a:lstStyle xmlns:a="http://schemas.openxmlformats.org/drawingml/2006/main"/>
           <a:p xmlns:a="http://schemas.openxmlformats.org/drawingml/2006/main">
             <a:pPr algn="l">
-              <a:defRPr sz="825" b="1">
-                <a:solidFill>
-                  <a:srgbClr val="9E3F2F"/>
-                </a:solidFill>
-              </a:defRPr>
-            </a:pPr>
-            <a:r>
-              <a:rPr sz="825" b="1">
-                <a:solidFill>
-                  <a:srgbClr val="9E3F2F"/>
+              <a:defRPr sz="788" b="1">
+                <a:solidFill>
+                  <a:srgbClr val="A63F24"/>
+                </a:solidFill>
+              </a:defRPr>
+            </a:pPr>
+            <a:r>
+              <a:rPr sz="788" b="1">
+                <a:solidFill>
+                  <a:srgbClr val="A63F24"/>
                 </a:solidFill>
               </a:rPr>
               <a:t>DISCOVER → PROFILE IN PARALLEL → SYNTHESIZE</a:t>
@@ -2706,110 +2841,10 @@
       </p:sp>
       <p:sp>
         <p:nvSpPr>
-          <p:cNvPr id="40" name="map-note">
-            <a:extLst xmlns:a="http://schemas.openxmlformats.org/drawingml/2006/main">
-              <a:ext uri="{FF2B5EF4-FFF2-40B4-BE49-F238E27FC236}">
-                <a16:creationId xmlns:a16="http://schemas.microsoft.com/office/drawing/2014/main" id="{6010102C-C2E4-4A01-AB93-179BC2C75826}"/>
-              </a:ext>
-            </a:extLst>
-          </p:cNvPr>
-          <p:cNvSpPr>
-            <a:spLocks xmlns:a="http://schemas.openxmlformats.org/drawingml/2006/main" noGrp="1"/>
-          </p:cNvSpPr>
-          <p:nvPr/>
-        </p:nvSpPr>
-        <p:spPr>
-          <a:xfrm xmlns:a="http://schemas.openxmlformats.org/drawingml/2006/main">
-            <a:off x="2705100" y="581025"/>
-            <a:ext cx="5143500" cy="228600"/>
-          </a:xfrm>
-          <a:prstGeom xmlns:a="http://schemas.openxmlformats.org/drawingml/2006/main" prst="rect">
-            <a:avLst/>
-          </a:prstGeom>
-          <a:noFill xmlns:a="http://schemas.openxmlformats.org/drawingml/2006/main"/>
-          <a:ln xmlns:a="http://schemas.openxmlformats.org/drawingml/2006/main" w="0">
-            <a:noFill/>
-            <a:prstDash val="solid"/>
-          </a:ln>
-        </p:spPr>
-        <p:txBody>
-          <a:bodyPr xmlns:a="http://schemas.openxmlformats.org/drawingml/2006/main"/>
-          <a:lstStyle xmlns:a="http://schemas.openxmlformats.org/drawingml/2006/main"/>
-          <a:p xmlns:a="http://schemas.openxmlformats.org/drawingml/2006/main">
-            <a:pPr algn="l">
-              <a:defRPr sz="1125" b="0">
-                <a:solidFill>
-                  <a:srgbClr val="6B665F"/>
-                </a:solidFill>
-              </a:defRPr>
-            </a:pPr>
-            <a:r>
-              <a:rPr sz="1125" b="0">
-                <a:solidFill>
-                  <a:srgbClr val="6B665F"/>
-                </a:solidFill>
-              </a:rPr>
-              <a:t>The node graph is stable across demo and live modes.</a:t>
-            </a:r>
-          </a:p>
-        </p:txBody>
-      </p:sp>
-      <p:sp>
-        <p:nvSpPr>
-          <p:cNvPr id="41" name="graph-type">
-            <a:extLst xmlns:a="http://schemas.openxmlformats.org/drawingml/2006/main">
-              <a:ext uri="{FF2B5EF4-FFF2-40B4-BE49-F238E27FC236}">
-                <a16:creationId xmlns:a16="http://schemas.microsoft.com/office/drawing/2014/main" id="{78E1D4AF-3CCC-40A6-81C7-FA3A32B64C13}"/>
-              </a:ext>
-            </a:extLst>
-          </p:cNvPr>
-          <p:cNvSpPr>
-            <a:spLocks xmlns:a="http://schemas.openxmlformats.org/drawingml/2006/main" noGrp="1"/>
-          </p:cNvSpPr>
-          <p:nvPr/>
-        </p:nvSpPr>
-        <p:spPr>
-          <a:xfrm xmlns:a="http://schemas.openxmlformats.org/drawingml/2006/main">
-            <a:off x="9544050" y="371475"/>
-            <a:ext cx="2228850" cy="190500"/>
-          </a:xfrm>
-          <a:prstGeom xmlns:a="http://schemas.openxmlformats.org/drawingml/2006/main" prst="rect">
-            <a:avLst/>
-          </a:prstGeom>
-          <a:noFill xmlns:a="http://schemas.openxmlformats.org/drawingml/2006/main"/>
-          <a:ln xmlns:a="http://schemas.openxmlformats.org/drawingml/2006/main" w="0">
-            <a:noFill/>
-            <a:prstDash val="solid"/>
-          </a:ln>
-        </p:spPr>
-        <p:txBody>
-          <a:bodyPr xmlns:a="http://schemas.openxmlformats.org/drawingml/2006/main"/>
-          <a:lstStyle xmlns:a="http://schemas.openxmlformats.org/drawingml/2006/main"/>
-          <a:p xmlns:a="http://schemas.openxmlformats.org/drawingml/2006/main">
-            <a:pPr algn="r">
-              <a:defRPr sz="863" b="1">
-                <a:solidFill>
-                  <a:srgbClr val="52725D"/>
-                </a:solidFill>
-              </a:defRPr>
-            </a:pPr>
-            <a:r>
-              <a:rPr sz="863" b="1">
-                <a:solidFill>
-                  <a:srgbClr val="52725D"/>
-                </a:solidFill>
-              </a:rPr>
-              <a:t>ResearchPipeline / LangGraph</a:t>
-            </a:r>
-          </a:p>
-        </p:txBody>
-      </p:sp>
-      <p:sp>
-        <p:nvSpPr>
-          <p:cNvPr id="42" name="discover-circle">
-            <a:extLst xmlns:a="http://schemas.openxmlformats.org/drawingml/2006/main">
-              <a:ext uri="{FF2B5EF4-FFF2-40B4-BE49-F238E27FC236}">
-                <a16:creationId xmlns:a16="http://schemas.microsoft.com/office/drawing/2014/main" id="{95E9E978-7F83-4E22-B4D0-BC01A25CFABA}"/>
+          <p:cNvPr id="43" name="discover-circle">
+            <a:extLst xmlns:a="http://schemas.openxmlformats.org/drawingml/2006/main">
+              <a:ext uri="{FF2B5EF4-FFF2-40B4-BE49-F238E27FC236}">
+                <a16:creationId xmlns:a16="http://schemas.microsoft.com/office/drawing/2014/main" id="{FEE1210B-E990-4AE4-805C-E4397CDBCE3D}"/>
               </a:ext>
             </a:extLst>
           </p:cNvPr>
@@ -2827,11 +2862,11 @@
             <a:avLst/>
           </a:prstGeom>
           <a:solidFill xmlns:a="http://schemas.openxmlformats.org/drawingml/2006/main">
-            <a:srgbClr val="DDE8DC"/>
+            <a:srgbClr val="E7F1F6"/>
           </a:solidFill>
           <a:ln xmlns:a="http://schemas.openxmlformats.org/drawingml/2006/main" w="16193">
             <a:solidFill>
-              <a:srgbClr val="52725D"/>
+              <a:srgbClr val="397EA5"/>
             </a:solidFill>
             <a:prstDash val="solid"/>
           </a:ln>
@@ -2839,10 +2874,10 @@
       </p:sp>
       <p:sp>
         <p:nvSpPr>
-          <p:cNvPr id="43" name="discover-step">
-            <a:extLst xmlns:a="http://schemas.openxmlformats.org/drawingml/2006/main">
-              <a:ext uri="{FF2B5EF4-FFF2-40B4-BE49-F238E27FC236}">
-                <a16:creationId xmlns:a16="http://schemas.microsoft.com/office/drawing/2014/main" id="{5B58CC69-31FF-4E3C-B115-115B5730B7D9}"/>
+          <p:cNvPr id="44" name="discover-step">
+            <a:extLst xmlns:a="http://schemas.openxmlformats.org/drawingml/2006/main">
+              <a:ext uri="{FF2B5EF4-FFF2-40B4-BE49-F238E27FC236}">
+                <a16:creationId xmlns:a16="http://schemas.microsoft.com/office/drawing/2014/main" id="{D01DF026-CC95-40CA-B6A4-32F3A03DDD9F}"/>
               </a:ext>
             </a:extLst>
           </p:cNvPr>
@@ -2860,11 +2895,11 @@
             <a:avLst/>
           </a:prstGeom>
           <a:solidFill xmlns:a="http://schemas.openxmlformats.org/drawingml/2006/main">
-            <a:srgbClr val="52725D"/>
+            <a:srgbClr val="397EA5"/>
           </a:solidFill>
           <a:ln xmlns:a="http://schemas.openxmlformats.org/drawingml/2006/main" w="0">
             <a:solidFill>
-              <a:srgbClr val="52725D"/>
+              <a:srgbClr val="397EA5"/>
             </a:solidFill>
             <a:prstDash val="solid"/>
           </a:ln>
@@ -2872,10 +2907,10 @@
       </p:sp>
       <p:sp>
         <p:nvSpPr>
-          <p:cNvPr id="44" name="discover-step-text">
-            <a:extLst xmlns:a="http://schemas.openxmlformats.org/drawingml/2006/main">
-              <a:ext uri="{FF2B5EF4-FFF2-40B4-BE49-F238E27FC236}">
-                <a16:creationId xmlns:a16="http://schemas.microsoft.com/office/drawing/2014/main" id="{35B63E1A-52B3-45C7-9639-7C2E632E55D3}"/>
+          <p:cNvPr id="45" name="discover-step-text">
+            <a:extLst xmlns:a="http://schemas.openxmlformats.org/drawingml/2006/main">
+              <a:ext uri="{FF2B5EF4-FFF2-40B4-BE49-F238E27FC236}">
+                <a16:creationId xmlns:a16="http://schemas.microsoft.com/office/drawing/2014/main" id="{12C5B9EF-B566-464E-8675-A9CB9C515D63}"/>
               </a:ext>
             </a:extLst>
           </p:cNvPr>
@@ -2905,14 +2940,14 @@
             <a:pPr algn="ctr">
               <a:defRPr sz="750" b="1">
                 <a:solidFill>
-                  <a:srgbClr val="FFFDF8"/>
+                  <a:srgbClr val="FFFFFF"/>
                 </a:solidFill>
               </a:defRPr>
             </a:pPr>
             <a:r>
               <a:rPr sz="750" b="1">
                 <a:solidFill>
-                  <a:srgbClr val="FFFDF8"/>
+                  <a:srgbClr val="FFFFFF"/>
                 </a:solidFill>
               </a:rPr>
               <a:t>1</a:t>
@@ -2922,10 +2957,10 @@
       </p:sp>
       <p:sp>
         <p:nvSpPr>
-          <p:cNvPr id="45" name="discover-title">
-            <a:extLst xmlns:a="http://schemas.openxmlformats.org/drawingml/2006/main">
-              <a:ext uri="{FF2B5EF4-FFF2-40B4-BE49-F238E27FC236}">
-                <a16:creationId xmlns:a16="http://schemas.microsoft.com/office/drawing/2014/main" id="{5FF9CB34-E371-4F78-BF8A-B71D6D808901}"/>
+          <p:cNvPr id="46" name="discover-title">
+            <a:extLst xmlns:a="http://schemas.openxmlformats.org/drawingml/2006/main">
+              <a:ext uri="{FF2B5EF4-FFF2-40B4-BE49-F238E27FC236}">
+                <a16:creationId xmlns:a16="http://schemas.microsoft.com/office/drawing/2014/main" id="{7BAF3AE2-0394-4184-BB9D-29C9D5F0EEBF}"/>
               </a:ext>
             </a:extLst>
           </p:cNvPr>
@@ -2955,14 +2990,14 @@
             <a:pPr algn="ctr">
               <a:defRPr sz="1125" b="1">
                 <a:solidFill>
-                  <a:srgbClr val="52725D"/>
+                  <a:srgbClr val="397EA5"/>
                 </a:solidFill>
               </a:defRPr>
             </a:pPr>
             <a:r>
               <a:rPr sz="1125" b="1">
                 <a:solidFill>
-                  <a:srgbClr val="52725D"/>
+                  <a:srgbClr val="397EA5"/>
                 </a:solidFill>
               </a:rPr>
               <a:t>Discover</a:t>
@@ -2972,10 +3007,10 @@
       </p:sp>
       <p:sp>
         <p:nvSpPr>
-          <p:cNvPr id="46" name="discover-body">
-            <a:extLst xmlns:a="http://schemas.openxmlformats.org/drawingml/2006/main">
-              <a:ext uri="{FF2B5EF4-FFF2-40B4-BE49-F238E27FC236}">
-                <a16:creationId xmlns:a16="http://schemas.microsoft.com/office/drawing/2014/main" id="{D3EDBF2D-2A61-44AD-932D-D5329D3C0F37}"/>
+          <p:cNvPr id="47" name="discover-body">
+            <a:extLst xmlns:a="http://schemas.openxmlformats.org/drawingml/2006/main">
+              <a:ext uri="{FF2B5EF4-FFF2-40B4-BE49-F238E27FC236}">
+                <a16:creationId xmlns:a16="http://schemas.microsoft.com/office/drawing/2014/main" id="{917D6F50-36DD-4669-ABED-9A0E07897857}"/>
               </a:ext>
             </a:extLst>
           </p:cNvPr>
@@ -3005,14 +3040,14 @@
             <a:pPr algn="ctr">
               <a:defRPr sz="788" b="0">
                 <a:solidFill>
-                  <a:srgbClr val="6B665F"/>
+                  <a:srgbClr val="667085"/>
                 </a:solidFill>
               </a:defRPr>
             </a:pPr>
             <a:r>
               <a:rPr sz="788" b="0">
                 <a:solidFill>
-                  <a:srgbClr val="6B665F"/>
+                  <a:srgbClr val="667085"/>
                 </a:solidFill>
               </a:rPr>
               <a:t>normalize query</a:t>
@@ -3022,14 +3057,14 @@
             <a:pPr algn="ctr">
               <a:defRPr sz="788" b="0">
                 <a:solidFill>
-                  <a:srgbClr val="6B665F"/>
+                  <a:srgbClr val="667085"/>
                 </a:solidFill>
               </a:defRPr>
             </a:pPr>
             <a:r>
               <a:rPr sz="788" b="0">
                 <a:solidFill>
-                  <a:srgbClr val="6B665F"/>
+                  <a:srgbClr val="667085"/>
                 </a:solidFill>
               </a:rPr>
               <a:t>search comparison docs</a:t>
@@ -3039,14 +3074,14 @@
             <a:pPr algn="ctr">
               <a:defRPr sz="788" b="0">
                 <a:solidFill>
-                  <a:srgbClr val="6B665F"/>
+                  <a:srgbClr val="667085"/>
                 </a:solidFill>
               </a:defRPr>
             </a:pPr>
             <a:r>
               <a:rPr sz="788" b="0">
                 <a:solidFill>
-                  <a:srgbClr val="6B665F"/>
+                  <a:srgbClr val="667085"/>
                 </a:solidFill>
               </a:rPr>
               <a:t>deduplicate 1–6 tools</a:t>
@@ -3056,10 +3091,10 @@
       </p:sp>
       <p:sp>
         <p:nvSpPr>
-          <p:cNvPr id="47" name="research-circle">
-            <a:extLst xmlns:a="http://schemas.openxmlformats.org/drawingml/2006/main">
-              <a:ext uri="{FF2B5EF4-FFF2-40B4-BE49-F238E27FC236}">
-                <a16:creationId xmlns:a16="http://schemas.microsoft.com/office/drawing/2014/main" id="{73CB9764-4CEE-4FE5-8CB1-CA0B542A413B}"/>
+          <p:cNvPr id="48" name="research-circle">
+            <a:extLst xmlns:a="http://schemas.openxmlformats.org/drawingml/2006/main">
+              <a:ext uri="{FF2B5EF4-FFF2-40B4-BE49-F238E27FC236}">
+                <a16:creationId xmlns:a16="http://schemas.microsoft.com/office/drawing/2014/main" id="{36ECE169-6565-4193-BDFF-0B621D4B6B9E}"/>
               </a:ext>
             </a:extLst>
           </p:cNvPr>
@@ -3077,11 +3112,11 @@
             <a:avLst/>
           </a:prstGeom>
           <a:solidFill xmlns:a="http://schemas.openxmlformats.org/drawingml/2006/main">
-            <a:srgbClr val="F1DDD1"/>
+            <a:srgbClr val="FBE9E1"/>
           </a:solidFill>
           <a:ln xmlns:a="http://schemas.openxmlformats.org/drawingml/2006/main" w="16193">
             <a:solidFill>
-              <a:srgbClr val="C6653E"/>
+              <a:srgbClr val="D05A2A"/>
             </a:solidFill>
             <a:prstDash val="solid"/>
           </a:ln>
@@ -3089,10 +3124,10 @@
       </p:sp>
       <p:sp>
         <p:nvSpPr>
-          <p:cNvPr id="48" name="research-step">
-            <a:extLst xmlns:a="http://schemas.openxmlformats.org/drawingml/2006/main">
-              <a:ext uri="{FF2B5EF4-FFF2-40B4-BE49-F238E27FC236}">
-                <a16:creationId xmlns:a16="http://schemas.microsoft.com/office/drawing/2014/main" id="{7FC7FBA6-4A01-41C2-8217-9D1F8DA3A6A1}"/>
+          <p:cNvPr id="49" name="research-step">
+            <a:extLst xmlns:a="http://schemas.openxmlformats.org/drawingml/2006/main">
+              <a:ext uri="{FF2B5EF4-FFF2-40B4-BE49-F238E27FC236}">
+                <a16:creationId xmlns:a16="http://schemas.microsoft.com/office/drawing/2014/main" id="{58EB5E6C-2B0C-4E9D-A078-06FB291C7FB4}"/>
               </a:ext>
             </a:extLst>
           </p:cNvPr>
@@ -3110,11 +3145,11 @@
             <a:avLst/>
           </a:prstGeom>
           <a:solidFill xmlns:a="http://schemas.openxmlformats.org/drawingml/2006/main">
-            <a:srgbClr val="C6653E"/>
+            <a:srgbClr val="D05A2A"/>
           </a:solidFill>
           <a:ln xmlns:a="http://schemas.openxmlformats.org/drawingml/2006/main" w="0">
             <a:solidFill>
-              <a:srgbClr val="C6653E"/>
+              <a:srgbClr val="D05A2A"/>
             </a:solidFill>
             <a:prstDash val="solid"/>
           </a:ln>
@@ -3122,10 +3157,10 @@
       </p:sp>
       <p:sp>
         <p:nvSpPr>
-          <p:cNvPr id="49" name="research-step-text">
-            <a:extLst xmlns:a="http://schemas.openxmlformats.org/drawingml/2006/main">
-              <a:ext uri="{FF2B5EF4-FFF2-40B4-BE49-F238E27FC236}">
-                <a16:creationId xmlns:a16="http://schemas.microsoft.com/office/drawing/2014/main" id="{77F5FAE0-80CD-4FE1-A26F-853C56D03AE3}"/>
+          <p:cNvPr id="50" name="research-step-text">
+            <a:extLst xmlns:a="http://schemas.openxmlformats.org/drawingml/2006/main">
+              <a:ext uri="{FF2B5EF4-FFF2-40B4-BE49-F238E27FC236}">
+                <a16:creationId xmlns:a16="http://schemas.microsoft.com/office/drawing/2014/main" id="{B72EDDC3-9B36-4239-9390-9EE3900FAB4B}"/>
               </a:ext>
             </a:extLst>
           </p:cNvPr>
@@ -3155,14 +3190,14 @@
             <a:pPr algn="ctr">
               <a:defRPr sz="750" b="1">
                 <a:solidFill>
-                  <a:srgbClr val="FFFDF8"/>
+                  <a:srgbClr val="FFFFFF"/>
                 </a:solidFill>
               </a:defRPr>
             </a:pPr>
             <a:r>
               <a:rPr sz="750" b="1">
                 <a:solidFill>
-                  <a:srgbClr val="FFFDF8"/>
+                  <a:srgbClr val="FFFFFF"/>
                 </a:solidFill>
               </a:rPr>
               <a:t>2</a:t>
@@ -3172,10 +3207,10 @@
       </p:sp>
       <p:sp>
         <p:nvSpPr>
-          <p:cNvPr id="50" name="research-title">
-            <a:extLst xmlns:a="http://schemas.openxmlformats.org/drawingml/2006/main">
-              <a:ext uri="{FF2B5EF4-FFF2-40B4-BE49-F238E27FC236}">
-                <a16:creationId xmlns:a16="http://schemas.microsoft.com/office/drawing/2014/main" id="{3AAD2F59-65C1-4DE7-840D-5F4D25AFF669}"/>
+          <p:cNvPr id="51" name="research-title">
+            <a:extLst xmlns:a="http://schemas.openxmlformats.org/drawingml/2006/main">
+              <a:ext uri="{FF2B5EF4-FFF2-40B4-BE49-F238E27FC236}">
+                <a16:creationId xmlns:a16="http://schemas.microsoft.com/office/drawing/2014/main" id="{14F4A1BD-571D-4C4E-BEB3-DB54BB4BFC62}"/>
               </a:ext>
             </a:extLst>
           </p:cNvPr>
@@ -3205,14 +3240,14 @@
             <a:pPr algn="ctr">
               <a:defRPr sz="1125" b="1">
                 <a:solidFill>
-                  <a:srgbClr val="C6653E"/>
+                  <a:srgbClr val="D05A2A"/>
                 </a:solidFill>
               </a:defRPr>
             </a:pPr>
             <a:r>
               <a:rPr sz="1125" b="1">
                 <a:solidFill>
-                  <a:srgbClr val="C6653E"/>
+                  <a:srgbClr val="D05A2A"/>
                 </a:solidFill>
               </a:rPr>
               <a:t>Research</a:t>
@@ -3222,10 +3257,10 @@
       </p:sp>
       <p:sp>
         <p:nvSpPr>
-          <p:cNvPr id="51" name="research-body">
-            <a:extLst xmlns:a="http://schemas.openxmlformats.org/drawingml/2006/main">
-              <a:ext uri="{FF2B5EF4-FFF2-40B4-BE49-F238E27FC236}">
-                <a16:creationId xmlns:a16="http://schemas.microsoft.com/office/drawing/2014/main" id="{930F7966-706C-4F0B-8E4C-253A52794936}"/>
+          <p:cNvPr id="52" name="research-body">
+            <a:extLst xmlns:a="http://schemas.openxmlformats.org/drawingml/2006/main">
+              <a:ext uri="{FF2B5EF4-FFF2-40B4-BE49-F238E27FC236}">
+                <a16:creationId xmlns:a16="http://schemas.microsoft.com/office/drawing/2014/main" id="{64878537-8B09-4D6C-A24D-3ED31EE04DF4}"/>
               </a:ext>
             </a:extLst>
           </p:cNvPr>
@@ -3255,14 +3290,14 @@
             <a:pPr algn="ctr">
               <a:defRPr sz="788" b="0">
                 <a:solidFill>
-                  <a:srgbClr val="6B665F"/>
+                  <a:srgbClr val="667085"/>
                 </a:solidFill>
               </a:defRPr>
             </a:pPr>
             <a:r>
               <a:rPr sz="788" b="0">
                 <a:solidFill>
-                  <a:srgbClr val="6B665F"/>
+                  <a:srgbClr val="667085"/>
                 </a:solidFill>
               </a:rPr>
               <a:t>asyncio.gather</a:t>
@@ -3272,14 +3307,14 @@
             <a:pPr algn="ctr">
               <a:defRPr sz="788" b="0">
                 <a:solidFill>
-                  <a:srgbClr val="6B665F"/>
+                  <a:srgbClr val="667085"/>
                 </a:solidFill>
               </a:defRPr>
             </a:pPr>
             <a:r>
               <a:rPr sz="788" b="0">
                 <a:solidFill>
-                  <a:srgbClr val="6B665F"/>
+                  <a:srgbClr val="667085"/>
                 </a:solidFill>
               </a:rPr>
               <a:t>bounded per-tool work</a:t>
@@ -3289,14 +3324,14 @@
             <a:pPr algn="ctr">
               <a:defRPr sz="788" b="0">
                 <a:solidFill>
-                  <a:srgbClr val="6B665F"/>
+                  <a:srgbClr val="667085"/>
                 </a:solidFill>
               </a:defRPr>
             </a:pPr>
             <a:r>
               <a:rPr sz="788" b="0">
                 <a:solidFill>
-                  <a:srgbClr val="6B665F"/>
+                  <a:srgbClr val="667085"/>
                 </a:solidFill>
               </a:rPr>
               <a:t>search + analyze</a:t>
@@ -3306,10 +3341,10 @@
       </p:sp>
       <p:sp>
         <p:nvSpPr>
-          <p:cNvPr id="52" name="recommend-circle">
-            <a:extLst xmlns:a="http://schemas.openxmlformats.org/drawingml/2006/main">
-              <a:ext uri="{FF2B5EF4-FFF2-40B4-BE49-F238E27FC236}">
-                <a16:creationId xmlns:a16="http://schemas.microsoft.com/office/drawing/2014/main" id="{A205DDD0-8A68-42B6-8FB8-9EE9EE25D439}"/>
+          <p:cNvPr id="53" name="recommend-circle">
+            <a:extLst xmlns:a="http://schemas.openxmlformats.org/drawingml/2006/main">
+              <a:ext uri="{FF2B5EF4-FFF2-40B4-BE49-F238E27FC236}">
+                <a16:creationId xmlns:a16="http://schemas.microsoft.com/office/drawing/2014/main" id="{7D386C9F-175C-450C-BED1-1C1EE4140BD2}"/>
               </a:ext>
             </a:extLst>
           </p:cNvPr>
@@ -3327,11 +3362,11 @@
             <a:avLst/>
           </a:prstGeom>
           <a:solidFill xmlns:a="http://schemas.openxmlformats.org/drawingml/2006/main">
-            <a:srgbClr val="EAE0EB"/>
+            <a:srgbClr val="E8EDF1"/>
           </a:solidFill>
           <a:ln xmlns:a="http://schemas.openxmlformats.org/drawingml/2006/main" w="16193">
             <a:solidFill>
-              <a:srgbClr val="6D536F"/>
+              <a:srgbClr val="24384C"/>
             </a:solidFill>
             <a:prstDash val="solid"/>
           </a:ln>
@@ -3339,10 +3374,10 @@
       </p:sp>
       <p:sp>
         <p:nvSpPr>
-          <p:cNvPr id="53" name="recommend-step">
-            <a:extLst xmlns:a="http://schemas.openxmlformats.org/drawingml/2006/main">
-              <a:ext uri="{FF2B5EF4-FFF2-40B4-BE49-F238E27FC236}">
-                <a16:creationId xmlns:a16="http://schemas.microsoft.com/office/drawing/2014/main" id="{80915262-16E1-4117-B293-3E9FD1DE5A03}"/>
+          <p:cNvPr id="54" name="recommend-step">
+            <a:extLst xmlns:a="http://schemas.openxmlformats.org/drawingml/2006/main">
+              <a:ext uri="{FF2B5EF4-FFF2-40B4-BE49-F238E27FC236}">
+                <a16:creationId xmlns:a16="http://schemas.microsoft.com/office/drawing/2014/main" id="{F12C7241-A210-4FDE-B181-47618DDD0D17}"/>
               </a:ext>
             </a:extLst>
           </p:cNvPr>
@@ -3360,11 +3395,11 @@
             <a:avLst/>
           </a:prstGeom>
           <a:solidFill xmlns:a="http://schemas.openxmlformats.org/drawingml/2006/main">
-            <a:srgbClr val="6D536F"/>
+            <a:srgbClr val="24384C"/>
           </a:solidFill>
           <a:ln xmlns:a="http://schemas.openxmlformats.org/drawingml/2006/main" w="0">
             <a:solidFill>
-              <a:srgbClr val="6D536F"/>
+              <a:srgbClr val="24384C"/>
             </a:solidFill>
             <a:prstDash val="solid"/>
           </a:ln>
@@ -3372,10 +3407,10 @@
       </p:sp>
       <p:sp>
         <p:nvSpPr>
-          <p:cNvPr id="54" name="recommend-step-text">
-            <a:extLst xmlns:a="http://schemas.openxmlformats.org/drawingml/2006/main">
-              <a:ext uri="{FF2B5EF4-FFF2-40B4-BE49-F238E27FC236}">
-                <a16:creationId xmlns:a16="http://schemas.microsoft.com/office/drawing/2014/main" id="{7742FB5D-C4E1-4917-8EF9-FA154753B031}"/>
+          <p:cNvPr id="55" name="recommend-step-text">
+            <a:extLst xmlns:a="http://schemas.openxmlformats.org/drawingml/2006/main">
+              <a:ext uri="{FF2B5EF4-FFF2-40B4-BE49-F238E27FC236}">
+                <a16:creationId xmlns:a16="http://schemas.microsoft.com/office/drawing/2014/main" id="{F2F718BF-3748-4A83-AEB2-FCF4DB74B41E}"/>
               </a:ext>
             </a:extLst>
           </p:cNvPr>
@@ -3405,14 +3440,14 @@
             <a:pPr algn="ctr">
               <a:defRPr sz="750" b="1">
                 <a:solidFill>
-                  <a:srgbClr val="FFFDF8"/>
+                  <a:srgbClr val="FFFFFF"/>
                 </a:solidFill>
               </a:defRPr>
             </a:pPr>
             <a:r>
               <a:rPr sz="750" b="1">
                 <a:solidFill>
-                  <a:srgbClr val="FFFDF8"/>
+                  <a:srgbClr val="FFFFFF"/>
                 </a:solidFill>
               </a:rPr>
               <a:t>3</a:t>
@@ -3422,10 +3457,10 @@
       </p:sp>
       <p:sp>
         <p:nvSpPr>
-          <p:cNvPr id="55" name="recommend-title">
-            <a:extLst xmlns:a="http://schemas.openxmlformats.org/drawingml/2006/main">
-              <a:ext uri="{FF2B5EF4-FFF2-40B4-BE49-F238E27FC236}">
-                <a16:creationId xmlns:a16="http://schemas.microsoft.com/office/drawing/2014/main" id="{AD376469-67E6-4596-981D-DD60D5DBDD78}"/>
+          <p:cNvPr id="56" name="recommend-title">
+            <a:extLst xmlns:a="http://schemas.openxmlformats.org/drawingml/2006/main">
+              <a:ext uri="{FF2B5EF4-FFF2-40B4-BE49-F238E27FC236}">
+                <a16:creationId xmlns:a16="http://schemas.microsoft.com/office/drawing/2014/main" id="{CC13FF2A-DBD3-4089-8587-48F5BCDA3F2A}"/>
               </a:ext>
             </a:extLst>
           </p:cNvPr>
@@ -3460,10 +3495,10 @@
       </p:sp>
       <p:sp>
         <p:nvSpPr>
-          <p:cNvPr id="56" name="recommend-body">
-            <a:extLst xmlns:a="http://schemas.openxmlformats.org/drawingml/2006/main">
-              <a:ext uri="{FF2B5EF4-FFF2-40B4-BE49-F238E27FC236}">
-                <a16:creationId xmlns:a16="http://schemas.microsoft.com/office/drawing/2014/main" id="{84E23C81-9CA1-4F75-819E-79A91BBCFC61}"/>
+          <p:cNvPr id="57" name="recommend-body">
+            <a:extLst xmlns:a="http://schemas.openxmlformats.org/drawingml/2006/main">
+              <a:ext uri="{FF2B5EF4-FFF2-40B4-BE49-F238E27FC236}">
+                <a16:creationId xmlns:a16="http://schemas.microsoft.com/office/drawing/2014/main" id="{86DA6ED6-20AE-4671-9C74-1EEFABEDE5A0}"/>
               </a:ext>
             </a:extLst>
           </p:cNvPr>
@@ -3493,14 +3528,14 @@
             <a:pPr algn="ctr">
               <a:defRPr sz="788" b="0">
                 <a:solidFill>
-                  <a:srgbClr val="6B665F"/>
+                  <a:srgbClr val="667085"/>
                 </a:solidFill>
               </a:defRPr>
             </a:pPr>
             <a:r>
               <a:rPr sz="788" b="0">
                 <a:solidFill>
-                  <a:srgbClr val="6B665F"/>
+                  <a:srgbClr val="667085"/>
                 </a:solidFill>
               </a:rPr>
               <a:t>validated ToolReport[]</a:t>
@@ -3510,14 +3545,14 @@
             <a:pPr algn="ctr">
               <a:defRPr sz="788" b="0">
                 <a:solidFill>
-                  <a:srgbClr val="6B665F"/>
+                  <a:srgbClr val="667085"/>
                 </a:solidFill>
               </a:defRPr>
             </a:pPr>
             <a:r>
               <a:rPr sz="788" b="0">
                 <a:solidFill>
-                  <a:srgbClr val="6B665F"/>
+                  <a:srgbClr val="667085"/>
                 </a:solidFill>
               </a:rPr>
               <a:t>neutral fallback</a:t>
@@ -3527,14 +3562,14 @@
             <a:pPr algn="ctr">
               <a:defRPr sz="788" b="0">
                 <a:solidFill>
-                  <a:srgbClr val="6B665F"/>
+                  <a:srgbClr val="667085"/>
                 </a:solidFill>
               </a:defRPr>
             </a:pPr>
             <a:r>
               <a:rPr sz="788" b="0">
                 <a:solidFill>
-                  <a:srgbClr val="6B665F"/>
+                  <a:srgbClr val="667085"/>
                 </a:solidFill>
               </a:rPr>
               <a:t>on provider failure</a:t>
@@ -3544,10 +3579,10 @@
       </p:sp>
       <p:sp>
         <p:nvSpPr>
-          <p:cNvPr id="57" name="recommend-title-fix">
-            <a:extLst xmlns:a="http://schemas.openxmlformats.org/drawingml/2006/main">
-              <a:ext uri="{FF2B5EF4-FFF2-40B4-BE49-F238E27FC236}">
-                <a16:creationId xmlns:a16="http://schemas.microsoft.com/office/drawing/2014/main" id="{4FD308D2-598B-4AFA-809C-231D6DB2D17F}"/>
+          <p:cNvPr id="58" name="recommend-title-fix">
+            <a:extLst xmlns:a="http://schemas.openxmlformats.org/drawingml/2006/main">
+              <a:ext uri="{FF2B5EF4-FFF2-40B4-BE49-F238E27FC236}">
+                <a16:creationId xmlns:a16="http://schemas.microsoft.com/office/drawing/2014/main" id="{464B8B6A-BA82-4DE4-8C9A-8DD25EEDD833}"/>
               </a:ext>
             </a:extLst>
           </p:cNvPr>
@@ -3577,14 +3612,14 @@
             <a:pPr algn="ctr">
               <a:defRPr sz="975" b="1">
                 <a:solidFill>
-                  <a:srgbClr val="6D536F"/>
+                  <a:srgbClr val="24384C"/>
                 </a:solidFill>
               </a:defRPr>
             </a:pPr>
             <a:r>
               <a:rPr sz="975" b="1">
                 <a:solidFill>
-                  <a:srgbClr val="6D536F"/>
+                  <a:srgbClr val="24384C"/>
                 </a:solidFill>
               </a:rPr>
               <a:t>Recommend</a:t>
@@ -3594,10 +3629,10 @@
       </p:sp>
       <p:sp>
         <p:nvSpPr>
-          <p:cNvPr id="58" name="fanout-label">
-            <a:extLst xmlns:a="http://schemas.openxmlformats.org/drawingml/2006/main">
-              <a:ext uri="{FF2B5EF4-FFF2-40B4-BE49-F238E27FC236}">
-                <a16:creationId xmlns:a16="http://schemas.microsoft.com/office/drawing/2014/main" id="{7989EEEC-EE37-4A57-AC2E-6FFECC9136E3}"/>
+          <p:cNvPr id="59" name="fanout-label">
+            <a:extLst xmlns:a="http://schemas.openxmlformats.org/drawingml/2006/main">
+              <a:ext uri="{FF2B5EF4-FFF2-40B4-BE49-F238E27FC236}">
+                <a16:creationId xmlns:a16="http://schemas.microsoft.com/office/drawing/2014/main" id="{DAEBA156-07FA-4DE6-AADD-71401E3A94A7}"/>
               </a:ext>
             </a:extLst>
           </p:cNvPr>
@@ -3627,14 +3662,14 @@
             <a:pPr algn="ctr">
               <a:defRPr sz="788" b="1">
                 <a:solidFill>
-                  <a:srgbClr val="C6653E"/>
+                  <a:srgbClr val="D05A2A"/>
                 </a:solidFill>
               </a:defRPr>
             </a:pPr>
             <a:r>
               <a:rPr sz="788" b="1">
                 <a:solidFill>
-                  <a:srgbClr val="C6653E"/>
+                  <a:srgbClr val="D05A2A"/>
                 </a:solidFill>
               </a:rPr>
               <a:t>parallel tool workers</a:t>
@@ -3644,10 +3679,10 @@
       </p:sp>
       <p:sp>
         <p:nvSpPr>
-          <p:cNvPr id="59" name="tool-0">
-            <a:extLst xmlns:a="http://schemas.openxmlformats.org/drawingml/2006/main">
-              <a:ext uri="{FF2B5EF4-FFF2-40B4-BE49-F238E27FC236}">
-                <a16:creationId xmlns:a16="http://schemas.microsoft.com/office/drawing/2014/main" id="{46B3DF49-540E-4B05-B8C8-86E517CED8B8}"/>
+          <p:cNvPr id="60" name="tool-0">
+            <a:extLst xmlns:a="http://schemas.openxmlformats.org/drawingml/2006/main">
+              <a:ext uri="{FF2B5EF4-FFF2-40B4-BE49-F238E27FC236}">
+                <a16:creationId xmlns:a16="http://schemas.microsoft.com/office/drawing/2014/main" id="{859381FD-DE78-4426-9D78-02D9A8E0714B}"/>
               </a:ext>
             </a:extLst>
           </p:cNvPr>
@@ -3665,11 +3700,11 @@
             <a:avLst/>
           </a:prstGeom>
           <a:solidFill xmlns:a="http://schemas.openxmlformats.org/drawingml/2006/main">
-            <a:srgbClr val="FFFDF8"/>
+            <a:srgbClr val="FFFFFF"/>
           </a:solidFill>
           <a:ln xmlns:a="http://schemas.openxmlformats.org/drawingml/2006/main" w="12383">
             <a:solidFill>
-              <a:srgbClr val="C6653E"/>
+              <a:srgbClr val="D05A2A"/>
             </a:solidFill>
             <a:prstDash val="solid"/>
           </a:ln>
@@ -3677,10 +3712,10 @@
       </p:sp>
       <p:sp>
         <p:nvSpPr>
-          <p:cNvPr id="60" name="tool-0-title">
-            <a:extLst xmlns:a="http://schemas.openxmlformats.org/drawingml/2006/main">
-              <a:ext uri="{FF2B5EF4-FFF2-40B4-BE49-F238E27FC236}">
-                <a16:creationId xmlns:a16="http://schemas.microsoft.com/office/drawing/2014/main" id="{194EA016-28BA-41D8-823A-5778B5EA4247}"/>
+          <p:cNvPr id="61" name="tool-0-title">
+            <a:extLst xmlns:a="http://schemas.openxmlformats.org/drawingml/2006/main">
+              <a:ext uri="{FF2B5EF4-FFF2-40B4-BE49-F238E27FC236}">
+                <a16:creationId xmlns:a16="http://schemas.microsoft.com/office/drawing/2014/main" id="{FE3410AF-C8BF-4F7F-9526-8C1A9B2E4799}"/>
               </a:ext>
             </a:extLst>
           </p:cNvPr>
@@ -3710,14 +3745,14 @@
             <a:pPr algn="ctr">
               <a:defRPr sz="863" b="1">
                 <a:solidFill>
-                  <a:srgbClr val="24211D"/>
+                  <a:srgbClr val="1C2430"/>
                 </a:solidFill>
               </a:defRPr>
             </a:pPr>
             <a:r>
               <a:rPr sz="863" b="1">
                 <a:solidFill>
-                  <a:srgbClr val="24211D"/>
+                  <a:srgbClr val="1C2430"/>
                 </a:solidFill>
               </a:rPr>
               <a:t>tool A</a:t>
@@ -3727,10 +3762,10 @@
       </p:sp>
       <p:sp>
         <p:nvSpPr>
-          <p:cNvPr id="61" name="tool-0-copy">
-            <a:extLst xmlns:a="http://schemas.openxmlformats.org/drawingml/2006/main">
-              <a:ext uri="{FF2B5EF4-FFF2-40B4-BE49-F238E27FC236}">
-                <a16:creationId xmlns:a16="http://schemas.microsoft.com/office/drawing/2014/main" id="{FDA68FB3-1131-4E89-9E86-D301D78F866B}"/>
+          <p:cNvPr id="62" name="tool-0-copy">
+            <a:extLst xmlns:a="http://schemas.openxmlformats.org/drawingml/2006/main">
+              <a:ext uri="{FF2B5EF4-FFF2-40B4-BE49-F238E27FC236}">
+                <a16:creationId xmlns:a16="http://schemas.microsoft.com/office/drawing/2014/main" id="{ED04F68A-BA83-47C0-9308-F50782F11FD4}"/>
               </a:ext>
             </a:extLst>
           </p:cNvPr>
@@ -3760,14 +3795,14 @@
             <a:pPr algn="ctr">
               <a:defRPr sz="713" b="0">
                 <a:solidFill>
-                  <a:srgbClr val="6B665F"/>
+                  <a:srgbClr val="667085"/>
                 </a:solidFill>
               </a:defRPr>
             </a:pPr>
             <a:r>
               <a:rPr sz="713" b="0">
                 <a:solidFill>
-                  <a:srgbClr val="6B665F"/>
+                  <a:srgbClr val="667085"/>
                 </a:solidFill>
               </a:rPr>
               <a:t>search</a:t>
@@ -3777,14 +3812,14 @@
             <a:pPr algn="ctr">
               <a:defRPr sz="713" b="0">
                 <a:solidFill>
-                  <a:srgbClr val="6B665F"/>
+                  <a:srgbClr val="667085"/>
                 </a:solidFill>
               </a:defRPr>
             </a:pPr>
             <a:r>
               <a:rPr sz="713" b="0">
                 <a:solidFill>
-                  <a:srgbClr val="6B665F"/>
+                  <a:srgbClr val="667085"/>
                 </a:solidFill>
               </a:rPr>
               <a:t>+ analyze</a:t>
@@ -3794,10 +3829,10 @@
       </p:sp>
       <p:sp>
         <p:nvSpPr>
-          <p:cNvPr id="62" name="tool-1">
-            <a:extLst xmlns:a="http://schemas.openxmlformats.org/drawingml/2006/main">
-              <a:ext uri="{FF2B5EF4-FFF2-40B4-BE49-F238E27FC236}">
-                <a16:creationId xmlns:a16="http://schemas.microsoft.com/office/drawing/2014/main" id="{B659195A-ED33-4CB8-84C9-71DF8F493382}"/>
+          <p:cNvPr id="63" name="tool-1">
+            <a:extLst xmlns:a="http://schemas.openxmlformats.org/drawingml/2006/main">
+              <a:ext uri="{FF2B5EF4-FFF2-40B4-BE49-F238E27FC236}">
+                <a16:creationId xmlns:a16="http://schemas.microsoft.com/office/drawing/2014/main" id="{14B7C9A1-3655-4933-95D8-6E1EB2F016DF}"/>
               </a:ext>
             </a:extLst>
           </p:cNvPr>
@@ -3815,11 +3850,11 @@
             <a:avLst/>
           </a:prstGeom>
           <a:solidFill xmlns:a="http://schemas.openxmlformats.org/drawingml/2006/main">
-            <a:srgbClr val="FFFDF8"/>
+            <a:srgbClr val="FFFFFF"/>
           </a:solidFill>
           <a:ln xmlns:a="http://schemas.openxmlformats.org/drawingml/2006/main" w="12383">
             <a:solidFill>
-              <a:srgbClr val="C6653E"/>
+              <a:srgbClr val="D05A2A"/>
             </a:solidFill>
             <a:prstDash val="solid"/>
           </a:ln>
@@ -3827,10 +3862,10 @@
       </p:sp>
       <p:sp>
         <p:nvSpPr>
-          <p:cNvPr id="63" name="tool-1-title">
-            <a:extLst xmlns:a="http://schemas.openxmlformats.org/drawingml/2006/main">
-              <a:ext uri="{FF2B5EF4-FFF2-40B4-BE49-F238E27FC236}">
-                <a16:creationId xmlns:a16="http://schemas.microsoft.com/office/drawing/2014/main" id="{3435F7E0-F58F-4F0C-891E-CD4B1B70A95C}"/>
+          <p:cNvPr id="64" name="tool-1-title">
+            <a:extLst xmlns:a="http://schemas.openxmlformats.org/drawingml/2006/main">
+              <a:ext uri="{FF2B5EF4-FFF2-40B4-BE49-F238E27FC236}">
+                <a16:creationId xmlns:a16="http://schemas.microsoft.com/office/drawing/2014/main" id="{5E857C58-37F9-44F8-B0DF-015F78A912D4}"/>
               </a:ext>
             </a:extLst>
           </p:cNvPr>
@@ -3860,14 +3895,14 @@
             <a:pPr algn="ctr">
               <a:defRPr sz="863" b="1">
                 <a:solidFill>
-                  <a:srgbClr val="24211D"/>
+                  <a:srgbClr val="1C2430"/>
                 </a:solidFill>
               </a:defRPr>
             </a:pPr>
             <a:r>
               <a:rPr sz="863" b="1">
                 <a:solidFill>
-                  <a:srgbClr val="24211D"/>
+                  <a:srgbClr val="1C2430"/>
                 </a:solidFill>
               </a:rPr>
               <a:t>tool B</a:t>
@@ -3877,10 +3912,10 @@
       </p:sp>
       <p:sp>
         <p:nvSpPr>
-          <p:cNvPr id="64" name="tool-1-copy">
-            <a:extLst xmlns:a="http://schemas.openxmlformats.org/drawingml/2006/main">
-              <a:ext uri="{FF2B5EF4-FFF2-40B4-BE49-F238E27FC236}">
-                <a16:creationId xmlns:a16="http://schemas.microsoft.com/office/drawing/2014/main" id="{415EB914-A69A-45FE-A1CA-34DBCC38245F}"/>
+          <p:cNvPr id="65" name="tool-1-copy">
+            <a:extLst xmlns:a="http://schemas.openxmlformats.org/drawingml/2006/main">
+              <a:ext uri="{FF2B5EF4-FFF2-40B4-BE49-F238E27FC236}">
+                <a16:creationId xmlns:a16="http://schemas.microsoft.com/office/drawing/2014/main" id="{45F6906A-789C-493C-81EF-5D084D965F61}"/>
               </a:ext>
             </a:extLst>
           </p:cNvPr>
@@ -3910,14 +3945,14 @@
             <a:pPr algn="ctr">
               <a:defRPr sz="713" b="0">
                 <a:solidFill>
-                  <a:srgbClr val="6B665F"/>
+                  <a:srgbClr val="667085"/>
                 </a:solidFill>
               </a:defRPr>
             </a:pPr>
             <a:r>
               <a:rPr sz="713" b="0">
                 <a:solidFill>
-                  <a:srgbClr val="6B665F"/>
+                  <a:srgbClr val="667085"/>
                 </a:solidFill>
               </a:rPr>
               <a:t>search</a:t>
@@ -3927,14 +3962,14 @@
             <a:pPr algn="ctr">
               <a:defRPr sz="713" b="0">
                 <a:solidFill>
-                  <a:srgbClr val="6B665F"/>
+                  <a:srgbClr val="667085"/>
                 </a:solidFill>
               </a:defRPr>
             </a:pPr>
             <a:r>
               <a:rPr sz="713" b="0">
                 <a:solidFill>
-                  <a:srgbClr val="6B665F"/>
+                  <a:srgbClr val="667085"/>
                 </a:solidFill>
               </a:rPr>
               <a:t>+ analyze</a:t>
@@ -3944,10 +3979,10 @@
       </p:sp>
       <p:sp>
         <p:nvSpPr>
-          <p:cNvPr id="65" name="tool-2">
-            <a:extLst xmlns:a="http://schemas.openxmlformats.org/drawingml/2006/main">
-              <a:ext uri="{FF2B5EF4-FFF2-40B4-BE49-F238E27FC236}">
-                <a16:creationId xmlns:a16="http://schemas.microsoft.com/office/drawing/2014/main" id="{0ED1036D-B660-44D0-93B2-8F4693C0AF11}"/>
+          <p:cNvPr id="66" name="tool-2">
+            <a:extLst xmlns:a="http://schemas.openxmlformats.org/drawingml/2006/main">
+              <a:ext uri="{FF2B5EF4-FFF2-40B4-BE49-F238E27FC236}">
+                <a16:creationId xmlns:a16="http://schemas.microsoft.com/office/drawing/2014/main" id="{E14239CC-DA53-4EE9-A5C8-CED39F36DF21}"/>
               </a:ext>
             </a:extLst>
           </p:cNvPr>
@@ -3965,11 +4000,11 @@
             <a:avLst/>
           </a:prstGeom>
           <a:solidFill xmlns:a="http://schemas.openxmlformats.org/drawingml/2006/main">
-            <a:srgbClr val="FFFDF8"/>
+            <a:srgbClr val="FFFFFF"/>
           </a:solidFill>
           <a:ln xmlns:a="http://schemas.openxmlformats.org/drawingml/2006/main" w="12383">
             <a:solidFill>
-              <a:srgbClr val="C6653E"/>
+              <a:srgbClr val="D05A2A"/>
             </a:solidFill>
             <a:prstDash val="solid"/>
           </a:ln>
@@ -3977,10 +4012,10 @@
       </p:sp>
       <p:sp>
         <p:nvSpPr>
-          <p:cNvPr id="66" name="tool-2-title">
-            <a:extLst xmlns:a="http://schemas.openxmlformats.org/drawingml/2006/main">
-              <a:ext uri="{FF2B5EF4-FFF2-40B4-BE49-F238E27FC236}">
-                <a16:creationId xmlns:a16="http://schemas.microsoft.com/office/drawing/2014/main" id="{69940375-97BB-4C47-A13B-7C23674F2B08}"/>
+          <p:cNvPr id="67" name="tool-2-title">
+            <a:extLst xmlns:a="http://schemas.openxmlformats.org/drawingml/2006/main">
+              <a:ext uri="{FF2B5EF4-FFF2-40B4-BE49-F238E27FC236}">
+                <a16:creationId xmlns:a16="http://schemas.microsoft.com/office/drawing/2014/main" id="{040741A6-1775-408D-B8BC-AF131FE26B4E}"/>
               </a:ext>
             </a:extLst>
           </p:cNvPr>
@@ -4010,14 +4045,14 @@
             <a:pPr algn="ctr">
               <a:defRPr sz="863" b="1">
                 <a:solidFill>
-                  <a:srgbClr val="24211D"/>
+                  <a:srgbClr val="1C2430"/>
                 </a:solidFill>
               </a:defRPr>
             </a:pPr>
             <a:r>
               <a:rPr sz="863" b="1">
                 <a:solidFill>
-                  <a:srgbClr val="24211D"/>
+                  <a:srgbClr val="1C2430"/>
                 </a:solidFill>
               </a:rPr>
               <a:t>tool N</a:t>
@@ -4027,10 +4062,10 @@
       </p:sp>
       <p:sp>
         <p:nvSpPr>
-          <p:cNvPr id="67" name="tool-2-copy">
-            <a:extLst xmlns:a="http://schemas.openxmlformats.org/drawingml/2006/main">
-              <a:ext uri="{FF2B5EF4-FFF2-40B4-BE49-F238E27FC236}">
-                <a16:creationId xmlns:a16="http://schemas.microsoft.com/office/drawing/2014/main" id="{A9360F6E-DE66-46DE-9E56-84C0A13D73B7}"/>
+          <p:cNvPr id="68" name="tool-2-copy">
+            <a:extLst xmlns:a="http://schemas.openxmlformats.org/drawingml/2006/main">
+              <a:ext uri="{FF2B5EF4-FFF2-40B4-BE49-F238E27FC236}">
+                <a16:creationId xmlns:a16="http://schemas.microsoft.com/office/drawing/2014/main" id="{66787634-ACA9-4DD3-9695-55094DAA99B2}"/>
               </a:ext>
             </a:extLst>
           </p:cNvPr>
@@ -4060,14 +4095,14 @@
             <a:pPr algn="ctr">
               <a:defRPr sz="713" b="0">
                 <a:solidFill>
-                  <a:srgbClr val="6B665F"/>
+                  <a:srgbClr val="667085"/>
                 </a:solidFill>
               </a:defRPr>
             </a:pPr>
             <a:r>
               <a:rPr sz="713" b="0">
                 <a:solidFill>
-                  <a:srgbClr val="6B665F"/>
+                  <a:srgbClr val="667085"/>
                 </a:solidFill>
               </a:rPr>
               <a:t>search</a:t>
@@ -4077,14 +4112,14 @@
             <a:pPr algn="ctr">
               <a:defRPr sz="713" b="0">
                 <a:solidFill>
-                  <a:srgbClr val="6B665F"/>
+                  <a:srgbClr val="667085"/>
                 </a:solidFill>
               </a:defRPr>
             </a:pPr>
             <a:r>
               <a:rPr sz="713" b="0">
                 <a:solidFill>
-                  <a:srgbClr val="6B665F"/>
+                  <a:srgbClr val="667085"/>
                 </a:solidFill>
               </a:rPr>
               <a:t>+ analyze</a:t>
@@ -4094,10 +4129,10 @@
       </p:sp>
       <p:sp>
         <p:nvSpPr>
-          <p:cNvPr id="68" name="tool-report">
-            <a:extLst xmlns:a="http://schemas.openxmlformats.org/drawingml/2006/main">
-              <a:ext uri="{FF2B5EF4-FFF2-40B4-BE49-F238E27FC236}">
-                <a16:creationId xmlns:a16="http://schemas.microsoft.com/office/drawing/2014/main" id="{5776A80B-EE85-4201-BB17-8AA828A2725C}"/>
+          <p:cNvPr id="69" name="tool-report">
+            <a:extLst xmlns:a="http://schemas.openxmlformats.org/drawingml/2006/main">
+              <a:ext uri="{FF2B5EF4-FFF2-40B4-BE49-F238E27FC236}">
+                <a16:creationId xmlns:a16="http://schemas.microsoft.com/office/drawing/2014/main" id="{5B581054-6438-44BC-BB7E-B3C5005732C6}"/>
               </a:ext>
             </a:extLst>
           </p:cNvPr>
@@ -4117,11 +4152,11 @@
             </a:avLst>
           </a:prstGeom>
           <a:solidFill xmlns:a="http://schemas.openxmlformats.org/drawingml/2006/main">
-            <a:srgbClr val="FFFDF8"/>
+            <a:srgbClr val="FFFFFF"/>
           </a:solidFill>
           <a:ln xmlns:a="http://schemas.openxmlformats.org/drawingml/2006/main" w="14288">
             <a:solidFill>
-              <a:srgbClr val="6D536F"/>
+              <a:srgbClr val="24384C"/>
             </a:solidFill>
             <a:prstDash val="solid"/>
           </a:ln>
@@ -4129,10 +4164,10 @@
       </p:sp>
       <p:sp>
         <p:nvSpPr>
-          <p:cNvPr id="69" name="tool-report-title">
-            <a:extLst xmlns:a="http://schemas.openxmlformats.org/drawingml/2006/main">
-              <a:ext uri="{FF2B5EF4-FFF2-40B4-BE49-F238E27FC236}">
-                <a16:creationId xmlns:a16="http://schemas.microsoft.com/office/drawing/2014/main" id="{B6F20F6D-B0B5-4A20-94B8-F2F6925E9186}"/>
+          <p:cNvPr id="70" name="tool-report-title">
+            <a:extLst xmlns:a="http://schemas.openxmlformats.org/drawingml/2006/main">
+              <a:ext uri="{FF2B5EF4-FFF2-40B4-BE49-F238E27FC236}">
+                <a16:creationId xmlns:a16="http://schemas.microsoft.com/office/drawing/2014/main" id="{FEC05AED-5A91-468D-944C-3F7FB878193E}"/>
               </a:ext>
             </a:extLst>
           </p:cNvPr>
@@ -4162,14 +4197,14 @@
             <a:pPr algn="ctr">
               <a:defRPr sz="938" b="1">
                 <a:solidFill>
-                  <a:srgbClr val="6D536F"/>
+                  <a:srgbClr val="24384C"/>
                 </a:solidFill>
               </a:defRPr>
             </a:pPr>
             <a:r>
               <a:rPr sz="938" b="1">
                 <a:solidFill>
-                  <a:srgbClr val="6D536F"/>
+                  <a:srgbClr val="24384C"/>
                 </a:solidFill>
               </a:rPr>
               <a:t>ToolReport[]</a:t>
@@ -4179,10 +4214,10 @@
       </p:sp>
       <p:sp>
         <p:nvSpPr>
-          <p:cNvPr id="70" name="tool-report-copy">
-            <a:extLst xmlns:a="http://schemas.openxmlformats.org/drawingml/2006/main">
-              <a:ext uri="{FF2B5EF4-FFF2-40B4-BE49-F238E27FC236}">
-                <a16:creationId xmlns:a16="http://schemas.microsoft.com/office/drawing/2014/main" id="{40F95BC2-39E1-4829-8481-DBED4BCF1B84}"/>
+          <p:cNvPr id="71" name="tool-report-copy">
+            <a:extLst xmlns:a="http://schemas.openxmlformats.org/drawingml/2006/main">
+              <a:ext uri="{FF2B5EF4-FFF2-40B4-BE49-F238E27FC236}">
+                <a16:creationId xmlns:a16="http://schemas.microsoft.com/office/drawing/2014/main" id="{C7BF6E6C-1847-4ABF-952F-6D5C86D84662}"/>
               </a:ext>
             </a:extLst>
           </p:cNvPr>
@@ -4212,14 +4247,14 @@
             <a:pPr algn="ctr">
               <a:defRPr sz="653" b="0">
                 <a:solidFill>
-                  <a:srgbClr val="6B665F"/>
+                  <a:srgbClr val="667085"/>
                 </a:solidFill>
               </a:defRPr>
             </a:pPr>
             <a:r>
               <a:rPr sz="653" b="0">
                 <a:solidFill>
-                  <a:srgbClr val="6B665F"/>
+                  <a:srgbClr val="667085"/>
                 </a:solidFill>
               </a:rPr>
               <a:t>unknown IDs rejected</a:t>
@@ -4229,10 +4264,10 @@
       </p:sp>
       <p:sp>
         <p:nvSpPr>
-          <p:cNvPr id="71" name="public-url-note">
-            <a:extLst xmlns:a="http://schemas.openxmlformats.org/drawingml/2006/main">
-              <a:ext uri="{FF2B5EF4-FFF2-40B4-BE49-F238E27FC236}">
-                <a16:creationId xmlns:a16="http://schemas.microsoft.com/office/drawing/2014/main" id="{2AA53233-E986-4EB8-90E9-F0FCC392AD09}"/>
+          <p:cNvPr id="72" name="public-url-note">
+            <a:extLst xmlns:a="http://schemas.openxmlformats.org/drawingml/2006/main">
+              <a:ext uri="{FF2B5EF4-FFF2-40B4-BE49-F238E27FC236}">
+                <a16:creationId xmlns:a16="http://schemas.microsoft.com/office/drawing/2014/main" id="{9088C41B-ECAC-4D13-AC90-72DCA60F5BDA}"/>
               </a:ext>
             </a:extLst>
           </p:cNvPr>
@@ -4252,11 +4287,11 @@
             </a:avLst>
           </a:prstGeom>
           <a:solidFill xmlns:a="http://schemas.openxmlformats.org/drawingml/2006/main">
-            <a:srgbClr val="E6E0D5"/>
+            <a:srgbClr val="F2F2EF"/>
           </a:solidFill>
           <a:ln xmlns:a="http://schemas.openxmlformats.org/drawingml/2006/main" w="9525">
             <a:solidFill>
-              <a:srgbClr val="B9B0A2"/>
+              <a:srgbClr val="C9CED6"/>
             </a:solidFill>
             <a:prstDash val="solid"/>
           </a:ln>
@@ -4264,10 +4299,10 @@
       </p:sp>
       <p:sp>
         <p:nvSpPr>
-          <p:cNvPr id="72" name="public-url-head">
-            <a:extLst xmlns:a="http://schemas.openxmlformats.org/drawingml/2006/main">
-              <a:ext uri="{FF2B5EF4-FFF2-40B4-BE49-F238E27FC236}">
-                <a16:creationId xmlns:a16="http://schemas.microsoft.com/office/drawing/2014/main" id="{FF832F79-8D2D-46B0-9629-132C68DCE40C}"/>
+          <p:cNvPr id="73" name="public-url-head">
+            <a:extLst xmlns:a="http://schemas.openxmlformats.org/drawingml/2006/main">
+              <a:ext uri="{FF2B5EF4-FFF2-40B4-BE49-F238E27FC236}">
+                <a16:creationId xmlns:a16="http://schemas.microsoft.com/office/drawing/2014/main" id="{1A1BAFC1-B50A-481D-8FC7-D9954FD6296D}"/>
               </a:ext>
             </a:extLst>
           </p:cNvPr>
@@ -4297,14 +4332,14 @@
             <a:pPr algn="l">
               <a:defRPr sz="713" b="1">
                 <a:solidFill>
-                  <a:srgbClr val="52725D"/>
+                  <a:srgbClr val="397EA5"/>
                 </a:solidFill>
               </a:defRPr>
             </a:pPr>
             <a:r>
               <a:rPr sz="713" b="1">
                 <a:solidFill>
-                  <a:srgbClr val="52725D"/>
+                  <a:srgbClr val="397EA5"/>
                 </a:solidFill>
               </a:rPr>
               <a:t>PUBLIC URL GATE</a:t>
@@ -4314,10 +4349,10 @@
       </p:sp>
       <p:sp>
         <p:nvSpPr>
-          <p:cNvPr id="73" name="public-url-copy">
-            <a:extLst xmlns:a="http://schemas.openxmlformats.org/drawingml/2006/main">
-              <a:ext uri="{FF2B5EF4-FFF2-40B4-BE49-F238E27FC236}">
-                <a16:creationId xmlns:a16="http://schemas.microsoft.com/office/drawing/2014/main" id="{F4CF988C-5E6F-429D-8B5B-FDA154CB864E}"/>
+          <p:cNvPr id="74" name="public-url-copy">
+            <a:extLst xmlns:a="http://schemas.openxmlformats.org/drawingml/2006/main">
+              <a:ext uri="{FF2B5EF4-FFF2-40B4-BE49-F238E27FC236}">
+                <a16:creationId xmlns:a16="http://schemas.microsoft.com/office/drawing/2014/main" id="{3428B91B-FB86-4342-BE65-3B565D52E836}"/>
               </a:ext>
             </a:extLst>
           </p:cNvPr>
@@ -4347,14 +4382,14 @@
             <a:pPr algn="l">
               <a:defRPr sz="698" b="0">
                 <a:solidFill>
-                  <a:srgbClr val="6B665F"/>
+                  <a:srgbClr val="667085"/>
                 </a:solidFill>
               </a:defRPr>
             </a:pPr>
             <a:r>
               <a:rPr sz="698" b="0">
                 <a:solidFill>
-                  <a:srgbClr val="6B665F"/>
+                  <a:srgbClr val="667085"/>
                 </a:solidFill>
               </a:rPr>
               <a:t>reject local, private, reserved, or credentialed targets</a:t>
@@ -4364,10 +4399,10 @@
       </p:sp>
       <p:sp>
         <p:nvSpPr>
-          <p:cNvPr id="74" name="partial-note">
-            <a:extLst xmlns:a="http://schemas.openxmlformats.org/drawingml/2006/main">
-              <a:ext uri="{FF2B5EF4-FFF2-40B4-BE49-F238E27FC236}">
-                <a16:creationId xmlns:a16="http://schemas.microsoft.com/office/drawing/2014/main" id="{0FEE5E33-4AB3-46DB-AEE5-1E81EBF567CD}"/>
+          <p:cNvPr id="75" name="partial-note">
+            <a:extLst xmlns:a="http://schemas.openxmlformats.org/drawingml/2006/main">
+              <a:ext uri="{FF2B5EF4-FFF2-40B4-BE49-F238E27FC236}">
+                <a16:creationId xmlns:a16="http://schemas.microsoft.com/office/drawing/2014/main" id="{B7A8F808-9DB9-43C9-ACD3-4AB83BA81ED4}"/>
               </a:ext>
             </a:extLst>
           </p:cNvPr>
@@ -4387,11 +4422,11 @@
             </a:avLst>
           </a:prstGeom>
           <a:solidFill xmlns:a="http://schemas.openxmlformats.org/drawingml/2006/main">
-            <a:srgbClr val="F1DDD1"/>
+            <a:srgbClr val="FBE9E1"/>
           </a:solidFill>
           <a:ln xmlns:a="http://schemas.openxmlformats.org/drawingml/2006/main" w="9525">
             <a:solidFill>
-              <a:srgbClr val="C6653E"/>
+              <a:srgbClr val="D05A2A"/>
             </a:solidFill>
             <a:prstDash val="solid"/>
           </a:ln>
@@ -4399,10 +4434,10 @@
       </p:sp>
       <p:sp>
         <p:nvSpPr>
-          <p:cNvPr id="75" name="partial-head">
-            <a:extLst xmlns:a="http://schemas.openxmlformats.org/drawingml/2006/main">
-              <a:ext uri="{FF2B5EF4-FFF2-40B4-BE49-F238E27FC236}">
-                <a16:creationId xmlns:a16="http://schemas.microsoft.com/office/drawing/2014/main" id="{5021699A-EA0F-4874-BFEC-0B01B9F630DF}"/>
+          <p:cNvPr id="76" name="partial-head">
+            <a:extLst xmlns:a="http://schemas.openxmlformats.org/drawingml/2006/main">
+              <a:ext uri="{FF2B5EF4-FFF2-40B4-BE49-F238E27FC236}">
+                <a16:creationId xmlns:a16="http://schemas.microsoft.com/office/drawing/2014/main" id="{4A05DB06-3035-4AE6-BE93-4E1F37B5C272}"/>
               </a:ext>
             </a:extLst>
           </p:cNvPr>
@@ -4432,14 +4467,14 @@
             <a:pPr algn="l">
               <a:defRPr sz="713" b="1">
                 <a:solidFill>
-                  <a:srgbClr val="C6653E"/>
+                  <a:srgbClr val="D05A2A"/>
                 </a:solidFill>
               </a:defRPr>
             </a:pPr>
             <a:r>
               <a:rPr sz="713" b="1">
                 <a:solidFill>
-                  <a:srgbClr val="C6653E"/>
+                  <a:srgbClr val="D05A2A"/>
                 </a:solidFill>
               </a:rPr>
               <a:t>DEGRADED RUN</a:t>
@@ -4449,10 +4484,10 @@
       </p:sp>
       <p:sp>
         <p:nvSpPr>
-          <p:cNvPr id="76" name="partial-copy">
-            <a:extLst xmlns:a="http://schemas.openxmlformats.org/drawingml/2006/main">
-              <a:ext uri="{FF2B5EF4-FFF2-40B4-BE49-F238E27FC236}">
-                <a16:creationId xmlns:a16="http://schemas.microsoft.com/office/drawing/2014/main" id="{C1114DBC-60EE-46DF-9FB6-E42E16993181}"/>
+          <p:cNvPr id="77" name="partial-copy">
+            <a:extLst xmlns:a="http://schemas.openxmlformats.org/drawingml/2006/main">
+              <a:ext uri="{FF2B5EF4-FFF2-40B4-BE49-F238E27FC236}">
+                <a16:creationId xmlns:a16="http://schemas.microsoft.com/office/drawing/2014/main" id="{54F8AD4D-3A4B-4EB6-930A-7F9E02897DFB}"/>
               </a:ext>
             </a:extLst>
           </p:cNvPr>
@@ -4482,14 +4517,14 @@
             <a:pPr algn="l">
               <a:defRPr sz="698" b="0">
                 <a:solidFill>
-                  <a:srgbClr val="6B665F"/>
+                  <a:srgbClr val="667085"/>
                 </a:solidFill>
               </a:defRPr>
             </a:pPr>
             <a:r>
               <a:rPr sz="698" b="0">
                 <a:solidFill>
-                  <a:srgbClr val="6B665F"/>
+                  <a:srgbClr val="667085"/>
                 </a:solidFill>
               </a:rPr>
               <a:t>failed tools become warnings; sourced profiles continue</a:t>
@@ -4499,10 +4534,10 @@
       </p:sp>
       <p:sp>
         <p:nvSpPr>
-          <p:cNvPr id="77" name="research-report">
-            <a:extLst xmlns:a="http://schemas.openxmlformats.org/drawingml/2006/main">
-              <a:ext uri="{FF2B5EF4-FFF2-40B4-BE49-F238E27FC236}">
-                <a16:creationId xmlns:a16="http://schemas.microsoft.com/office/drawing/2014/main" id="{D829A7B3-11F5-493B-8260-38294E1D8FB1}"/>
+          <p:cNvPr id="78" name="research-report">
+            <a:extLst xmlns:a="http://schemas.openxmlformats.org/drawingml/2006/main">
+              <a:ext uri="{FF2B5EF4-FFF2-40B4-BE49-F238E27FC236}">
+                <a16:creationId xmlns:a16="http://schemas.microsoft.com/office/drawing/2014/main" id="{42AD2C90-64BE-4DB8-8B4C-0ECC4E05FF75}"/>
               </a:ext>
             </a:extLst>
           </p:cNvPr>
@@ -4522,11 +4557,11 @@
             </a:avLst>
           </a:prstGeom>
           <a:solidFill xmlns:a="http://schemas.openxmlformats.org/drawingml/2006/main">
-            <a:srgbClr val="F5E6BE"/>
+            <a:srgbClr val="FBE9E1"/>
           </a:solidFill>
           <a:ln xmlns:a="http://schemas.openxmlformats.org/drawingml/2006/main" w="16193">
             <a:solidFill>
-              <a:srgbClr val="B47A1B"/>
+              <a:srgbClr val="D05A2A"/>
             </a:solidFill>
             <a:prstDash val="solid"/>
           </a:ln>
@@ -4534,10 +4569,10 @@
       </p:sp>
       <p:sp>
         <p:nvSpPr>
-          <p:cNvPr id="78" name="report-type">
-            <a:extLst xmlns:a="http://schemas.openxmlformats.org/drawingml/2006/main">
-              <a:ext uri="{FF2B5EF4-FFF2-40B4-BE49-F238E27FC236}">
-                <a16:creationId xmlns:a16="http://schemas.microsoft.com/office/drawing/2014/main" id="{2EE9A487-D492-4F19-B453-17F4751EDEF5}"/>
+          <p:cNvPr id="79" name="report-type">
+            <a:extLst xmlns:a="http://schemas.openxmlformats.org/drawingml/2006/main">
+              <a:ext uri="{FF2B5EF4-FFF2-40B4-BE49-F238E27FC236}">
+                <a16:creationId xmlns:a16="http://schemas.microsoft.com/office/drawing/2014/main" id="{E4E320C3-0CEE-4480-8E65-684AF0787148}"/>
               </a:ext>
             </a:extLst>
           </p:cNvPr>
@@ -4567,14 +4602,14 @@
             <a:pPr algn="ctr">
               <a:defRPr sz="713" b="1">
                 <a:solidFill>
-                  <a:srgbClr val="B47A1B"/>
+                  <a:srgbClr val="D05A2A"/>
                 </a:solidFill>
               </a:defRPr>
             </a:pPr>
             <a:r>
               <a:rPr sz="713" b="1">
                 <a:solidFill>
-                  <a:srgbClr val="B47A1B"/>
+                  <a:srgbClr val="D05A2A"/>
                 </a:solidFill>
               </a:rPr>
               <a:t>STRICT OUTPUT</a:t>
@@ -4584,10 +4619,10 @@
       </p:sp>
       <p:sp>
         <p:nvSpPr>
-          <p:cNvPr id="79" name="report-title">
-            <a:extLst xmlns:a="http://schemas.openxmlformats.org/drawingml/2006/main">
-              <a:ext uri="{FF2B5EF4-FFF2-40B4-BE49-F238E27FC236}">
-                <a16:creationId xmlns:a16="http://schemas.microsoft.com/office/drawing/2014/main" id="{EE3E3D9F-388E-4D69-A942-9A0AA81785B0}"/>
+          <p:cNvPr id="80" name="report-title">
+            <a:extLst xmlns:a="http://schemas.openxmlformats.org/drawingml/2006/main">
+              <a:ext uri="{FF2B5EF4-FFF2-40B4-BE49-F238E27FC236}">
+                <a16:creationId xmlns:a16="http://schemas.microsoft.com/office/drawing/2014/main" id="{ECB8B01F-A021-40FE-A0A2-789DAAD90374}"/>
               </a:ext>
             </a:extLst>
           </p:cNvPr>
@@ -4617,14 +4652,14 @@
             <a:pPr algn="ctr">
               <a:defRPr sz="1163" b="1">
                 <a:solidFill>
-                  <a:srgbClr val="24211D"/>
+                  <a:srgbClr val="1C2430"/>
                 </a:solidFill>
               </a:defRPr>
             </a:pPr>
             <a:r>
               <a:rPr sz="1163" b="1">
                 <a:solidFill>
-                  <a:srgbClr val="24211D"/>
+                  <a:srgbClr val="1C2430"/>
                 </a:solidFill>
               </a:rPr>
               <a:t>Research</a:t>
@@ -4634,14 +4669,14 @@
             <a:pPr algn="ctr">
               <a:defRPr sz="1163" b="1">
                 <a:solidFill>
-                  <a:srgbClr val="24211D"/>
+                  <a:srgbClr val="1C2430"/>
                 </a:solidFill>
               </a:defRPr>
             </a:pPr>
             <a:r>
               <a:rPr sz="1163" b="1">
                 <a:solidFill>
-                  <a:srgbClr val="24211D"/>
+                  <a:srgbClr val="1C2430"/>
                 </a:solidFill>
               </a:rPr>
               <a:t>Report</a:t>
@@ -4651,10 +4686,10 @@
       </p:sp>
       <p:sp>
         <p:nvSpPr>
-          <p:cNvPr id="80" name="report-copy">
-            <a:extLst xmlns:a="http://schemas.openxmlformats.org/drawingml/2006/main">
-              <a:ext uri="{FF2B5EF4-FFF2-40B4-BE49-F238E27FC236}">
-                <a16:creationId xmlns:a16="http://schemas.microsoft.com/office/drawing/2014/main" id="{6BB1B3D3-CC62-44AF-9B20-E5F21F54AF40}"/>
+          <p:cNvPr id="81" name="report-copy">
+            <a:extLst xmlns:a="http://schemas.openxmlformats.org/drawingml/2006/main">
+              <a:ext uri="{FF2B5EF4-FFF2-40B4-BE49-F238E27FC236}">
+                <a16:creationId xmlns:a16="http://schemas.microsoft.com/office/drawing/2014/main" id="{44BC8464-5665-429C-8B4C-72E9D46138FE}"/>
               </a:ext>
             </a:extLst>
           </p:cNvPr>
@@ -4684,14 +4719,14 @@
             <a:pPr algn="ctr">
               <a:defRPr sz="713" b="0">
                 <a:solidFill>
-                  <a:srgbClr val="6B665F"/>
+                  <a:srgbClr val="667085"/>
                 </a:solidFill>
               </a:defRPr>
             </a:pPr>
             <a:r>
               <a:rPr sz="713" b="0">
                 <a:solidFill>
-                  <a:srgbClr val="6B665F"/>
+                  <a:srgbClr val="667085"/>
                 </a:solidFill>
               </a:rPr>
               <a:t>citations serialized</a:t>
@@ -4701,14 +4736,14 @@
             <a:pPr algn="ctr">
               <a:defRPr sz="713" b="0">
                 <a:solidFill>
-                  <a:srgbClr val="6B665F"/>
+                  <a:srgbClr val="667085"/>
                 </a:solidFill>
               </a:defRPr>
             </a:pPr>
             <a:r>
               <a:rPr sz="713" b="0">
                 <a:solidFill>
-                  <a:srgbClr val="6B665F"/>
+                  <a:srgbClr val="667085"/>
                 </a:solidFill>
               </a:rPr>
               <a:t>scraped bodies excluded</a:t>
@@ -4718,10 +4753,10 @@
       </p:sp>
       <p:sp>
         <p:nvSpPr>
-          <p:cNvPr id="81" name="renderers-label">
-            <a:extLst xmlns:a="http://schemas.openxmlformats.org/drawingml/2006/main">
-              <a:ext uri="{FF2B5EF4-FFF2-40B4-BE49-F238E27FC236}">
-                <a16:creationId xmlns:a16="http://schemas.microsoft.com/office/drawing/2014/main" id="{BD2F75F8-F2AE-4176-8B7D-618F6EBF883D}"/>
+          <p:cNvPr id="82" name="renderers-label">
+            <a:extLst xmlns:a="http://schemas.openxmlformats.org/drawingml/2006/main">
+              <a:ext uri="{FF2B5EF4-FFF2-40B4-BE49-F238E27FC236}">
+                <a16:creationId xmlns:a16="http://schemas.microsoft.com/office/drawing/2014/main" id="{326E1B3C-DF5D-460B-ACA4-F4A9FCBCCA3D}"/>
               </a:ext>
             </a:extLst>
           </p:cNvPr>
@@ -4751,14 +4786,14 @@
             <a:pPr algn="ctr">
               <a:defRPr sz="713" b="1">
                 <a:solidFill>
-                  <a:srgbClr val="B47A1B"/>
+                  <a:srgbClr val="D05A2A"/>
                 </a:solidFill>
               </a:defRPr>
             </a:pPr>
             <a:r>
               <a:rPr sz="713" b="1">
                 <a:solidFill>
-                  <a:srgbClr val="B47A1B"/>
+                  <a:srgbClr val="D05A2A"/>
                 </a:solidFill>
               </a:rPr>
               <a:t>RENDER AS</a:t>
@@ -4768,10 +4803,10 @@
       </p:sp>
       <p:sp>
         <p:nvSpPr>
-          <p:cNvPr id="82" name="renderer-0">
-            <a:extLst xmlns:a="http://schemas.openxmlformats.org/drawingml/2006/main">
-              <a:ext uri="{FF2B5EF4-FFF2-40B4-BE49-F238E27FC236}">
-                <a16:creationId xmlns:a16="http://schemas.microsoft.com/office/drawing/2014/main" id="{5BCF304B-8860-492C-810E-E14DC235890F}"/>
+          <p:cNvPr id="83" name="renderer-0">
+            <a:extLst xmlns:a="http://schemas.openxmlformats.org/drawingml/2006/main">
+              <a:ext uri="{FF2B5EF4-FFF2-40B4-BE49-F238E27FC236}">
+                <a16:creationId xmlns:a16="http://schemas.microsoft.com/office/drawing/2014/main" id="{C0309587-B1E3-40AA-904A-9656CBC45EE0}"/>
               </a:ext>
             </a:extLst>
           </p:cNvPr>
@@ -4789,11 +4824,11 @@
             <a:avLst/>
           </a:prstGeom>
           <a:solidFill xmlns:a="http://schemas.openxmlformats.org/drawingml/2006/main">
-            <a:srgbClr val="FFFDF8"/>
+            <a:srgbClr val="FFFFFF"/>
           </a:solidFill>
           <a:ln xmlns:a="http://schemas.openxmlformats.org/drawingml/2006/main" w="10478">
             <a:solidFill>
-              <a:srgbClr val="B47A1B"/>
+              <a:srgbClr val="D05A2A"/>
             </a:solidFill>
             <a:prstDash val="solid"/>
           </a:ln>
@@ -4801,10 +4836,10 @@
       </p:sp>
       <p:sp>
         <p:nvSpPr>
-          <p:cNvPr id="83" name="renderer-0-text">
-            <a:extLst xmlns:a="http://schemas.openxmlformats.org/drawingml/2006/main">
-              <a:ext uri="{FF2B5EF4-FFF2-40B4-BE49-F238E27FC236}">
-                <a16:creationId xmlns:a16="http://schemas.microsoft.com/office/drawing/2014/main" id="{5DDACF32-15AE-4AE6-87B3-98579848BC78}"/>
+          <p:cNvPr id="84" name="renderer-0-text">
+            <a:extLst xmlns:a="http://schemas.openxmlformats.org/drawingml/2006/main">
+              <a:ext uri="{FF2B5EF4-FFF2-40B4-BE49-F238E27FC236}">
+                <a16:creationId xmlns:a16="http://schemas.microsoft.com/office/drawing/2014/main" id="{CA36C92C-F670-432F-94AC-B62E044277D6}"/>
               </a:ext>
             </a:extLst>
           </p:cNvPr>
@@ -4834,14 +4869,14 @@
             <a:pPr algn="ctr">
               <a:defRPr sz="735" b="1">
                 <a:solidFill>
-                  <a:srgbClr val="24211D"/>
+                  <a:srgbClr val="1C2430"/>
                 </a:solidFill>
               </a:defRPr>
             </a:pPr>
             <a:r>
               <a:rPr sz="735" b="1">
                 <a:solidFill>
-                  <a:srgbClr val="24211D"/>
+                  <a:srgbClr val="1C2430"/>
                 </a:solidFill>
               </a:rPr>
               <a:t>terminal</a:t>
@@ -4851,10 +4886,10 @@
       </p:sp>
       <p:sp>
         <p:nvSpPr>
-          <p:cNvPr id="84" name="renderer-1">
-            <a:extLst xmlns:a="http://schemas.openxmlformats.org/drawingml/2006/main">
-              <a:ext uri="{FF2B5EF4-FFF2-40B4-BE49-F238E27FC236}">
-                <a16:creationId xmlns:a16="http://schemas.microsoft.com/office/drawing/2014/main" id="{13C23375-729E-46A5-BC63-B479004BB02C}"/>
+          <p:cNvPr id="85" name="renderer-1">
+            <a:extLst xmlns:a="http://schemas.openxmlformats.org/drawingml/2006/main">
+              <a:ext uri="{FF2B5EF4-FFF2-40B4-BE49-F238E27FC236}">
+                <a16:creationId xmlns:a16="http://schemas.microsoft.com/office/drawing/2014/main" id="{BF83FCD8-8144-44A5-93C4-D2116F7ECEED}"/>
               </a:ext>
             </a:extLst>
           </p:cNvPr>
@@ -4872,11 +4907,11 @@
             <a:avLst/>
           </a:prstGeom>
           <a:solidFill xmlns:a="http://schemas.openxmlformats.org/drawingml/2006/main">
-            <a:srgbClr val="FFFDF8"/>
+            <a:srgbClr val="FFFFFF"/>
           </a:solidFill>
           <a:ln xmlns:a="http://schemas.openxmlformats.org/drawingml/2006/main" w="10478">
             <a:solidFill>
-              <a:srgbClr val="B47A1B"/>
+              <a:srgbClr val="D05A2A"/>
             </a:solidFill>
             <a:prstDash val="solid"/>
           </a:ln>
@@ -4884,10 +4919,10 @@
       </p:sp>
       <p:sp>
         <p:nvSpPr>
-          <p:cNvPr id="85" name="renderer-1-text">
-            <a:extLst xmlns:a="http://schemas.openxmlformats.org/drawingml/2006/main">
-              <a:ext uri="{FF2B5EF4-FFF2-40B4-BE49-F238E27FC236}">
-                <a16:creationId xmlns:a16="http://schemas.microsoft.com/office/drawing/2014/main" id="{DB23B7FB-5F0C-4018-B25A-2EB005AE41A6}"/>
+          <p:cNvPr id="86" name="renderer-1-text">
+            <a:extLst xmlns:a="http://schemas.openxmlformats.org/drawingml/2006/main">
+              <a:ext uri="{FF2B5EF4-FFF2-40B4-BE49-F238E27FC236}">
+                <a16:creationId xmlns:a16="http://schemas.microsoft.com/office/drawing/2014/main" id="{0B9A4B19-3E50-4DAA-9D3C-EF35862F69F8}"/>
               </a:ext>
             </a:extLst>
           </p:cNvPr>
@@ -4917,14 +4952,14 @@
             <a:pPr algn="ctr">
               <a:defRPr sz="735" b="1">
                 <a:solidFill>
-                  <a:srgbClr val="24211D"/>
+                  <a:srgbClr val="1C2430"/>
                 </a:solidFill>
               </a:defRPr>
             </a:pPr>
             <a:r>
               <a:rPr sz="735" b="1">
                 <a:solidFill>
-                  <a:srgbClr val="24211D"/>
+                  <a:srgbClr val="1C2430"/>
                 </a:solidFill>
               </a:rPr>
               <a:t>Markdown</a:t>
@@ -4934,10 +4969,10 @@
       </p:sp>
       <p:sp>
         <p:nvSpPr>
-          <p:cNvPr id="86" name="renderer-2">
-            <a:extLst xmlns:a="http://schemas.openxmlformats.org/drawingml/2006/main">
-              <a:ext uri="{FF2B5EF4-FFF2-40B4-BE49-F238E27FC236}">
-                <a16:creationId xmlns:a16="http://schemas.microsoft.com/office/drawing/2014/main" id="{B41A3292-912F-4B26-9B33-D0785FBA2AF3}"/>
+          <p:cNvPr id="87" name="renderer-2">
+            <a:extLst xmlns:a="http://schemas.openxmlformats.org/drawingml/2006/main">
+              <a:ext uri="{FF2B5EF4-FFF2-40B4-BE49-F238E27FC236}">
+                <a16:creationId xmlns:a16="http://schemas.microsoft.com/office/drawing/2014/main" id="{5F7C4089-6032-42DD-A1E5-548A9A1B53E5}"/>
               </a:ext>
             </a:extLst>
           </p:cNvPr>
@@ -4955,11 +4990,11 @@
             <a:avLst/>
           </a:prstGeom>
           <a:solidFill xmlns:a="http://schemas.openxmlformats.org/drawingml/2006/main">
-            <a:srgbClr val="FFFDF8"/>
+            <a:srgbClr val="FFFFFF"/>
           </a:solidFill>
           <a:ln xmlns:a="http://schemas.openxmlformats.org/drawingml/2006/main" w="10478">
             <a:solidFill>
-              <a:srgbClr val="B47A1B"/>
+              <a:srgbClr val="D05A2A"/>
             </a:solidFill>
             <a:prstDash val="solid"/>
           </a:ln>
@@ -4967,10 +5002,10 @@
       </p:sp>
       <p:sp>
         <p:nvSpPr>
-          <p:cNvPr id="87" name="renderer-2-text">
-            <a:extLst xmlns:a="http://schemas.openxmlformats.org/drawingml/2006/main">
-              <a:ext uri="{FF2B5EF4-FFF2-40B4-BE49-F238E27FC236}">
-                <a16:creationId xmlns:a16="http://schemas.microsoft.com/office/drawing/2014/main" id="{91F02E81-809E-4ADC-9822-DF1663648138}"/>
+          <p:cNvPr id="88" name="renderer-2-text">
+            <a:extLst xmlns:a="http://schemas.openxmlformats.org/drawingml/2006/main">
+              <a:ext uri="{FF2B5EF4-FFF2-40B4-BE49-F238E27FC236}">
+                <a16:creationId xmlns:a16="http://schemas.microsoft.com/office/drawing/2014/main" id="{A041C31B-4A2F-42AD-9F0E-6252E5F7FEC4}"/>
               </a:ext>
             </a:extLst>
           </p:cNvPr>
@@ -5000,14 +5035,14 @@
             <a:pPr algn="ctr">
               <a:defRPr sz="735" b="1">
                 <a:solidFill>
-                  <a:srgbClr val="24211D"/>
+                  <a:srgbClr val="1C2430"/>
                 </a:solidFill>
               </a:defRPr>
             </a:pPr>
             <a:r>
               <a:rPr sz="735" b="1">
                 <a:solidFill>
-                  <a:srgbClr val="24211D"/>
+                  <a:srgbClr val="1C2430"/>
                 </a:solidFill>
               </a:rPr>
               <a:t>JSON</a:t>
@@ -5017,10 +5052,10 @@
       </p:sp>
       <p:sp>
         <p:nvSpPr>
-          <p:cNvPr id="88" name="renderer-3">
-            <a:extLst xmlns:a="http://schemas.openxmlformats.org/drawingml/2006/main">
-              <a:ext uri="{FF2B5EF4-FFF2-40B4-BE49-F238E27FC236}">
-                <a16:creationId xmlns:a16="http://schemas.microsoft.com/office/drawing/2014/main" id="{CCF6687E-5DB7-4C22-B237-AC5AF66AA7AF}"/>
+          <p:cNvPr id="89" name="renderer-3">
+            <a:extLst xmlns:a="http://schemas.openxmlformats.org/drawingml/2006/main">
+              <a:ext uri="{FF2B5EF4-FFF2-40B4-BE49-F238E27FC236}">
+                <a16:creationId xmlns:a16="http://schemas.microsoft.com/office/drawing/2014/main" id="{3DF41FC9-D944-400B-B4B5-00B8D652108F}"/>
               </a:ext>
             </a:extLst>
           </p:cNvPr>
@@ -5038,11 +5073,11 @@
             <a:avLst/>
           </a:prstGeom>
           <a:solidFill xmlns:a="http://schemas.openxmlformats.org/drawingml/2006/main">
-            <a:srgbClr val="FFFDF8"/>
+            <a:srgbClr val="FFFFFF"/>
           </a:solidFill>
           <a:ln xmlns:a="http://schemas.openxmlformats.org/drawingml/2006/main" w="10478">
             <a:solidFill>
-              <a:srgbClr val="B47A1B"/>
+              <a:srgbClr val="D05A2A"/>
             </a:solidFill>
             <a:prstDash val="solid"/>
           </a:ln>
@@ -5050,10 +5085,10 @@
       </p:sp>
       <p:sp>
         <p:nvSpPr>
-          <p:cNvPr id="89" name="renderer-3-text">
-            <a:extLst xmlns:a="http://schemas.openxmlformats.org/drawingml/2006/main">
-              <a:ext uri="{FF2B5EF4-FFF2-40B4-BE49-F238E27FC236}">
-                <a16:creationId xmlns:a16="http://schemas.microsoft.com/office/drawing/2014/main" id="{6DBAA0BB-659E-4396-A51D-5624B7E3D794}"/>
+          <p:cNvPr id="90" name="renderer-3-text">
+            <a:extLst xmlns:a="http://schemas.openxmlformats.org/drawingml/2006/main">
+              <a:ext uri="{FF2B5EF4-FFF2-40B4-BE49-F238E27FC236}">
+                <a16:creationId xmlns:a16="http://schemas.microsoft.com/office/drawing/2014/main" id="{4CB7EA20-43E4-43F8-9E98-EB719007CC0C}"/>
               </a:ext>
             </a:extLst>
           </p:cNvPr>
@@ -5083,14 +5118,14 @@
             <a:pPr algn="ctr">
               <a:defRPr sz="735" b="1">
                 <a:solidFill>
-                  <a:srgbClr val="24211D"/>
+                  <a:srgbClr val="1C2430"/>
                 </a:solidFill>
               </a:defRPr>
             </a:pPr>
             <a:r>
               <a:rPr sz="735" b="1">
                 <a:solidFill>
-                  <a:srgbClr val="24211D"/>
+                  <a:srgbClr val="1C2430"/>
                 </a:solidFill>
               </a:rPr>
               <a:t>CSV</a:t>
@@ -5100,10 +5135,10 @@
       </p:sp>
       <p:sp>
         <p:nvSpPr>
-          <p:cNvPr id="90" name="safe-write">
-            <a:extLst xmlns:a="http://schemas.openxmlformats.org/drawingml/2006/main">
-              <a:ext uri="{FF2B5EF4-FFF2-40B4-BE49-F238E27FC236}">
-                <a16:creationId xmlns:a16="http://schemas.microsoft.com/office/drawing/2014/main" id="{2381FB30-EA97-4F4A-9F91-ADBE3EC32519}"/>
+          <p:cNvPr id="91" name="safe-write">
+            <a:extLst xmlns:a="http://schemas.openxmlformats.org/drawingml/2006/main">
+              <a:ext uri="{FF2B5EF4-FFF2-40B4-BE49-F238E27FC236}">
+                <a16:creationId xmlns:a16="http://schemas.microsoft.com/office/drawing/2014/main" id="{1F8DFCF8-0921-4D47-B874-58FB1FB5CB5C}"/>
               </a:ext>
             </a:extLst>
           </p:cNvPr>
@@ -5133,14 +5168,14 @@
             <a:pPr algn="ctr">
               <a:defRPr sz="863" b="1">
                 <a:solidFill>
-                  <a:srgbClr val="52725D"/>
+                  <a:srgbClr val="397EA5"/>
                 </a:solidFill>
               </a:defRPr>
             </a:pPr>
             <a:r>
               <a:rPr sz="863" b="1">
                 <a:solidFill>
-                  <a:srgbClr val="52725D"/>
+                  <a:srgbClr val="397EA5"/>
                 </a:solidFill>
               </a:rPr>
               <a:t>write → replace</a:t>
@@ -5150,10 +5185,10 @@
       </p:sp>
       <p:sp>
         <p:nvSpPr>
-          <p:cNvPr id="91" name="safe-write-copy">
-            <a:extLst xmlns:a="http://schemas.openxmlformats.org/drawingml/2006/main">
-              <a:ext uri="{FF2B5EF4-FFF2-40B4-BE49-F238E27FC236}">
-                <a16:creationId xmlns:a16="http://schemas.microsoft.com/office/drawing/2014/main" id="{21962091-4585-45E5-A4DE-06637E12AAFA}"/>
+          <p:cNvPr id="92" name="safe-write-copy">
+            <a:extLst xmlns:a="http://schemas.openxmlformats.org/drawingml/2006/main">
+              <a:ext uri="{FF2B5EF4-FFF2-40B4-BE49-F238E27FC236}">
+                <a16:creationId xmlns:a16="http://schemas.microsoft.com/office/drawing/2014/main" id="{C93B3D90-E8A6-4C66-B872-C8D4B60A7834}"/>
               </a:ext>
             </a:extLst>
           </p:cNvPr>
@@ -5183,14 +5218,14 @@
             <a:pPr algn="ctr">
               <a:defRPr sz="690" b="0">
                 <a:solidFill>
-                  <a:srgbClr val="6B665F"/>
+                  <a:srgbClr val="667085"/>
                 </a:solidFill>
               </a:defRPr>
             </a:pPr>
             <a:r>
               <a:rPr sz="690" b="0">
                 <a:solidFill>
-                  <a:srgbClr val="6B665F"/>
+                  <a:srgbClr val="667085"/>
                 </a:solidFill>
               </a:rPr>
               <a:t>atomic output boundary</a:t>
@@ -5200,10 +5235,10 @@
       </p:sp>
       <p:sp>
         <p:nvSpPr>
-          <p:cNvPr id="92" name="caption">
-            <a:extLst xmlns:a="http://schemas.openxmlformats.org/drawingml/2006/main">
-              <a:ext uri="{FF2B5EF4-FFF2-40B4-BE49-F238E27FC236}">
-                <a16:creationId xmlns:a16="http://schemas.microsoft.com/office/drawing/2014/main" id="{BD649E52-B280-448E-ACB6-B7DFF1F8B802}"/>
+          <p:cNvPr id="93" name="caption">
+            <a:extLst xmlns:a="http://schemas.openxmlformats.org/drawingml/2006/main">
+              <a:ext uri="{FF2B5EF4-FFF2-40B4-BE49-F238E27FC236}">
+                <a16:creationId xmlns:a16="http://schemas.microsoft.com/office/drawing/2014/main" id="{8BE09A29-296C-4B1B-A732-0DF37C06FC11}"/>
               </a:ext>
             </a:extLst>
           </p:cNvPr>
@@ -5233,14 +5268,14 @@
             <a:pPr algn="l">
               <a:defRPr sz="975" b="0">
                 <a:solidFill>
-                  <a:srgbClr val="24211D"/>
+                  <a:srgbClr val="1C2430"/>
                 </a:solidFill>
               </a:defRPr>
             </a:pPr>
             <a:r>
               <a:rPr sz="975" b="0">
                 <a:solidFill>
-                  <a:srgbClr val="24211D"/>
+                  <a:srgbClr val="1C2430"/>
                 </a:solidFill>
               </a:rPr>
               <a:t>Provider implementations plug into a single typed state machine; validation and degraded-run behavior remain inside the graph rather than the UI.</a:t>
@@ -5250,10 +5285,10 @@
       </p:sp>
       <p:sp>
         <p:nvSpPr>
-          <p:cNvPr id="93" name="sources">
-            <a:extLst xmlns:a="http://schemas.openxmlformats.org/drawingml/2006/main">
-              <a:ext uri="{FF2B5EF4-FFF2-40B4-BE49-F238E27FC236}">
-                <a16:creationId xmlns:a16="http://schemas.microsoft.com/office/drawing/2014/main" id="{BACF6673-34E2-47B6-8AF8-B7EA0CA7E75E}"/>
+          <p:cNvPr id="94" name="sources">
+            <a:extLst xmlns:a="http://schemas.openxmlformats.org/drawingml/2006/main">
+              <a:ext uri="{FF2B5EF4-FFF2-40B4-BE49-F238E27FC236}">
+                <a16:creationId xmlns:a16="http://schemas.microsoft.com/office/drawing/2014/main" id="{DD1AF169-DA26-4DDE-9B72-599AAA898F56}"/>
               </a:ext>
             </a:extLst>
           </p:cNvPr>
@@ -5283,14 +5318,14 @@
             <a:pPr algn="l">
               <a:defRPr sz="690" b="0">
                 <a:solidFill>
-                  <a:srgbClr val="6B665F"/>
+                  <a:srgbClr val="667085"/>
                 </a:solidFill>
               </a:defRPr>
             </a:pPr>
             <a:r>
               <a:rPr sz="690" b="0">
                 <a:solidFill>
-                  <a:srgbClr val="6B665F"/>
+                  <a:srgbClr val="667085"/>
                 </a:solidFill>
               </a:rPr>
               <a:t>pipeline.py · contracts.py · demo.py · live.py · providers.py · models.py · renderers.py</a:t>
@@ -5301,7 +5336,7 @@
     </p:spTree>
     <p:extLst>
       <p:ext uri="{BB962C8B-B14F-4D97-AF65-F5344CB8AC3E}">
-        <p14:creationId xmlns:p14="http://schemas.microsoft.com/office/powerpoint/2010/main" val="345529698"/>
+        <p14:creationId xmlns:p14="http://schemas.microsoft.com/office/powerpoint/2010/main" val="1525223631"/>
       </p:ext>
     </p:extLst>
   </p:cSld>

</xml_diff>

<commit_message>
Align IntelliCrawl figure with its visual language (#11)
## What changed

- replaced the dark editorial rail with a light paper-style provider
group
- limited the palette to neutral ink, search blue, and terminal orange
- preserved the graph-native layout, parallel research fan-out, and
evidence boundaries
- regenerated editable, vector, raster, provenance, and preflight
artifacts

## Why

The prior styling was visually invented rather than grounded in the
project. This revision follows the project's terminal artifact and the
restrained hierarchy used by strong robotics-paper system diagrams.

## Validation

- PowerPoint overflow check
- 716 px final-size and grayscale review
- vector-only PDF preflight
- provenance checksums verified
</commit_message>
<xml_diff>
--- a/docs/figures/evidence-trace/editable/intellicrawl-evidence-trace.pptx
+++ b/docs/figures/evidence-trace/editable/intellicrawl-evidence-trace.pptx
@@ -2,13 +2,13 @@
 <file path=ppt/presentation.xml><?xml version="1.0" encoding="utf-8"?>
 <p:presentation xmlns:p="http://schemas.openxmlformats.org/presentationml/2006/main">
   <p:sldMasterIdLst>
-    <p:sldMasterId xmlns:r="http://schemas.openxmlformats.org/officeDocument/2006/relationships" id="2147483648" r:id="R709051e2cdb64471"/>
+    <p:sldMasterId xmlns:r="http://schemas.openxmlformats.org/officeDocument/2006/relationships" id="2147483648" r:id="Rc28a7ad03daf4a75"/>
   </p:sldMasterIdLst>
   <p:notesMasterIdLst>
-    <p:notesMasterId xmlns:r="http://schemas.openxmlformats.org/officeDocument/2006/relationships" r:id="Rca785600a9d64195"/>
+    <p:notesMasterId xmlns:r="http://schemas.openxmlformats.org/officeDocument/2006/relationships" r:id="Rba8c3fdb0a964fa2"/>
   </p:notesMasterIdLst>
   <p:sldIdLst>
-    <p:sldId xmlns:r="http://schemas.openxmlformats.org/officeDocument/2006/relationships" id="256" r:id="Rc65f6466d3b345c1"/>
+    <p:sldId xmlns:r="http://schemas.openxmlformats.org/officeDocument/2006/relationships" id="256" r:id="Rcc3edeaed6b8438e"/>
   </p:sldIdLst>
   <p:sldSz cx="12192000" cy="6858000"/>
   <p:notesSz cx="6858000" cy="9144000"/>
@@ -601,7 +601,7 @@
   </p:cSld>
   <p:clrMap bg1="lt1" tx1="dk1" bg2="lt2" tx2="dk2" accent1="accent1" accent2="accent2" accent3="accent3" accent4="accent4" accent5="accent5" accent6="accent6" hlink="hlink" folHlink="folHlink"/>
   <p:sldLayoutIdLst>
-    <p:sldLayoutId xmlns:r="http://schemas.openxmlformats.org/officeDocument/2006/relationships" id="2147483649" r:id="R364b8fe773ec41c5"/>
+    <p:sldLayoutId xmlns:r="http://schemas.openxmlformats.org/officeDocument/2006/relationships" id="2147483649" r:id="R54f6e25696df4d21"/>
   </p:sldLayoutIdLst>
   <p:txStyles>
     <p:titleStyle>
@@ -1134,7 +1134,7 @@
     <p:bg>
       <p:bgPr>
         <a:solidFill xmlns:a="http://schemas.openxmlformats.org/drawingml/2006/main">
-          <a:srgbClr val="F4F0E8"/>
+          <a:srgbClr val="FFFFFF"/>
         </a:solidFill>
       </p:bgPr>
     </p:bg>
@@ -1149,32 +1149,184 @@
       </p:grpSpPr>
       <p:sp>
         <p:nvSpPr>
-          <p:cNvPr id="94" name="editorial-rail">
-            <a:extLst xmlns:a="http://schemas.openxmlformats.org/drawingml/2006/main">
-              <a:ext uri="{FF2B5EF4-FFF2-40B4-BE49-F238E27FC236}">
-                <a16:creationId xmlns:a16="http://schemas.microsoft.com/office/drawing/2014/main" id="{3EAE890B-2283-44DD-A5A7-B3BC5BE0D054}"/>
-              </a:ext>
-            </a:extLst>
-          </p:cNvPr>
-          <p:cNvSpPr>
-            <a:spLocks xmlns:a="http://schemas.openxmlformats.org/drawingml/2006/main" noGrp="1"/>
-          </p:cNvSpPr>
-          <p:nvPr/>
-        </p:nvSpPr>
-        <p:spPr>
-          <a:xfrm xmlns:a="http://schemas.openxmlformats.org/drawingml/2006/main">
-            <a:off x="0" y="0"/>
-            <a:ext cx="2400300" cy="6858000"/>
-          </a:xfrm>
-          <a:prstGeom xmlns:a="http://schemas.openxmlformats.org/drawingml/2006/main" prst="rect">
-            <a:avLst/>
+          <p:cNvPr id="95" name="title">
+            <a:extLst xmlns:a="http://schemas.openxmlformats.org/drawingml/2006/main">
+              <a:ext uri="{FF2B5EF4-FFF2-40B4-BE49-F238E27FC236}">
+                <a16:creationId xmlns:a16="http://schemas.microsoft.com/office/drawing/2014/main" id="{0B35D5EE-4BFC-4D02-BD22-22270C9A0840}"/>
+              </a:ext>
+            </a:extLst>
+          </p:cNvPr>
+          <p:cNvSpPr>
+            <a:spLocks xmlns:a="http://schemas.openxmlformats.org/drawingml/2006/main" noGrp="1"/>
+          </p:cNvSpPr>
+          <p:nvPr/>
+        </p:nvSpPr>
+        <p:spPr>
+          <a:xfrm xmlns:a="http://schemas.openxmlformats.org/drawingml/2006/main">
+            <a:off x="323850" y="228600"/>
+            <a:ext cx="9048750" cy="361950"/>
+          </a:xfrm>
+          <a:prstGeom xmlns:a="http://schemas.openxmlformats.org/drawingml/2006/main" prst="rect">
+            <a:avLst/>
+          </a:prstGeom>
+          <a:noFill xmlns:a="http://schemas.openxmlformats.org/drawingml/2006/main"/>
+          <a:ln xmlns:a="http://schemas.openxmlformats.org/drawingml/2006/main" w="0">
+            <a:noFill/>
+            <a:prstDash val="solid"/>
+          </a:ln>
+        </p:spPr>
+        <p:txBody>
+          <a:bodyPr xmlns:a="http://schemas.openxmlformats.org/drawingml/2006/main"/>
+          <a:lstStyle xmlns:a="http://schemas.openxmlformats.org/drawingml/2006/main"/>
+          <a:p xmlns:a="http://schemas.openxmlformats.org/drawingml/2006/main">
+            <a:pPr algn="l">
+              <a:defRPr sz="2025" b="1">
+                <a:solidFill>
+                  <a:srgbClr val="1C2430"/>
+                </a:solidFill>
+              </a:defRPr>
+            </a:pPr>
+            <a:r>
+              <a:rPr sz="2025" b="1">
+                <a:solidFill>
+                  <a:srgbClr val="1C2430"/>
+                </a:solidFill>
+              </a:rPr>
+              <a:t>IntelliCrawl: replaceable providers, one typed research graph</a:t>
+            </a:r>
+          </a:p>
+        </p:txBody>
+      </p:sp>
+      <p:sp>
+        <p:nvSpPr>
+          <p:cNvPr id="2" name="subtitle">
+            <a:extLst xmlns:a="http://schemas.openxmlformats.org/drawingml/2006/main">
+              <a:ext uri="{FF2B5EF4-FFF2-40B4-BE49-F238E27FC236}">
+                <a16:creationId xmlns:a16="http://schemas.microsoft.com/office/drawing/2014/main" id="{0DD85B4D-91EA-4C32-8474-C1BCF1A53CF9}"/>
+              </a:ext>
+            </a:extLst>
+          </p:cNvPr>
+          <p:cNvSpPr>
+            <a:spLocks xmlns:a="http://schemas.openxmlformats.org/drawingml/2006/main" noGrp="1"/>
+          </p:cNvSpPr>
+          <p:nvPr/>
+        </p:nvSpPr>
+        <p:spPr>
+          <a:xfrm xmlns:a="http://schemas.openxmlformats.org/drawingml/2006/main">
+            <a:off x="323850" y="619125"/>
+            <a:ext cx="8763000" cy="209550"/>
+          </a:xfrm>
+          <a:prstGeom xmlns:a="http://schemas.openxmlformats.org/drawingml/2006/main" prst="rect">
+            <a:avLst/>
+          </a:prstGeom>
+          <a:noFill xmlns:a="http://schemas.openxmlformats.org/drawingml/2006/main"/>
+          <a:ln xmlns:a="http://schemas.openxmlformats.org/drawingml/2006/main" w="0">
+            <a:noFill/>
+            <a:prstDash val="solid"/>
+          </a:ln>
+        </p:spPr>
+        <p:txBody>
+          <a:bodyPr xmlns:a="http://schemas.openxmlformats.org/drawingml/2006/main"/>
+          <a:lstStyle xmlns:a="http://schemas.openxmlformats.org/drawingml/2006/main"/>
+          <a:p xmlns:a="http://schemas.openxmlformats.org/drawingml/2006/main">
+            <a:pPr algn="l">
+              <a:defRPr sz="1050" b="0">
+                <a:solidFill>
+                  <a:srgbClr val="667085"/>
+                </a:solidFill>
+              </a:defRPr>
+            </a:pPr>
+            <a:r>
+              <a:rPr sz="1050" b="0">
+                <a:solidFill>
+                  <a:srgbClr val="667085"/>
+                </a:solidFill>
+              </a:rPr>
+              <a:t>Demo and live assemblies enter the same code-grounded LangGraph; validation remains inside the execution path.</a:t>
+            </a:r>
+          </a:p>
+        </p:txBody>
+      </p:sp>
+      <p:sp>
+        <p:nvSpPr>
+          <p:cNvPr id="3" name="graph-type">
+            <a:extLst xmlns:a="http://schemas.openxmlformats.org/drawingml/2006/main">
+              <a:ext uri="{FF2B5EF4-FFF2-40B4-BE49-F238E27FC236}">
+                <a16:creationId xmlns:a16="http://schemas.microsoft.com/office/drawing/2014/main" id="{4E0927B8-2605-4D43-B376-FEC97F8D2809}"/>
+              </a:ext>
+            </a:extLst>
+          </p:cNvPr>
+          <p:cNvSpPr>
+            <a:spLocks xmlns:a="http://schemas.openxmlformats.org/drawingml/2006/main" noGrp="1"/>
+          </p:cNvSpPr>
+          <p:nvPr/>
+        </p:nvSpPr>
+        <p:spPr>
+          <a:xfrm xmlns:a="http://schemas.openxmlformats.org/drawingml/2006/main">
+            <a:off x="9525000" y="323850"/>
+            <a:ext cx="2247900" cy="171450"/>
+          </a:xfrm>
+          <a:prstGeom xmlns:a="http://schemas.openxmlformats.org/drawingml/2006/main" prst="rect">
+            <a:avLst/>
+          </a:prstGeom>
+          <a:noFill xmlns:a="http://schemas.openxmlformats.org/drawingml/2006/main"/>
+          <a:ln xmlns:a="http://schemas.openxmlformats.org/drawingml/2006/main" w="0">
+            <a:noFill/>
+            <a:prstDash val="solid"/>
+          </a:ln>
+        </p:spPr>
+        <p:txBody>
+          <a:bodyPr xmlns:a="http://schemas.openxmlformats.org/drawingml/2006/main"/>
+          <a:lstStyle xmlns:a="http://schemas.openxmlformats.org/drawingml/2006/main"/>
+          <a:p xmlns:a="http://schemas.openxmlformats.org/drawingml/2006/main">
+            <a:pPr algn="r">
+              <a:defRPr sz="788" b="1">
+                <a:solidFill>
+                  <a:srgbClr val="397EA5"/>
+                </a:solidFill>
+              </a:defRPr>
+            </a:pPr>
+            <a:r>
+              <a:rPr sz="788" b="1">
+                <a:solidFill>
+                  <a:srgbClr val="397EA5"/>
+                </a:solidFill>
+              </a:rPr>
+              <a:t>ResearchPipeline / LangGraph</a:t>
+            </a:r>
+          </a:p>
+        </p:txBody>
+      </p:sp>
+      <p:sp>
+        <p:nvSpPr>
+          <p:cNvPr id="4" name="editorial-rail">
+            <a:extLst xmlns:a="http://schemas.openxmlformats.org/drawingml/2006/main">
+              <a:ext uri="{FF2B5EF4-FFF2-40B4-BE49-F238E27FC236}">
+                <a16:creationId xmlns:a16="http://schemas.microsoft.com/office/drawing/2014/main" id="{0A96221A-C1D6-458A-A785-074C7708365A}"/>
+              </a:ext>
+            </a:extLst>
+          </p:cNvPr>
+          <p:cNvSpPr>
+            <a:spLocks xmlns:a="http://schemas.openxmlformats.org/drawingml/2006/main" noGrp="1"/>
+          </p:cNvSpPr>
+          <p:nvPr/>
+        </p:nvSpPr>
+        <p:spPr>
+          <a:xfrm xmlns:a="http://schemas.openxmlformats.org/drawingml/2006/main">
+            <a:off x="266700" y="1066800"/>
+            <a:ext cx="2152650" cy="4914900"/>
+          </a:xfrm>
+          <a:prstGeom xmlns:a="http://schemas.openxmlformats.org/drawingml/2006/main" prst="roundRect">
+            <a:avLst>
+              <a:gd name="adj" fmla="val 4425"/>
+            </a:avLst>
           </a:prstGeom>
           <a:solidFill xmlns:a="http://schemas.openxmlformats.org/drawingml/2006/main">
-            <a:srgbClr val="263B35"/>
+            <a:srgbClr val="F3F4F5"/>
           </a:solidFill>
           <a:ln xmlns:a="http://schemas.openxmlformats.org/drawingml/2006/main" w="9525">
             <a:solidFill>
-              <a:srgbClr val="263B35"/>
+              <a:srgbClr val="C9CED6"/>
             </a:solidFill>
             <a:prstDash val="solid"/>
           </a:ln>
@@ -1182,32 +1334,32 @@
       </p:sp>
       <p:sp>
         <p:nvSpPr>
-          <p:cNvPr id="2" name="rail-accent">
-            <a:extLst xmlns:a="http://schemas.openxmlformats.org/drawingml/2006/main">
-              <a:ext uri="{FF2B5EF4-FFF2-40B4-BE49-F238E27FC236}">
-                <a16:creationId xmlns:a16="http://schemas.microsoft.com/office/drawing/2014/main" id="{C5048EFA-EE45-47F2-880C-C1B080A3FBC1}"/>
-              </a:ext>
-            </a:extLst>
-          </p:cNvPr>
-          <p:cNvSpPr>
-            <a:spLocks xmlns:a="http://schemas.openxmlformats.org/drawingml/2006/main" noGrp="1"/>
-          </p:cNvSpPr>
-          <p:nvPr/>
-        </p:nvSpPr>
-        <p:spPr>
-          <a:xfrm xmlns:a="http://schemas.openxmlformats.org/drawingml/2006/main">
-            <a:off x="0" y="0"/>
-            <a:ext cx="114300" cy="6858000"/>
+          <p:cNvPr id="5" name="rail-accent">
+            <a:extLst xmlns:a="http://schemas.openxmlformats.org/drawingml/2006/main">
+              <a:ext uri="{FF2B5EF4-FFF2-40B4-BE49-F238E27FC236}">
+                <a16:creationId xmlns:a16="http://schemas.microsoft.com/office/drawing/2014/main" id="{758DDAB9-517C-493E-9DA7-C6779A79D2C9}"/>
+              </a:ext>
+            </a:extLst>
+          </p:cNvPr>
+          <p:cNvSpPr>
+            <a:spLocks xmlns:a="http://schemas.openxmlformats.org/drawingml/2006/main" noGrp="1"/>
+          </p:cNvSpPr>
+          <p:nvPr/>
+        </p:nvSpPr>
+        <p:spPr>
+          <a:xfrm xmlns:a="http://schemas.openxmlformats.org/drawingml/2006/main">
+            <a:off x="266700" y="1066800"/>
+            <a:ext cx="57150" cy="4914900"/>
           </a:xfrm>
           <a:prstGeom xmlns:a="http://schemas.openxmlformats.org/drawingml/2006/main" prst="rect">
             <a:avLst/>
           </a:prstGeom>
           <a:solidFill xmlns:a="http://schemas.openxmlformats.org/drawingml/2006/main">
-            <a:srgbClr val="C6653E"/>
+            <a:srgbClr val="D05A2A"/>
           </a:solidFill>
           <a:ln xmlns:a="http://schemas.openxmlformats.org/drawingml/2006/main" w="9525">
             <a:solidFill>
-              <a:srgbClr val="C6653E"/>
+              <a:srgbClr val="D05A2A"/>
             </a:solidFill>
             <a:prstDash val="solid"/>
           </a:ln>
@@ -1215,22 +1367,22 @@
       </p:sp>
       <p:sp>
         <p:nvSpPr>
-          <p:cNvPr id="3" name="rail-kicker">
-            <a:extLst xmlns:a="http://schemas.openxmlformats.org/drawingml/2006/main">
-              <a:ext uri="{FF2B5EF4-FFF2-40B4-BE49-F238E27FC236}">
-                <a16:creationId xmlns:a16="http://schemas.microsoft.com/office/drawing/2014/main" id="{8B74C024-3FCA-42D0-9479-0051BF000534}"/>
-              </a:ext>
-            </a:extLst>
-          </p:cNvPr>
-          <p:cNvSpPr>
-            <a:spLocks xmlns:a="http://schemas.openxmlformats.org/drawingml/2006/main" noGrp="1"/>
-          </p:cNvSpPr>
-          <p:nvPr/>
-        </p:nvSpPr>
-        <p:spPr>
-          <a:xfrm xmlns:a="http://schemas.openxmlformats.org/drawingml/2006/main">
-            <a:off x="323850" y="333375"/>
-            <a:ext cx="1809750" cy="171450"/>
+          <p:cNvPr id="6" name="rail-kicker">
+            <a:extLst xmlns:a="http://schemas.openxmlformats.org/drawingml/2006/main">
+              <a:ext uri="{FF2B5EF4-FFF2-40B4-BE49-F238E27FC236}">
+                <a16:creationId xmlns:a16="http://schemas.microsoft.com/office/drawing/2014/main" id="{C56A2925-D9E7-4164-99AA-6A2D86155674}"/>
+              </a:ext>
+            </a:extLst>
+          </p:cNvPr>
+          <p:cNvSpPr>
+            <a:spLocks xmlns:a="http://schemas.openxmlformats.org/drawingml/2006/main" noGrp="1"/>
+          </p:cNvSpPr>
+          <p:nvPr/>
+        </p:nvSpPr>
+        <p:spPr>
+          <a:xfrm xmlns:a="http://schemas.openxmlformats.org/drawingml/2006/main">
+            <a:off x="457200" y="1257300"/>
+            <a:ext cx="1676400" cy="171450"/>
           </a:xfrm>
           <a:prstGeom xmlns:a="http://schemas.openxmlformats.org/drawingml/2006/main" prst="rect">
             <a:avLst/>
@@ -1248,39 +1400,39 @@
             <a:pPr algn="l">
               <a:defRPr sz="788" b="1">
                 <a:solidFill>
-                  <a:srgbClr val="C8D8D0"/>
+                  <a:srgbClr val="D05A2A"/>
                 </a:solidFill>
               </a:defRPr>
             </a:pPr>
             <a:r>
               <a:rPr sz="788" b="1">
                 <a:solidFill>
-                  <a:srgbClr val="C8D8D0"/>
-                </a:solidFill>
-              </a:rPr>
-              <a:t>SYSTEM MAP · CODE-GROUNDED</a:t>
-            </a:r>
-          </a:p>
-        </p:txBody>
-      </p:sp>
-      <p:sp>
-        <p:nvSpPr>
-          <p:cNvPr id="4" name="rail-title">
-            <a:extLst xmlns:a="http://schemas.openxmlformats.org/drawingml/2006/main">
-              <a:ext uri="{FF2B5EF4-FFF2-40B4-BE49-F238E27FC236}">
-                <a16:creationId xmlns:a16="http://schemas.microsoft.com/office/drawing/2014/main" id="{888755AE-3826-44AC-8478-72E28AD2D21E}"/>
-              </a:ext>
-            </a:extLst>
-          </p:cNvPr>
-          <p:cNvSpPr>
-            <a:spLocks xmlns:a="http://schemas.openxmlformats.org/drawingml/2006/main" noGrp="1"/>
-          </p:cNvSpPr>
-          <p:nvPr/>
-        </p:nvSpPr>
-        <p:spPr>
-          <a:xfrm xmlns:a="http://schemas.openxmlformats.org/drawingml/2006/main">
-            <a:off x="323850" y="695325"/>
-            <a:ext cx="1809750" cy="952500"/>
+                  <a:srgbClr val="D05A2A"/>
+                </a:solidFill>
+              </a:rPr>
+              <a:t>REPLACEABLE INPUTS</a:t>
+            </a:r>
+          </a:p>
+        </p:txBody>
+      </p:sp>
+      <p:sp>
+        <p:nvSpPr>
+          <p:cNvPr id="7" name="rail-title">
+            <a:extLst xmlns:a="http://schemas.openxmlformats.org/drawingml/2006/main">
+              <a:ext uri="{FF2B5EF4-FFF2-40B4-BE49-F238E27FC236}">
+                <a16:creationId xmlns:a16="http://schemas.microsoft.com/office/drawing/2014/main" id="{4CA6B870-F2A6-4D3F-8CCE-6C9E8DF04D5E}"/>
+              </a:ext>
+            </a:extLst>
+          </p:cNvPr>
+          <p:cNvSpPr>
+            <a:spLocks xmlns:a="http://schemas.openxmlformats.org/drawingml/2006/main" noGrp="1"/>
+          </p:cNvSpPr>
+          <p:nvPr/>
+        </p:nvSpPr>
+        <p:spPr>
+          <a:xfrm xmlns:a="http://schemas.openxmlformats.org/drawingml/2006/main">
+            <a:off x="457200" y="1514475"/>
+            <a:ext cx="1676400" cy="238125"/>
           </a:xfrm>
           <a:prstGeom xmlns:a="http://schemas.openxmlformats.org/drawingml/2006/main" prst="rect">
             <a:avLst/>
@@ -1296,116 +1448,99 @@
           <a:lstStyle xmlns:a="http://schemas.openxmlformats.org/drawingml/2006/main"/>
           <a:p xmlns:a="http://schemas.openxmlformats.org/drawingml/2006/main">
             <a:pPr algn="l">
-              <a:defRPr sz="2100" b="1">
-                <a:solidFill>
-                  <a:srgbClr val="FFFDF8"/>
-                </a:solidFill>
-              </a:defRPr>
-            </a:pPr>
-            <a:r>
-              <a:rPr sz="2100" b="1">
-                <a:solidFill>
-                  <a:srgbClr val="FFFDF8"/>
-                </a:solidFill>
-              </a:rPr>
-              <a:t>IntelliCrawl</a:t>
-            </a:r>
-          </a:p>
+              <a:defRPr sz="1275" b="1">
+                <a:solidFill>
+                  <a:srgbClr val="1C2430"/>
+                </a:solidFill>
+              </a:defRPr>
+            </a:pPr>
+            <a:r>
+              <a:rPr sz="1275" b="1">
+                <a:solidFill>
+                  <a:srgbClr val="1C2430"/>
+                </a:solidFill>
+              </a:rPr>
+              <a:t>Provider boundary</a:t>
+            </a:r>
+          </a:p>
+        </p:txBody>
+      </p:sp>
+      <p:sp>
+        <p:nvSpPr>
+          <p:cNvPr id="8" name="rail-copy">
+            <a:extLst xmlns:a="http://schemas.openxmlformats.org/drawingml/2006/main">
+              <a:ext uri="{FF2B5EF4-FFF2-40B4-BE49-F238E27FC236}">
+                <a16:creationId xmlns:a16="http://schemas.microsoft.com/office/drawing/2014/main" id="{8D921B38-CBE8-47B2-A52C-91CCA89B7631}"/>
+              </a:ext>
+            </a:extLst>
+          </p:cNvPr>
+          <p:cNvSpPr>
+            <a:spLocks xmlns:a="http://schemas.openxmlformats.org/drawingml/2006/main" noGrp="1"/>
+          </p:cNvSpPr>
+          <p:nvPr/>
+        </p:nvSpPr>
+        <p:spPr>
+          <a:xfrm xmlns:a="http://schemas.openxmlformats.org/drawingml/2006/main">
+            <a:off x="457200" y="1809750"/>
+            <a:ext cx="1619250" cy="457200"/>
+          </a:xfrm>
+          <a:prstGeom xmlns:a="http://schemas.openxmlformats.org/drawingml/2006/main" prst="rect">
+            <a:avLst/>
+          </a:prstGeom>
+          <a:noFill xmlns:a="http://schemas.openxmlformats.org/drawingml/2006/main"/>
+          <a:ln xmlns:a="http://schemas.openxmlformats.org/drawingml/2006/main" w="0">
+            <a:noFill/>
+            <a:prstDash val="solid"/>
+          </a:ln>
+        </p:spPr>
+        <p:txBody>
+          <a:bodyPr xmlns:a="http://schemas.openxmlformats.org/drawingml/2006/main"/>
+          <a:lstStyle xmlns:a="http://schemas.openxmlformats.org/drawingml/2006/main"/>
           <a:p xmlns:a="http://schemas.openxmlformats.org/drawingml/2006/main">
             <a:pPr algn="l">
-              <a:defRPr sz="2100" b="1">
-                <a:solidFill>
-                  <a:srgbClr val="FFFDF8"/>
-                </a:solidFill>
-              </a:defRPr>
-            </a:pPr>
-            <a:r>
-              <a:rPr sz="2100" b="1">
-                <a:solidFill>
-                  <a:srgbClr val="FFFDF8"/>
-                </a:solidFill>
-              </a:rPr>
-              <a:t>research graph</a:t>
-            </a:r>
-          </a:p>
-        </p:txBody>
-      </p:sp>
-      <p:sp>
-        <p:nvSpPr>
-          <p:cNvPr id="5" name="rail-copy">
-            <a:extLst xmlns:a="http://schemas.openxmlformats.org/drawingml/2006/main">
-              <a:ext uri="{FF2B5EF4-FFF2-40B4-BE49-F238E27FC236}">
-                <a16:creationId xmlns:a16="http://schemas.microsoft.com/office/drawing/2014/main" id="{38112ACD-72B8-4264-80A8-1CC87FF6BF35}"/>
-              </a:ext>
-            </a:extLst>
-          </p:cNvPr>
-          <p:cNvSpPr>
-            <a:spLocks xmlns:a="http://schemas.openxmlformats.org/drawingml/2006/main" noGrp="1"/>
-          </p:cNvSpPr>
-          <p:nvPr/>
-        </p:nvSpPr>
-        <p:spPr>
-          <a:xfrm xmlns:a="http://schemas.openxmlformats.org/drawingml/2006/main">
-            <a:off x="323850" y="1771650"/>
-            <a:ext cx="1752600" cy="666750"/>
-          </a:xfrm>
-          <a:prstGeom xmlns:a="http://schemas.openxmlformats.org/drawingml/2006/main" prst="rect">
-            <a:avLst/>
-          </a:prstGeom>
-          <a:noFill xmlns:a="http://schemas.openxmlformats.org/drawingml/2006/main"/>
-          <a:ln xmlns:a="http://schemas.openxmlformats.org/drawingml/2006/main" w="0">
-            <a:noFill/>
-            <a:prstDash val="solid"/>
-          </a:ln>
-        </p:spPr>
-        <p:txBody>
-          <a:bodyPr xmlns:a="http://schemas.openxmlformats.org/drawingml/2006/main"/>
-          <a:lstStyle xmlns:a="http://schemas.openxmlformats.org/drawingml/2006/main"/>
-          <a:p xmlns:a="http://schemas.openxmlformats.org/drawingml/2006/main">
-            <a:pPr algn="l">
-              <a:defRPr sz="975" b="0">
-                <a:solidFill>
-                  <a:srgbClr val="D8E3DE"/>
-                </a:solidFill>
-              </a:defRPr>
-            </a:pPr>
-            <a:r>
-              <a:rPr sz="975" b="0">
-                <a:solidFill>
-                  <a:srgbClr val="D8E3DE"/>
-                </a:solidFill>
-              </a:rPr>
-              <a:t>One LangGraph owns control flow. Providers can change without changing the graph.</a:t>
-            </a:r>
-          </a:p>
-        </p:txBody>
-      </p:sp>
-      <p:sp>
-        <p:nvSpPr>
-          <p:cNvPr id="6" name="rail-rule">
-            <a:extLst xmlns:a="http://schemas.openxmlformats.org/drawingml/2006/main">
-              <a:ext uri="{FF2B5EF4-FFF2-40B4-BE49-F238E27FC236}">
-                <a16:creationId xmlns:a16="http://schemas.microsoft.com/office/drawing/2014/main" id="{F79F303D-7DDF-4106-A76A-A2A84B4EF791}"/>
-              </a:ext>
-            </a:extLst>
-          </p:cNvPr>
-          <p:cNvSpPr>
-            <a:spLocks xmlns:a="http://schemas.openxmlformats.org/drawingml/2006/main" noGrp="1"/>
-          </p:cNvSpPr>
-          <p:nvPr/>
-        </p:nvSpPr>
-        <p:spPr>
-          <a:xfrm xmlns:a="http://schemas.openxmlformats.org/drawingml/2006/main">
-            <a:off x="323850" y="2667000"/>
-            <a:ext cx="1752600" cy="0"/>
+              <a:defRPr sz="863" b="0">
+                <a:solidFill>
+                  <a:srgbClr val="667085"/>
+                </a:solidFill>
+              </a:defRPr>
+            </a:pPr>
+            <a:r>
+              <a:rPr sz="863" b="0">
+                <a:solidFill>
+                  <a:srgbClr val="667085"/>
+                </a:solidFill>
+              </a:rPr>
+              <a:t>Implementations change; graph state and output contracts do not.</a:t>
+            </a:r>
+          </a:p>
+        </p:txBody>
+      </p:sp>
+      <p:sp>
+        <p:nvSpPr>
+          <p:cNvPr id="9" name="rail-rule">
+            <a:extLst xmlns:a="http://schemas.openxmlformats.org/drawingml/2006/main">
+              <a:ext uri="{FF2B5EF4-FFF2-40B4-BE49-F238E27FC236}">
+                <a16:creationId xmlns:a16="http://schemas.microsoft.com/office/drawing/2014/main" id="{EE228B12-C131-4475-BC71-044AFE89C49C}"/>
+              </a:ext>
+            </a:extLst>
+          </p:cNvPr>
+          <p:cNvSpPr>
+            <a:spLocks xmlns:a="http://schemas.openxmlformats.org/drawingml/2006/main" noGrp="1"/>
+          </p:cNvSpPr>
+          <p:nvPr/>
+        </p:nvSpPr>
+        <p:spPr>
+          <a:xfrm xmlns:a="http://schemas.openxmlformats.org/drawingml/2006/main">
+            <a:off x="457200" y="2381250"/>
+            <a:ext cx="1695450" cy="0"/>
           </a:xfrm>
           <a:prstGeom xmlns:a="http://schemas.openxmlformats.org/drawingml/2006/main" prst="line">
             <a:avLst/>
           </a:prstGeom>
           <a:noFill xmlns:a="http://schemas.openxmlformats.org/drawingml/2006/main"/>
-          <a:ln xmlns:a="http://schemas.openxmlformats.org/drawingml/2006/main" w="11430">
+          <a:ln xmlns:a="http://schemas.openxmlformats.org/drawingml/2006/main" w="10478">
             <a:solidFill>
-              <a:srgbClr val="648076"/>
+              <a:srgbClr val="C9CED6"/>
             </a:solidFill>
             <a:prstDash val="solid"/>
           </a:ln>
@@ -1413,22 +1548,22 @@
       </p:sp>
       <p:sp>
         <p:nvSpPr>
-          <p:cNvPr id="7" name="rail-assemblies">
-            <a:extLst xmlns:a="http://schemas.openxmlformats.org/drawingml/2006/main">
-              <a:ext uri="{FF2B5EF4-FFF2-40B4-BE49-F238E27FC236}">
-                <a16:creationId xmlns:a16="http://schemas.microsoft.com/office/drawing/2014/main" id="{AE3B9B4A-7DBF-4A5E-BB30-DCF12D888C04}"/>
-              </a:ext>
-            </a:extLst>
-          </p:cNvPr>
-          <p:cNvSpPr>
-            <a:spLocks xmlns:a="http://schemas.openxmlformats.org/drawingml/2006/main" noGrp="1"/>
-          </p:cNvSpPr>
-          <p:nvPr/>
-        </p:nvSpPr>
-        <p:spPr>
-          <a:xfrm xmlns:a="http://schemas.openxmlformats.org/drawingml/2006/main">
-            <a:off x="323850" y="2876550"/>
-            <a:ext cx="1714500" cy="171450"/>
+          <p:cNvPr id="10" name="rail-assemblies">
+            <a:extLst xmlns:a="http://schemas.openxmlformats.org/drawingml/2006/main">
+              <a:ext uri="{FF2B5EF4-FFF2-40B4-BE49-F238E27FC236}">
+                <a16:creationId xmlns:a16="http://schemas.microsoft.com/office/drawing/2014/main" id="{D76EB637-D768-4B45-8FF4-F67539F9427E}"/>
+              </a:ext>
+            </a:extLst>
+          </p:cNvPr>
+          <p:cNvSpPr>
+            <a:spLocks xmlns:a="http://schemas.openxmlformats.org/drawingml/2006/main" noGrp="1"/>
+          </p:cNvSpPr>
+          <p:nvPr/>
+        </p:nvSpPr>
+        <p:spPr>
+          <a:xfrm xmlns:a="http://schemas.openxmlformats.org/drawingml/2006/main">
+            <a:off x="457200" y="2562225"/>
+            <a:ext cx="1524000" cy="171450"/>
           </a:xfrm>
           <a:prstGeom xmlns:a="http://schemas.openxmlformats.org/drawingml/2006/main" prst="rect">
             <a:avLst/>
@@ -1446,39 +1581,39 @@
             <a:pPr algn="l">
               <a:defRPr sz="788" b="1">
                 <a:solidFill>
-                  <a:srgbClr val="AFC4BA"/>
+                  <a:srgbClr val="667085"/>
                 </a:solidFill>
               </a:defRPr>
             </a:pPr>
             <a:r>
               <a:rPr sz="788" b="1">
                 <a:solidFill>
-                  <a:srgbClr val="AFC4BA"/>
-                </a:solidFill>
-              </a:rPr>
-              <a:t>PROVIDER ASSEMBLIES</a:t>
-            </a:r>
-          </a:p>
-        </p:txBody>
-      </p:sp>
-      <p:sp>
-        <p:nvSpPr>
-          <p:cNvPr id="8" name="rail-demo">
-            <a:extLst xmlns:a="http://schemas.openxmlformats.org/drawingml/2006/main">
-              <a:ext uri="{FF2B5EF4-FFF2-40B4-BE49-F238E27FC236}">
-                <a16:creationId xmlns:a16="http://schemas.microsoft.com/office/drawing/2014/main" id="{3908851B-0D92-47F5-B0B3-1AFA92FC067E}"/>
-              </a:ext>
-            </a:extLst>
-          </p:cNvPr>
-          <p:cNvSpPr>
-            <a:spLocks xmlns:a="http://schemas.openxmlformats.org/drawingml/2006/main" noGrp="1"/>
-          </p:cNvSpPr>
-          <p:nvPr/>
-        </p:nvSpPr>
-        <p:spPr>
-          <a:xfrm xmlns:a="http://schemas.openxmlformats.org/drawingml/2006/main">
-            <a:off x="323850" y="3209925"/>
-            <a:ext cx="495300" cy="171450"/>
+                  <a:srgbClr val="667085"/>
+                </a:solidFill>
+              </a:rPr>
+              <a:t>ASSEMBLIES</a:t>
+            </a:r>
+          </a:p>
+        </p:txBody>
+      </p:sp>
+      <p:sp>
+        <p:nvSpPr>
+          <p:cNvPr id="11" name="rail-demo">
+            <a:extLst xmlns:a="http://schemas.openxmlformats.org/drawingml/2006/main">
+              <a:ext uri="{FF2B5EF4-FFF2-40B4-BE49-F238E27FC236}">
+                <a16:creationId xmlns:a16="http://schemas.microsoft.com/office/drawing/2014/main" id="{7CA8C776-1360-42DC-A040-071312AE2C3C}"/>
+              </a:ext>
+            </a:extLst>
+          </p:cNvPr>
+          <p:cNvSpPr>
+            <a:spLocks xmlns:a="http://schemas.openxmlformats.org/drawingml/2006/main" noGrp="1"/>
+          </p:cNvSpPr>
+          <p:nvPr/>
+        </p:nvSpPr>
+        <p:spPr>
+          <a:xfrm xmlns:a="http://schemas.openxmlformats.org/drawingml/2006/main">
+            <a:off x="457200" y="2867025"/>
+            <a:ext cx="590550" cy="171450"/>
           </a:xfrm>
           <a:prstGeom xmlns:a="http://schemas.openxmlformats.org/drawingml/2006/main" prst="rect">
             <a:avLst/>
@@ -1494,16 +1629,16 @@
           <a:lstStyle xmlns:a="http://schemas.openxmlformats.org/drawingml/2006/main"/>
           <a:p xmlns:a="http://schemas.openxmlformats.org/drawingml/2006/main">
             <a:pPr algn="l">
-              <a:defRPr sz="750" b="1">
-                <a:solidFill>
-                  <a:srgbClr val="A9D1AE"/>
-                </a:solidFill>
-              </a:defRPr>
-            </a:pPr>
-            <a:r>
-              <a:rPr sz="750" b="1">
-                <a:solidFill>
-                  <a:srgbClr val="A9D1AE"/>
+              <a:defRPr sz="713" b="1">
+                <a:solidFill>
+                  <a:srgbClr val="397EA5"/>
+                </a:solidFill>
+              </a:defRPr>
+            </a:pPr>
+            <a:r>
+              <a:rPr sz="713" b="1">
+                <a:solidFill>
+                  <a:srgbClr val="397EA5"/>
                 </a:solidFill>
               </a:rPr>
               <a:t>DEMO</a:t>
@@ -1513,22 +1648,22 @@
       </p:sp>
       <p:sp>
         <p:nvSpPr>
-          <p:cNvPr id="9" name="rail-demo-copy">
-            <a:extLst xmlns:a="http://schemas.openxmlformats.org/drawingml/2006/main">
-              <a:ext uri="{FF2B5EF4-FFF2-40B4-BE49-F238E27FC236}">
-                <a16:creationId xmlns:a16="http://schemas.microsoft.com/office/drawing/2014/main" id="{86CD9237-FDFA-4E34-AAEC-7CC66CDB6EB7}"/>
-              </a:ext>
-            </a:extLst>
-          </p:cNvPr>
-          <p:cNvSpPr>
-            <a:spLocks xmlns:a="http://schemas.openxmlformats.org/drawingml/2006/main" noGrp="1"/>
-          </p:cNvSpPr>
-          <p:nvPr/>
-        </p:nvSpPr>
-        <p:spPr>
-          <a:xfrm xmlns:a="http://schemas.openxmlformats.org/drawingml/2006/main">
-            <a:off x="857250" y="3181350"/>
-            <a:ext cx="1219200" cy="400050"/>
+          <p:cNvPr id="12" name="rail-demo-copy">
+            <a:extLst xmlns:a="http://schemas.openxmlformats.org/drawingml/2006/main">
+              <a:ext uri="{FF2B5EF4-FFF2-40B4-BE49-F238E27FC236}">
+                <a16:creationId xmlns:a16="http://schemas.microsoft.com/office/drawing/2014/main" id="{7627E05E-177B-4727-B5D4-87A2D6B11C71}"/>
+              </a:ext>
+            </a:extLst>
+          </p:cNvPr>
+          <p:cNvSpPr>
+            <a:spLocks xmlns:a="http://schemas.openxmlformats.org/drawingml/2006/main" noGrp="1"/>
+          </p:cNvSpPr>
+          <p:nvPr/>
+        </p:nvSpPr>
+        <p:spPr>
+          <a:xfrm xmlns:a="http://schemas.openxmlformats.org/drawingml/2006/main">
+            <a:off x="1066800" y="2838450"/>
+            <a:ext cx="1028700" cy="400050"/>
           </a:xfrm>
           <a:prstGeom xmlns:a="http://schemas.openxmlformats.org/drawingml/2006/main" prst="rect">
             <a:avLst/>
@@ -1544,16 +1679,16 @@
           <a:lstStyle xmlns:a="http://schemas.openxmlformats.org/drawingml/2006/main"/>
           <a:p xmlns:a="http://schemas.openxmlformats.org/drawingml/2006/main">
             <a:pPr algn="l">
-              <a:defRPr sz="863" b="0">
-                <a:solidFill>
-                  <a:srgbClr val="FFFDF8"/>
-                </a:solidFill>
-              </a:defRPr>
-            </a:pPr>
-            <a:r>
-              <a:rPr sz="863" b="0">
-                <a:solidFill>
-                  <a:srgbClr val="FFFDF8"/>
+              <a:defRPr sz="788" b="0">
+                <a:solidFill>
+                  <a:srgbClr val="1C2430"/>
+                </a:solidFill>
+              </a:defRPr>
+            </a:pPr>
+            <a:r>
+              <a:rPr sz="788" b="0">
+                <a:solidFill>
+                  <a:srgbClr val="1C2430"/>
                 </a:solidFill>
               </a:rPr>
               <a:t>deterministic search</a:t>
@@ -1561,16 +1696,16 @@
           </a:p>
           <a:p xmlns:a="http://schemas.openxmlformats.org/drawingml/2006/main">
             <a:pPr algn="l">
-              <a:defRPr sz="863" b="0">
-                <a:solidFill>
-                  <a:srgbClr val="FFFDF8"/>
-                </a:solidFill>
-              </a:defRPr>
-            </a:pPr>
-            <a:r>
-              <a:rPr sz="863" b="0">
-                <a:solidFill>
-                  <a:srgbClr val="FFFDF8"/>
+              <a:defRPr sz="788" b="0">
+                <a:solidFill>
+                  <a:srgbClr val="1C2430"/>
+                </a:solidFill>
+              </a:defRPr>
+            </a:pPr>
+            <a:r>
+              <a:rPr sz="788" b="0">
+                <a:solidFill>
+                  <a:srgbClr val="1C2430"/>
                 </a:solidFill>
               </a:rPr>
               <a:t>+ analysis fixtures</a:t>
@@ -1580,22 +1715,22 @@
       </p:sp>
       <p:sp>
         <p:nvSpPr>
-          <p:cNvPr id="10" name="rail-live">
-            <a:extLst xmlns:a="http://schemas.openxmlformats.org/drawingml/2006/main">
-              <a:ext uri="{FF2B5EF4-FFF2-40B4-BE49-F238E27FC236}">
-                <a16:creationId xmlns:a16="http://schemas.microsoft.com/office/drawing/2014/main" id="{4BA49A36-3210-4CB8-8BA4-CEE9B4E86AE6}"/>
-              </a:ext>
-            </a:extLst>
-          </p:cNvPr>
-          <p:cNvSpPr>
-            <a:spLocks xmlns:a="http://schemas.openxmlformats.org/drawingml/2006/main" noGrp="1"/>
-          </p:cNvSpPr>
-          <p:nvPr/>
-        </p:nvSpPr>
-        <p:spPr>
-          <a:xfrm xmlns:a="http://schemas.openxmlformats.org/drawingml/2006/main">
-            <a:off x="323850" y="3781425"/>
-            <a:ext cx="495300" cy="171450"/>
+          <p:cNvPr id="13" name="rail-live">
+            <a:extLst xmlns:a="http://schemas.openxmlformats.org/drawingml/2006/main">
+              <a:ext uri="{FF2B5EF4-FFF2-40B4-BE49-F238E27FC236}">
+                <a16:creationId xmlns:a16="http://schemas.microsoft.com/office/drawing/2014/main" id="{5A247251-BABD-4140-86BF-963BFA63E849}"/>
+              </a:ext>
+            </a:extLst>
+          </p:cNvPr>
+          <p:cNvSpPr>
+            <a:spLocks xmlns:a="http://schemas.openxmlformats.org/drawingml/2006/main" noGrp="1"/>
+          </p:cNvSpPr>
+          <p:nvPr/>
+        </p:nvSpPr>
+        <p:spPr>
+          <a:xfrm xmlns:a="http://schemas.openxmlformats.org/drawingml/2006/main">
+            <a:off x="457200" y="3362325"/>
+            <a:ext cx="590550" cy="171450"/>
           </a:xfrm>
           <a:prstGeom xmlns:a="http://schemas.openxmlformats.org/drawingml/2006/main" prst="rect">
             <a:avLst/>
@@ -1611,16 +1746,16 @@
           <a:lstStyle xmlns:a="http://schemas.openxmlformats.org/drawingml/2006/main"/>
           <a:p xmlns:a="http://schemas.openxmlformats.org/drawingml/2006/main">
             <a:pPr algn="l">
-              <a:defRPr sz="750" b="1">
-                <a:solidFill>
-                  <a:srgbClr val="F2A077"/>
-                </a:solidFill>
-              </a:defRPr>
-            </a:pPr>
-            <a:r>
-              <a:rPr sz="750" b="1">
-                <a:solidFill>
-                  <a:srgbClr val="F2A077"/>
+              <a:defRPr sz="713" b="1">
+                <a:solidFill>
+                  <a:srgbClr val="D05A2A"/>
+                </a:solidFill>
+              </a:defRPr>
+            </a:pPr>
+            <a:r>
+              <a:rPr sz="713" b="1">
+                <a:solidFill>
+                  <a:srgbClr val="D05A2A"/>
                 </a:solidFill>
               </a:rPr>
               <a:t>LIVE</a:t>
@@ -1630,22 +1765,22 @@
       </p:sp>
       <p:sp>
         <p:nvSpPr>
-          <p:cNvPr id="11" name="rail-live-copy">
-            <a:extLst xmlns:a="http://schemas.openxmlformats.org/drawingml/2006/main">
-              <a:ext uri="{FF2B5EF4-FFF2-40B4-BE49-F238E27FC236}">
-                <a16:creationId xmlns:a16="http://schemas.microsoft.com/office/drawing/2014/main" id="{B7D02D0B-8269-4040-B667-08DF05F48D63}"/>
-              </a:ext>
-            </a:extLst>
-          </p:cNvPr>
-          <p:cNvSpPr>
-            <a:spLocks xmlns:a="http://schemas.openxmlformats.org/drawingml/2006/main" noGrp="1"/>
-          </p:cNvSpPr>
-          <p:nvPr/>
-        </p:nvSpPr>
-        <p:spPr>
-          <a:xfrm xmlns:a="http://schemas.openxmlformats.org/drawingml/2006/main">
-            <a:off x="857250" y="3752850"/>
-            <a:ext cx="1257300" cy="400050"/>
+          <p:cNvPr id="14" name="rail-live-copy">
+            <a:extLst xmlns:a="http://schemas.openxmlformats.org/drawingml/2006/main">
+              <a:ext uri="{FF2B5EF4-FFF2-40B4-BE49-F238E27FC236}">
+                <a16:creationId xmlns:a16="http://schemas.microsoft.com/office/drawing/2014/main" id="{8794E44B-F769-4303-B3ED-5733DD521C4A}"/>
+              </a:ext>
+            </a:extLst>
+          </p:cNvPr>
+          <p:cNvSpPr>
+            <a:spLocks xmlns:a="http://schemas.openxmlformats.org/drawingml/2006/main" noGrp="1"/>
+          </p:cNvSpPr>
+          <p:nvPr/>
+        </p:nvSpPr>
+        <p:spPr>
+          <a:xfrm xmlns:a="http://schemas.openxmlformats.org/drawingml/2006/main">
+            <a:off x="1066800" y="3333750"/>
+            <a:ext cx="1028700" cy="400050"/>
           </a:xfrm>
           <a:prstGeom xmlns:a="http://schemas.openxmlformats.org/drawingml/2006/main" prst="rect">
             <a:avLst/>
@@ -1661,16 +1796,16 @@
           <a:lstStyle xmlns:a="http://schemas.openxmlformats.org/drawingml/2006/main"/>
           <a:p xmlns:a="http://schemas.openxmlformats.org/drawingml/2006/main">
             <a:pPr algn="l">
-              <a:defRPr sz="863" b="0">
-                <a:solidFill>
-                  <a:srgbClr val="FFFDF8"/>
-                </a:solidFill>
-              </a:defRPr>
-            </a:pPr>
-            <a:r>
-              <a:rPr sz="863" b="0">
-                <a:solidFill>
-                  <a:srgbClr val="FFFDF8"/>
+              <a:defRPr sz="788" b="0">
+                <a:solidFill>
+                  <a:srgbClr val="1C2430"/>
+                </a:solidFill>
+              </a:defRPr>
+            </a:pPr>
+            <a:r>
+              <a:rPr sz="788" b="0">
+                <a:solidFill>
+                  <a:srgbClr val="1C2430"/>
                 </a:solidFill>
               </a:rPr>
               <a:t>Firecrawl + cache</a:t>
@@ -1678,16 +1813,16 @@
           </a:p>
           <a:p xmlns:a="http://schemas.openxmlformats.org/drawingml/2006/main">
             <a:pPr algn="l">
-              <a:defRPr sz="863" b="0">
-                <a:solidFill>
-                  <a:srgbClr val="FFFDF8"/>
-                </a:solidFill>
-              </a:defRPr>
-            </a:pPr>
-            <a:r>
-              <a:rPr sz="863" b="0">
-                <a:solidFill>
-                  <a:srgbClr val="FFFDF8"/>
+              <a:defRPr sz="788" b="0">
+                <a:solidFill>
+                  <a:srgbClr val="1C2430"/>
+                </a:solidFill>
+              </a:defRPr>
+            </a:pPr>
+            <a:r>
+              <a:rPr sz="788" b="0">
+                <a:solidFill>
+                  <a:srgbClr val="1C2430"/>
                 </a:solidFill>
               </a:rPr>
               <a:t>OpenAI structured output</a:t>
@@ -1697,30 +1832,30 @@
       </p:sp>
       <p:sp>
         <p:nvSpPr>
-          <p:cNvPr id="12" name="rail-rule-2">
-            <a:extLst xmlns:a="http://schemas.openxmlformats.org/drawingml/2006/main">
-              <a:ext uri="{FF2B5EF4-FFF2-40B4-BE49-F238E27FC236}">
-                <a16:creationId xmlns:a16="http://schemas.microsoft.com/office/drawing/2014/main" id="{8B58D728-569A-4CB2-B6AA-41E573331F76}"/>
-              </a:ext>
-            </a:extLst>
-          </p:cNvPr>
-          <p:cNvSpPr>
-            <a:spLocks xmlns:a="http://schemas.openxmlformats.org/drawingml/2006/main" noGrp="1"/>
-          </p:cNvSpPr>
-          <p:nvPr/>
-        </p:nvSpPr>
-        <p:spPr>
-          <a:xfrm xmlns:a="http://schemas.openxmlformats.org/drawingml/2006/main">
-            <a:off x="323850" y="4400550"/>
-            <a:ext cx="1752600" cy="0"/>
+          <p:cNvPr id="15" name="rail-rule-2">
+            <a:extLst xmlns:a="http://schemas.openxmlformats.org/drawingml/2006/main">
+              <a:ext uri="{FF2B5EF4-FFF2-40B4-BE49-F238E27FC236}">
+                <a16:creationId xmlns:a16="http://schemas.microsoft.com/office/drawing/2014/main" id="{A21B816F-F9FF-4383-81E8-9DA960970A64}"/>
+              </a:ext>
+            </a:extLst>
+          </p:cNvPr>
+          <p:cNvSpPr>
+            <a:spLocks xmlns:a="http://schemas.openxmlformats.org/drawingml/2006/main" noGrp="1"/>
+          </p:cNvSpPr>
+          <p:nvPr/>
+        </p:nvSpPr>
+        <p:spPr>
+          <a:xfrm xmlns:a="http://schemas.openxmlformats.org/drawingml/2006/main">
+            <a:off x="457200" y="3905250"/>
+            <a:ext cx="1695450" cy="0"/>
           </a:xfrm>
           <a:prstGeom xmlns:a="http://schemas.openxmlformats.org/drawingml/2006/main" prst="line">
             <a:avLst/>
           </a:prstGeom>
           <a:noFill xmlns:a="http://schemas.openxmlformats.org/drawingml/2006/main"/>
-          <a:ln xmlns:a="http://schemas.openxmlformats.org/drawingml/2006/main" w="11430">
+          <a:ln xmlns:a="http://schemas.openxmlformats.org/drawingml/2006/main" w="10478">
             <a:solidFill>
-              <a:srgbClr val="648076"/>
+              <a:srgbClr val="C9CED6"/>
             </a:solidFill>
             <a:prstDash val="solid"/>
           </a:ln>
@@ -1728,22 +1863,22 @@
       </p:sp>
       <p:sp>
         <p:nvSpPr>
-          <p:cNvPr id="13" name="rail-interfaces">
-            <a:extLst xmlns:a="http://schemas.openxmlformats.org/drawingml/2006/main">
-              <a:ext uri="{FF2B5EF4-FFF2-40B4-BE49-F238E27FC236}">
-                <a16:creationId xmlns:a16="http://schemas.microsoft.com/office/drawing/2014/main" id="{27D4F76E-4D48-4BAC-B874-7C048EF6A4E4}"/>
-              </a:ext>
-            </a:extLst>
-          </p:cNvPr>
-          <p:cNvSpPr>
-            <a:spLocks xmlns:a="http://schemas.openxmlformats.org/drawingml/2006/main" noGrp="1"/>
-          </p:cNvSpPr>
-          <p:nvPr/>
-        </p:nvSpPr>
-        <p:spPr>
-          <a:xfrm xmlns:a="http://schemas.openxmlformats.org/drawingml/2006/main">
-            <a:off x="323850" y="4610100"/>
-            <a:ext cx="1714500" cy="171450"/>
+          <p:cNvPr id="16" name="rail-interfaces">
+            <a:extLst xmlns:a="http://schemas.openxmlformats.org/drawingml/2006/main">
+              <a:ext uri="{FF2B5EF4-FFF2-40B4-BE49-F238E27FC236}">
+                <a16:creationId xmlns:a16="http://schemas.microsoft.com/office/drawing/2014/main" id="{B76102D5-E951-4309-AABD-A2EEFC0266D6}"/>
+              </a:ext>
+            </a:extLst>
+          </p:cNvPr>
+          <p:cNvSpPr>
+            <a:spLocks xmlns:a="http://schemas.openxmlformats.org/drawingml/2006/main" noGrp="1"/>
+          </p:cNvSpPr>
+          <p:nvPr/>
+        </p:nvSpPr>
+        <p:spPr>
+          <a:xfrm xmlns:a="http://schemas.openxmlformats.org/drawingml/2006/main">
+            <a:off x="457200" y="4076700"/>
+            <a:ext cx="1524000" cy="171450"/>
           </a:xfrm>
           <a:prstGeom xmlns:a="http://schemas.openxmlformats.org/drawingml/2006/main" prst="rect">
             <a:avLst/>
@@ -1761,39 +1896,39 @@
             <a:pPr algn="l">
               <a:defRPr sz="788" b="1">
                 <a:solidFill>
-                  <a:srgbClr val="AFC4BA"/>
+                  <a:srgbClr val="667085"/>
                 </a:solidFill>
               </a:defRPr>
             </a:pPr>
             <a:r>
               <a:rPr sz="788" b="1">
                 <a:solidFill>
-                  <a:srgbClr val="AFC4BA"/>
-                </a:solidFill>
-              </a:rPr>
-              <a:t>REPLACEABLE PORTS</a:t>
-            </a:r>
-          </a:p>
-        </p:txBody>
-      </p:sp>
-      <p:sp>
-        <p:nvSpPr>
-          <p:cNvPr id="14" name="rail-search">
-            <a:extLst xmlns:a="http://schemas.openxmlformats.org/drawingml/2006/main">
-              <a:ext uri="{FF2B5EF4-FFF2-40B4-BE49-F238E27FC236}">
-                <a16:creationId xmlns:a16="http://schemas.microsoft.com/office/drawing/2014/main" id="{54AF017C-6C0B-4BAF-B259-91827C051EC4}"/>
-              </a:ext>
-            </a:extLst>
-          </p:cNvPr>
-          <p:cNvSpPr>
-            <a:spLocks xmlns:a="http://schemas.openxmlformats.org/drawingml/2006/main" noGrp="1"/>
-          </p:cNvSpPr>
-          <p:nvPr/>
-        </p:nvSpPr>
-        <p:spPr>
-          <a:xfrm xmlns:a="http://schemas.openxmlformats.org/drawingml/2006/main">
-            <a:off x="323850" y="4953000"/>
-            <a:ext cx="1428750" cy="190500"/>
+                  <a:srgbClr val="667085"/>
+                </a:solidFill>
+              </a:rPr>
+              <a:t>PORTS</a:t>
+            </a:r>
+          </a:p>
+        </p:txBody>
+      </p:sp>
+      <p:sp>
+        <p:nvSpPr>
+          <p:cNvPr id="17" name="rail-search">
+            <a:extLst xmlns:a="http://schemas.openxmlformats.org/drawingml/2006/main">
+              <a:ext uri="{FF2B5EF4-FFF2-40B4-BE49-F238E27FC236}">
+                <a16:creationId xmlns:a16="http://schemas.microsoft.com/office/drawing/2014/main" id="{5B0301BC-3ADD-4ECC-AFE4-EF7D47879DB7}"/>
+              </a:ext>
+            </a:extLst>
+          </p:cNvPr>
+          <p:cNvSpPr>
+            <a:spLocks xmlns:a="http://schemas.openxmlformats.org/drawingml/2006/main" noGrp="1"/>
+          </p:cNvSpPr>
+          <p:nvPr/>
+        </p:nvSpPr>
+        <p:spPr>
+          <a:xfrm xmlns:a="http://schemas.openxmlformats.org/drawingml/2006/main">
+            <a:off x="457200" y="4333875"/>
+            <a:ext cx="1466850" cy="190500"/>
           </a:xfrm>
           <a:prstGeom xmlns:a="http://schemas.openxmlformats.org/drawingml/2006/main" prst="rect">
             <a:avLst/>
@@ -1809,16 +1944,16 @@
           <a:lstStyle xmlns:a="http://schemas.openxmlformats.org/drawingml/2006/main"/>
           <a:p xmlns:a="http://schemas.openxmlformats.org/drawingml/2006/main">
             <a:pPr algn="l">
-              <a:defRPr sz="900" b="1">
-                <a:solidFill>
-                  <a:srgbClr val="FFFDF8"/>
-                </a:solidFill>
-              </a:defRPr>
-            </a:pPr>
-            <a:r>
-              <a:rPr sz="900" b="1">
-                <a:solidFill>
-                  <a:srgbClr val="FFFDF8"/>
+              <a:defRPr sz="863" b="1">
+                <a:solidFill>
+                  <a:srgbClr val="1C2430"/>
+                </a:solidFill>
+              </a:defRPr>
+            </a:pPr>
+            <a:r>
+              <a:rPr sz="863" b="1">
+                <a:solidFill>
+                  <a:srgbClr val="1C2430"/>
                 </a:solidFill>
               </a:rPr>
               <a:t>SearchProvider</a:t>
@@ -1828,172 +1963,22 @@
       </p:sp>
       <p:sp>
         <p:nvSpPr>
-          <p:cNvPr id="15" name="rail-source">
-            <a:extLst xmlns:a="http://schemas.openxmlformats.org/drawingml/2006/main">
-              <a:ext uri="{FF2B5EF4-FFF2-40B4-BE49-F238E27FC236}">
-                <a16:creationId xmlns:a16="http://schemas.microsoft.com/office/drawing/2014/main" id="{CDAC75F6-D20A-4F36-AE85-5AE53143CE22}"/>
-              </a:ext>
-            </a:extLst>
-          </p:cNvPr>
-          <p:cNvSpPr>
-            <a:spLocks xmlns:a="http://schemas.openxmlformats.org/drawingml/2006/main" noGrp="1"/>
-          </p:cNvSpPr>
-          <p:nvPr/>
-        </p:nvSpPr>
-        <p:spPr>
-          <a:xfrm xmlns:a="http://schemas.openxmlformats.org/drawingml/2006/main">
-            <a:off x="323850" y="5191125"/>
+          <p:cNvPr id="18" name="rail-source">
+            <a:extLst xmlns:a="http://schemas.openxmlformats.org/drawingml/2006/main">
+              <a:ext uri="{FF2B5EF4-FFF2-40B4-BE49-F238E27FC236}">
+                <a16:creationId xmlns:a16="http://schemas.microsoft.com/office/drawing/2014/main" id="{8CCA0B5F-74B0-41E5-B8B0-96929CD57D95}"/>
+              </a:ext>
+            </a:extLst>
+          </p:cNvPr>
+          <p:cNvSpPr>
+            <a:spLocks xmlns:a="http://schemas.openxmlformats.org/drawingml/2006/main" noGrp="1"/>
+          </p:cNvSpPr>
+          <p:nvPr/>
+        </p:nvSpPr>
+        <p:spPr>
+          <a:xfrm xmlns:a="http://schemas.openxmlformats.org/drawingml/2006/main">
+            <a:off x="457200" y="4572000"/>
             <a:ext cx="1524000" cy="171450"/>
-          </a:xfrm>
-          <a:prstGeom xmlns:a="http://schemas.openxmlformats.org/drawingml/2006/main" prst="rect">
-            <a:avLst/>
-          </a:prstGeom>
-          <a:noFill xmlns:a="http://schemas.openxmlformats.org/drawingml/2006/main"/>
-          <a:ln xmlns:a="http://schemas.openxmlformats.org/drawingml/2006/main" w="0">
-            <a:noFill/>
-            <a:prstDash val="solid"/>
-          </a:ln>
-        </p:spPr>
-        <p:txBody>
-          <a:bodyPr xmlns:a="http://schemas.openxmlformats.org/drawingml/2006/main"/>
-          <a:lstStyle xmlns:a="http://schemas.openxmlformats.org/drawingml/2006/main"/>
-          <a:p xmlns:a="http://schemas.openxmlformats.org/drawingml/2006/main">
-            <a:pPr algn="l">
-              <a:defRPr sz="750" b="0">
-                <a:solidFill>
-                  <a:srgbClr val="C8D8D0"/>
-                </a:solidFill>
-              </a:defRPr>
-            </a:pPr>
-            <a:r>
-              <a:rPr sz="750" b="0">
-                <a:solidFill>
-                  <a:srgbClr val="C8D8D0"/>
-                </a:solidFill>
-              </a:rPr>
-              <a:t>→ SourceDocument[]</a:t>
-            </a:r>
-          </a:p>
-        </p:txBody>
-      </p:sp>
-      <p:sp>
-        <p:nvSpPr>
-          <p:cNvPr id="16" name="rail-analysis">
-            <a:extLst xmlns:a="http://schemas.openxmlformats.org/drawingml/2006/main">
-              <a:ext uri="{FF2B5EF4-FFF2-40B4-BE49-F238E27FC236}">
-                <a16:creationId xmlns:a16="http://schemas.microsoft.com/office/drawing/2014/main" id="{EC269638-9C3A-4A84-B6D4-0E54159DEE9F}"/>
-              </a:ext>
-            </a:extLst>
-          </p:cNvPr>
-          <p:cNvSpPr>
-            <a:spLocks xmlns:a="http://schemas.openxmlformats.org/drawingml/2006/main" noGrp="1"/>
-          </p:cNvSpPr>
-          <p:nvPr/>
-        </p:nvSpPr>
-        <p:spPr>
-          <a:xfrm xmlns:a="http://schemas.openxmlformats.org/drawingml/2006/main">
-            <a:off x="323850" y="5505450"/>
-            <a:ext cx="1524000" cy="190500"/>
-          </a:xfrm>
-          <a:prstGeom xmlns:a="http://schemas.openxmlformats.org/drawingml/2006/main" prst="rect">
-            <a:avLst/>
-          </a:prstGeom>
-          <a:noFill xmlns:a="http://schemas.openxmlformats.org/drawingml/2006/main"/>
-          <a:ln xmlns:a="http://schemas.openxmlformats.org/drawingml/2006/main" w="0">
-            <a:noFill/>
-            <a:prstDash val="solid"/>
-          </a:ln>
-        </p:spPr>
-        <p:txBody>
-          <a:bodyPr xmlns:a="http://schemas.openxmlformats.org/drawingml/2006/main"/>
-          <a:lstStyle xmlns:a="http://schemas.openxmlformats.org/drawingml/2006/main"/>
-          <a:p xmlns:a="http://schemas.openxmlformats.org/drawingml/2006/main">
-            <a:pPr algn="l">
-              <a:defRPr sz="900" b="1">
-                <a:solidFill>
-                  <a:srgbClr val="FFFDF8"/>
-                </a:solidFill>
-              </a:defRPr>
-            </a:pPr>
-            <a:r>
-              <a:rPr sz="900" b="1">
-                <a:solidFill>
-                  <a:srgbClr val="FFFDF8"/>
-                </a:solidFill>
-              </a:rPr>
-              <a:t>AnalysisProvider</a:t>
-            </a:r>
-          </a:p>
-        </p:txBody>
-      </p:sp>
-      <p:sp>
-        <p:nvSpPr>
-          <p:cNvPr id="17" name="rail-schema">
-            <a:extLst xmlns:a="http://schemas.openxmlformats.org/drawingml/2006/main">
-              <a:ext uri="{FF2B5EF4-FFF2-40B4-BE49-F238E27FC236}">
-                <a16:creationId xmlns:a16="http://schemas.microsoft.com/office/drawing/2014/main" id="{BD0CEC5F-9192-4358-980A-ED796389D075}"/>
-              </a:ext>
-            </a:extLst>
-          </p:cNvPr>
-          <p:cNvSpPr>
-            <a:spLocks xmlns:a="http://schemas.openxmlformats.org/drawingml/2006/main" noGrp="1"/>
-          </p:cNvSpPr>
-          <p:nvPr/>
-        </p:nvSpPr>
-        <p:spPr>
-          <a:xfrm xmlns:a="http://schemas.openxmlformats.org/drawingml/2006/main">
-            <a:off x="323850" y="5743575"/>
-            <a:ext cx="1428750" cy="171450"/>
-          </a:xfrm>
-          <a:prstGeom xmlns:a="http://schemas.openxmlformats.org/drawingml/2006/main" prst="rect">
-            <a:avLst/>
-          </a:prstGeom>
-          <a:noFill xmlns:a="http://schemas.openxmlformats.org/drawingml/2006/main"/>
-          <a:ln xmlns:a="http://schemas.openxmlformats.org/drawingml/2006/main" w="0">
-            <a:noFill/>
-            <a:prstDash val="solid"/>
-          </a:ln>
-        </p:spPr>
-        <p:txBody>
-          <a:bodyPr xmlns:a="http://schemas.openxmlformats.org/drawingml/2006/main"/>
-          <a:lstStyle xmlns:a="http://schemas.openxmlformats.org/drawingml/2006/main"/>
-          <a:p xmlns:a="http://schemas.openxmlformats.org/drawingml/2006/main">
-            <a:pPr algn="l">
-              <a:defRPr sz="750" b="0">
-                <a:solidFill>
-                  <a:srgbClr val="C8D8D0"/>
-                </a:solidFill>
-              </a:defRPr>
-            </a:pPr>
-            <a:r>
-              <a:rPr sz="750" b="0">
-                <a:solidFill>
-                  <a:srgbClr val="C8D8D0"/>
-                </a:solidFill>
-              </a:rPr>
-              <a:t>→ typed schemas</a:t>
-            </a:r>
-          </a:p>
-        </p:txBody>
-      </p:sp>
-      <p:sp>
-        <p:nvSpPr>
-          <p:cNvPr id="18" name="rail-foot">
-            <a:extLst xmlns:a="http://schemas.openxmlformats.org/drawingml/2006/main">
-              <a:ext uri="{FF2B5EF4-FFF2-40B4-BE49-F238E27FC236}">
-                <a16:creationId xmlns:a16="http://schemas.microsoft.com/office/drawing/2014/main" id="{27EA839D-E1AA-483C-BD10-9B32EA6E0635}"/>
-              </a:ext>
-            </a:extLst>
-          </p:cNvPr>
-          <p:cNvSpPr>
-            <a:spLocks xmlns:a="http://schemas.openxmlformats.org/drawingml/2006/main" noGrp="1"/>
-          </p:cNvSpPr>
-          <p:nvPr/>
-        </p:nvSpPr>
-        <p:spPr>
-          <a:xfrm xmlns:a="http://schemas.openxmlformats.org/drawingml/2006/main">
-            <a:off x="323850" y="6381750"/>
-            <a:ext cx="1752600" cy="266700"/>
           </a:xfrm>
           <a:prstGeom xmlns:a="http://schemas.openxmlformats.org/drawingml/2006/main" prst="rect">
             <a:avLst/>
@@ -2011,27 +1996,177 @@
             <a:pPr algn="l">
               <a:defRPr sz="713" b="0">
                 <a:solidFill>
-                  <a:srgbClr val="9FB5AA"/>
+                  <a:srgbClr val="397EA5"/>
                 </a:solidFill>
               </a:defRPr>
             </a:pPr>
             <a:r>
               <a:rPr sz="713" b="0">
                 <a:solidFill>
-                  <a:srgbClr val="9FB5AA"/>
-                </a:solidFill>
-              </a:rPr>
-              <a:t>Public web content remains untrusted input.</a:t>
-            </a:r>
-          </a:p>
-        </p:txBody>
-      </p:sp>
-      <p:sp>
-        <p:nvSpPr>
-          <p:cNvPr id="19" name="discover-research">
-            <a:extLst xmlns:a="http://schemas.openxmlformats.org/drawingml/2006/main">
-              <a:ext uri="{FF2B5EF4-FFF2-40B4-BE49-F238E27FC236}">
-                <a16:creationId xmlns:a16="http://schemas.microsoft.com/office/drawing/2014/main" id="{D704B8A2-C8A9-4FE3-ADBC-AF115A7FE2E4}"/>
+                  <a:srgbClr val="397EA5"/>
+                </a:solidFill>
+              </a:rPr>
+              <a:t>→ SourceDocument[]</a:t>
+            </a:r>
+          </a:p>
+        </p:txBody>
+      </p:sp>
+      <p:sp>
+        <p:nvSpPr>
+          <p:cNvPr id="19" name="rail-analysis">
+            <a:extLst xmlns:a="http://schemas.openxmlformats.org/drawingml/2006/main">
+              <a:ext uri="{FF2B5EF4-FFF2-40B4-BE49-F238E27FC236}">
+                <a16:creationId xmlns:a16="http://schemas.microsoft.com/office/drawing/2014/main" id="{A943B109-BE4D-414A-8719-03A845967AE6}"/>
+              </a:ext>
+            </a:extLst>
+          </p:cNvPr>
+          <p:cNvSpPr>
+            <a:spLocks xmlns:a="http://schemas.openxmlformats.org/drawingml/2006/main" noGrp="1"/>
+          </p:cNvSpPr>
+          <p:nvPr/>
+        </p:nvSpPr>
+        <p:spPr>
+          <a:xfrm xmlns:a="http://schemas.openxmlformats.org/drawingml/2006/main">
+            <a:off x="457200" y="4895850"/>
+            <a:ext cx="1524000" cy="190500"/>
+          </a:xfrm>
+          <a:prstGeom xmlns:a="http://schemas.openxmlformats.org/drawingml/2006/main" prst="rect">
+            <a:avLst/>
+          </a:prstGeom>
+          <a:noFill xmlns:a="http://schemas.openxmlformats.org/drawingml/2006/main"/>
+          <a:ln xmlns:a="http://schemas.openxmlformats.org/drawingml/2006/main" w="0">
+            <a:noFill/>
+            <a:prstDash val="solid"/>
+          </a:ln>
+        </p:spPr>
+        <p:txBody>
+          <a:bodyPr xmlns:a="http://schemas.openxmlformats.org/drawingml/2006/main"/>
+          <a:lstStyle xmlns:a="http://schemas.openxmlformats.org/drawingml/2006/main"/>
+          <a:p xmlns:a="http://schemas.openxmlformats.org/drawingml/2006/main">
+            <a:pPr algn="l">
+              <a:defRPr sz="863" b="1">
+                <a:solidFill>
+                  <a:srgbClr val="1C2430"/>
+                </a:solidFill>
+              </a:defRPr>
+            </a:pPr>
+            <a:r>
+              <a:rPr sz="863" b="1">
+                <a:solidFill>
+                  <a:srgbClr val="1C2430"/>
+                </a:solidFill>
+              </a:rPr>
+              <a:t>AnalysisProvider</a:t>
+            </a:r>
+          </a:p>
+        </p:txBody>
+      </p:sp>
+      <p:sp>
+        <p:nvSpPr>
+          <p:cNvPr id="20" name="rail-schema">
+            <a:extLst xmlns:a="http://schemas.openxmlformats.org/drawingml/2006/main">
+              <a:ext uri="{FF2B5EF4-FFF2-40B4-BE49-F238E27FC236}">
+                <a16:creationId xmlns:a16="http://schemas.microsoft.com/office/drawing/2014/main" id="{97692019-A330-4FD9-AC09-EED9D4E4CCBF}"/>
+              </a:ext>
+            </a:extLst>
+          </p:cNvPr>
+          <p:cNvSpPr>
+            <a:spLocks xmlns:a="http://schemas.openxmlformats.org/drawingml/2006/main" noGrp="1"/>
+          </p:cNvSpPr>
+          <p:nvPr/>
+        </p:nvSpPr>
+        <p:spPr>
+          <a:xfrm xmlns:a="http://schemas.openxmlformats.org/drawingml/2006/main">
+            <a:off x="457200" y="5133975"/>
+            <a:ext cx="1428750" cy="171450"/>
+          </a:xfrm>
+          <a:prstGeom xmlns:a="http://schemas.openxmlformats.org/drawingml/2006/main" prst="rect">
+            <a:avLst/>
+          </a:prstGeom>
+          <a:noFill xmlns:a="http://schemas.openxmlformats.org/drawingml/2006/main"/>
+          <a:ln xmlns:a="http://schemas.openxmlformats.org/drawingml/2006/main" w="0">
+            <a:noFill/>
+            <a:prstDash val="solid"/>
+          </a:ln>
+        </p:spPr>
+        <p:txBody>
+          <a:bodyPr xmlns:a="http://schemas.openxmlformats.org/drawingml/2006/main"/>
+          <a:lstStyle xmlns:a="http://schemas.openxmlformats.org/drawingml/2006/main"/>
+          <a:p xmlns:a="http://schemas.openxmlformats.org/drawingml/2006/main">
+            <a:pPr algn="l">
+              <a:defRPr sz="713" b="0">
+                <a:solidFill>
+                  <a:srgbClr val="D05A2A"/>
+                </a:solidFill>
+              </a:defRPr>
+            </a:pPr>
+            <a:r>
+              <a:rPr sz="713" b="0">
+                <a:solidFill>
+                  <a:srgbClr val="D05A2A"/>
+                </a:solidFill>
+              </a:rPr>
+              <a:t>→ typed schemas</a:t>
+            </a:r>
+          </a:p>
+        </p:txBody>
+      </p:sp>
+      <p:sp>
+        <p:nvSpPr>
+          <p:cNvPr id="21" name="rail-foot">
+            <a:extLst xmlns:a="http://schemas.openxmlformats.org/drawingml/2006/main">
+              <a:ext uri="{FF2B5EF4-FFF2-40B4-BE49-F238E27FC236}">
+                <a16:creationId xmlns:a16="http://schemas.microsoft.com/office/drawing/2014/main" id="{72B8FB90-AE4F-4720-A100-6A726E07D8FC}"/>
+              </a:ext>
+            </a:extLst>
+          </p:cNvPr>
+          <p:cNvSpPr>
+            <a:spLocks xmlns:a="http://schemas.openxmlformats.org/drawingml/2006/main" noGrp="1"/>
+          </p:cNvSpPr>
+          <p:nvPr/>
+        </p:nvSpPr>
+        <p:spPr>
+          <a:xfrm xmlns:a="http://schemas.openxmlformats.org/drawingml/2006/main">
+            <a:off x="457200" y="5562600"/>
+            <a:ext cx="1619250" cy="266700"/>
+          </a:xfrm>
+          <a:prstGeom xmlns:a="http://schemas.openxmlformats.org/drawingml/2006/main" prst="rect">
+            <a:avLst/>
+          </a:prstGeom>
+          <a:noFill xmlns:a="http://schemas.openxmlformats.org/drawingml/2006/main"/>
+          <a:ln xmlns:a="http://schemas.openxmlformats.org/drawingml/2006/main" w="0">
+            <a:noFill/>
+            <a:prstDash val="solid"/>
+          </a:ln>
+        </p:spPr>
+        <p:txBody>
+          <a:bodyPr xmlns:a="http://schemas.openxmlformats.org/drawingml/2006/main"/>
+          <a:lstStyle xmlns:a="http://schemas.openxmlformats.org/drawingml/2006/main"/>
+          <a:p xmlns:a="http://schemas.openxmlformats.org/drawingml/2006/main">
+            <a:pPr algn="l">
+              <a:defRPr sz="698" b="0">
+                <a:solidFill>
+                  <a:srgbClr val="667085"/>
+                </a:solidFill>
+              </a:defRPr>
+            </a:pPr>
+            <a:r>
+              <a:rPr sz="698" b="0">
+                <a:solidFill>
+                  <a:srgbClr val="667085"/>
+                </a:solidFill>
+              </a:rPr>
+              <a:t>Public-web content remains untrusted input.</a:t>
+            </a:r>
+          </a:p>
+        </p:txBody>
+      </p:sp>
+      <p:sp>
+        <p:nvSpPr>
+          <p:cNvPr id="22" name="discover-research">
+            <a:extLst xmlns:a="http://schemas.openxmlformats.org/drawingml/2006/main">
+              <a:ext uri="{FF2B5EF4-FFF2-40B4-BE49-F238E27FC236}">
+                <a16:creationId xmlns:a16="http://schemas.microsoft.com/office/drawing/2014/main" id="{9976D371-5C05-41A2-9BEF-9C8FFD33DD86}"/>
               </a:ext>
             </a:extLst>
           </p:cNvPr>
@@ -2049,11 +2184,11 @@
             <a:avLst/>
           </a:prstGeom>
           <a:solidFill xmlns:a="http://schemas.openxmlformats.org/drawingml/2006/main">
-            <a:srgbClr val="52725D"/>
+            <a:srgbClr val="397EA5"/>
           </a:solidFill>
           <a:ln xmlns:a="http://schemas.openxmlformats.org/drawingml/2006/main" w="0">
             <a:solidFill>
-              <a:srgbClr val="52725D"/>
+              <a:srgbClr val="397EA5"/>
             </a:solidFill>
             <a:prstDash val="solid"/>
           </a:ln>
@@ -2061,10 +2196,10 @@
       </p:sp>
       <p:sp>
         <p:nvSpPr>
-          <p:cNvPr id="20" name="research-recommend">
-            <a:extLst xmlns:a="http://schemas.openxmlformats.org/drawingml/2006/main">
-              <a:ext uri="{FF2B5EF4-FFF2-40B4-BE49-F238E27FC236}">
-                <a16:creationId xmlns:a16="http://schemas.microsoft.com/office/drawing/2014/main" id="{4616D20B-CA2B-44A1-BC05-88983533FFEE}"/>
+          <p:cNvPr id="23" name="research-recommend">
+            <a:extLst xmlns:a="http://schemas.openxmlformats.org/drawingml/2006/main">
+              <a:ext uri="{FF2B5EF4-FFF2-40B4-BE49-F238E27FC236}">
+                <a16:creationId xmlns:a16="http://schemas.microsoft.com/office/drawing/2014/main" id="{E4D8D007-3A72-4F1F-B696-AA5930945F35}"/>
               </a:ext>
             </a:extLst>
           </p:cNvPr>
@@ -2082,11 +2217,11 @@
             <a:avLst/>
           </a:prstGeom>
           <a:solidFill xmlns:a="http://schemas.openxmlformats.org/drawingml/2006/main">
-            <a:srgbClr val="C6653E"/>
+            <a:srgbClr val="D05A2A"/>
           </a:solidFill>
           <a:ln xmlns:a="http://schemas.openxmlformats.org/drawingml/2006/main" w="0">
             <a:solidFill>
-              <a:srgbClr val="C6653E"/>
+              <a:srgbClr val="D05A2A"/>
             </a:solidFill>
             <a:prstDash val="solid"/>
           </a:ln>
@@ -2094,10 +2229,10 @@
       </p:sp>
       <p:sp>
         <p:nvSpPr>
-          <p:cNvPr id="21" name="recommend-report">
-            <a:extLst xmlns:a="http://schemas.openxmlformats.org/drawingml/2006/main">
-              <a:ext uri="{FF2B5EF4-FFF2-40B4-BE49-F238E27FC236}">
-                <a16:creationId xmlns:a16="http://schemas.microsoft.com/office/drawing/2014/main" id="{420A8459-5BDC-44F3-A1F6-BF25B6FE90F8}"/>
+          <p:cNvPr id="24" name="recommend-report">
+            <a:extLst xmlns:a="http://schemas.openxmlformats.org/drawingml/2006/main">
+              <a:ext uri="{FF2B5EF4-FFF2-40B4-BE49-F238E27FC236}">
+                <a16:creationId xmlns:a16="http://schemas.microsoft.com/office/drawing/2014/main" id="{C4D319ED-AC83-4DE1-9E24-5E302DE941CA}"/>
               </a:ext>
             </a:extLst>
           </p:cNvPr>
@@ -2115,11 +2250,11 @@
             <a:avLst/>
           </a:prstGeom>
           <a:solidFill xmlns:a="http://schemas.openxmlformats.org/drawingml/2006/main">
-            <a:srgbClr val="6D536F"/>
+            <a:srgbClr val="24384C"/>
           </a:solidFill>
           <a:ln xmlns:a="http://schemas.openxmlformats.org/drawingml/2006/main" w="0">
             <a:solidFill>
-              <a:srgbClr val="6D536F"/>
+              <a:srgbClr val="24384C"/>
             </a:solidFill>
             <a:prstDash val="solid"/>
           </a:ln>
@@ -2127,22 +2262,22 @@
       </p:sp>
       <p:sp>
         <p:nvSpPr>
-          <p:cNvPr id="22" name="port-search-a">
-            <a:extLst xmlns:a="http://schemas.openxmlformats.org/drawingml/2006/main">
-              <a:ext uri="{FF2B5EF4-FFF2-40B4-BE49-F238E27FC236}">
-                <a16:creationId xmlns:a16="http://schemas.microsoft.com/office/drawing/2014/main" id="{31DD95DF-6971-445D-8B40-DF16181AC07F}"/>
-              </a:ext>
-            </a:extLst>
-          </p:cNvPr>
-          <p:cNvSpPr>
-            <a:spLocks xmlns:a="http://schemas.openxmlformats.org/drawingml/2006/main" noGrp="1"/>
-          </p:cNvSpPr>
-          <p:nvPr/>
-        </p:nvSpPr>
-        <p:spPr>
-          <a:xfrm xmlns:a="http://schemas.openxmlformats.org/drawingml/2006/main">
-            <a:off x="2190750" y="5048250"/>
-            <a:ext cx="666750" cy="0"/>
+          <p:cNvPr id="25" name="port-search-a">
+            <a:extLst xmlns:a="http://schemas.openxmlformats.org/drawingml/2006/main">
+              <a:ext uri="{FF2B5EF4-FFF2-40B4-BE49-F238E27FC236}">
+                <a16:creationId xmlns:a16="http://schemas.microsoft.com/office/drawing/2014/main" id="{07921FA8-C8DD-4386-9391-095CC201EA6E}"/>
+              </a:ext>
+            </a:extLst>
+          </p:cNvPr>
+          <p:cNvSpPr>
+            <a:spLocks xmlns:a="http://schemas.openxmlformats.org/drawingml/2006/main" noGrp="1"/>
+          </p:cNvSpPr>
+          <p:nvPr/>
+        </p:nvSpPr>
+        <p:spPr>
+          <a:xfrm xmlns:a="http://schemas.openxmlformats.org/drawingml/2006/main">
+            <a:off x="2324100" y="4438650"/>
+            <a:ext cx="533400" cy="0"/>
           </a:xfrm>
           <a:prstGeom xmlns:a="http://schemas.openxmlformats.org/drawingml/2006/main" prst="line">
             <a:avLst/>
@@ -2150,7 +2285,7 @@
           <a:noFill xmlns:a="http://schemas.openxmlformats.org/drawingml/2006/main"/>
           <a:ln xmlns:a="http://schemas.openxmlformats.org/drawingml/2006/main" w="20955">
             <a:solidFill>
-              <a:srgbClr val="52725D"/>
+              <a:srgbClr val="397EA5"/>
             </a:solidFill>
             <a:prstDash val="solid"/>
           </a:ln>
@@ -2158,10 +2293,10 @@
       </p:sp>
       <p:sp>
         <p:nvSpPr>
-          <p:cNvPr id="23" name="port-search-b">
-            <a:extLst xmlns:a="http://schemas.openxmlformats.org/drawingml/2006/main">
-              <a:ext uri="{FF2B5EF4-FFF2-40B4-BE49-F238E27FC236}">
-                <a16:creationId xmlns:a16="http://schemas.microsoft.com/office/drawing/2014/main" id="{02C59DBB-BA73-4049-BAE1-A797143DAEA5}"/>
+          <p:cNvPr id="26" name="port-search-b">
+            <a:extLst xmlns:a="http://schemas.openxmlformats.org/drawingml/2006/main">
+              <a:ext uri="{FF2B5EF4-FFF2-40B4-BE49-F238E27FC236}">
+                <a16:creationId xmlns:a16="http://schemas.microsoft.com/office/drawing/2014/main" id="{1102E2EA-4B80-481C-BD4A-CA76F7062B93}"/>
               </a:ext>
             </a:extLst>
           </p:cNvPr>
@@ -2173,7 +2308,7 @@
         <p:spPr>
           <a:xfrm xmlns:a="http://schemas.openxmlformats.org/drawingml/2006/main">
             <a:off x="2857500" y="1952625"/>
-            <a:ext cx="0" cy="3095625"/>
+            <a:ext cx="0" cy="2486025"/>
           </a:xfrm>
           <a:prstGeom xmlns:a="http://schemas.openxmlformats.org/drawingml/2006/main" prst="line">
             <a:avLst/>
@@ -2181,7 +2316,7 @@
           <a:noFill xmlns:a="http://schemas.openxmlformats.org/drawingml/2006/main"/>
           <a:ln xmlns:a="http://schemas.openxmlformats.org/drawingml/2006/main" w="20955">
             <a:solidFill>
-              <a:srgbClr val="52725D"/>
+              <a:srgbClr val="397EA5"/>
             </a:solidFill>
             <a:prstDash val="solid"/>
           </a:ln>
@@ -2189,10 +2324,10 @@
       </p:sp>
       <p:sp>
         <p:nvSpPr>
-          <p:cNvPr id="24" name="port-search-c">
-            <a:extLst xmlns:a="http://schemas.openxmlformats.org/drawingml/2006/main">
-              <a:ext uri="{FF2B5EF4-FFF2-40B4-BE49-F238E27FC236}">
-                <a16:creationId xmlns:a16="http://schemas.microsoft.com/office/drawing/2014/main" id="{68E6320B-0BA3-4C31-927C-15CFB82C012A}"/>
+          <p:cNvPr id="27" name="port-search-c">
+            <a:extLst xmlns:a="http://schemas.openxmlformats.org/drawingml/2006/main">
+              <a:ext uri="{FF2B5EF4-FFF2-40B4-BE49-F238E27FC236}">
+                <a16:creationId xmlns:a16="http://schemas.microsoft.com/office/drawing/2014/main" id="{63EC019A-7155-4639-ADC4-61AECAC201A8}"/>
               </a:ext>
             </a:extLst>
           </p:cNvPr>
@@ -2212,7 +2347,7 @@
           <a:noFill xmlns:a="http://schemas.openxmlformats.org/drawingml/2006/main"/>
           <a:ln xmlns:a="http://schemas.openxmlformats.org/drawingml/2006/main" w="20955">
             <a:solidFill>
-              <a:srgbClr val="52725D"/>
+              <a:srgbClr val="397EA5"/>
             </a:solidFill>
             <a:prstDash val="solid"/>
           </a:ln>
@@ -2220,22 +2355,22 @@
       </p:sp>
       <p:sp>
         <p:nvSpPr>
-          <p:cNvPr id="25" name="port-analysis-a">
-            <a:extLst xmlns:a="http://schemas.openxmlformats.org/drawingml/2006/main">
-              <a:ext uri="{FF2B5EF4-FFF2-40B4-BE49-F238E27FC236}">
-                <a16:creationId xmlns:a16="http://schemas.microsoft.com/office/drawing/2014/main" id="{17968206-1026-4789-BDFD-56B758484430}"/>
-              </a:ext>
-            </a:extLst>
-          </p:cNvPr>
-          <p:cNvSpPr>
-            <a:spLocks xmlns:a="http://schemas.openxmlformats.org/drawingml/2006/main" noGrp="1"/>
-          </p:cNvSpPr>
-          <p:nvPr/>
-        </p:nvSpPr>
-        <p:spPr>
-          <a:xfrm xmlns:a="http://schemas.openxmlformats.org/drawingml/2006/main">
-            <a:off x="2190750" y="5619750"/>
-            <a:ext cx="952500" cy="0"/>
+          <p:cNvPr id="28" name="port-analysis-a">
+            <a:extLst xmlns:a="http://schemas.openxmlformats.org/drawingml/2006/main">
+              <a:ext uri="{FF2B5EF4-FFF2-40B4-BE49-F238E27FC236}">
+                <a16:creationId xmlns:a16="http://schemas.microsoft.com/office/drawing/2014/main" id="{4D5F3F53-2B8B-40CC-9DE1-3EA46708AF09}"/>
+              </a:ext>
+            </a:extLst>
+          </p:cNvPr>
+          <p:cNvSpPr>
+            <a:spLocks xmlns:a="http://schemas.openxmlformats.org/drawingml/2006/main" noGrp="1"/>
+          </p:cNvSpPr>
+          <p:nvPr/>
+        </p:nvSpPr>
+        <p:spPr>
+          <a:xfrm xmlns:a="http://schemas.openxmlformats.org/drawingml/2006/main">
+            <a:off x="2324100" y="5000625"/>
+            <a:ext cx="819150" cy="0"/>
           </a:xfrm>
           <a:prstGeom xmlns:a="http://schemas.openxmlformats.org/drawingml/2006/main" prst="line">
             <a:avLst/>
@@ -2243,7 +2378,7 @@
           <a:noFill xmlns:a="http://schemas.openxmlformats.org/drawingml/2006/main"/>
           <a:ln xmlns:a="http://schemas.openxmlformats.org/drawingml/2006/main" w="20955">
             <a:solidFill>
-              <a:srgbClr val="C6653E"/>
+              <a:srgbClr val="D05A2A"/>
             </a:solidFill>
             <a:prstDash val="solid"/>
           </a:ln>
@@ -2251,10 +2386,10 @@
       </p:sp>
       <p:sp>
         <p:nvSpPr>
-          <p:cNvPr id="26" name="port-analysis-b">
-            <a:extLst xmlns:a="http://schemas.openxmlformats.org/drawingml/2006/main">
-              <a:ext uri="{FF2B5EF4-FFF2-40B4-BE49-F238E27FC236}">
-                <a16:creationId xmlns:a16="http://schemas.microsoft.com/office/drawing/2014/main" id="{AED36863-DCA5-4C1C-AC69-4833073A12CF}"/>
+          <p:cNvPr id="29" name="port-analysis-b">
+            <a:extLst xmlns:a="http://schemas.openxmlformats.org/drawingml/2006/main">
+              <a:ext uri="{FF2B5EF4-FFF2-40B4-BE49-F238E27FC236}">
+                <a16:creationId xmlns:a16="http://schemas.microsoft.com/office/drawing/2014/main" id="{CEF7B853-C434-4BB0-8E70-D2A3B90CAE18}"/>
               </a:ext>
             </a:extLst>
           </p:cNvPr>
@@ -2266,7 +2401,7 @@
         <p:spPr>
           <a:xfrm xmlns:a="http://schemas.openxmlformats.org/drawingml/2006/main">
             <a:off x="3143250" y="1143000"/>
-            <a:ext cx="0" cy="4476750"/>
+            <a:ext cx="0" cy="3857625"/>
           </a:xfrm>
           <a:prstGeom xmlns:a="http://schemas.openxmlformats.org/drawingml/2006/main" prst="line">
             <a:avLst/>
@@ -2274,7 +2409,7 @@
           <a:noFill xmlns:a="http://schemas.openxmlformats.org/drawingml/2006/main"/>
           <a:ln xmlns:a="http://schemas.openxmlformats.org/drawingml/2006/main" w="20955">
             <a:solidFill>
-              <a:srgbClr val="C6653E"/>
+              <a:srgbClr val="D05A2A"/>
             </a:solidFill>
             <a:prstDash val="solid"/>
           </a:ln>
@@ -2282,10 +2417,10 @@
       </p:sp>
       <p:sp>
         <p:nvSpPr>
-          <p:cNvPr id="27" name="port-analysis-c">
-            <a:extLst xmlns:a="http://schemas.openxmlformats.org/drawingml/2006/main">
-              <a:ext uri="{FF2B5EF4-FFF2-40B4-BE49-F238E27FC236}">
-                <a16:creationId xmlns:a16="http://schemas.microsoft.com/office/drawing/2014/main" id="{AC44FA31-07CC-4B16-A530-EC912B997DE9}"/>
+          <p:cNvPr id="30" name="port-analysis-c">
+            <a:extLst xmlns:a="http://schemas.openxmlformats.org/drawingml/2006/main">
+              <a:ext uri="{FF2B5EF4-FFF2-40B4-BE49-F238E27FC236}">
+                <a16:creationId xmlns:a16="http://schemas.microsoft.com/office/drawing/2014/main" id="{3CDCAF7B-77D2-4C87-8404-2B123F90013F}"/>
               </a:ext>
             </a:extLst>
           </p:cNvPr>
@@ -2305,7 +2440,7 @@
           <a:noFill xmlns:a="http://schemas.openxmlformats.org/drawingml/2006/main"/>
           <a:ln xmlns:a="http://schemas.openxmlformats.org/drawingml/2006/main" w="20955">
             <a:solidFill>
-              <a:srgbClr val="C6653E"/>
+              <a:srgbClr val="D05A2A"/>
             </a:solidFill>
             <a:prstDash val="solid"/>
           </a:ln>
@@ -2313,10 +2448,10 @@
       </p:sp>
       <p:sp>
         <p:nvSpPr>
-          <p:cNvPr id="28" name="port-analysis-d">
-            <a:extLst xmlns:a="http://schemas.openxmlformats.org/drawingml/2006/main">
-              <a:ext uri="{FF2B5EF4-FFF2-40B4-BE49-F238E27FC236}">
-                <a16:creationId xmlns:a16="http://schemas.microsoft.com/office/drawing/2014/main" id="{62BA6CBA-4332-4251-9CB3-EA63B2551128}"/>
+          <p:cNvPr id="31" name="port-analysis-d">
+            <a:extLst xmlns:a="http://schemas.openxmlformats.org/drawingml/2006/main">
+              <a:ext uri="{FF2B5EF4-FFF2-40B4-BE49-F238E27FC236}">
+                <a16:creationId xmlns:a16="http://schemas.microsoft.com/office/drawing/2014/main" id="{7858BD48-E1CF-4902-ABEC-1A95705AFD3E}"/>
               </a:ext>
             </a:extLst>
           </p:cNvPr>
@@ -2336,7 +2471,7 @@
           <a:noFill xmlns:a="http://schemas.openxmlformats.org/drawingml/2006/main"/>
           <a:ln xmlns:a="http://schemas.openxmlformats.org/drawingml/2006/main" w="20955">
             <a:solidFill>
-              <a:srgbClr val="C6653E"/>
+              <a:srgbClr val="D05A2A"/>
             </a:solidFill>
             <a:prstDash val="solid"/>
           </a:ln>
@@ -2344,10 +2479,10 @@
       </p:sp>
       <p:sp>
         <p:nvSpPr>
-          <p:cNvPr id="29" name="research-fan-stem">
-            <a:extLst xmlns:a="http://schemas.openxmlformats.org/drawingml/2006/main">
-              <a:ext uri="{FF2B5EF4-FFF2-40B4-BE49-F238E27FC236}">
-                <a16:creationId xmlns:a16="http://schemas.microsoft.com/office/drawing/2014/main" id="{3AD52359-810C-4EAD-B62E-2376716E1CF0}"/>
+          <p:cNvPr id="32" name="research-fan-stem">
+            <a:extLst xmlns:a="http://schemas.openxmlformats.org/drawingml/2006/main">
+              <a:ext uri="{FF2B5EF4-FFF2-40B4-BE49-F238E27FC236}">
+                <a16:creationId xmlns:a16="http://schemas.microsoft.com/office/drawing/2014/main" id="{13DD8B05-FFFB-40A1-A8E5-E0F8844C7956}"/>
               </a:ext>
             </a:extLst>
           </p:cNvPr>
@@ -2367,7 +2502,7 @@
           <a:noFill xmlns:a="http://schemas.openxmlformats.org/drawingml/2006/main"/>
           <a:ln xmlns:a="http://schemas.openxmlformats.org/drawingml/2006/main" w="16193">
             <a:solidFill>
-              <a:srgbClr val="C6653E"/>
+              <a:srgbClr val="D05A2A"/>
             </a:solidFill>
             <a:prstDash val="solid"/>
           </a:ln>
@@ -2375,10 +2510,10 @@
       </p:sp>
       <p:sp>
         <p:nvSpPr>
-          <p:cNvPr id="30" name="research-fan-bus">
-            <a:extLst xmlns:a="http://schemas.openxmlformats.org/drawingml/2006/main">
-              <a:ext uri="{FF2B5EF4-FFF2-40B4-BE49-F238E27FC236}">
-                <a16:creationId xmlns:a16="http://schemas.microsoft.com/office/drawing/2014/main" id="{FE2B19B0-F298-4401-9D63-F987CD5B39E9}"/>
+          <p:cNvPr id="33" name="research-fan-bus">
+            <a:extLst xmlns:a="http://schemas.openxmlformats.org/drawingml/2006/main">
+              <a:ext uri="{FF2B5EF4-FFF2-40B4-BE49-F238E27FC236}">
+                <a16:creationId xmlns:a16="http://schemas.microsoft.com/office/drawing/2014/main" id="{F939C901-6AD8-46EE-B227-E9D72802468C}"/>
               </a:ext>
             </a:extLst>
           </p:cNvPr>
@@ -2398,7 +2533,7 @@
           <a:noFill xmlns:a="http://schemas.openxmlformats.org/drawingml/2006/main"/>
           <a:ln xmlns:a="http://schemas.openxmlformats.org/drawingml/2006/main" w="16193">
             <a:solidFill>
-              <a:srgbClr val="C6653E"/>
+              <a:srgbClr val="D05A2A"/>
             </a:solidFill>
             <a:prstDash val="solid"/>
           </a:ln>
@@ -2406,10 +2541,10 @@
       </p:sp>
       <p:sp>
         <p:nvSpPr>
-          <p:cNvPr id="31" name="research-fan-a">
-            <a:extLst xmlns:a="http://schemas.openxmlformats.org/drawingml/2006/main">
-              <a:ext uri="{FF2B5EF4-FFF2-40B4-BE49-F238E27FC236}">
-                <a16:creationId xmlns:a16="http://schemas.microsoft.com/office/drawing/2014/main" id="{D604D4F6-A0BE-4ADD-982C-5836D5489F0C}"/>
+          <p:cNvPr id="34" name="research-fan-a">
+            <a:extLst xmlns:a="http://schemas.openxmlformats.org/drawingml/2006/main">
+              <a:ext uri="{FF2B5EF4-FFF2-40B4-BE49-F238E27FC236}">
+                <a16:creationId xmlns:a16="http://schemas.microsoft.com/office/drawing/2014/main" id="{59449A6C-C348-4246-943A-C2E644C2C7C7}"/>
               </a:ext>
             </a:extLst>
           </p:cNvPr>
@@ -2429,7 +2564,7 @@
           <a:noFill xmlns:a="http://schemas.openxmlformats.org/drawingml/2006/main"/>
           <a:ln xmlns:a="http://schemas.openxmlformats.org/drawingml/2006/main" w="16193">
             <a:solidFill>
-              <a:srgbClr val="C6653E"/>
+              <a:srgbClr val="D05A2A"/>
             </a:solidFill>
             <a:prstDash val="solid"/>
           </a:ln>
@@ -2437,10 +2572,10 @@
       </p:sp>
       <p:sp>
         <p:nvSpPr>
-          <p:cNvPr id="32" name="research-fan-b">
-            <a:extLst xmlns:a="http://schemas.openxmlformats.org/drawingml/2006/main">
-              <a:ext uri="{FF2B5EF4-FFF2-40B4-BE49-F238E27FC236}">
-                <a16:creationId xmlns:a16="http://schemas.microsoft.com/office/drawing/2014/main" id="{7C7D120F-CB83-4F1C-AAFB-6F806EB03346}"/>
+          <p:cNvPr id="35" name="research-fan-b">
+            <a:extLst xmlns:a="http://schemas.openxmlformats.org/drawingml/2006/main">
+              <a:ext uri="{FF2B5EF4-FFF2-40B4-BE49-F238E27FC236}">
+                <a16:creationId xmlns:a16="http://schemas.microsoft.com/office/drawing/2014/main" id="{8E311A9B-8178-48A6-A727-F40923296EDE}"/>
               </a:ext>
             </a:extLst>
           </p:cNvPr>
@@ -2460,7 +2595,7 @@
           <a:noFill xmlns:a="http://schemas.openxmlformats.org/drawingml/2006/main"/>
           <a:ln xmlns:a="http://schemas.openxmlformats.org/drawingml/2006/main" w="16193">
             <a:solidFill>
-              <a:srgbClr val="C6653E"/>
+              <a:srgbClr val="D05A2A"/>
             </a:solidFill>
             <a:prstDash val="solid"/>
           </a:ln>
@@ -2468,10 +2603,10 @@
       </p:sp>
       <p:sp>
         <p:nvSpPr>
-          <p:cNvPr id="33" name="research-fan-c">
-            <a:extLst xmlns:a="http://schemas.openxmlformats.org/drawingml/2006/main">
-              <a:ext uri="{FF2B5EF4-FFF2-40B4-BE49-F238E27FC236}">
-                <a16:creationId xmlns:a16="http://schemas.microsoft.com/office/drawing/2014/main" id="{6D09C502-C9CC-45C8-9D61-D30C07D3A3E0}"/>
+          <p:cNvPr id="36" name="research-fan-c">
+            <a:extLst xmlns:a="http://schemas.openxmlformats.org/drawingml/2006/main">
+              <a:ext uri="{FF2B5EF4-FFF2-40B4-BE49-F238E27FC236}">
+                <a16:creationId xmlns:a16="http://schemas.microsoft.com/office/drawing/2014/main" id="{3F114B9F-542B-4DEB-ACDF-8D94D08653D6}"/>
               </a:ext>
             </a:extLst>
           </p:cNvPr>
@@ -2491,7 +2626,7 @@
           <a:noFill xmlns:a="http://schemas.openxmlformats.org/drawingml/2006/main"/>
           <a:ln xmlns:a="http://schemas.openxmlformats.org/drawingml/2006/main" w="16193">
             <a:solidFill>
-              <a:srgbClr val="C6653E"/>
+              <a:srgbClr val="D05A2A"/>
             </a:solidFill>
             <a:prstDash val="solid"/>
           </a:ln>
@@ -2499,10 +2634,10 @@
       </p:sp>
       <p:sp>
         <p:nvSpPr>
-          <p:cNvPr id="34" name="tool-a-report">
-            <a:extLst xmlns:a="http://schemas.openxmlformats.org/drawingml/2006/main">
-              <a:ext uri="{FF2B5EF4-FFF2-40B4-BE49-F238E27FC236}">
-                <a16:creationId xmlns:a16="http://schemas.microsoft.com/office/drawing/2014/main" id="{C57C6A71-D4BD-4972-8034-5B6FFF37AD4D}"/>
+          <p:cNvPr id="37" name="tool-a-report">
+            <a:extLst xmlns:a="http://schemas.openxmlformats.org/drawingml/2006/main">
+              <a:ext uri="{FF2B5EF4-FFF2-40B4-BE49-F238E27FC236}">
+                <a16:creationId xmlns:a16="http://schemas.microsoft.com/office/drawing/2014/main" id="{915C7FBC-B287-4C8D-8300-DAE9ECDD53F7}"/>
               </a:ext>
             </a:extLst>
           </p:cNvPr>
@@ -2522,7 +2657,7 @@
           <a:noFill xmlns:a="http://schemas.openxmlformats.org/drawingml/2006/main"/>
           <a:ln xmlns:a="http://schemas.openxmlformats.org/drawingml/2006/main" w="14288">
             <a:solidFill>
-              <a:srgbClr val="C6653E"/>
+              <a:srgbClr val="D05A2A"/>
             </a:solidFill>
             <a:prstDash val="solid"/>
           </a:ln>
@@ -2530,10 +2665,10 @@
       </p:sp>
       <p:sp>
         <p:nvSpPr>
-          <p:cNvPr id="35" name="tool-b-report">
-            <a:extLst xmlns:a="http://schemas.openxmlformats.org/drawingml/2006/main">
-              <a:ext uri="{FF2B5EF4-FFF2-40B4-BE49-F238E27FC236}">
-                <a16:creationId xmlns:a16="http://schemas.microsoft.com/office/drawing/2014/main" id="{37E9C19D-E6F2-4BBB-B477-E933D4EA88A8}"/>
+          <p:cNvPr id="38" name="tool-b-report">
+            <a:extLst xmlns:a="http://schemas.openxmlformats.org/drawingml/2006/main">
+              <a:ext uri="{FF2B5EF4-FFF2-40B4-BE49-F238E27FC236}">
+                <a16:creationId xmlns:a16="http://schemas.microsoft.com/office/drawing/2014/main" id="{28B9715B-F498-4889-A827-1C9C24F3FC25}"/>
               </a:ext>
             </a:extLst>
           </p:cNvPr>
@@ -2553,7 +2688,7 @@
           <a:noFill xmlns:a="http://schemas.openxmlformats.org/drawingml/2006/main"/>
           <a:ln xmlns:a="http://schemas.openxmlformats.org/drawingml/2006/main" w="14288">
             <a:solidFill>
-              <a:srgbClr val="C6653E"/>
+              <a:srgbClr val="D05A2A"/>
             </a:solidFill>
             <a:prstDash val="solid"/>
           </a:ln>
@@ -2561,10 +2696,10 @@
       </p:sp>
       <p:sp>
         <p:nvSpPr>
-          <p:cNvPr id="36" name="tool-c-report">
-            <a:extLst xmlns:a="http://schemas.openxmlformats.org/drawingml/2006/main">
-              <a:ext uri="{FF2B5EF4-FFF2-40B4-BE49-F238E27FC236}">
-                <a16:creationId xmlns:a16="http://schemas.microsoft.com/office/drawing/2014/main" id="{B0DF8526-BD77-4C90-9FA6-F34311C87A48}"/>
+          <p:cNvPr id="39" name="tool-c-report">
+            <a:extLst xmlns:a="http://schemas.openxmlformats.org/drawingml/2006/main">
+              <a:ext uri="{FF2B5EF4-FFF2-40B4-BE49-F238E27FC236}">
+                <a16:creationId xmlns:a16="http://schemas.microsoft.com/office/drawing/2014/main" id="{7A098649-0934-4F96-9778-EBAA352CCF97}"/>
               </a:ext>
             </a:extLst>
           </p:cNvPr>
@@ -2584,7 +2719,7 @@
           <a:noFill xmlns:a="http://schemas.openxmlformats.org/drawingml/2006/main"/>
           <a:ln xmlns:a="http://schemas.openxmlformats.org/drawingml/2006/main" w="14288">
             <a:solidFill>
-              <a:srgbClr val="C6653E"/>
+              <a:srgbClr val="D05A2A"/>
             </a:solidFill>
             <a:prstDash val="solid"/>
           </a:ln>
@@ -2592,10 +2727,10 @@
       </p:sp>
       <p:sp>
         <p:nvSpPr>
-          <p:cNvPr id="37" name="tool-report-bus">
-            <a:extLst xmlns:a="http://schemas.openxmlformats.org/drawingml/2006/main">
-              <a:ext uri="{FF2B5EF4-FFF2-40B4-BE49-F238E27FC236}">
-                <a16:creationId xmlns:a16="http://schemas.microsoft.com/office/drawing/2014/main" id="{9A9D3983-1EBC-4AD8-8C95-EC5949083035}"/>
+          <p:cNvPr id="40" name="tool-report-bus">
+            <a:extLst xmlns:a="http://schemas.openxmlformats.org/drawingml/2006/main">
+              <a:ext uri="{FF2B5EF4-FFF2-40B4-BE49-F238E27FC236}">
+                <a16:creationId xmlns:a16="http://schemas.microsoft.com/office/drawing/2014/main" id="{98D3263F-CE9B-404E-A123-19E0318F41C5}"/>
               </a:ext>
             </a:extLst>
           </p:cNvPr>
@@ -2615,7 +2750,7 @@
           <a:noFill xmlns:a="http://schemas.openxmlformats.org/drawingml/2006/main"/>
           <a:ln xmlns:a="http://schemas.openxmlformats.org/drawingml/2006/main" w="14288">
             <a:solidFill>
-              <a:srgbClr val="C6653E"/>
+              <a:srgbClr val="D05A2A"/>
             </a:solidFill>
             <a:prstDash val="solid"/>
           </a:ln>
@@ -2623,10 +2758,10 @@
       </p:sp>
       <p:sp>
         <p:nvSpPr>
-          <p:cNvPr id="38" name="report-renderers">
-            <a:extLst xmlns:a="http://schemas.openxmlformats.org/drawingml/2006/main">
-              <a:ext uri="{FF2B5EF4-FFF2-40B4-BE49-F238E27FC236}">
-                <a16:creationId xmlns:a16="http://schemas.microsoft.com/office/drawing/2014/main" id="{C8B69344-FF88-49C1-8AE3-1B255C4B542D}"/>
+          <p:cNvPr id="41" name="report-renderers">
+            <a:extLst xmlns:a="http://schemas.openxmlformats.org/drawingml/2006/main">
+              <a:ext uri="{FF2B5EF4-FFF2-40B4-BE49-F238E27FC236}">
+                <a16:creationId xmlns:a16="http://schemas.microsoft.com/office/drawing/2014/main" id="{DA64A598-94C8-4C7B-8429-19660B98316E}"/>
               </a:ext>
             </a:extLst>
           </p:cNvPr>
@@ -2644,11 +2779,11 @@
             <a:avLst/>
           </a:prstGeom>
           <a:solidFill xmlns:a="http://schemas.openxmlformats.org/drawingml/2006/main">
-            <a:srgbClr val="B47A1B"/>
+            <a:srgbClr val="D05A2A"/>
           </a:solidFill>
           <a:ln xmlns:a="http://schemas.openxmlformats.org/drawingml/2006/main" w="0">
             <a:solidFill>
-              <a:srgbClr val="B47A1B"/>
+              <a:srgbClr val="D05A2A"/>
             </a:solidFill>
             <a:prstDash val="solid"/>
           </a:ln>
@@ -2656,21 +2791,21 @@
       </p:sp>
       <p:sp>
         <p:nvSpPr>
-          <p:cNvPr id="39" name="map-label">
-            <a:extLst xmlns:a="http://schemas.openxmlformats.org/drawingml/2006/main">
-              <a:ext uri="{FF2B5EF4-FFF2-40B4-BE49-F238E27FC236}">
-                <a16:creationId xmlns:a16="http://schemas.microsoft.com/office/drawing/2014/main" id="{B258B445-C865-48AD-91D9-9F1FF4013D3E}"/>
-              </a:ext>
-            </a:extLst>
-          </p:cNvPr>
-          <p:cNvSpPr>
-            <a:spLocks xmlns:a="http://schemas.openxmlformats.org/drawingml/2006/main" noGrp="1"/>
-          </p:cNvSpPr>
-          <p:nvPr/>
-        </p:nvSpPr>
-        <p:spPr>
-          <a:xfrm xmlns:a="http://schemas.openxmlformats.org/drawingml/2006/main">
-            <a:off x="2705100" y="304800"/>
+          <p:cNvPr id="42" name="map-label">
+            <a:extLst xmlns:a="http://schemas.openxmlformats.org/drawingml/2006/main">
+              <a:ext uri="{FF2B5EF4-FFF2-40B4-BE49-F238E27FC236}">
+                <a16:creationId xmlns:a16="http://schemas.microsoft.com/office/drawing/2014/main" id="{A8CE9C1F-A9B5-45E5-B87B-DF989CF49A98}"/>
+              </a:ext>
+            </a:extLst>
+          </p:cNvPr>
+          <p:cNvSpPr>
+            <a:spLocks xmlns:a="http://schemas.openxmlformats.org/drawingml/2006/main" noGrp="1"/>
+          </p:cNvSpPr>
+          <p:nvPr/>
+        </p:nvSpPr>
+        <p:spPr>
+          <a:xfrm xmlns:a="http://schemas.openxmlformats.org/drawingml/2006/main">
+            <a:off x="2705100" y="971550"/>
             <a:ext cx="5905500" cy="190500"/>
           </a:xfrm>
           <a:prstGeom xmlns:a="http://schemas.openxmlformats.org/drawingml/2006/main" prst="rect">
@@ -2687,16 +2822,16 @@
           <a:lstStyle xmlns:a="http://schemas.openxmlformats.org/drawingml/2006/main"/>
           <a:p xmlns:a="http://schemas.openxmlformats.org/drawingml/2006/main">
             <a:pPr algn="l">
-              <a:defRPr sz="825" b="1">
-                <a:solidFill>
-                  <a:srgbClr val="9E3F2F"/>
-                </a:solidFill>
-              </a:defRPr>
-            </a:pPr>
-            <a:r>
-              <a:rPr sz="825" b="1">
-                <a:solidFill>
-                  <a:srgbClr val="9E3F2F"/>
+              <a:defRPr sz="788" b="1">
+                <a:solidFill>
+                  <a:srgbClr val="A63F24"/>
+                </a:solidFill>
+              </a:defRPr>
+            </a:pPr>
+            <a:r>
+              <a:rPr sz="788" b="1">
+                <a:solidFill>
+                  <a:srgbClr val="A63F24"/>
                 </a:solidFill>
               </a:rPr>
               <a:t>DISCOVER → PROFILE IN PARALLEL → SYNTHESIZE</a:t>
@@ -2706,110 +2841,10 @@
       </p:sp>
       <p:sp>
         <p:nvSpPr>
-          <p:cNvPr id="40" name="map-note">
-            <a:extLst xmlns:a="http://schemas.openxmlformats.org/drawingml/2006/main">
-              <a:ext uri="{FF2B5EF4-FFF2-40B4-BE49-F238E27FC236}">
-                <a16:creationId xmlns:a16="http://schemas.microsoft.com/office/drawing/2014/main" id="{6010102C-C2E4-4A01-AB93-179BC2C75826}"/>
-              </a:ext>
-            </a:extLst>
-          </p:cNvPr>
-          <p:cNvSpPr>
-            <a:spLocks xmlns:a="http://schemas.openxmlformats.org/drawingml/2006/main" noGrp="1"/>
-          </p:cNvSpPr>
-          <p:nvPr/>
-        </p:nvSpPr>
-        <p:spPr>
-          <a:xfrm xmlns:a="http://schemas.openxmlformats.org/drawingml/2006/main">
-            <a:off x="2705100" y="581025"/>
-            <a:ext cx="5143500" cy="228600"/>
-          </a:xfrm>
-          <a:prstGeom xmlns:a="http://schemas.openxmlformats.org/drawingml/2006/main" prst="rect">
-            <a:avLst/>
-          </a:prstGeom>
-          <a:noFill xmlns:a="http://schemas.openxmlformats.org/drawingml/2006/main"/>
-          <a:ln xmlns:a="http://schemas.openxmlformats.org/drawingml/2006/main" w="0">
-            <a:noFill/>
-            <a:prstDash val="solid"/>
-          </a:ln>
-        </p:spPr>
-        <p:txBody>
-          <a:bodyPr xmlns:a="http://schemas.openxmlformats.org/drawingml/2006/main"/>
-          <a:lstStyle xmlns:a="http://schemas.openxmlformats.org/drawingml/2006/main"/>
-          <a:p xmlns:a="http://schemas.openxmlformats.org/drawingml/2006/main">
-            <a:pPr algn="l">
-              <a:defRPr sz="1125" b="0">
-                <a:solidFill>
-                  <a:srgbClr val="6B665F"/>
-                </a:solidFill>
-              </a:defRPr>
-            </a:pPr>
-            <a:r>
-              <a:rPr sz="1125" b="0">
-                <a:solidFill>
-                  <a:srgbClr val="6B665F"/>
-                </a:solidFill>
-              </a:rPr>
-              <a:t>The node graph is stable across demo and live modes.</a:t>
-            </a:r>
-          </a:p>
-        </p:txBody>
-      </p:sp>
-      <p:sp>
-        <p:nvSpPr>
-          <p:cNvPr id="41" name="graph-type">
-            <a:extLst xmlns:a="http://schemas.openxmlformats.org/drawingml/2006/main">
-              <a:ext uri="{FF2B5EF4-FFF2-40B4-BE49-F238E27FC236}">
-                <a16:creationId xmlns:a16="http://schemas.microsoft.com/office/drawing/2014/main" id="{78E1D4AF-3CCC-40A6-81C7-FA3A32B64C13}"/>
-              </a:ext>
-            </a:extLst>
-          </p:cNvPr>
-          <p:cNvSpPr>
-            <a:spLocks xmlns:a="http://schemas.openxmlformats.org/drawingml/2006/main" noGrp="1"/>
-          </p:cNvSpPr>
-          <p:nvPr/>
-        </p:nvSpPr>
-        <p:spPr>
-          <a:xfrm xmlns:a="http://schemas.openxmlformats.org/drawingml/2006/main">
-            <a:off x="9544050" y="371475"/>
-            <a:ext cx="2228850" cy="190500"/>
-          </a:xfrm>
-          <a:prstGeom xmlns:a="http://schemas.openxmlformats.org/drawingml/2006/main" prst="rect">
-            <a:avLst/>
-          </a:prstGeom>
-          <a:noFill xmlns:a="http://schemas.openxmlformats.org/drawingml/2006/main"/>
-          <a:ln xmlns:a="http://schemas.openxmlformats.org/drawingml/2006/main" w="0">
-            <a:noFill/>
-            <a:prstDash val="solid"/>
-          </a:ln>
-        </p:spPr>
-        <p:txBody>
-          <a:bodyPr xmlns:a="http://schemas.openxmlformats.org/drawingml/2006/main"/>
-          <a:lstStyle xmlns:a="http://schemas.openxmlformats.org/drawingml/2006/main"/>
-          <a:p xmlns:a="http://schemas.openxmlformats.org/drawingml/2006/main">
-            <a:pPr algn="r">
-              <a:defRPr sz="863" b="1">
-                <a:solidFill>
-                  <a:srgbClr val="52725D"/>
-                </a:solidFill>
-              </a:defRPr>
-            </a:pPr>
-            <a:r>
-              <a:rPr sz="863" b="1">
-                <a:solidFill>
-                  <a:srgbClr val="52725D"/>
-                </a:solidFill>
-              </a:rPr>
-              <a:t>ResearchPipeline / LangGraph</a:t>
-            </a:r>
-          </a:p>
-        </p:txBody>
-      </p:sp>
-      <p:sp>
-        <p:nvSpPr>
-          <p:cNvPr id="42" name="discover-circle">
-            <a:extLst xmlns:a="http://schemas.openxmlformats.org/drawingml/2006/main">
-              <a:ext uri="{FF2B5EF4-FFF2-40B4-BE49-F238E27FC236}">
-                <a16:creationId xmlns:a16="http://schemas.microsoft.com/office/drawing/2014/main" id="{95E9E978-7F83-4E22-B4D0-BC01A25CFABA}"/>
+          <p:cNvPr id="43" name="discover-circle">
+            <a:extLst xmlns:a="http://schemas.openxmlformats.org/drawingml/2006/main">
+              <a:ext uri="{FF2B5EF4-FFF2-40B4-BE49-F238E27FC236}">
+                <a16:creationId xmlns:a16="http://schemas.microsoft.com/office/drawing/2014/main" id="{FEE1210B-E990-4AE4-805C-E4397CDBCE3D}"/>
               </a:ext>
             </a:extLst>
           </p:cNvPr>
@@ -2827,11 +2862,11 @@
             <a:avLst/>
           </a:prstGeom>
           <a:solidFill xmlns:a="http://schemas.openxmlformats.org/drawingml/2006/main">
-            <a:srgbClr val="DDE8DC"/>
+            <a:srgbClr val="E7F1F6"/>
           </a:solidFill>
           <a:ln xmlns:a="http://schemas.openxmlformats.org/drawingml/2006/main" w="16193">
             <a:solidFill>
-              <a:srgbClr val="52725D"/>
+              <a:srgbClr val="397EA5"/>
             </a:solidFill>
             <a:prstDash val="solid"/>
           </a:ln>
@@ -2839,10 +2874,10 @@
       </p:sp>
       <p:sp>
         <p:nvSpPr>
-          <p:cNvPr id="43" name="discover-step">
-            <a:extLst xmlns:a="http://schemas.openxmlformats.org/drawingml/2006/main">
-              <a:ext uri="{FF2B5EF4-FFF2-40B4-BE49-F238E27FC236}">
-                <a16:creationId xmlns:a16="http://schemas.microsoft.com/office/drawing/2014/main" id="{5B58CC69-31FF-4E3C-B115-115B5730B7D9}"/>
+          <p:cNvPr id="44" name="discover-step">
+            <a:extLst xmlns:a="http://schemas.openxmlformats.org/drawingml/2006/main">
+              <a:ext uri="{FF2B5EF4-FFF2-40B4-BE49-F238E27FC236}">
+                <a16:creationId xmlns:a16="http://schemas.microsoft.com/office/drawing/2014/main" id="{D01DF026-CC95-40CA-B6A4-32F3A03DDD9F}"/>
               </a:ext>
             </a:extLst>
           </p:cNvPr>
@@ -2860,11 +2895,11 @@
             <a:avLst/>
           </a:prstGeom>
           <a:solidFill xmlns:a="http://schemas.openxmlformats.org/drawingml/2006/main">
-            <a:srgbClr val="52725D"/>
+            <a:srgbClr val="397EA5"/>
           </a:solidFill>
           <a:ln xmlns:a="http://schemas.openxmlformats.org/drawingml/2006/main" w="0">
             <a:solidFill>
-              <a:srgbClr val="52725D"/>
+              <a:srgbClr val="397EA5"/>
             </a:solidFill>
             <a:prstDash val="solid"/>
           </a:ln>
@@ -2872,10 +2907,10 @@
       </p:sp>
       <p:sp>
         <p:nvSpPr>
-          <p:cNvPr id="44" name="discover-step-text">
-            <a:extLst xmlns:a="http://schemas.openxmlformats.org/drawingml/2006/main">
-              <a:ext uri="{FF2B5EF4-FFF2-40B4-BE49-F238E27FC236}">
-                <a16:creationId xmlns:a16="http://schemas.microsoft.com/office/drawing/2014/main" id="{35B63E1A-52B3-45C7-9639-7C2E632E55D3}"/>
+          <p:cNvPr id="45" name="discover-step-text">
+            <a:extLst xmlns:a="http://schemas.openxmlformats.org/drawingml/2006/main">
+              <a:ext uri="{FF2B5EF4-FFF2-40B4-BE49-F238E27FC236}">
+                <a16:creationId xmlns:a16="http://schemas.microsoft.com/office/drawing/2014/main" id="{12C5B9EF-B566-464E-8675-A9CB9C515D63}"/>
               </a:ext>
             </a:extLst>
           </p:cNvPr>
@@ -2905,14 +2940,14 @@
             <a:pPr algn="ctr">
               <a:defRPr sz="750" b="1">
                 <a:solidFill>
-                  <a:srgbClr val="FFFDF8"/>
+                  <a:srgbClr val="FFFFFF"/>
                 </a:solidFill>
               </a:defRPr>
             </a:pPr>
             <a:r>
               <a:rPr sz="750" b="1">
                 <a:solidFill>
-                  <a:srgbClr val="FFFDF8"/>
+                  <a:srgbClr val="FFFFFF"/>
                 </a:solidFill>
               </a:rPr>
               <a:t>1</a:t>
@@ -2922,10 +2957,10 @@
       </p:sp>
       <p:sp>
         <p:nvSpPr>
-          <p:cNvPr id="45" name="discover-title">
-            <a:extLst xmlns:a="http://schemas.openxmlformats.org/drawingml/2006/main">
-              <a:ext uri="{FF2B5EF4-FFF2-40B4-BE49-F238E27FC236}">
-                <a16:creationId xmlns:a16="http://schemas.microsoft.com/office/drawing/2014/main" id="{5FF9CB34-E371-4F78-BF8A-B71D6D808901}"/>
+          <p:cNvPr id="46" name="discover-title">
+            <a:extLst xmlns:a="http://schemas.openxmlformats.org/drawingml/2006/main">
+              <a:ext uri="{FF2B5EF4-FFF2-40B4-BE49-F238E27FC236}">
+                <a16:creationId xmlns:a16="http://schemas.microsoft.com/office/drawing/2014/main" id="{7BAF3AE2-0394-4184-BB9D-29C9D5F0EEBF}"/>
               </a:ext>
             </a:extLst>
           </p:cNvPr>
@@ -2955,14 +2990,14 @@
             <a:pPr algn="ctr">
               <a:defRPr sz="1125" b="1">
                 <a:solidFill>
-                  <a:srgbClr val="52725D"/>
+                  <a:srgbClr val="397EA5"/>
                 </a:solidFill>
               </a:defRPr>
             </a:pPr>
             <a:r>
               <a:rPr sz="1125" b="1">
                 <a:solidFill>
-                  <a:srgbClr val="52725D"/>
+                  <a:srgbClr val="397EA5"/>
                 </a:solidFill>
               </a:rPr>
               <a:t>Discover</a:t>
@@ -2972,10 +3007,10 @@
       </p:sp>
       <p:sp>
         <p:nvSpPr>
-          <p:cNvPr id="46" name="discover-body">
-            <a:extLst xmlns:a="http://schemas.openxmlformats.org/drawingml/2006/main">
-              <a:ext uri="{FF2B5EF4-FFF2-40B4-BE49-F238E27FC236}">
-                <a16:creationId xmlns:a16="http://schemas.microsoft.com/office/drawing/2014/main" id="{D3EDBF2D-2A61-44AD-932D-D5329D3C0F37}"/>
+          <p:cNvPr id="47" name="discover-body">
+            <a:extLst xmlns:a="http://schemas.openxmlformats.org/drawingml/2006/main">
+              <a:ext uri="{FF2B5EF4-FFF2-40B4-BE49-F238E27FC236}">
+                <a16:creationId xmlns:a16="http://schemas.microsoft.com/office/drawing/2014/main" id="{917D6F50-36DD-4669-ABED-9A0E07897857}"/>
               </a:ext>
             </a:extLst>
           </p:cNvPr>
@@ -3005,14 +3040,14 @@
             <a:pPr algn="ctr">
               <a:defRPr sz="788" b="0">
                 <a:solidFill>
-                  <a:srgbClr val="6B665F"/>
+                  <a:srgbClr val="667085"/>
                 </a:solidFill>
               </a:defRPr>
             </a:pPr>
             <a:r>
               <a:rPr sz="788" b="0">
                 <a:solidFill>
-                  <a:srgbClr val="6B665F"/>
+                  <a:srgbClr val="667085"/>
                 </a:solidFill>
               </a:rPr>
               <a:t>normalize query</a:t>
@@ -3022,14 +3057,14 @@
             <a:pPr algn="ctr">
               <a:defRPr sz="788" b="0">
                 <a:solidFill>
-                  <a:srgbClr val="6B665F"/>
+                  <a:srgbClr val="667085"/>
                 </a:solidFill>
               </a:defRPr>
             </a:pPr>
             <a:r>
               <a:rPr sz="788" b="0">
                 <a:solidFill>
-                  <a:srgbClr val="6B665F"/>
+                  <a:srgbClr val="667085"/>
                 </a:solidFill>
               </a:rPr>
               <a:t>search comparison docs</a:t>
@@ -3039,14 +3074,14 @@
             <a:pPr algn="ctr">
               <a:defRPr sz="788" b="0">
                 <a:solidFill>
-                  <a:srgbClr val="6B665F"/>
+                  <a:srgbClr val="667085"/>
                 </a:solidFill>
               </a:defRPr>
             </a:pPr>
             <a:r>
               <a:rPr sz="788" b="0">
                 <a:solidFill>
-                  <a:srgbClr val="6B665F"/>
+                  <a:srgbClr val="667085"/>
                 </a:solidFill>
               </a:rPr>
               <a:t>deduplicate 1–6 tools</a:t>
@@ -3056,10 +3091,10 @@
       </p:sp>
       <p:sp>
         <p:nvSpPr>
-          <p:cNvPr id="47" name="research-circle">
-            <a:extLst xmlns:a="http://schemas.openxmlformats.org/drawingml/2006/main">
-              <a:ext uri="{FF2B5EF4-FFF2-40B4-BE49-F238E27FC236}">
-                <a16:creationId xmlns:a16="http://schemas.microsoft.com/office/drawing/2014/main" id="{73CB9764-4CEE-4FE5-8CB1-CA0B542A413B}"/>
+          <p:cNvPr id="48" name="research-circle">
+            <a:extLst xmlns:a="http://schemas.openxmlformats.org/drawingml/2006/main">
+              <a:ext uri="{FF2B5EF4-FFF2-40B4-BE49-F238E27FC236}">
+                <a16:creationId xmlns:a16="http://schemas.microsoft.com/office/drawing/2014/main" id="{36ECE169-6565-4193-BDFF-0B621D4B6B9E}"/>
               </a:ext>
             </a:extLst>
           </p:cNvPr>
@@ -3077,11 +3112,11 @@
             <a:avLst/>
           </a:prstGeom>
           <a:solidFill xmlns:a="http://schemas.openxmlformats.org/drawingml/2006/main">
-            <a:srgbClr val="F1DDD1"/>
+            <a:srgbClr val="FBE9E1"/>
           </a:solidFill>
           <a:ln xmlns:a="http://schemas.openxmlformats.org/drawingml/2006/main" w="16193">
             <a:solidFill>
-              <a:srgbClr val="C6653E"/>
+              <a:srgbClr val="D05A2A"/>
             </a:solidFill>
             <a:prstDash val="solid"/>
           </a:ln>
@@ -3089,10 +3124,10 @@
       </p:sp>
       <p:sp>
         <p:nvSpPr>
-          <p:cNvPr id="48" name="research-step">
-            <a:extLst xmlns:a="http://schemas.openxmlformats.org/drawingml/2006/main">
-              <a:ext uri="{FF2B5EF4-FFF2-40B4-BE49-F238E27FC236}">
-                <a16:creationId xmlns:a16="http://schemas.microsoft.com/office/drawing/2014/main" id="{7FC7FBA6-4A01-41C2-8217-9D1F8DA3A6A1}"/>
+          <p:cNvPr id="49" name="research-step">
+            <a:extLst xmlns:a="http://schemas.openxmlformats.org/drawingml/2006/main">
+              <a:ext uri="{FF2B5EF4-FFF2-40B4-BE49-F238E27FC236}">
+                <a16:creationId xmlns:a16="http://schemas.microsoft.com/office/drawing/2014/main" id="{58EB5E6C-2B0C-4E9D-A078-06FB291C7FB4}"/>
               </a:ext>
             </a:extLst>
           </p:cNvPr>
@@ -3110,11 +3145,11 @@
             <a:avLst/>
           </a:prstGeom>
           <a:solidFill xmlns:a="http://schemas.openxmlformats.org/drawingml/2006/main">
-            <a:srgbClr val="C6653E"/>
+            <a:srgbClr val="D05A2A"/>
           </a:solidFill>
           <a:ln xmlns:a="http://schemas.openxmlformats.org/drawingml/2006/main" w="0">
             <a:solidFill>
-              <a:srgbClr val="C6653E"/>
+              <a:srgbClr val="D05A2A"/>
             </a:solidFill>
             <a:prstDash val="solid"/>
           </a:ln>
@@ -3122,10 +3157,10 @@
       </p:sp>
       <p:sp>
         <p:nvSpPr>
-          <p:cNvPr id="49" name="research-step-text">
-            <a:extLst xmlns:a="http://schemas.openxmlformats.org/drawingml/2006/main">
-              <a:ext uri="{FF2B5EF4-FFF2-40B4-BE49-F238E27FC236}">
-                <a16:creationId xmlns:a16="http://schemas.microsoft.com/office/drawing/2014/main" id="{77F5FAE0-80CD-4FE1-A26F-853C56D03AE3}"/>
+          <p:cNvPr id="50" name="research-step-text">
+            <a:extLst xmlns:a="http://schemas.openxmlformats.org/drawingml/2006/main">
+              <a:ext uri="{FF2B5EF4-FFF2-40B4-BE49-F238E27FC236}">
+                <a16:creationId xmlns:a16="http://schemas.microsoft.com/office/drawing/2014/main" id="{B72EDDC3-9B36-4239-9390-9EE3900FAB4B}"/>
               </a:ext>
             </a:extLst>
           </p:cNvPr>
@@ -3155,14 +3190,14 @@
             <a:pPr algn="ctr">
               <a:defRPr sz="750" b="1">
                 <a:solidFill>
-                  <a:srgbClr val="FFFDF8"/>
+                  <a:srgbClr val="FFFFFF"/>
                 </a:solidFill>
               </a:defRPr>
             </a:pPr>
             <a:r>
               <a:rPr sz="750" b="1">
                 <a:solidFill>
-                  <a:srgbClr val="FFFDF8"/>
+                  <a:srgbClr val="FFFFFF"/>
                 </a:solidFill>
               </a:rPr>
               <a:t>2</a:t>
@@ -3172,10 +3207,10 @@
       </p:sp>
       <p:sp>
         <p:nvSpPr>
-          <p:cNvPr id="50" name="research-title">
-            <a:extLst xmlns:a="http://schemas.openxmlformats.org/drawingml/2006/main">
-              <a:ext uri="{FF2B5EF4-FFF2-40B4-BE49-F238E27FC236}">
-                <a16:creationId xmlns:a16="http://schemas.microsoft.com/office/drawing/2014/main" id="{3AAD2F59-65C1-4DE7-840D-5F4D25AFF669}"/>
+          <p:cNvPr id="51" name="research-title">
+            <a:extLst xmlns:a="http://schemas.openxmlformats.org/drawingml/2006/main">
+              <a:ext uri="{FF2B5EF4-FFF2-40B4-BE49-F238E27FC236}">
+                <a16:creationId xmlns:a16="http://schemas.microsoft.com/office/drawing/2014/main" id="{14F4A1BD-571D-4C4E-BEB3-DB54BB4BFC62}"/>
               </a:ext>
             </a:extLst>
           </p:cNvPr>
@@ -3205,14 +3240,14 @@
             <a:pPr algn="ctr">
               <a:defRPr sz="1125" b="1">
                 <a:solidFill>
-                  <a:srgbClr val="C6653E"/>
+                  <a:srgbClr val="D05A2A"/>
                 </a:solidFill>
               </a:defRPr>
             </a:pPr>
             <a:r>
               <a:rPr sz="1125" b="1">
                 <a:solidFill>
-                  <a:srgbClr val="C6653E"/>
+                  <a:srgbClr val="D05A2A"/>
                 </a:solidFill>
               </a:rPr>
               <a:t>Research</a:t>
@@ -3222,10 +3257,10 @@
       </p:sp>
       <p:sp>
         <p:nvSpPr>
-          <p:cNvPr id="51" name="research-body">
-            <a:extLst xmlns:a="http://schemas.openxmlformats.org/drawingml/2006/main">
-              <a:ext uri="{FF2B5EF4-FFF2-40B4-BE49-F238E27FC236}">
-                <a16:creationId xmlns:a16="http://schemas.microsoft.com/office/drawing/2014/main" id="{930F7966-706C-4F0B-8E4C-253A52794936}"/>
+          <p:cNvPr id="52" name="research-body">
+            <a:extLst xmlns:a="http://schemas.openxmlformats.org/drawingml/2006/main">
+              <a:ext uri="{FF2B5EF4-FFF2-40B4-BE49-F238E27FC236}">
+                <a16:creationId xmlns:a16="http://schemas.microsoft.com/office/drawing/2014/main" id="{64878537-8B09-4D6C-A24D-3ED31EE04DF4}"/>
               </a:ext>
             </a:extLst>
           </p:cNvPr>
@@ -3255,14 +3290,14 @@
             <a:pPr algn="ctr">
               <a:defRPr sz="788" b="0">
                 <a:solidFill>
-                  <a:srgbClr val="6B665F"/>
+                  <a:srgbClr val="667085"/>
                 </a:solidFill>
               </a:defRPr>
             </a:pPr>
             <a:r>
               <a:rPr sz="788" b="0">
                 <a:solidFill>
-                  <a:srgbClr val="6B665F"/>
+                  <a:srgbClr val="667085"/>
                 </a:solidFill>
               </a:rPr>
               <a:t>asyncio.gather</a:t>
@@ -3272,14 +3307,14 @@
             <a:pPr algn="ctr">
               <a:defRPr sz="788" b="0">
                 <a:solidFill>
-                  <a:srgbClr val="6B665F"/>
+                  <a:srgbClr val="667085"/>
                 </a:solidFill>
               </a:defRPr>
             </a:pPr>
             <a:r>
               <a:rPr sz="788" b="0">
                 <a:solidFill>
-                  <a:srgbClr val="6B665F"/>
+                  <a:srgbClr val="667085"/>
                 </a:solidFill>
               </a:rPr>
               <a:t>bounded per-tool work</a:t>
@@ -3289,14 +3324,14 @@
             <a:pPr algn="ctr">
               <a:defRPr sz="788" b="0">
                 <a:solidFill>
-                  <a:srgbClr val="6B665F"/>
+                  <a:srgbClr val="667085"/>
                 </a:solidFill>
               </a:defRPr>
             </a:pPr>
             <a:r>
               <a:rPr sz="788" b="0">
                 <a:solidFill>
-                  <a:srgbClr val="6B665F"/>
+                  <a:srgbClr val="667085"/>
                 </a:solidFill>
               </a:rPr>
               <a:t>search + analyze</a:t>
@@ -3306,10 +3341,10 @@
       </p:sp>
       <p:sp>
         <p:nvSpPr>
-          <p:cNvPr id="52" name="recommend-circle">
-            <a:extLst xmlns:a="http://schemas.openxmlformats.org/drawingml/2006/main">
-              <a:ext uri="{FF2B5EF4-FFF2-40B4-BE49-F238E27FC236}">
-                <a16:creationId xmlns:a16="http://schemas.microsoft.com/office/drawing/2014/main" id="{A205DDD0-8A68-42B6-8FB8-9EE9EE25D439}"/>
+          <p:cNvPr id="53" name="recommend-circle">
+            <a:extLst xmlns:a="http://schemas.openxmlformats.org/drawingml/2006/main">
+              <a:ext uri="{FF2B5EF4-FFF2-40B4-BE49-F238E27FC236}">
+                <a16:creationId xmlns:a16="http://schemas.microsoft.com/office/drawing/2014/main" id="{7D386C9F-175C-450C-BED1-1C1EE4140BD2}"/>
               </a:ext>
             </a:extLst>
           </p:cNvPr>
@@ -3327,11 +3362,11 @@
             <a:avLst/>
           </a:prstGeom>
           <a:solidFill xmlns:a="http://schemas.openxmlformats.org/drawingml/2006/main">
-            <a:srgbClr val="EAE0EB"/>
+            <a:srgbClr val="E8EDF1"/>
           </a:solidFill>
           <a:ln xmlns:a="http://schemas.openxmlformats.org/drawingml/2006/main" w="16193">
             <a:solidFill>
-              <a:srgbClr val="6D536F"/>
+              <a:srgbClr val="24384C"/>
             </a:solidFill>
             <a:prstDash val="solid"/>
           </a:ln>
@@ -3339,10 +3374,10 @@
       </p:sp>
       <p:sp>
         <p:nvSpPr>
-          <p:cNvPr id="53" name="recommend-step">
-            <a:extLst xmlns:a="http://schemas.openxmlformats.org/drawingml/2006/main">
-              <a:ext uri="{FF2B5EF4-FFF2-40B4-BE49-F238E27FC236}">
-                <a16:creationId xmlns:a16="http://schemas.microsoft.com/office/drawing/2014/main" id="{80915262-16E1-4117-B293-3E9FD1DE5A03}"/>
+          <p:cNvPr id="54" name="recommend-step">
+            <a:extLst xmlns:a="http://schemas.openxmlformats.org/drawingml/2006/main">
+              <a:ext uri="{FF2B5EF4-FFF2-40B4-BE49-F238E27FC236}">
+                <a16:creationId xmlns:a16="http://schemas.microsoft.com/office/drawing/2014/main" id="{F12C7241-A210-4FDE-B181-47618DDD0D17}"/>
               </a:ext>
             </a:extLst>
           </p:cNvPr>
@@ -3360,11 +3395,11 @@
             <a:avLst/>
           </a:prstGeom>
           <a:solidFill xmlns:a="http://schemas.openxmlformats.org/drawingml/2006/main">
-            <a:srgbClr val="6D536F"/>
+            <a:srgbClr val="24384C"/>
           </a:solidFill>
           <a:ln xmlns:a="http://schemas.openxmlformats.org/drawingml/2006/main" w="0">
             <a:solidFill>
-              <a:srgbClr val="6D536F"/>
+              <a:srgbClr val="24384C"/>
             </a:solidFill>
             <a:prstDash val="solid"/>
           </a:ln>
@@ -3372,10 +3407,10 @@
       </p:sp>
       <p:sp>
         <p:nvSpPr>
-          <p:cNvPr id="54" name="recommend-step-text">
-            <a:extLst xmlns:a="http://schemas.openxmlformats.org/drawingml/2006/main">
-              <a:ext uri="{FF2B5EF4-FFF2-40B4-BE49-F238E27FC236}">
-                <a16:creationId xmlns:a16="http://schemas.microsoft.com/office/drawing/2014/main" id="{7742FB5D-C4E1-4917-8EF9-FA154753B031}"/>
+          <p:cNvPr id="55" name="recommend-step-text">
+            <a:extLst xmlns:a="http://schemas.openxmlformats.org/drawingml/2006/main">
+              <a:ext uri="{FF2B5EF4-FFF2-40B4-BE49-F238E27FC236}">
+                <a16:creationId xmlns:a16="http://schemas.microsoft.com/office/drawing/2014/main" id="{F2F718BF-3748-4A83-AEB2-FCF4DB74B41E}"/>
               </a:ext>
             </a:extLst>
           </p:cNvPr>
@@ -3405,14 +3440,14 @@
             <a:pPr algn="ctr">
               <a:defRPr sz="750" b="1">
                 <a:solidFill>
-                  <a:srgbClr val="FFFDF8"/>
+                  <a:srgbClr val="FFFFFF"/>
                 </a:solidFill>
               </a:defRPr>
             </a:pPr>
             <a:r>
               <a:rPr sz="750" b="1">
                 <a:solidFill>
-                  <a:srgbClr val="FFFDF8"/>
+                  <a:srgbClr val="FFFFFF"/>
                 </a:solidFill>
               </a:rPr>
               <a:t>3</a:t>
@@ -3422,10 +3457,10 @@
       </p:sp>
       <p:sp>
         <p:nvSpPr>
-          <p:cNvPr id="55" name="recommend-title">
-            <a:extLst xmlns:a="http://schemas.openxmlformats.org/drawingml/2006/main">
-              <a:ext uri="{FF2B5EF4-FFF2-40B4-BE49-F238E27FC236}">
-                <a16:creationId xmlns:a16="http://schemas.microsoft.com/office/drawing/2014/main" id="{AD376469-67E6-4596-981D-DD60D5DBDD78}"/>
+          <p:cNvPr id="56" name="recommend-title">
+            <a:extLst xmlns:a="http://schemas.openxmlformats.org/drawingml/2006/main">
+              <a:ext uri="{FF2B5EF4-FFF2-40B4-BE49-F238E27FC236}">
+                <a16:creationId xmlns:a16="http://schemas.microsoft.com/office/drawing/2014/main" id="{CC13FF2A-DBD3-4089-8587-48F5BCDA3F2A}"/>
               </a:ext>
             </a:extLst>
           </p:cNvPr>
@@ -3460,10 +3495,10 @@
       </p:sp>
       <p:sp>
         <p:nvSpPr>
-          <p:cNvPr id="56" name="recommend-body">
-            <a:extLst xmlns:a="http://schemas.openxmlformats.org/drawingml/2006/main">
-              <a:ext uri="{FF2B5EF4-FFF2-40B4-BE49-F238E27FC236}">
-                <a16:creationId xmlns:a16="http://schemas.microsoft.com/office/drawing/2014/main" id="{84E23C81-9CA1-4F75-819E-79A91BBCFC61}"/>
+          <p:cNvPr id="57" name="recommend-body">
+            <a:extLst xmlns:a="http://schemas.openxmlformats.org/drawingml/2006/main">
+              <a:ext uri="{FF2B5EF4-FFF2-40B4-BE49-F238E27FC236}">
+                <a16:creationId xmlns:a16="http://schemas.microsoft.com/office/drawing/2014/main" id="{86DA6ED6-20AE-4671-9C74-1EEFABEDE5A0}"/>
               </a:ext>
             </a:extLst>
           </p:cNvPr>
@@ -3493,14 +3528,14 @@
             <a:pPr algn="ctr">
               <a:defRPr sz="788" b="0">
                 <a:solidFill>
-                  <a:srgbClr val="6B665F"/>
+                  <a:srgbClr val="667085"/>
                 </a:solidFill>
               </a:defRPr>
             </a:pPr>
             <a:r>
               <a:rPr sz="788" b="0">
                 <a:solidFill>
-                  <a:srgbClr val="6B665F"/>
+                  <a:srgbClr val="667085"/>
                 </a:solidFill>
               </a:rPr>
               <a:t>validated ToolReport[]</a:t>
@@ -3510,14 +3545,14 @@
             <a:pPr algn="ctr">
               <a:defRPr sz="788" b="0">
                 <a:solidFill>
-                  <a:srgbClr val="6B665F"/>
+                  <a:srgbClr val="667085"/>
                 </a:solidFill>
               </a:defRPr>
             </a:pPr>
             <a:r>
               <a:rPr sz="788" b="0">
                 <a:solidFill>
-                  <a:srgbClr val="6B665F"/>
+                  <a:srgbClr val="667085"/>
                 </a:solidFill>
               </a:rPr>
               <a:t>neutral fallback</a:t>
@@ -3527,14 +3562,14 @@
             <a:pPr algn="ctr">
               <a:defRPr sz="788" b="0">
                 <a:solidFill>
-                  <a:srgbClr val="6B665F"/>
+                  <a:srgbClr val="667085"/>
                 </a:solidFill>
               </a:defRPr>
             </a:pPr>
             <a:r>
               <a:rPr sz="788" b="0">
                 <a:solidFill>
-                  <a:srgbClr val="6B665F"/>
+                  <a:srgbClr val="667085"/>
                 </a:solidFill>
               </a:rPr>
               <a:t>on provider failure</a:t>
@@ -3544,10 +3579,10 @@
       </p:sp>
       <p:sp>
         <p:nvSpPr>
-          <p:cNvPr id="57" name="recommend-title-fix">
-            <a:extLst xmlns:a="http://schemas.openxmlformats.org/drawingml/2006/main">
-              <a:ext uri="{FF2B5EF4-FFF2-40B4-BE49-F238E27FC236}">
-                <a16:creationId xmlns:a16="http://schemas.microsoft.com/office/drawing/2014/main" id="{4FD308D2-598B-4AFA-809C-231D6DB2D17F}"/>
+          <p:cNvPr id="58" name="recommend-title-fix">
+            <a:extLst xmlns:a="http://schemas.openxmlformats.org/drawingml/2006/main">
+              <a:ext uri="{FF2B5EF4-FFF2-40B4-BE49-F238E27FC236}">
+                <a16:creationId xmlns:a16="http://schemas.microsoft.com/office/drawing/2014/main" id="{464B8B6A-BA82-4DE4-8C9A-8DD25EEDD833}"/>
               </a:ext>
             </a:extLst>
           </p:cNvPr>
@@ -3577,14 +3612,14 @@
             <a:pPr algn="ctr">
               <a:defRPr sz="975" b="1">
                 <a:solidFill>
-                  <a:srgbClr val="6D536F"/>
+                  <a:srgbClr val="24384C"/>
                 </a:solidFill>
               </a:defRPr>
             </a:pPr>
             <a:r>
               <a:rPr sz="975" b="1">
                 <a:solidFill>
-                  <a:srgbClr val="6D536F"/>
+                  <a:srgbClr val="24384C"/>
                 </a:solidFill>
               </a:rPr>
               <a:t>Recommend</a:t>
@@ -3594,10 +3629,10 @@
       </p:sp>
       <p:sp>
         <p:nvSpPr>
-          <p:cNvPr id="58" name="fanout-label">
-            <a:extLst xmlns:a="http://schemas.openxmlformats.org/drawingml/2006/main">
-              <a:ext uri="{FF2B5EF4-FFF2-40B4-BE49-F238E27FC236}">
-                <a16:creationId xmlns:a16="http://schemas.microsoft.com/office/drawing/2014/main" id="{7989EEEC-EE37-4A57-AC2E-6FFECC9136E3}"/>
+          <p:cNvPr id="59" name="fanout-label">
+            <a:extLst xmlns:a="http://schemas.openxmlformats.org/drawingml/2006/main">
+              <a:ext uri="{FF2B5EF4-FFF2-40B4-BE49-F238E27FC236}">
+                <a16:creationId xmlns:a16="http://schemas.microsoft.com/office/drawing/2014/main" id="{DAEBA156-07FA-4DE6-AADD-71401E3A94A7}"/>
               </a:ext>
             </a:extLst>
           </p:cNvPr>
@@ -3627,14 +3662,14 @@
             <a:pPr algn="ctr">
               <a:defRPr sz="788" b="1">
                 <a:solidFill>
-                  <a:srgbClr val="C6653E"/>
+                  <a:srgbClr val="D05A2A"/>
                 </a:solidFill>
               </a:defRPr>
             </a:pPr>
             <a:r>
               <a:rPr sz="788" b="1">
                 <a:solidFill>
-                  <a:srgbClr val="C6653E"/>
+                  <a:srgbClr val="D05A2A"/>
                 </a:solidFill>
               </a:rPr>
               <a:t>parallel tool workers</a:t>
@@ -3644,10 +3679,10 @@
       </p:sp>
       <p:sp>
         <p:nvSpPr>
-          <p:cNvPr id="59" name="tool-0">
-            <a:extLst xmlns:a="http://schemas.openxmlformats.org/drawingml/2006/main">
-              <a:ext uri="{FF2B5EF4-FFF2-40B4-BE49-F238E27FC236}">
-                <a16:creationId xmlns:a16="http://schemas.microsoft.com/office/drawing/2014/main" id="{46B3DF49-540E-4B05-B8C8-86E517CED8B8}"/>
+          <p:cNvPr id="60" name="tool-0">
+            <a:extLst xmlns:a="http://schemas.openxmlformats.org/drawingml/2006/main">
+              <a:ext uri="{FF2B5EF4-FFF2-40B4-BE49-F238E27FC236}">
+                <a16:creationId xmlns:a16="http://schemas.microsoft.com/office/drawing/2014/main" id="{859381FD-DE78-4426-9D78-02D9A8E0714B}"/>
               </a:ext>
             </a:extLst>
           </p:cNvPr>
@@ -3665,11 +3700,11 @@
             <a:avLst/>
           </a:prstGeom>
           <a:solidFill xmlns:a="http://schemas.openxmlformats.org/drawingml/2006/main">
-            <a:srgbClr val="FFFDF8"/>
+            <a:srgbClr val="FFFFFF"/>
           </a:solidFill>
           <a:ln xmlns:a="http://schemas.openxmlformats.org/drawingml/2006/main" w="12383">
             <a:solidFill>
-              <a:srgbClr val="C6653E"/>
+              <a:srgbClr val="D05A2A"/>
             </a:solidFill>
             <a:prstDash val="solid"/>
           </a:ln>
@@ -3677,10 +3712,10 @@
       </p:sp>
       <p:sp>
         <p:nvSpPr>
-          <p:cNvPr id="60" name="tool-0-title">
-            <a:extLst xmlns:a="http://schemas.openxmlformats.org/drawingml/2006/main">
-              <a:ext uri="{FF2B5EF4-FFF2-40B4-BE49-F238E27FC236}">
-                <a16:creationId xmlns:a16="http://schemas.microsoft.com/office/drawing/2014/main" id="{194EA016-28BA-41D8-823A-5778B5EA4247}"/>
+          <p:cNvPr id="61" name="tool-0-title">
+            <a:extLst xmlns:a="http://schemas.openxmlformats.org/drawingml/2006/main">
+              <a:ext uri="{FF2B5EF4-FFF2-40B4-BE49-F238E27FC236}">
+                <a16:creationId xmlns:a16="http://schemas.microsoft.com/office/drawing/2014/main" id="{FE3410AF-C8BF-4F7F-9526-8C1A9B2E4799}"/>
               </a:ext>
             </a:extLst>
           </p:cNvPr>
@@ -3710,14 +3745,14 @@
             <a:pPr algn="ctr">
               <a:defRPr sz="863" b="1">
                 <a:solidFill>
-                  <a:srgbClr val="24211D"/>
+                  <a:srgbClr val="1C2430"/>
                 </a:solidFill>
               </a:defRPr>
             </a:pPr>
             <a:r>
               <a:rPr sz="863" b="1">
                 <a:solidFill>
-                  <a:srgbClr val="24211D"/>
+                  <a:srgbClr val="1C2430"/>
                 </a:solidFill>
               </a:rPr>
               <a:t>tool A</a:t>
@@ -3727,10 +3762,10 @@
       </p:sp>
       <p:sp>
         <p:nvSpPr>
-          <p:cNvPr id="61" name="tool-0-copy">
-            <a:extLst xmlns:a="http://schemas.openxmlformats.org/drawingml/2006/main">
-              <a:ext uri="{FF2B5EF4-FFF2-40B4-BE49-F238E27FC236}">
-                <a16:creationId xmlns:a16="http://schemas.microsoft.com/office/drawing/2014/main" id="{FDA68FB3-1131-4E89-9E86-D301D78F866B}"/>
+          <p:cNvPr id="62" name="tool-0-copy">
+            <a:extLst xmlns:a="http://schemas.openxmlformats.org/drawingml/2006/main">
+              <a:ext uri="{FF2B5EF4-FFF2-40B4-BE49-F238E27FC236}">
+                <a16:creationId xmlns:a16="http://schemas.microsoft.com/office/drawing/2014/main" id="{ED04F68A-BA83-47C0-9308-F50782F11FD4}"/>
               </a:ext>
             </a:extLst>
           </p:cNvPr>
@@ -3760,14 +3795,14 @@
             <a:pPr algn="ctr">
               <a:defRPr sz="713" b="0">
                 <a:solidFill>
-                  <a:srgbClr val="6B665F"/>
+                  <a:srgbClr val="667085"/>
                 </a:solidFill>
               </a:defRPr>
             </a:pPr>
             <a:r>
               <a:rPr sz="713" b="0">
                 <a:solidFill>
-                  <a:srgbClr val="6B665F"/>
+                  <a:srgbClr val="667085"/>
                 </a:solidFill>
               </a:rPr>
               <a:t>search</a:t>
@@ -3777,14 +3812,14 @@
             <a:pPr algn="ctr">
               <a:defRPr sz="713" b="0">
                 <a:solidFill>
-                  <a:srgbClr val="6B665F"/>
+                  <a:srgbClr val="667085"/>
                 </a:solidFill>
               </a:defRPr>
             </a:pPr>
             <a:r>
               <a:rPr sz="713" b="0">
                 <a:solidFill>
-                  <a:srgbClr val="6B665F"/>
+                  <a:srgbClr val="667085"/>
                 </a:solidFill>
               </a:rPr>
               <a:t>+ analyze</a:t>
@@ -3794,10 +3829,10 @@
       </p:sp>
       <p:sp>
         <p:nvSpPr>
-          <p:cNvPr id="62" name="tool-1">
-            <a:extLst xmlns:a="http://schemas.openxmlformats.org/drawingml/2006/main">
-              <a:ext uri="{FF2B5EF4-FFF2-40B4-BE49-F238E27FC236}">
-                <a16:creationId xmlns:a16="http://schemas.microsoft.com/office/drawing/2014/main" id="{B659195A-ED33-4CB8-84C9-71DF8F493382}"/>
+          <p:cNvPr id="63" name="tool-1">
+            <a:extLst xmlns:a="http://schemas.openxmlformats.org/drawingml/2006/main">
+              <a:ext uri="{FF2B5EF4-FFF2-40B4-BE49-F238E27FC236}">
+                <a16:creationId xmlns:a16="http://schemas.microsoft.com/office/drawing/2014/main" id="{14B7C9A1-3655-4933-95D8-6E1EB2F016DF}"/>
               </a:ext>
             </a:extLst>
           </p:cNvPr>
@@ -3815,11 +3850,11 @@
             <a:avLst/>
           </a:prstGeom>
           <a:solidFill xmlns:a="http://schemas.openxmlformats.org/drawingml/2006/main">
-            <a:srgbClr val="FFFDF8"/>
+            <a:srgbClr val="FFFFFF"/>
           </a:solidFill>
           <a:ln xmlns:a="http://schemas.openxmlformats.org/drawingml/2006/main" w="12383">
             <a:solidFill>
-              <a:srgbClr val="C6653E"/>
+              <a:srgbClr val="D05A2A"/>
             </a:solidFill>
             <a:prstDash val="solid"/>
           </a:ln>
@@ -3827,10 +3862,10 @@
       </p:sp>
       <p:sp>
         <p:nvSpPr>
-          <p:cNvPr id="63" name="tool-1-title">
-            <a:extLst xmlns:a="http://schemas.openxmlformats.org/drawingml/2006/main">
-              <a:ext uri="{FF2B5EF4-FFF2-40B4-BE49-F238E27FC236}">
-                <a16:creationId xmlns:a16="http://schemas.microsoft.com/office/drawing/2014/main" id="{3435F7E0-F58F-4F0C-891E-CD4B1B70A95C}"/>
+          <p:cNvPr id="64" name="tool-1-title">
+            <a:extLst xmlns:a="http://schemas.openxmlformats.org/drawingml/2006/main">
+              <a:ext uri="{FF2B5EF4-FFF2-40B4-BE49-F238E27FC236}">
+                <a16:creationId xmlns:a16="http://schemas.microsoft.com/office/drawing/2014/main" id="{5E857C58-37F9-44F8-B0DF-015F78A912D4}"/>
               </a:ext>
             </a:extLst>
           </p:cNvPr>
@@ -3860,14 +3895,14 @@
             <a:pPr algn="ctr">
               <a:defRPr sz="863" b="1">
                 <a:solidFill>
-                  <a:srgbClr val="24211D"/>
+                  <a:srgbClr val="1C2430"/>
                 </a:solidFill>
               </a:defRPr>
             </a:pPr>
             <a:r>
               <a:rPr sz="863" b="1">
                 <a:solidFill>
-                  <a:srgbClr val="24211D"/>
+                  <a:srgbClr val="1C2430"/>
                 </a:solidFill>
               </a:rPr>
               <a:t>tool B</a:t>
@@ -3877,10 +3912,10 @@
       </p:sp>
       <p:sp>
         <p:nvSpPr>
-          <p:cNvPr id="64" name="tool-1-copy">
-            <a:extLst xmlns:a="http://schemas.openxmlformats.org/drawingml/2006/main">
-              <a:ext uri="{FF2B5EF4-FFF2-40B4-BE49-F238E27FC236}">
-                <a16:creationId xmlns:a16="http://schemas.microsoft.com/office/drawing/2014/main" id="{415EB914-A69A-45FE-A1CA-34DBCC38245F}"/>
+          <p:cNvPr id="65" name="tool-1-copy">
+            <a:extLst xmlns:a="http://schemas.openxmlformats.org/drawingml/2006/main">
+              <a:ext uri="{FF2B5EF4-FFF2-40B4-BE49-F238E27FC236}">
+                <a16:creationId xmlns:a16="http://schemas.microsoft.com/office/drawing/2014/main" id="{45F6906A-789C-493C-81EF-5D084D965F61}"/>
               </a:ext>
             </a:extLst>
           </p:cNvPr>
@@ -3910,14 +3945,14 @@
             <a:pPr algn="ctr">
               <a:defRPr sz="713" b="0">
                 <a:solidFill>
-                  <a:srgbClr val="6B665F"/>
+                  <a:srgbClr val="667085"/>
                 </a:solidFill>
               </a:defRPr>
             </a:pPr>
             <a:r>
               <a:rPr sz="713" b="0">
                 <a:solidFill>
-                  <a:srgbClr val="6B665F"/>
+                  <a:srgbClr val="667085"/>
                 </a:solidFill>
               </a:rPr>
               <a:t>search</a:t>
@@ -3927,14 +3962,14 @@
             <a:pPr algn="ctr">
               <a:defRPr sz="713" b="0">
                 <a:solidFill>
-                  <a:srgbClr val="6B665F"/>
+                  <a:srgbClr val="667085"/>
                 </a:solidFill>
               </a:defRPr>
             </a:pPr>
             <a:r>
               <a:rPr sz="713" b="0">
                 <a:solidFill>
-                  <a:srgbClr val="6B665F"/>
+                  <a:srgbClr val="667085"/>
                 </a:solidFill>
               </a:rPr>
               <a:t>+ analyze</a:t>
@@ -3944,10 +3979,10 @@
       </p:sp>
       <p:sp>
         <p:nvSpPr>
-          <p:cNvPr id="65" name="tool-2">
-            <a:extLst xmlns:a="http://schemas.openxmlformats.org/drawingml/2006/main">
-              <a:ext uri="{FF2B5EF4-FFF2-40B4-BE49-F238E27FC236}">
-                <a16:creationId xmlns:a16="http://schemas.microsoft.com/office/drawing/2014/main" id="{0ED1036D-B660-44D0-93B2-8F4693C0AF11}"/>
+          <p:cNvPr id="66" name="tool-2">
+            <a:extLst xmlns:a="http://schemas.openxmlformats.org/drawingml/2006/main">
+              <a:ext uri="{FF2B5EF4-FFF2-40B4-BE49-F238E27FC236}">
+                <a16:creationId xmlns:a16="http://schemas.microsoft.com/office/drawing/2014/main" id="{E14239CC-DA53-4EE9-A5C8-CED39F36DF21}"/>
               </a:ext>
             </a:extLst>
           </p:cNvPr>
@@ -3965,11 +4000,11 @@
             <a:avLst/>
           </a:prstGeom>
           <a:solidFill xmlns:a="http://schemas.openxmlformats.org/drawingml/2006/main">
-            <a:srgbClr val="FFFDF8"/>
+            <a:srgbClr val="FFFFFF"/>
           </a:solidFill>
           <a:ln xmlns:a="http://schemas.openxmlformats.org/drawingml/2006/main" w="12383">
             <a:solidFill>
-              <a:srgbClr val="C6653E"/>
+              <a:srgbClr val="D05A2A"/>
             </a:solidFill>
             <a:prstDash val="solid"/>
           </a:ln>
@@ -3977,10 +4012,10 @@
       </p:sp>
       <p:sp>
         <p:nvSpPr>
-          <p:cNvPr id="66" name="tool-2-title">
-            <a:extLst xmlns:a="http://schemas.openxmlformats.org/drawingml/2006/main">
-              <a:ext uri="{FF2B5EF4-FFF2-40B4-BE49-F238E27FC236}">
-                <a16:creationId xmlns:a16="http://schemas.microsoft.com/office/drawing/2014/main" id="{69940375-97BB-4C47-A13B-7C23674F2B08}"/>
+          <p:cNvPr id="67" name="tool-2-title">
+            <a:extLst xmlns:a="http://schemas.openxmlformats.org/drawingml/2006/main">
+              <a:ext uri="{FF2B5EF4-FFF2-40B4-BE49-F238E27FC236}">
+                <a16:creationId xmlns:a16="http://schemas.microsoft.com/office/drawing/2014/main" id="{040741A6-1775-408D-B8BC-AF131FE26B4E}"/>
               </a:ext>
             </a:extLst>
           </p:cNvPr>
@@ -4010,14 +4045,14 @@
             <a:pPr algn="ctr">
               <a:defRPr sz="863" b="1">
                 <a:solidFill>
-                  <a:srgbClr val="24211D"/>
+                  <a:srgbClr val="1C2430"/>
                 </a:solidFill>
               </a:defRPr>
             </a:pPr>
             <a:r>
               <a:rPr sz="863" b="1">
                 <a:solidFill>
-                  <a:srgbClr val="24211D"/>
+                  <a:srgbClr val="1C2430"/>
                 </a:solidFill>
               </a:rPr>
               <a:t>tool N</a:t>
@@ -4027,10 +4062,10 @@
       </p:sp>
       <p:sp>
         <p:nvSpPr>
-          <p:cNvPr id="67" name="tool-2-copy">
-            <a:extLst xmlns:a="http://schemas.openxmlformats.org/drawingml/2006/main">
-              <a:ext uri="{FF2B5EF4-FFF2-40B4-BE49-F238E27FC236}">
-                <a16:creationId xmlns:a16="http://schemas.microsoft.com/office/drawing/2014/main" id="{A9360F6E-DE66-46DE-9E56-84C0A13D73B7}"/>
+          <p:cNvPr id="68" name="tool-2-copy">
+            <a:extLst xmlns:a="http://schemas.openxmlformats.org/drawingml/2006/main">
+              <a:ext uri="{FF2B5EF4-FFF2-40B4-BE49-F238E27FC236}">
+                <a16:creationId xmlns:a16="http://schemas.microsoft.com/office/drawing/2014/main" id="{66787634-ACA9-4DD3-9695-55094DAA99B2}"/>
               </a:ext>
             </a:extLst>
           </p:cNvPr>
@@ -4060,14 +4095,14 @@
             <a:pPr algn="ctr">
               <a:defRPr sz="713" b="0">
                 <a:solidFill>
-                  <a:srgbClr val="6B665F"/>
+                  <a:srgbClr val="667085"/>
                 </a:solidFill>
               </a:defRPr>
             </a:pPr>
             <a:r>
               <a:rPr sz="713" b="0">
                 <a:solidFill>
-                  <a:srgbClr val="6B665F"/>
+                  <a:srgbClr val="667085"/>
                 </a:solidFill>
               </a:rPr>
               <a:t>search</a:t>
@@ -4077,14 +4112,14 @@
             <a:pPr algn="ctr">
               <a:defRPr sz="713" b="0">
                 <a:solidFill>
-                  <a:srgbClr val="6B665F"/>
+                  <a:srgbClr val="667085"/>
                 </a:solidFill>
               </a:defRPr>
             </a:pPr>
             <a:r>
               <a:rPr sz="713" b="0">
                 <a:solidFill>
-                  <a:srgbClr val="6B665F"/>
+                  <a:srgbClr val="667085"/>
                 </a:solidFill>
               </a:rPr>
               <a:t>+ analyze</a:t>
@@ -4094,10 +4129,10 @@
       </p:sp>
       <p:sp>
         <p:nvSpPr>
-          <p:cNvPr id="68" name="tool-report">
-            <a:extLst xmlns:a="http://schemas.openxmlformats.org/drawingml/2006/main">
-              <a:ext uri="{FF2B5EF4-FFF2-40B4-BE49-F238E27FC236}">
-                <a16:creationId xmlns:a16="http://schemas.microsoft.com/office/drawing/2014/main" id="{5776A80B-EE85-4201-BB17-8AA828A2725C}"/>
+          <p:cNvPr id="69" name="tool-report">
+            <a:extLst xmlns:a="http://schemas.openxmlformats.org/drawingml/2006/main">
+              <a:ext uri="{FF2B5EF4-FFF2-40B4-BE49-F238E27FC236}">
+                <a16:creationId xmlns:a16="http://schemas.microsoft.com/office/drawing/2014/main" id="{5B581054-6438-44BC-BB7E-B3C5005732C6}"/>
               </a:ext>
             </a:extLst>
           </p:cNvPr>
@@ -4117,11 +4152,11 @@
             </a:avLst>
           </a:prstGeom>
           <a:solidFill xmlns:a="http://schemas.openxmlformats.org/drawingml/2006/main">
-            <a:srgbClr val="FFFDF8"/>
+            <a:srgbClr val="FFFFFF"/>
           </a:solidFill>
           <a:ln xmlns:a="http://schemas.openxmlformats.org/drawingml/2006/main" w="14288">
             <a:solidFill>
-              <a:srgbClr val="6D536F"/>
+              <a:srgbClr val="24384C"/>
             </a:solidFill>
             <a:prstDash val="solid"/>
           </a:ln>
@@ -4129,10 +4164,10 @@
       </p:sp>
       <p:sp>
         <p:nvSpPr>
-          <p:cNvPr id="69" name="tool-report-title">
-            <a:extLst xmlns:a="http://schemas.openxmlformats.org/drawingml/2006/main">
-              <a:ext uri="{FF2B5EF4-FFF2-40B4-BE49-F238E27FC236}">
-                <a16:creationId xmlns:a16="http://schemas.microsoft.com/office/drawing/2014/main" id="{B6F20F6D-B0B5-4A20-94B8-F2F6925E9186}"/>
+          <p:cNvPr id="70" name="tool-report-title">
+            <a:extLst xmlns:a="http://schemas.openxmlformats.org/drawingml/2006/main">
+              <a:ext uri="{FF2B5EF4-FFF2-40B4-BE49-F238E27FC236}">
+                <a16:creationId xmlns:a16="http://schemas.microsoft.com/office/drawing/2014/main" id="{FEC05AED-5A91-468D-944C-3F7FB878193E}"/>
               </a:ext>
             </a:extLst>
           </p:cNvPr>
@@ -4162,14 +4197,14 @@
             <a:pPr algn="ctr">
               <a:defRPr sz="938" b="1">
                 <a:solidFill>
-                  <a:srgbClr val="6D536F"/>
+                  <a:srgbClr val="24384C"/>
                 </a:solidFill>
               </a:defRPr>
             </a:pPr>
             <a:r>
               <a:rPr sz="938" b="1">
                 <a:solidFill>
-                  <a:srgbClr val="6D536F"/>
+                  <a:srgbClr val="24384C"/>
                 </a:solidFill>
               </a:rPr>
               <a:t>ToolReport[]</a:t>
@@ -4179,10 +4214,10 @@
       </p:sp>
       <p:sp>
         <p:nvSpPr>
-          <p:cNvPr id="70" name="tool-report-copy">
-            <a:extLst xmlns:a="http://schemas.openxmlformats.org/drawingml/2006/main">
-              <a:ext uri="{FF2B5EF4-FFF2-40B4-BE49-F238E27FC236}">
-                <a16:creationId xmlns:a16="http://schemas.microsoft.com/office/drawing/2014/main" id="{40F95BC2-39E1-4829-8481-DBED4BCF1B84}"/>
+          <p:cNvPr id="71" name="tool-report-copy">
+            <a:extLst xmlns:a="http://schemas.openxmlformats.org/drawingml/2006/main">
+              <a:ext uri="{FF2B5EF4-FFF2-40B4-BE49-F238E27FC236}">
+                <a16:creationId xmlns:a16="http://schemas.microsoft.com/office/drawing/2014/main" id="{C7BF6E6C-1847-4ABF-952F-6D5C86D84662}"/>
               </a:ext>
             </a:extLst>
           </p:cNvPr>
@@ -4212,14 +4247,14 @@
             <a:pPr algn="ctr">
               <a:defRPr sz="653" b="0">
                 <a:solidFill>
-                  <a:srgbClr val="6B665F"/>
+                  <a:srgbClr val="667085"/>
                 </a:solidFill>
               </a:defRPr>
             </a:pPr>
             <a:r>
               <a:rPr sz="653" b="0">
                 <a:solidFill>
-                  <a:srgbClr val="6B665F"/>
+                  <a:srgbClr val="667085"/>
                 </a:solidFill>
               </a:rPr>
               <a:t>unknown IDs rejected</a:t>
@@ -4229,10 +4264,10 @@
       </p:sp>
       <p:sp>
         <p:nvSpPr>
-          <p:cNvPr id="71" name="public-url-note">
-            <a:extLst xmlns:a="http://schemas.openxmlformats.org/drawingml/2006/main">
-              <a:ext uri="{FF2B5EF4-FFF2-40B4-BE49-F238E27FC236}">
-                <a16:creationId xmlns:a16="http://schemas.microsoft.com/office/drawing/2014/main" id="{2AA53233-E986-4EB8-90E9-F0FCC392AD09}"/>
+          <p:cNvPr id="72" name="public-url-note">
+            <a:extLst xmlns:a="http://schemas.openxmlformats.org/drawingml/2006/main">
+              <a:ext uri="{FF2B5EF4-FFF2-40B4-BE49-F238E27FC236}">
+                <a16:creationId xmlns:a16="http://schemas.microsoft.com/office/drawing/2014/main" id="{9088C41B-ECAC-4D13-AC90-72DCA60F5BDA}"/>
               </a:ext>
             </a:extLst>
           </p:cNvPr>
@@ -4252,11 +4287,11 @@
             </a:avLst>
           </a:prstGeom>
           <a:solidFill xmlns:a="http://schemas.openxmlformats.org/drawingml/2006/main">
-            <a:srgbClr val="E6E0D5"/>
+            <a:srgbClr val="F2F2EF"/>
           </a:solidFill>
           <a:ln xmlns:a="http://schemas.openxmlformats.org/drawingml/2006/main" w="9525">
             <a:solidFill>
-              <a:srgbClr val="B9B0A2"/>
+              <a:srgbClr val="C9CED6"/>
             </a:solidFill>
             <a:prstDash val="solid"/>
           </a:ln>
@@ -4264,10 +4299,10 @@
       </p:sp>
       <p:sp>
         <p:nvSpPr>
-          <p:cNvPr id="72" name="public-url-head">
-            <a:extLst xmlns:a="http://schemas.openxmlformats.org/drawingml/2006/main">
-              <a:ext uri="{FF2B5EF4-FFF2-40B4-BE49-F238E27FC236}">
-                <a16:creationId xmlns:a16="http://schemas.microsoft.com/office/drawing/2014/main" id="{FF832F79-8D2D-46B0-9629-132C68DCE40C}"/>
+          <p:cNvPr id="73" name="public-url-head">
+            <a:extLst xmlns:a="http://schemas.openxmlformats.org/drawingml/2006/main">
+              <a:ext uri="{FF2B5EF4-FFF2-40B4-BE49-F238E27FC236}">
+                <a16:creationId xmlns:a16="http://schemas.microsoft.com/office/drawing/2014/main" id="{1A1BAFC1-B50A-481D-8FC7-D9954FD6296D}"/>
               </a:ext>
             </a:extLst>
           </p:cNvPr>
@@ -4297,14 +4332,14 @@
             <a:pPr algn="l">
               <a:defRPr sz="713" b="1">
                 <a:solidFill>
-                  <a:srgbClr val="52725D"/>
+                  <a:srgbClr val="397EA5"/>
                 </a:solidFill>
               </a:defRPr>
             </a:pPr>
             <a:r>
               <a:rPr sz="713" b="1">
                 <a:solidFill>
-                  <a:srgbClr val="52725D"/>
+                  <a:srgbClr val="397EA5"/>
                 </a:solidFill>
               </a:rPr>
               <a:t>PUBLIC URL GATE</a:t>
@@ -4314,10 +4349,10 @@
       </p:sp>
       <p:sp>
         <p:nvSpPr>
-          <p:cNvPr id="73" name="public-url-copy">
-            <a:extLst xmlns:a="http://schemas.openxmlformats.org/drawingml/2006/main">
-              <a:ext uri="{FF2B5EF4-FFF2-40B4-BE49-F238E27FC236}">
-                <a16:creationId xmlns:a16="http://schemas.microsoft.com/office/drawing/2014/main" id="{F4CF988C-5E6F-429D-8B5B-FDA154CB864E}"/>
+          <p:cNvPr id="74" name="public-url-copy">
+            <a:extLst xmlns:a="http://schemas.openxmlformats.org/drawingml/2006/main">
+              <a:ext uri="{FF2B5EF4-FFF2-40B4-BE49-F238E27FC236}">
+                <a16:creationId xmlns:a16="http://schemas.microsoft.com/office/drawing/2014/main" id="{3428B91B-FB86-4342-BE65-3B565D52E836}"/>
               </a:ext>
             </a:extLst>
           </p:cNvPr>
@@ -4347,14 +4382,14 @@
             <a:pPr algn="l">
               <a:defRPr sz="698" b="0">
                 <a:solidFill>
-                  <a:srgbClr val="6B665F"/>
+                  <a:srgbClr val="667085"/>
                 </a:solidFill>
               </a:defRPr>
             </a:pPr>
             <a:r>
               <a:rPr sz="698" b="0">
                 <a:solidFill>
-                  <a:srgbClr val="6B665F"/>
+                  <a:srgbClr val="667085"/>
                 </a:solidFill>
               </a:rPr>
               <a:t>reject local, private, reserved, or credentialed targets</a:t>
@@ -4364,10 +4399,10 @@
       </p:sp>
       <p:sp>
         <p:nvSpPr>
-          <p:cNvPr id="74" name="partial-note">
-            <a:extLst xmlns:a="http://schemas.openxmlformats.org/drawingml/2006/main">
-              <a:ext uri="{FF2B5EF4-FFF2-40B4-BE49-F238E27FC236}">
-                <a16:creationId xmlns:a16="http://schemas.microsoft.com/office/drawing/2014/main" id="{0FEE5E33-4AB3-46DB-AEE5-1E81EBF567CD}"/>
+          <p:cNvPr id="75" name="partial-note">
+            <a:extLst xmlns:a="http://schemas.openxmlformats.org/drawingml/2006/main">
+              <a:ext uri="{FF2B5EF4-FFF2-40B4-BE49-F238E27FC236}">
+                <a16:creationId xmlns:a16="http://schemas.microsoft.com/office/drawing/2014/main" id="{B7A8F808-9DB9-43C9-ACD3-4AB83BA81ED4}"/>
               </a:ext>
             </a:extLst>
           </p:cNvPr>
@@ -4387,11 +4422,11 @@
             </a:avLst>
           </a:prstGeom>
           <a:solidFill xmlns:a="http://schemas.openxmlformats.org/drawingml/2006/main">
-            <a:srgbClr val="F1DDD1"/>
+            <a:srgbClr val="FBE9E1"/>
           </a:solidFill>
           <a:ln xmlns:a="http://schemas.openxmlformats.org/drawingml/2006/main" w="9525">
             <a:solidFill>
-              <a:srgbClr val="C6653E"/>
+              <a:srgbClr val="D05A2A"/>
             </a:solidFill>
             <a:prstDash val="solid"/>
           </a:ln>
@@ -4399,10 +4434,10 @@
       </p:sp>
       <p:sp>
         <p:nvSpPr>
-          <p:cNvPr id="75" name="partial-head">
-            <a:extLst xmlns:a="http://schemas.openxmlformats.org/drawingml/2006/main">
-              <a:ext uri="{FF2B5EF4-FFF2-40B4-BE49-F238E27FC236}">
-                <a16:creationId xmlns:a16="http://schemas.microsoft.com/office/drawing/2014/main" id="{5021699A-EA0F-4874-BFEC-0B01B9F630DF}"/>
+          <p:cNvPr id="76" name="partial-head">
+            <a:extLst xmlns:a="http://schemas.openxmlformats.org/drawingml/2006/main">
+              <a:ext uri="{FF2B5EF4-FFF2-40B4-BE49-F238E27FC236}">
+                <a16:creationId xmlns:a16="http://schemas.microsoft.com/office/drawing/2014/main" id="{4A05DB06-3035-4AE6-BE93-4E1F37B5C272}"/>
               </a:ext>
             </a:extLst>
           </p:cNvPr>
@@ -4432,14 +4467,14 @@
             <a:pPr algn="l">
               <a:defRPr sz="713" b="1">
                 <a:solidFill>
-                  <a:srgbClr val="C6653E"/>
+                  <a:srgbClr val="D05A2A"/>
                 </a:solidFill>
               </a:defRPr>
             </a:pPr>
             <a:r>
               <a:rPr sz="713" b="1">
                 <a:solidFill>
-                  <a:srgbClr val="C6653E"/>
+                  <a:srgbClr val="D05A2A"/>
                 </a:solidFill>
               </a:rPr>
               <a:t>DEGRADED RUN</a:t>
@@ -4449,10 +4484,10 @@
       </p:sp>
       <p:sp>
         <p:nvSpPr>
-          <p:cNvPr id="76" name="partial-copy">
-            <a:extLst xmlns:a="http://schemas.openxmlformats.org/drawingml/2006/main">
-              <a:ext uri="{FF2B5EF4-FFF2-40B4-BE49-F238E27FC236}">
-                <a16:creationId xmlns:a16="http://schemas.microsoft.com/office/drawing/2014/main" id="{C1114DBC-60EE-46DF-9FB6-E42E16993181}"/>
+          <p:cNvPr id="77" name="partial-copy">
+            <a:extLst xmlns:a="http://schemas.openxmlformats.org/drawingml/2006/main">
+              <a:ext uri="{FF2B5EF4-FFF2-40B4-BE49-F238E27FC236}">
+                <a16:creationId xmlns:a16="http://schemas.microsoft.com/office/drawing/2014/main" id="{54F8AD4D-3A4B-4EB6-930A-7F9E02897DFB}"/>
               </a:ext>
             </a:extLst>
           </p:cNvPr>
@@ -4482,14 +4517,14 @@
             <a:pPr algn="l">
               <a:defRPr sz="698" b="0">
                 <a:solidFill>
-                  <a:srgbClr val="6B665F"/>
+                  <a:srgbClr val="667085"/>
                 </a:solidFill>
               </a:defRPr>
             </a:pPr>
             <a:r>
               <a:rPr sz="698" b="0">
                 <a:solidFill>
-                  <a:srgbClr val="6B665F"/>
+                  <a:srgbClr val="667085"/>
                 </a:solidFill>
               </a:rPr>
               <a:t>failed tools become warnings; sourced profiles continue</a:t>
@@ -4499,10 +4534,10 @@
       </p:sp>
       <p:sp>
         <p:nvSpPr>
-          <p:cNvPr id="77" name="research-report">
-            <a:extLst xmlns:a="http://schemas.openxmlformats.org/drawingml/2006/main">
-              <a:ext uri="{FF2B5EF4-FFF2-40B4-BE49-F238E27FC236}">
-                <a16:creationId xmlns:a16="http://schemas.microsoft.com/office/drawing/2014/main" id="{D829A7B3-11F5-493B-8260-38294E1D8FB1}"/>
+          <p:cNvPr id="78" name="research-report">
+            <a:extLst xmlns:a="http://schemas.openxmlformats.org/drawingml/2006/main">
+              <a:ext uri="{FF2B5EF4-FFF2-40B4-BE49-F238E27FC236}">
+                <a16:creationId xmlns:a16="http://schemas.microsoft.com/office/drawing/2014/main" id="{42AD2C90-64BE-4DB8-8B4C-0ECC4E05FF75}"/>
               </a:ext>
             </a:extLst>
           </p:cNvPr>
@@ -4522,11 +4557,11 @@
             </a:avLst>
           </a:prstGeom>
           <a:solidFill xmlns:a="http://schemas.openxmlformats.org/drawingml/2006/main">
-            <a:srgbClr val="F5E6BE"/>
+            <a:srgbClr val="FBE9E1"/>
           </a:solidFill>
           <a:ln xmlns:a="http://schemas.openxmlformats.org/drawingml/2006/main" w="16193">
             <a:solidFill>
-              <a:srgbClr val="B47A1B"/>
+              <a:srgbClr val="D05A2A"/>
             </a:solidFill>
             <a:prstDash val="solid"/>
           </a:ln>
@@ -4534,10 +4569,10 @@
       </p:sp>
       <p:sp>
         <p:nvSpPr>
-          <p:cNvPr id="78" name="report-type">
-            <a:extLst xmlns:a="http://schemas.openxmlformats.org/drawingml/2006/main">
-              <a:ext uri="{FF2B5EF4-FFF2-40B4-BE49-F238E27FC236}">
-                <a16:creationId xmlns:a16="http://schemas.microsoft.com/office/drawing/2014/main" id="{2EE9A487-D492-4F19-B453-17F4751EDEF5}"/>
+          <p:cNvPr id="79" name="report-type">
+            <a:extLst xmlns:a="http://schemas.openxmlformats.org/drawingml/2006/main">
+              <a:ext uri="{FF2B5EF4-FFF2-40B4-BE49-F238E27FC236}">
+                <a16:creationId xmlns:a16="http://schemas.microsoft.com/office/drawing/2014/main" id="{E4E320C3-0CEE-4480-8E65-684AF0787148}"/>
               </a:ext>
             </a:extLst>
           </p:cNvPr>
@@ -4567,14 +4602,14 @@
             <a:pPr algn="ctr">
               <a:defRPr sz="713" b="1">
                 <a:solidFill>
-                  <a:srgbClr val="B47A1B"/>
+                  <a:srgbClr val="D05A2A"/>
                 </a:solidFill>
               </a:defRPr>
             </a:pPr>
             <a:r>
               <a:rPr sz="713" b="1">
                 <a:solidFill>
-                  <a:srgbClr val="B47A1B"/>
+                  <a:srgbClr val="D05A2A"/>
                 </a:solidFill>
               </a:rPr>
               <a:t>STRICT OUTPUT</a:t>
@@ -4584,10 +4619,10 @@
       </p:sp>
       <p:sp>
         <p:nvSpPr>
-          <p:cNvPr id="79" name="report-title">
-            <a:extLst xmlns:a="http://schemas.openxmlformats.org/drawingml/2006/main">
-              <a:ext uri="{FF2B5EF4-FFF2-40B4-BE49-F238E27FC236}">
-                <a16:creationId xmlns:a16="http://schemas.microsoft.com/office/drawing/2014/main" id="{EE3E3D9F-388E-4D69-A942-9A0AA81785B0}"/>
+          <p:cNvPr id="80" name="report-title">
+            <a:extLst xmlns:a="http://schemas.openxmlformats.org/drawingml/2006/main">
+              <a:ext uri="{FF2B5EF4-FFF2-40B4-BE49-F238E27FC236}">
+                <a16:creationId xmlns:a16="http://schemas.microsoft.com/office/drawing/2014/main" id="{ECB8B01F-A021-40FE-A0A2-789DAAD90374}"/>
               </a:ext>
             </a:extLst>
           </p:cNvPr>
@@ -4617,14 +4652,14 @@
             <a:pPr algn="ctr">
               <a:defRPr sz="1163" b="1">
                 <a:solidFill>
-                  <a:srgbClr val="24211D"/>
+                  <a:srgbClr val="1C2430"/>
                 </a:solidFill>
               </a:defRPr>
             </a:pPr>
             <a:r>
               <a:rPr sz="1163" b="1">
                 <a:solidFill>
-                  <a:srgbClr val="24211D"/>
+                  <a:srgbClr val="1C2430"/>
                 </a:solidFill>
               </a:rPr>
               <a:t>Research</a:t>
@@ -4634,14 +4669,14 @@
             <a:pPr algn="ctr">
               <a:defRPr sz="1163" b="1">
                 <a:solidFill>
-                  <a:srgbClr val="24211D"/>
+                  <a:srgbClr val="1C2430"/>
                 </a:solidFill>
               </a:defRPr>
             </a:pPr>
             <a:r>
               <a:rPr sz="1163" b="1">
                 <a:solidFill>
-                  <a:srgbClr val="24211D"/>
+                  <a:srgbClr val="1C2430"/>
                 </a:solidFill>
               </a:rPr>
               <a:t>Report</a:t>
@@ -4651,10 +4686,10 @@
       </p:sp>
       <p:sp>
         <p:nvSpPr>
-          <p:cNvPr id="80" name="report-copy">
-            <a:extLst xmlns:a="http://schemas.openxmlformats.org/drawingml/2006/main">
-              <a:ext uri="{FF2B5EF4-FFF2-40B4-BE49-F238E27FC236}">
-                <a16:creationId xmlns:a16="http://schemas.microsoft.com/office/drawing/2014/main" id="{6BB1B3D3-CC62-44AF-9B20-E5F21F54AF40}"/>
+          <p:cNvPr id="81" name="report-copy">
+            <a:extLst xmlns:a="http://schemas.openxmlformats.org/drawingml/2006/main">
+              <a:ext uri="{FF2B5EF4-FFF2-40B4-BE49-F238E27FC236}">
+                <a16:creationId xmlns:a16="http://schemas.microsoft.com/office/drawing/2014/main" id="{44BC8464-5665-429C-8B4C-72E9D46138FE}"/>
               </a:ext>
             </a:extLst>
           </p:cNvPr>
@@ -4684,14 +4719,14 @@
             <a:pPr algn="ctr">
               <a:defRPr sz="713" b="0">
                 <a:solidFill>
-                  <a:srgbClr val="6B665F"/>
+                  <a:srgbClr val="667085"/>
                 </a:solidFill>
               </a:defRPr>
             </a:pPr>
             <a:r>
               <a:rPr sz="713" b="0">
                 <a:solidFill>
-                  <a:srgbClr val="6B665F"/>
+                  <a:srgbClr val="667085"/>
                 </a:solidFill>
               </a:rPr>
               <a:t>citations serialized</a:t>
@@ -4701,14 +4736,14 @@
             <a:pPr algn="ctr">
               <a:defRPr sz="713" b="0">
                 <a:solidFill>
-                  <a:srgbClr val="6B665F"/>
+                  <a:srgbClr val="667085"/>
                 </a:solidFill>
               </a:defRPr>
             </a:pPr>
             <a:r>
               <a:rPr sz="713" b="0">
                 <a:solidFill>
-                  <a:srgbClr val="6B665F"/>
+                  <a:srgbClr val="667085"/>
                 </a:solidFill>
               </a:rPr>
               <a:t>scraped bodies excluded</a:t>
@@ -4718,10 +4753,10 @@
       </p:sp>
       <p:sp>
         <p:nvSpPr>
-          <p:cNvPr id="81" name="renderers-label">
-            <a:extLst xmlns:a="http://schemas.openxmlformats.org/drawingml/2006/main">
-              <a:ext uri="{FF2B5EF4-FFF2-40B4-BE49-F238E27FC236}">
-                <a16:creationId xmlns:a16="http://schemas.microsoft.com/office/drawing/2014/main" id="{BD2F75F8-F2AE-4176-8B7D-618F6EBF883D}"/>
+          <p:cNvPr id="82" name="renderers-label">
+            <a:extLst xmlns:a="http://schemas.openxmlformats.org/drawingml/2006/main">
+              <a:ext uri="{FF2B5EF4-FFF2-40B4-BE49-F238E27FC236}">
+                <a16:creationId xmlns:a16="http://schemas.microsoft.com/office/drawing/2014/main" id="{326E1B3C-DF5D-460B-ACA4-F4A9FCBCCA3D}"/>
               </a:ext>
             </a:extLst>
           </p:cNvPr>
@@ -4751,14 +4786,14 @@
             <a:pPr algn="ctr">
               <a:defRPr sz="713" b="1">
                 <a:solidFill>
-                  <a:srgbClr val="B47A1B"/>
+                  <a:srgbClr val="D05A2A"/>
                 </a:solidFill>
               </a:defRPr>
             </a:pPr>
             <a:r>
               <a:rPr sz="713" b="1">
                 <a:solidFill>
-                  <a:srgbClr val="B47A1B"/>
+                  <a:srgbClr val="D05A2A"/>
                 </a:solidFill>
               </a:rPr>
               <a:t>RENDER AS</a:t>
@@ -4768,10 +4803,10 @@
       </p:sp>
       <p:sp>
         <p:nvSpPr>
-          <p:cNvPr id="82" name="renderer-0">
-            <a:extLst xmlns:a="http://schemas.openxmlformats.org/drawingml/2006/main">
-              <a:ext uri="{FF2B5EF4-FFF2-40B4-BE49-F238E27FC236}">
-                <a16:creationId xmlns:a16="http://schemas.microsoft.com/office/drawing/2014/main" id="{5BCF304B-8860-492C-810E-E14DC235890F}"/>
+          <p:cNvPr id="83" name="renderer-0">
+            <a:extLst xmlns:a="http://schemas.openxmlformats.org/drawingml/2006/main">
+              <a:ext uri="{FF2B5EF4-FFF2-40B4-BE49-F238E27FC236}">
+                <a16:creationId xmlns:a16="http://schemas.microsoft.com/office/drawing/2014/main" id="{C0309587-B1E3-40AA-904A-9656CBC45EE0}"/>
               </a:ext>
             </a:extLst>
           </p:cNvPr>
@@ -4789,11 +4824,11 @@
             <a:avLst/>
           </a:prstGeom>
           <a:solidFill xmlns:a="http://schemas.openxmlformats.org/drawingml/2006/main">
-            <a:srgbClr val="FFFDF8"/>
+            <a:srgbClr val="FFFFFF"/>
           </a:solidFill>
           <a:ln xmlns:a="http://schemas.openxmlformats.org/drawingml/2006/main" w="10478">
             <a:solidFill>
-              <a:srgbClr val="B47A1B"/>
+              <a:srgbClr val="D05A2A"/>
             </a:solidFill>
             <a:prstDash val="solid"/>
           </a:ln>
@@ -4801,10 +4836,10 @@
       </p:sp>
       <p:sp>
         <p:nvSpPr>
-          <p:cNvPr id="83" name="renderer-0-text">
-            <a:extLst xmlns:a="http://schemas.openxmlformats.org/drawingml/2006/main">
-              <a:ext uri="{FF2B5EF4-FFF2-40B4-BE49-F238E27FC236}">
-                <a16:creationId xmlns:a16="http://schemas.microsoft.com/office/drawing/2014/main" id="{5DDACF32-15AE-4AE6-87B3-98579848BC78}"/>
+          <p:cNvPr id="84" name="renderer-0-text">
+            <a:extLst xmlns:a="http://schemas.openxmlformats.org/drawingml/2006/main">
+              <a:ext uri="{FF2B5EF4-FFF2-40B4-BE49-F238E27FC236}">
+                <a16:creationId xmlns:a16="http://schemas.microsoft.com/office/drawing/2014/main" id="{CA36C92C-F670-432F-94AC-B62E044277D6}"/>
               </a:ext>
             </a:extLst>
           </p:cNvPr>
@@ -4834,14 +4869,14 @@
             <a:pPr algn="ctr">
               <a:defRPr sz="735" b="1">
                 <a:solidFill>
-                  <a:srgbClr val="24211D"/>
+                  <a:srgbClr val="1C2430"/>
                 </a:solidFill>
               </a:defRPr>
             </a:pPr>
             <a:r>
               <a:rPr sz="735" b="1">
                 <a:solidFill>
-                  <a:srgbClr val="24211D"/>
+                  <a:srgbClr val="1C2430"/>
                 </a:solidFill>
               </a:rPr>
               <a:t>terminal</a:t>
@@ -4851,10 +4886,10 @@
       </p:sp>
       <p:sp>
         <p:nvSpPr>
-          <p:cNvPr id="84" name="renderer-1">
-            <a:extLst xmlns:a="http://schemas.openxmlformats.org/drawingml/2006/main">
-              <a:ext uri="{FF2B5EF4-FFF2-40B4-BE49-F238E27FC236}">
-                <a16:creationId xmlns:a16="http://schemas.microsoft.com/office/drawing/2014/main" id="{13C23375-729E-46A5-BC63-B479004BB02C}"/>
+          <p:cNvPr id="85" name="renderer-1">
+            <a:extLst xmlns:a="http://schemas.openxmlformats.org/drawingml/2006/main">
+              <a:ext uri="{FF2B5EF4-FFF2-40B4-BE49-F238E27FC236}">
+                <a16:creationId xmlns:a16="http://schemas.microsoft.com/office/drawing/2014/main" id="{BF83FCD8-8144-44A5-93C4-D2116F7ECEED}"/>
               </a:ext>
             </a:extLst>
           </p:cNvPr>
@@ -4872,11 +4907,11 @@
             <a:avLst/>
           </a:prstGeom>
           <a:solidFill xmlns:a="http://schemas.openxmlformats.org/drawingml/2006/main">
-            <a:srgbClr val="FFFDF8"/>
+            <a:srgbClr val="FFFFFF"/>
           </a:solidFill>
           <a:ln xmlns:a="http://schemas.openxmlformats.org/drawingml/2006/main" w="10478">
             <a:solidFill>
-              <a:srgbClr val="B47A1B"/>
+              <a:srgbClr val="D05A2A"/>
             </a:solidFill>
             <a:prstDash val="solid"/>
           </a:ln>
@@ -4884,10 +4919,10 @@
       </p:sp>
       <p:sp>
         <p:nvSpPr>
-          <p:cNvPr id="85" name="renderer-1-text">
-            <a:extLst xmlns:a="http://schemas.openxmlformats.org/drawingml/2006/main">
-              <a:ext uri="{FF2B5EF4-FFF2-40B4-BE49-F238E27FC236}">
-                <a16:creationId xmlns:a16="http://schemas.microsoft.com/office/drawing/2014/main" id="{DB23B7FB-5F0C-4018-B25A-2EB005AE41A6}"/>
+          <p:cNvPr id="86" name="renderer-1-text">
+            <a:extLst xmlns:a="http://schemas.openxmlformats.org/drawingml/2006/main">
+              <a:ext uri="{FF2B5EF4-FFF2-40B4-BE49-F238E27FC236}">
+                <a16:creationId xmlns:a16="http://schemas.microsoft.com/office/drawing/2014/main" id="{0B9A4B19-3E50-4DAA-9D3C-EF35862F69F8}"/>
               </a:ext>
             </a:extLst>
           </p:cNvPr>
@@ -4917,14 +4952,14 @@
             <a:pPr algn="ctr">
               <a:defRPr sz="735" b="1">
                 <a:solidFill>
-                  <a:srgbClr val="24211D"/>
+                  <a:srgbClr val="1C2430"/>
                 </a:solidFill>
               </a:defRPr>
             </a:pPr>
             <a:r>
               <a:rPr sz="735" b="1">
                 <a:solidFill>
-                  <a:srgbClr val="24211D"/>
+                  <a:srgbClr val="1C2430"/>
                 </a:solidFill>
               </a:rPr>
               <a:t>Markdown</a:t>
@@ -4934,10 +4969,10 @@
       </p:sp>
       <p:sp>
         <p:nvSpPr>
-          <p:cNvPr id="86" name="renderer-2">
-            <a:extLst xmlns:a="http://schemas.openxmlformats.org/drawingml/2006/main">
-              <a:ext uri="{FF2B5EF4-FFF2-40B4-BE49-F238E27FC236}">
-                <a16:creationId xmlns:a16="http://schemas.microsoft.com/office/drawing/2014/main" id="{B41A3292-912F-4B26-9B33-D0785FBA2AF3}"/>
+          <p:cNvPr id="87" name="renderer-2">
+            <a:extLst xmlns:a="http://schemas.openxmlformats.org/drawingml/2006/main">
+              <a:ext uri="{FF2B5EF4-FFF2-40B4-BE49-F238E27FC236}">
+                <a16:creationId xmlns:a16="http://schemas.microsoft.com/office/drawing/2014/main" id="{5F7C4089-6032-42DD-A1E5-548A9A1B53E5}"/>
               </a:ext>
             </a:extLst>
           </p:cNvPr>
@@ -4955,11 +4990,11 @@
             <a:avLst/>
           </a:prstGeom>
           <a:solidFill xmlns:a="http://schemas.openxmlformats.org/drawingml/2006/main">
-            <a:srgbClr val="FFFDF8"/>
+            <a:srgbClr val="FFFFFF"/>
           </a:solidFill>
           <a:ln xmlns:a="http://schemas.openxmlformats.org/drawingml/2006/main" w="10478">
             <a:solidFill>
-              <a:srgbClr val="B47A1B"/>
+              <a:srgbClr val="D05A2A"/>
             </a:solidFill>
             <a:prstDash val="solid"/>
           </a:ln>
@@ -4967,10 +5002,10 @@
       </p:sp>
       <p:sp>
         <p:nvSpPr>
-          <p:cNvPr id="87" name="renderer-2-text">
-            <a:extLst xmlns:a="http://schemas.openxmlformats.org/drawingml/2006/main">
-              <a:ext uri="{FF2B5EF4-FFF2-40B4-BE49-F238E27FC236}">
-                <a16:creationId xmlns:a16="http://schemas.microsoft.com/office/drawing/2014/main" id="{91F02E81-809E-4ADC-9822-DF1663648138}"/>
+          <p:cNvPr id="88" name="renderer-2-text">
+            <a:extLst xmlns:a="http://schemas.openxmlformats.org/drawingml/2006/main">
+              <a:ext uri="{FF2B5EF4-FFF2-40B4-BE49-F238E27FC236}">
+                <a16:creationId xmlns:a16="http://schemas.microsoft.com/office/drawing/2014/main" id="{A041C31B-4A2F-42AD-9F0E-6252E5F7FEC4}"/>
               </a:ext>
             </a:extLst>
           </p:cNvPr>
@@ -5000,14 +5035,14 @@
             <a:pPr algn="ctr">
               <a:defRPr sz="735" b="1">
                 <a:solidFill>
-                  <a:srgbClr val="24211D"/>
+                  <a:srgbClr val="1C2430"/>
                 </a:solidFill>
               </a:defRPr>
             </a:pPr>
             <a:r>
               <a:rPr sz="735" b="1">
                 <a:solidFill>
-                  <a:srgbClr val="24211D"/>
+                  <a:srgbClr val="1C2430"/>
                 </a:solidFill>
               </a:rPr>
               <a:t>JSON</a:t>
@@ -5017,10 +5052,10 @@
       </p:sp>
       <p:sp>
         <p:nvSpPr>
-          <p:cNvPr id="88" name="renderer-3">
-            <a:extLst xmlns:a="http://schemas.openxmlformats.org/drawingml/2006/main">
-              <a:ext uri="{FF2B5EF4-FFF2-40B4-BE49-F238E27FC236}">
-                <a16:creationId xmlns:a16="http://schemas.microsoft.com/office/drawing/2014/main" id="{CCF6687E-5DB7-4C22-B237-AC5AF66AA7AF}"/>
+          <p:cNvPr id="89" name="renderer-3">
+            <a:extLst xmlns:a="http://schemas.openxmlformats.org/drawingml/2006/main">
+              <a:ext uri="{FF2B5EF4-FFF2-40B4-BE49-F238E27FC236}">
+                <a16:creationId xmlns:a16="http://schemas.microsoft.com/office/drawing/2014/main" id="{3DF41FC9-D944-400B-B4B5-00B8D652108F}"/>
               </a:ext>
             </a:extLst>
           </p:cNvPr>
@@ -5038,11 +5073,11 @@
             <a:avLst/>
           </a:prstGeom>
           <a:solidFill xmlns:a="http://schemas.openxmlformats.org/drawingml/2006/main">
-            <a:srgbClr val="FFFDF8"/>
+            <a:srgbClr val="FFFFFF"/>
           </a:solidFill>
           <a:ln xmlns:a="http://schemas.openxmlformats.org/drawingml/2006/main" w="10478">
             <a:solidFill>
-              <a:srgbClr val="B47A1B"/>
+              <a:srgbClr val="D05A2A"/>
             </a:solidFill>
             <a:prstDash val="solid"/>
           </a:ln>
@@ -5050,10 +5085,10 @@
       </p:sp>
       <p:sp>
         <p:nvSpPr>
-          <p:cNvPr id="89" name="renderer-3-text">
-            <a:extLst xmlns:a="http://schemas.openxmlformats.org/drawingml/2006/main">
-              <a:ext uri="{FF2B5EF4-FFF2-40B4-BE49-F238E27FC236}">
-                <a16:creationId xmlns:a16="http://schemas.microsoft.com/office/drawing/2014/main" id="{6DBAA0BB-659E-4396-A51D-5624B7E3D794}"/>
+          <p:cNvPr id="90" name="renderer-3-text">
+            <a:extLst xmlns:a="http://schemas.openxmlformats.org/drawingml/2006/main">
+              <a:ext uri="{FF2B5EF4-FFF2-40B4-BE49-F238E27FC236}">
+                <a16:creationId xmlns:a16="http://schemas.microsoft.com/office/drawing/2014/main" id="{4CB7EA20-43E4-43F8-9E98-EB719007CC0C}"/>
               </a:ext>
             </a:extLst>
           </p:cNvPr>
@@ -5083,14 +5118,14 @@
             <a:pPr algn="ctr">
               <a:defRPr sz="735" b="1">
                 <a:solidFill>
-                  <a:srgbClr val="24211D"/>
+                  <a:srgbClr val="1C2430"/>
                 </a:solidFill>
               </a:defRPr>
             </a:pPr>
             <a:r>
               <a:rPr sz="735" b="1">
                 <a:solidFill>
-                  <a:srgbClr val="24211D"/>
+                  <a:srgbClr val="1C2430"/>
                 </a:solidFill>
               </a:rPr>
               <a:t>CSV</a:t>
@@ -5100,10 +5135,10 @@
       </p:sp>
       <p:sp>
         <p:nvSpPr>
-          <p:cNvPr id="90" name="safe-write">
-            <a:extLst xmlns:a="http://schemas.openxmlformats.org/drawingml/2006/main">
-              <a:ext uri="{FF2B5EF4-FFF2-40B4-BE49-F238E27FC236}">
-                <a16:creationId xmlns:a16="http://schemas.microsoft.com/office/drawing/2014/main" id="{2381FB30-EA97-4F4A-9F91-ADBE3EC32519}"/>
+          <p:cNvPr id="91" name="safe-write">
+            <a:extLst xmlns:a="http://schemas.openxmlformats.org/drawingml/2006/main">
+              <a:ext uri="{FF2B5EF4-FFF2-40B4-BE49-F238E27FC236}">
+                <a16:creationId xmlns:a16="http://schemas.microsoft.com/office/drawing/2014/main" id="{1F8DFCF8-0921-4D47-B874-58FB1FB5CB5C}"/>
               </a:ext>
             </a:extLst>
           </p:cNvPr>
@@ -5133,14 +5168,14 @@
             <a:pPr algn="ctr">
               <a:defRPr sz="863" b="1">
                 <a:solidFill>
-                  <a:srgbClr val="52725D"/>
+                  <a:srgbClr val="397EA5"/>
                 </a:solidFill>
               </a:defRPr>
             </a:pPr>
             <a:r>
               <a:rPr sz="863" b="1">
                 <a:solidFill>
-                  <a:srgbClr val="52725D"/>
+                  <a:srgbClr val="397EA5"/>
                 </a:solidFill>
               </a:rPr>
               <a:t>write → replace</a:t>
@@ -5150,10 +5185,10 @@
       </p:sp>
       <p:sp>
         <p:nvSpPr>
-          <p:cNvPr id="91" name="safe-write-copy">
-            <a:extLst xmlns:a="http://schemas.openxmlformats.org/drawingml/2006/main">
-              <a:ext uri="{FF2B5EF4-FFF2-40B4-BE49-F238E27FC236}">
-                <a16:creationId xmlns:a16="http://schemas.microsoft.com/office/drawing/2014/main" id="{21962091-4585-45E5-A4DE-06637E12AAFA}"/>
+          <p:cNvPr id="92" name="safe-write-copy">
+            <a:extLst xmlns:a="http://schemas.openxmlformats.org/drawingml/2006/main">
+              <a:ext uri="{FF2B5EF4-FFF2-40B4-BE49-F238E27FC236}">
+                <a16:creationId xmlns:a16="http://schemas.microsoft.com/office/drawing/2014/main" id="{C93B3D90-E8A6-4C66-B872-C8D4B60A7834}"/>
               </a:ext>
             </a:extLst>
           </p:cNvPr>
@@ -5183,14 +5218,14 @@
             <a:pPr algn="ctr">
               <a:defRPr sz="690" b="0">
                 <a:solidFill>
-                  <a:srgbClr val="6B665F"/>
+                  <a:srgbClr val="667085"/>
                 </a:solidFill>
               </a:defRPr>
             </a:pPr>
             <a:r>
               <a:rPr sz="690" b="0">
                 <a:solidFill>
-                  <a:srgbClr val="6B665F"/>
+                  <a:srgbClr val="667085"/>
                 </a:solidFill>
               </a:rPr>
               <a:t>atomic output boundary</a:t>
@@ -5200,10 +5235,10 @@
       </p:sp>
       <p:sp>
         <p:nvSpPr>
-          <p:cNvPr id="92" name="caption">
-            <a:extLst xmlns:a="http://schemas.openxmlformats.org/drawingml/2006/main">
-              <a:ext uri="{FF2B5EF4-FFF2-40B4-BE49-F238E27FC236}">
-                <a16:creationId xmlns:a16="http://schemas.microsoft.com/office/drawing/2014/main" id="{BD649E52-B280-448E-ACB6-B7DFF1F8B802}"/>
+          <p:cNvPr id="93" name="caption">
+            <a:extLst xmlns:a="http://schemas.openxmlformats.org/drawingml/2006/main">
+              <a:ext uri="{FF2B5EF4-FFF2-40B4-BE49-F238E27FC236}">
+                <a16:creationId xmlns:a16="http://schemas.microsoft.com/office/drawing/2014/main" id="{8BE09A29-296C-4B1B-A732-0DF37C06FC11}"/>
               </a:ext>
             </a:extLst>
           </p:cNvPr>
@@ -5233,14 +5268,14 @@
             <a:pPr algn="l">
               <a:defRPr sz="975" b="0">
                 <a:solidFill>
-                  <a:srgbClr val="24211D"/>
+                  <a:srgbClr val="1C2430"/>
                 </a:solidFill>
               </a:defRPr>
             </a:pPr>
             <a:r>
               <a:rPr sz="975" b="0">
                 <a:solidFill>
-                  <a:srgbClr val="24211D"/>
+                  <a:srgbClr val="1C2430"/>
                 </a:solidFill>
               </a:rPr>
               <a:t>Provider implementations plug into a single typed state machine; validation and degraded-run behavior remain inside the graph rather than the UI.</a:t>
@@ -5250,10 +5285,10 @@
       </p:sp>
       <p:sp>
         <p:nvSpPr>
-          <p:cNvPr id="93" name="sources">
-            <a:extLst xmlns:a="http://schemas.openxmlformats.org/drawingml/2006/main">
-              <a:ext uri="{FF2B5EF4-FFF2-40B4-BE49-F238E27FC236}">
-                <a16:creationId xmlns:a16="http://schemas.microsoft.com/office/drawing/2014/main" id="{BACF6673-34E2-47B6-8AF8-B7EA0CA7E75E}"/>
+          <p:cNvPr id="94" name="sources">
+            <a:extLst xmlns:a="http://schemas.openxmlformats.org/drawingml/2006/main">
+              <a:ext uri="{FF2B5EF4-FFF2-40B4-BE49-F238E27FC236}">
+                <a16:creationId xmlns:a16="http://schemas.microsoft.com/office/drawing/2014/main" id="{DD1AF169-DA26-4DDE-9B72-599AAA898F56}"/>
               </a:ext>
             </a:extLst>
           </p:cNvPr>
@@ -5283,14 +5318,14 @@
             <a:pPr algn="l">
               <a:defRPr sz="690" b="0">
                 <a:solidFill>
-                  <a:srgbClr val="6B665F"/>
+                  <a:srgbClr val="667085"/>
                 </a:solidFill>
               </a:defRPr>
             </a:pPr>
             <a:r>
               <a:rPr sz="690" b="0">
                 <a:solidFill>
-                  <a:srgbClr val="6B665F"/>
+                  <a:srgbClr val="667085"/>
                 </a:solidFill>
               </a:rPr>
               <a:t>pipeline.py · contracts.py · demo.py · live.py · providers.py · models.py · renderers.py</a:t>
@@ -5301,7 +5336,7 @@
     </p:spTree>
     <p:extLst>
       <p:ext uri="{BB962C8B-B14F-4D97-AF65-F5344CB8AC3E}">
-        <p14:creationId xmlns:p14="http://schemas.microsoft.com/office/powerpoint/2010/main" val="345529698"/>
+        <p14:creationId xmlns:p14="http://schemas.microsoft.com/office/powerpoint/2010/main" val="1525223631"/>
       </p:ext>
     </p:extLst>
   </p:cSld>

</xml_diff>